<commit_message>
Drop BETA wordmark from exec deck
Per-slide chrome and title slide both used "smartcredit BETA" — for an
internal exec proposal we want the production wordmark only.

Co-Authored-By: Claude Opus 4.7 (1M context) <noreply@anthropic.com>
</commit_message>
<xml_diff>
--- a/myReclaim-Exec-Deck.pptx
+++ b/myReclaim-Exec-Deck.pptx
@@ -3286,7 +3286,7 @@
         <p:spPr>
           <a:xfrm>
             <a:off x="914400" y="457200"/>
-            <a:ext cx="2743200" cy="411480"/>
+            <a:ext cx="3657600" cy="411480"/>
           </a:xfrm>
           <a:prstGeom prst="rect">
             <a:avLst/>
@@ -3315,41 +3315,6 @@
       <p:sp>
         <p:nvSpPr>
           <p:cNvPr id="7" name="TextBox 6"/>
-          <p:cNvSpPr txBox="1"/>
-          <p:nvPr/>
-        </p:nvSpPr>
-        <p:spPr>
-          <a:xfrm>
-            <a:off x="2606040" y="502920"/>
-            <a:ext cx="914400" cy="365760"/>
-          </a:xfrm>
-          <a:prstGeom prst="rect">
-            <a:avLst/>
-          </a:prstGeom>
-          <a:noFill/>
-        </p:spPr>
-        <p:txBody>
-          <a:bodyPr wrap="square" anchor="t" lIns="0" rIns="0" tIns="0" bIns="0">
-            <a:spAutoFit/>
-          </a:bodyPr>
-          <a:lstStyle/>
-          <a:p>
-            <a:pPr algn="l"/>
-            <a:r>
-              <a:rPr sz="1400" b="1">
-                <a:solidFill>
-                  <a:srgbClr val="2863C5"/>
-                </a:solidFill>
-                <a:latin typeface="Open Sans"/>
-              </a:rPr>
-              <a:t>BETA</a:t>
-            </a:r>
-          </a:p>
-        </p:txBody>
-      </p:sp>
-      <p:sp>
-        <p:nvSpPr>
-          <p:cNvPr id="8" name="TextBox 7"/>
           <p:cNvSpPr txBox="1"/>
           <p:nvPr/>
         </p:nvSpPr>
@@ -3384,7 +3349,7 @@
       </p:sp>
       <p:sp>
         <p:nvSpPr>
-          <p:cNvPr id="9" name="TextBox 8"/>
+          <p:cNvPr id="8" name="TextBox 7"/>
           <p:cNvSpPr txBox="1"/>
           <p:nvPr/>
         </p:nvSpPr>
@@ -3419,7 +3384,7 @@
       </p:sp>
       <p:sp>
         <p:nvSpPr>
-          <p:cNvPr id="10" name="TextBox 9"/>
+          <p:cNvPr id="9" name="TextBox 8"/>
           <p:cNvSpPr txBox="1"/>
           <p:nvPr/>
         </p:nvSpPr>
@@ -3455,7 +3420,7 @@
       </p:sp>
       <p:sp>
         <p:nvSpPr>
-          <p:cNvPr id="11" name="Rectangle 10"/>
+          <p:cNvPr id="10" name="Rectangle 9"/>
           <p:cNvSpPr/>
           <p:nvPr/>
         </p:nvSpPr>
@@ -3499,7 +3464,7 @@
       </p:sp>
       <p:sp>
         <p:nvSpPr>
-          <p:cNvPr id="12" name="TextBox 11"/>
+          <p:cNvPr id="11" name="TextBox 10"/>
           <p:cNvSpPr txBox="1"/>
           <p:nvPr/>
         </p:nvSpPr>
@@ -3647,7 +3612,7 @@
         <p:spPr>
           <a:xfrm>
             <a:off x="457200" y="164592"/>
-            <a:ext cx="1828800" cy="329184"/>
+            <a:ext cx="2286000" cy="329184"/>
           </a:xfrm>
           <a:prstGeom prst="rect">
             <a:avLst/>
@@ -3676,41 +3641,6 @@
       <p:sp>
         <p:nvSpPr>
           <p:cNvPr id="5" name="TextBox 4"/>
-          <p:cNvSpPr txBox="1"/>
-          <p:nvPr/>
-        </p:nvSpPr>
-        <p:spPr>
-          <a:xfrm>
-            <a:off x="1691640" y="201168"/>
-            <a:ext cx="822960" cy="274320"/>
-          </a:xfrm>
-          <a:prstGeom prst="rect">
-            <a:avLst/>
-          </a:prstGeom>
-          <a:noFill/>
-        </p:spPr>
-        <p:txBody>
-          <a:bodyPr wrap="square" anchor="t" lIns="0" rIns="0" tIns="0" bIns="0">
-            <a:spAutoFit/>
-          </a:bodyPr>
-          <a:lstStyle/>
-          <a:p>
-            <a:pPr algn="l"/>
-            <a:r>
-              <a:rPr sz="1100" b="1">
-                <a:solidFill>
-                  <a:srgbClr val="2863C5"/>
-                </a:solidFill>
-                <a:latin typeface="Open Sans"/>
-              </a:rPr>
-              <a:t>BETA</a:t>
-            </a:r>
-          </a:p>
-        </p:txBody>
-      </p:sp>
-      <p:sp>
-        <p:nvSpPr>
-          <p:cNvPr id="6" name="TextBox 5"/>
           <p:cNvSpPr txBox="1"/>
           <p:nvPr/>
         </p:nvSpPr>
@@ -3745,7 +3675,7 @@
       </p:sp>
       <p:sp>
         <p:nvSpPr>
-          <p:cNvPr id="7" name="TextBox 6"/>
+          <p:cNvPr id="6" name="TextBox 5"/>
           <p:cNvSpPr txBox="1"/>
           <p:nvPr/>
         </p:nvSpPr>
@@ -3780,7 +3710,7 @@
       </p:sp>
       <p:sp>
         <p:nvSpPr>
-          <p:cNvPr id="8" name="TextBox 7"/>
+          <p:cNvPr id="7" name="TextBox 6"/>
           <p:cNvSpPr txBox="1"/>
           <p:nvPr/>
         </p:nvSpPr>
@@ -3815,7 +3745,7 @@
       </p:sp>
       <p:sp>
         <p:nvSpPr>
-          <p:cNvPr id="9" name="TextBox 8"/>
+          <p:cNvPr id="8" name="TextBox 7"/>
           <p:cNvSpPr txBox="1"/>
           <p:nvPr/>
         </p:nvSpPr>
@@ -3850,7 +3780,7 @@
       </p:sp>
       <p:sp>
         <p:nvSpPr>
-          <p:cNvPr id="10" name="Rounded Rectangle 9"/>
+          <p:cNvPr id="9" name="Rounded Rectangle 8"/>
           <p:cNvSpPr/>
           <p:nvPr/>
         </p:nvSpPr>
@@ -3898,7 +3828,7 @@
       </p:sp>
       <p:sp>
         <p:nvSpPr>
-          <p:cNvPr id="11" name="Rectangle 10"/>
+          <p:cNvPr id="10" name="Rectangle 9"/>
           <p:cNvSpPr/>
           <p:nvPr/>
         </p:nvSpPr>
@@ -3942,7 +3872,7 @@
       </p:sp>
       <p:sp>
         <p:nvSpPr>
-          <p:cNvPr id="12" name="TextBox 11"/>
+          <p:cNvPr id="11" name="TextBox 10"/>
           <p:cNvSpPr txBox="1"/>
           <p:nvPr/>
         </p:nvSpPr>
@@ -3977,7 +3907,7 @@
       </p:sp>
       <p:sp>
         <p:nvSpPr>
-          <p:cNvPr id="13" name="TextBox 12"/>
+          <p:cNvPr id="12" name="TextBox 11"/>
           <p:cNvSpPr txBox="1"/>
           <p:nvPr/>
         </p:nvSpPr>
@@ -4012,7 +3942,7 @@
       </p:sp>
       <p:sp>
         <p:nvSpPr>
-          <p:cNvPr id="14" name="TextBox 13"/>
+          <p:cNvPr id="13" name="TextBox 12"/>
           <p:cNvSpPr txBox="1"/>
           <p:nvPr/>
         </p:nvSpPr>
@@ -4047,7 +3977,7 @@
       </p:sp>
       <p:sp>
         <p:nvSpPr>
-          <p:cNvPr id="15" name="Rounded Rectangle 14"/>
+          <p:cNvPr id="14" name="Rounded Rectangle 13"/>
           <p:cNvSpPr/>
           <p:nvPr/>
         </p:nvSpPr>
@@ -4095,7 +4025,7 @@
       </p:sp>
       <p:sp>
         <p:nvSpPr>
-          <p:cNvPr id="16" name="Rectangle 15"/>
+          <p:cNvPr id="15" name="Rectangle 14"/>
           <p:cNvSpPr/>
           <p:nvPr/>
         </p:nvSpPr>
@@ -4139,7 +4069,7 @@
       </p:sp>
       <p:sp>
         <p:nvSpPr>
-          <p:cNvPr id="17" name="TextBox 16"/>
+          <p:cNvPr id="16" name="TextBox 15"/>
           <p:cNvSpPr txBox="1"/>
           <p:nvPr/>
         </p:nvSpPr>
@@ -4174,7 +4104,7 @@
       </p:sp>
       <p:sp>
         <p:nvSpPr>
-          <p:cNvPr id="18" name="TextBox 17"/>
+          <p:cNvPr id="17" name="TextBox 16"/>
           <p:cNvSpPr txBox="1"/>
           <p:nvPr/>
         </p:nvSpPr>
@@ -4209,7 +4139,7 @@
       </p:sp>
       <p:sp>
         <p:nvSpPr>
-          <p:cNvPr id="19" name="TextBox 18"/>
+          <p:cNvPr id="18" name="TextBox 17"/>
           <p:cNvSpPr txBox="1"/>
           <p:nvPr/>
         </p:nvSpPr>
@@ -4244,7 +4174,7 @@
       </p:sp>
       <p:sp>
         <p:nvSpPr>
-          <p:cNvPr id="20" name="Rounded Rectangle 19"/>
+          <p:cNvPr id="19" name="Rounded Rectangle 18"/>
           <p:cNvSpPr/>
           <p:nvPr/>
         </p:nvSpPr>
@@ -4292,7 +4222,7 @@
       </p:sp>
       <p:sp>
         <p:nvSpPr>
-          <p:cNvPr id="21" name="Rectangle 20"/>
+          <p:cNvPr id="20" name="Rectangle 19"/>
           <p:cNvSpPr/>
           <p:nvPr/>
         </p:nvSpPr>
@@ -4336,7 +4266,7 @@
       </p:sp>
       <p:sp>
         <p:nvSpPr>
-          <p:cNvPr id="22" name="TextBox 21"/>
+          <p:cNvPr id="21" name="TextBox 20"/>
           <p:cNvSpPr txBox="1"/>
           <p:nvPr/>
         </p:nvSpPr>
@@ -4371,7 +4301,7 @@
       </p:sp>
       <p:sp>
         <p:nvSpPr>
-          <p:cNvPr id="23" name="TextBox 22"/>
+          <p:cNvPr id="22" name="TextBox 21"/>
           <p:cNvSpPr txBox="1"/>
           <p:nvPr/>
         </p:nvSpPr>
@@ -4406,7 +4336,7 @@
       </p:sp>
       <p:sp>
         <p:nvSpPr>
-          <p:cNvPr id="24" name="TextBox 23"/>
+          <p:cNvPr id="23" name="TextBox 22"/>
           <p:cNvSpPr txBox="1"/>
           <p:nvPr/>
         </p:nvSpPr>
@@ -4441,7 +4371,7 @@
       </p:sp>
       <p:sp>
         <p:nvSpPr>
-          <p:cNvPr id="25" name="Rounded Rectangle 24"/>
+          <p:cNvPr id="24" name="Rounded Rectangle 23"/>
           <p:cNvSpPr/>
           <p:nvPr/>
         </p:nvSpPr>
@@ -4489,7 +4419,7 @@
       </p:sp>
       <p:sp>
         <p:nvSpPr>
-          <p:cNvPr id="26" name="Rectangle 25"/>
+          <p:cNvPr id="25" name="Rectangle 24"/>
           <p:cNvSpPr/>
           <p:nvPr/>
         </p:nvSpPr>
@@ -4533,7 +4463,7 @@
       </p:sp>
       <p:sp>
         <p:nvSpPr>
-          <p:cNvPr id="27" name="TextBox 26"/>
+          <p:cNvPr id="26" name="TextBox 25"/>
           <p:cNvSpPr txBox="1"/>
           <p:nvPr/>
         </p:nvSpPr>
@@ -4568,7 +4498,7 @@
       </p:sp>
       <p:sp>
         <p:nvSpPr>
-          <p:cNvPr id="28" name="TextBox 27"/>
+          <p:cNvPr id="27" name="TextBox 26"/>
           <p:cNvSpPr txBox="1"/>
           <p:nvPr/>
         </p:nvSpPr>
@@ -4603,7 +4533,7 @@
       </p:sp>
       <p:sp>
         <p:nvSpPr>
-          <p:cNvPr id="29" name="TextBox 28"/>
+          <p:cNvPr id="28" name="TextBox 27"/>
           <p:cNvSpPr txBox="1"/>
           <p:nvPr/>
         </p:nvSpPr>
@@ -4638,7 +4568,7 @@
       </p:sp>
       <p:sp>
         <p:nvSpPr>
-          <p:cNvPr id="30" name="Rounded Rectangle 29"/>
+          <p:cNvPr id="29" name="Rounded Rectangle 28"/>
           <p:cNvSpPr/>
           <p:nvPr/>
         </p:nvSpPr>
@@ -4686,7 +4616,7 @@
       </p:sp>
       <p:sp>
         <p:nvSpPr>
-          <p:cNvPr id="31" name="Rectangle 30"/>
+          <p:cNvPr id="30" name="Rectangle 29"/>
           <p:cNvSpPr/>
           <p:nvPr/>
         </p:nvSpPr>
@@ -4730,7 +4660,7 @@
       </p:sp>
       <p:sp>
         <p:nvSpPr>
-          <p:cNvPr id="32" name="TextBox 31"/>
+          <p:cNvPr id="31" name="TextBox 30"/>
           <p:cNvSpPr txBox="1"/>
           <p:nvPr/>
         </p:nvSpPr>
@@ -4765,7 +4695,7 @@
       </p:sp>
       <p:sp>
         <p:nvSpPr>
-          <p:cNvPr id="33" name="TextBox 32"/>
+          <p:cNvPr id="32" name="TextBox 31"/>
           <p:cNvSpPr txBox="1"/>
           <p:nvPr/>
         </p:nvSpPr>
@@ -4800,7 +4730,7 @@
       </p:sp>
       <p:sp>
         <p:nvSpPr>
-          <p:cNvPr id="34" name="TextBox 33"/>
+          <p:cNvPr id="33" name="TextBox 32"/>
           <p:cNvSpPr txBox="1"/>
           <p:nvPr/>
         </p:nvSpPr>
@@ -4835,7 +4765,7 @@
       </p:sp>
       <p:sp>
         <p:nvSpPr>
-          <p:cNvPr id="35" name="Rounded Rectangle 34"/>
+          <p:cNvPr id="34" name="Rounded Rectangle 33"/>
           <p:cNvSpPr/>
           <p:nvPr/>
         </p:nvSpPr>
@@ -4883,7 +4813,7 @@
       </p:sp>
       <p:sp>
         <p:nvSpPr>
-          <p:cNvPr id="36" name="Rectangle 35"/>
+          <p:cNvPr id="35" name="Rectangle 34"/>
           <p:cNvSpPr/>
           <p:nvPr/>
         </p:nvSpPr>
@@ -4927,7 +4857,7 @@
       </p:sp>
       <p:sp>
         <p:nvSpPr>
-          <p:cNvPr id="37" name="TextBox 36"/>
+          <p:cNvPr id="36" name="TextBox 35"/>
           <p:cNvSpPr txBox="1"/>
           <p:nvPr/>
         </p:nvSpPr>
@@ -4962,7 +4892,7 @@
       </p:sp>
       <p:sp>
         <p:nvSpPr>
-          <p:cNvPr id="38" name="TextBox 37"/>
+          <p:cNvPr id="37" name="TextBox 36"/>
           <p:cNvSpPr txBox="1"/>
           <p:nvPr/>
         </p:nvSpPr>
@@ -4997,7 +4927,7 @@
       </p:sp>
       <p:sp>
         <p:nvSpPr>
-          <p:cNvPr id="39" name="TextBox 38"/>
+          <p:cNvPr id="38" name="TextBox 37"/>
           <p:cNvSpPr txBox="1"/>
           <p:nvPr/>
         </p:nvSpPr>
@@ -5145,7 +5075,7 @@
         <p:spPr>
           <a:xfrm>
             <a:off x="457200" y="164592"/>
-            <a:ext cx="1828800" cy="329184"/>
+            <a:ext cx="2286000" cy="329184"/>
           </a:xfrm>
           <a:prstGeom prst="rect">
             <a:avLst/>
@@ -5174,41 +5104,6 @@
       <p:sp>
         <p:nvSpPr>
           <p:cNvPr id="5" name="TextBox 4"/>
-          <p:cNvSpPr txBox="1"/>
-          <p:nvPr/>
-        </p:nvSpPr>
-        <p:spPr>
-          <a:xfrm>
-            <a:off x="1691640" y="201168"/>
-            <a:ext cx="822960" cy="274320"/>
-          </a:xfrm>
-          <a:prstGeom prst="rect">
-            <a:avLst/>
-          </a:prstGeom>
-          <a:noFill/>
-        </p:spPr>
-        <p:txBody>
-          <a:bodyPr wrap="square" anchor="t" lIns="0" rIns="0" tIns="0" bIns="0">
-            <a:spAutoFit/>
-          </a:bodyPr>
-          <a:lstStyle/>
-          <a:p>
-            <a:pPr algn="l"/>
-            <a:r>
-              <a:rPr sz="1100" b="1">
-                <a:solidFill>
-                  <a:srgbClr val="2863C5"/>
-                </a:solidFill>
-                <a:latin typeface="Open Sans"/>
-              </a:rPr>
-              <a:t>BETA</a:t>
-            </a:r>
-          </a:p>
-        </p:txBody>
-      </p:sp>
-      <p:sp>
-        <p:nvSpPr>
-          <p:cNvPr id="6" name="TextBox 5"/>
           <p:cNvSpPr txBox="1"/>
           <p:nvPr/>
         </p:nvSpPr>
@@ -5243,7 +5138,7 @@
       </p:sp>
       <p:sp>
         <p:nvSpPr>
-          <p:cNvPr id="7" name="TextBox 6"/>
+          <p:cNvPr id="6" name="TextBox 5"/>
           <p:cNvSpPr txBox="1"/>
           <p:nvPr/>
         </p:nvSpPr>
@@ -5278,7 +5173,7 @@
       </p:sp>
       <p:sp>
         <p:nvSpPr>
-          <p:cNvPr id="8" name="TextBox 7"/>
+          <p:cNvPr id="7" name="TextBox 6"/>
           <p:cNvSpPr txBox="1"/>
           <p:nvPr/>
         </p:nvSpPr>
@@ -5313,7 +5208,7 @@
       </p:sp>
       <p:sp>
         <p:nvSpPr>
-          <p:cNvPr id="9" name="TextBox 8"/>
+          <p:cNvPr id="8" name="TextBox 7"/>
           <p:cNvSpPr txBox="1"/>
           <p:nvPr/>
         </p:nvSpPr>
@@ -5348,7 +5243,7 @@
       </p:sp>
       <p:sp>
         <p:nvSpPr>
-          <p:cNvPr id="10" name="Rounded Rectangle 9"/>
+          <p:cNvPr id="9" name="Rounded Rectangle 8"/>
           <p:cNvSpPr/>
           <p:nvPr/>
         </p:nvSpPr>
@@ -5396,7 +5291,7 @@
       </p:sp>
       <p:sp>
         <p:nvSpPr>
-          <p:cNvPr id="11" name="Rectangle 10"/>
+          <p:cNvPr id="10" name="Rectangle 9"/>
           <p:cNvSpPr/>
           <p:nvPr/>
         </p:nvSpPr>
@@ -5440,7 +5335,7 @@
       </p:sp>
       <p:sp>
         <p:nvSpPr>
-          <p:cNvPr id="12" name="TextBox 11"/>
+          <p:cNvPr id="11" name="TextBox 10"/>
           <p:cNvSpPr txBox="1"/>
           <p:nvPr/>
         </p:nvSpPr>
@@ -5475,7 +5370,7 @@
       </p:sp>
       <p:sp>
         <p:nvSpPr>
-          <p:cNvPr id="13" name="TextBox 12"/>
+          <p:cNvPr id="12" name="TextBox 11"/>
           <p:cNvSpPr txBox="1"/>
           <p:nvPr/>
         </p:nvSpPr>
@@ -5510,7 +5405,7 @@
       </p:sp>
       <p:sp>
         <p:nvSpPr>
-          <p:cNvPr id="14" name="TextBox 13"/>
+          <p:cNvPr id="13" name="TextBox 12"/>
           <p:cNvSpPr txBox="1"/>
           <p:nvPr/>
         </p:nvSpPr>
@@ -5545,7 +5440,7 @@
       </p:sp>
       <p:sp>
         <p:nvSpPr>
-          <p:cNvPr id="15" name="Rounded Rectangle 14"/>
+          <p:cNvPr id="14" name="Rounded Rectangle 13"/>
           <p:cNvSpPr/>
           <p:nvPr/>
         </p:nvSpPr>
@@ -5593,7 +5488,7 @@
       </p:sp>
       <p:sp>
         <p:nvSpPr>
-          <p:cNvPr id="16" name="Rectangle 15"/>
+          <p:cNvPr id="15" name="Rectangle 14"/>
           <p:cNvSpPr/>
           <p:nvPr/>
         </p:nvSpPr>
@@ -5637,7 +5532,7 @@
       </p:sp>
       <p:sp>
         <p:nvSpPr>
-          <p:cNvPr id="17" name="TextBox 16"/>
+          <p:cNvPr id="16" name="TextBox 15"/>
           <p:cNvSpPr txBox="1"/>
           <p:nvPr/>
         </p:nvSpPr>
@@ -5672,7 +5567,7 @@
       </p:sp>
       <p:sp>
         <p:nvSpPr>
-          <p:cNvPr id="18" name="TextBox 17"/>
+          <p:cNvPr id="17" name="TextBox 16"/>
           <p:cNvSpPr txBox="1"/>
           <p:nvPr/>
         </p:nvSpPr>
@@ -5707,7 +5602,7 @@
       </p:sp>
       <p:sp>
         <p:nvSpPr>
-          <p:cNvPr id="19" name="TextBox 18"/>
+          <p:cNvPr id="18" name="TextBox 17"/>
           <p:cNvSpPr txBox="1"/>
           <p:nvPr/>
         </p:nvSpPr>
@@ -5742,7 +5637,7 @@
       </p:sp>
       <p:sp>
         <p:nvSpPr>
-          <p:cNvPr id="20" name="Rounded Rectangle 19"/>
+          <p:cNvPr id="19" name="Rounded Rectangle 18"/>
           <p:cNvSpPr/>
           <p:nvPr/>
         </p:nvSpPr>
@@ -5790,7 +5685,7 @@
       </p:sp>
       <p:sp>
         <p:nvSpPr>
-          <p:cNvPr id="21" name="Rectangle 20"/>
+          <p:cNvPr id="20" name="Rectangle 19"/>
           <p:cNvSpPr/>
           <p:nvPr/>
         </p:nvSpPr>
@@ -5834,7 +5729,7 @@
       </p:sp>
       <p:sp>
         <p:nvSpPr>
-          <p:cNvPr id="22" name="TextBox 21"/>
+          <p:cNvPr id="21" name="TextBox 20"/>
           <p:cNvSpPr txBox="1"/>
           <p:nvPr/>
         </p:nvSpPr>
@@ -5869,7 +5764,7 @@
       </p:sp>
       <p:sp>
         <p:nvSpPr>
-          <p:cNvPr id="23" name="TextBox 22"/>
+          <p:cNvPr id="22" name="TextBox 21"/>
           <p:cNvSpPr txBox="1"/>
           <p:nvPr/>
         </p:nvSpPr>
@@ -5904,7 +5799,7 @@
       </p:sp>
       <p:sp>
         <p:nvSpPr>
-          <p:cNvPr id="24" name="TextBox 23"/>
+          <p:cNvPr id="23" name="TextBox 22"/>
           <p:cNvSpPr txBox="1"/>
           <p:nvPr/>
         </p:nvSpPr>
@@ -5939,7 +5834,7 @@
       </p:sp>
       <p:sp>
         <p:nvSpPr>
-          <p:cNvPr id="25" name="Rounded Rectangle 24"/>
+          <p:cNvPr id="24" name="Rounded Rectangle 23"/>
           <p:cNvSpPr/>
           <p:nvPr/>
         </p:nvSpPr>
@@ -5987,7 +5882,7 @@
       </p:sp>
       <p:sp>
         <p:nvSpPr>
-          <p:cNvPr id="26" name="Rectangle 25"/>
+          <p:cNvPr id="25" name="Rectangle 24"/>
           <p:cNvSpPr/>
           <p:nvPr/>
         </p:nvSpPr>
@@ -6031,7 +5926,7 @@
       </p:sp>
       <p:sp>
         <p:nvSpPr>
-          <p:cNvPr id="27" name="TextBox 26"/>
+          <p:cNvPr id="26" name="TextBox 25"/>
           <p:cNvSpPr txBox="1"/>
           <p:nvPr/>
         </p:nvSpPr>
@@ -6066,7 +5961,7 @@
       </p:sp>
       <p:sp>
         <p:nvSpPr>
-          <p:cNvPr id="28" name="TextBox 27"/>
+          <p:cNvPr id="27" name="TextBox 26"/>
           <p:cNvSpPr txBox="1"/>
           <p:nvPr/>
         </p:nvSpPr>
@@ -6101,7 +5996,7 @@
       </p:sp>
       <p:sp>
         <p:nvSpPr>
-          <p:cNvPr id="29" name="TextBox 28"/>
+          <p:cNvPr id="28" name="TextBox 27"/>
           <p:cNvSpPr txBox="1"/>
           <p:nvPr/>
         </p:nvSpPr>
@@ -6136,7 +6031,7 @@
       </p:sp>
       <p:sp>
         <p:nvSpPr>
-          <p:cNvPr id="30" name="Rounded Rectangle 29"/>
+          <p:cNvPr id="29" name="Rounded Rectangle 28"/>
           <p:cNvSpPr/>
           <p:nvPr/>
         </p:nvSpPr>
@@ -6184,7 +6079,7 @@
       </p:sp>
       <p:sp>
         <p:nvSpPr>
-          <p:cNvPr id="31" name="Rectangle 30"/>
+          <p:cNvPr id="30" name="Rectangle 29"/>
           <p:cNvSpPr/>
           <p:nvPr/>
         </p:nvSpPr>
@@ -6228,7 +6123,7 @@
       </p:sp>
       <p:sp>
         <p:nvSpPr>
-          <p:cNvPr id="32" name="TextBox 31"/>
+          <p:cNvPr id="31" name="TextBox 30"/>
           <p:cNvSpPr txBox="1"/>
           <p:nvPr/>
         </p:nvSpPr>
@@ -6263,7 +6158,7 @@
       </p:sp>
       <p:sp>
         <p:nvSpPr>
-          <p:cNvPr id="33" name="TextBox 32"/>
+          <p:cNvPr id="32" name="TextBox 31"/>
           <p:cNvSpPr txBox="1"/>
           <p:nvPr/>
         </p:nvSpPr>
@@ -6298,7 +6193,7 @@
       </p:sp>
       <p:sp>
         <p:nvSpPr>
-          <p:cNvPr id="34" name="TextBox 33"/>
+          <p:cNvPr id="33" name="TextBox 32"/>
           <p:cNvSpPr txBox="1"/>
           <p:nvPr/>
         </p:nvSpPr>
@@ -6333,7 +6228,7 @@
       </p:sp>
       <p:sp>
         <p:nvSpPr>
-          <p:cNvPr id="35" name="Rounded Rectangle 34"/>
+          <p:cNvPr id="34" name="Rounded Rectangle 33"/>
           <p:cNvSpPr/>
           <p:nvPr/>
         </p:nvSpPr>
@@ -6381,7 +6276,7 @@
       </p:sp>
       <p:sp>
         <p:nvSpPr>
-          <p:cNvPr id="36" name="Rectangle 35"/>
+          <p:cNvPr id="35" name="Rectangle 34"/>
           <p:cNvSpPr/>
           <p:nvPr/>
         </p:nvSpPr>
@@ -6425,7 +6320,7 @@
       </p:sp>
       <p:sp>
         <p:nvSpPr>
-          <p:cNvPr id="37" name="TextBox 36"/>
+          <p:cNvPr id="36" name="TextBox 35"/>
           <p:cNvSpPr txBox="1"/>
           <p:nvPr/>
         </p:nvSpPr>
@@ -6460,7 +6355,7 @@
       </p:sp>
       <p:sp>
         <p:nvSpPr>
-          <p:cNvPr id="38" name="TextBox 37"/>
+          <p:cNvPr id="37" name="TextBox 36"/>
           <p:cNvSpPr txBox="1"/>
           <p:nvPr/>
         </p:nvSpPr>
@@ -6495,7 +6390,7 @@
       </p:sp>
       <p:sp>
         <p:nvSpPr>
-          <p:cNvPr id="39" name="TextBox 38"/>
+          <p:cNvPr id="38" name="TextBox 37"/>
           <p:cNvSpPr txBox="1"/>
           <p:nvPr/>
         </p:nvSpPr>
@@ -6643,7 +6538,7 @@
         <p:spPr>
           <a:xfrm>
             <a:off x="457200" y="164592"/>
-            <a:ext cx="1828800" cy="329184"/>
+            <a:ext cx="2286000" cy="329184"/>
           </a:xfrm>
           <a:prstGeom prst="rect">
             <a:avLst/>
@@ -6672,41 +6567,6 @@
       <p:sp>
         <p:nvSpPr>
           <p:cNvPr id="5" name="TextBox 4"/>
-          <p:cNvSpPr txBox="1"/>
-          <p:nvPr/>
-        </p:nvSpPr>
-        <p:spPr>
-          <a:xfrm>
-            <a:off x="1691640" y="201168"/>
-            <a:ext cx="822960" cy="274320"/>
-          </a:xfrm>
-          <a:prstGeom prst="rect">
-            <a:avLst/>
-          </a:prstGeom>
-          <a:noFill/>
-        </p:spPr>
-        <p:txBody>
-          <a:bodyPr wrap="square" anchor="t" lIns="0" rIns="0" tIns="0" bIns="0">
-            <a:spAutoFit/>
-          </a:bodyPr>
-          <a:lstStyle/>
-          <a:p>
-            <a:pPr algn="l"/>
-            <a:r>
-              <a:rPr sz="1100" b="1">
-                <a:solidFill>
-                  <a:srgbClr val="2863C5"/>
-                </a:solidFill>
-                <a:latin typeface="Open Sans"/>
-              </a:rPr>
-              <a:t>BETA</a:t>
-            </a:r>
-          </a:p>
-        </p:txBody>
-      </p:sp>
-      <p:sp>
-        <p:nvSpPr>
-          <p:cNvPr id="6" name="TextBox 5"/>
           <p:cNvSpPr txBox="1"/>
           <p:nvPr/>
         </p:nvSpPr>
@@ -6741,7 +6601,7 @@
       </p:sp>
       <p:sp>
         <p:nvSpPr>
-          <p:cNvPr id="7" name="TextBox 6"/>
+          <p:cNvPr id="6" name="TextBox 5"/>
           <p:cNvSpPr txBox="1"/>
           <p:nvPr/>
         </p:nvSpPr>
@@ -6776,7 +6636,7 @@
       </p:sp>
       <p:sp>
         <p:nvSpPr>
-          <p:cNvPr id="8" name="TextBox 7"/>
+          <p:cNvPr id="7" name="TextBox 6"/>
           <p:cNvSpPr txBox="1"/>
           <p:nvPr/>
         </p:nvSpPr>
@@ -6811,7 +6671,7 @@
       </p:sp>
       <p:sp>
         <p:nvSpPr>
-          <p:cNvPr id="9" name="TextBox 8"/>
+          <p:cNvPr id="8" name="TextBox 7"/>
           <p:cNvSpPr txBox="1"/>
           <p:nvPr/>
         </p:nvSpPr>
@@ -6846,7 +6706,7 @@
       </p:sp>
       <p:sp>
         <p:nvSpPr>
-          <p:cNvPr id="10" name="Rounded Rectangle 9"/>
+          <p:cNvPr id="9" name="Rounded Rectangle 8"/>
           <p:cNvSpPr/>
           <p:nvPr/>
         </p:nvSpPr>
@@ -6894,7 +6754,7 @@
       </p:sp>
       <p:sp>
         <p:nvSpPr>
-          <p:cNvPr id="11" name="Rectangle 10"/>
+          <p:cNvPr id="10" name="Rectangle 9"/>
           <p:cNvSpPr/>
           <p:nvPr/>
         </p:nvSpPr>
@@ -6938,7 +6798,7 @@
       </p:sp>
       <p:sp>
         <p:nvSpPr>
-          <p:cNvPr id="12" name="TextBox 11"/>
+          <p:cNvPr id="11" name="TextBox 10"/>
           <p:cNvSpPr txBox="1"/>
           <p:nvPr/>
         </p:nvSpPr>
@@ -6973,7 +6833,7 @@
       </p:sp>
       <p:sp>
         <p:nvSpPr>
-          <p:cNvPr id="13" name="TextBox 12"/>
+          <p:cNvPr id="12" name="TextBox 11"/>
           <p:cNvSpPr txBox="1"/>
           <p:nvPr/>
         </p:nvSpPr>
@@ -7008,7 +6868,7 @@
       </p:sp>
       <p:sp>
         <p:nvSpPr>
-          <p:cNvPr id="14" name="Rounded Rectangle 13"/>
+          <p:cNvPr id="13" name="Rounded Rectangle 12"/>
           <p:cNvSpPr/>
           <p:nvPr/>
         </p:nvSpPr>
@@ -7056,7 +6916,7 @@
       </p:sp>
       <p:sp>
         <p:nvSpPr>
-          <p:cNvPr id="15" name="Rectangle 14"/>
+          <p:cNvPr id="14" name="Rectangle 13"/>
           <p:cNvSpPr/>
           <p:nvPr/>
         </p:nvSpPr>
@@ -7100,7 +6960,7 @@
       </p:sp>
       <p:sp>
         <p:nvSpPr>
-          <p:cNvPr id="16" name="TextBox 15"/>
+          <p:cNvPr id="15" name="TextBox 14"/>
           <p:cNvSpPr txBox="1"/>
           <p:nvPr/>
         </p:nvSpPr>
@@ -7135,7 +6995,7 @@
       </p:sp>
       <p:sp>
         <p:nvSpPr>
-          <p:cNvPr id="17" name="TextBox 16"/>
+          <p:cNvPr id="16" name="TextBox 15"/>
           <p:cNvSpPr txBox="1"/>
           <p:nvPr/>
         </p:nvSpPr>
@@ -7170,7 +7030,7 @@
       </p:sp>
       <p:sp>
         <p:nvSpPr>
-          <p:cNvPr id="18" name="Rounded Rectangle 17"/>
+          <p:cNvPr id="17" name="Rounded Rectangle 16"/>
           <p:cNvSpPr/>
           <p:nvPr/>
         </p:nvSpPr>
@@ -7218,7 +7078,7 @@
       </p:sp>
       <p:sp>
         <p:nvSpPr>
-          <p:cNvPr id="19" name="Rectangle 18"/>
+          <p:cNvPr id="18" name="Rectangle 17"/>
           <p:cNvSpPr/>
           <p:nvPr/>
         </p:nvSpPr>
@@ -7262,7 +7122,7 @@
       </p:sp>
       <p:sp>
         <p:nvSpPr>
-          <p:cNvPr id="20" name="TextBox 19"/>
+          <p:cNvPr id="19" name="TextBox 18"/>
           <p:cNvSpPr txBox="1"/>
           <p:nvPr/>
         </p:nvSpPr>
@@ -7297,7 +7157,7 @@
       </p:sp>
       <p:sp>
         <p:nvSpPr>
-          <p:cNvPr id="21" name="TextBox 20"/>
+          <p:cNvPr id="20" name="TextBox 19"/>
           <p:cNvSpPr txBox="1"/>
           <p:nvPr/>
         </p:nvSpPr>
@@ -7332,7 +7192,7 @@
       </p:sp>
       <p:sp>
         <p:nvSpPr>
-          <p:cNvPr id="22" name="Rounded Rectangle 21"/>
+          <p:cNvPr id="21" name="Rounded Rectangle 20"/>
           <p:cNvSpPr/>
           <p:nvPr/>
         </p:nvSpPr>
@@ -7380,7 +7240,7 @@
       </p:sp>
       <p:sp>
         <p:nvSpPr>
-          <p:cNvPr id="23" name="Rectangle 22"/>
+          <p:cNvPr id="22" name="Rectangle 21"/>
           <p:cNvSpPr/>
           <p:nvPr/>
         </p:nvSpPr>
@@ -7424,7 +7284,7 @@
       </p:sp>
       <p:sp>
         <p:nvSpPr>
-          <p:cNvPr id="24" name="TextBox 23"/>
+          <p:cNvPr id="23" name="TextBox 22"/>
           <p:cNvSpPr txBox="1"/>
           <p:nvPr/>
         </p:nvSpPr>
@@ -7459,7 +7319,7 @@
       </p:sp>
       <p:sp>
         <p:nvSpPr>
-          <p:cNvPr id="25" name="TextBox 24"/>
+          <p:cNvPr id="24" name="TextBox 23"/>
           <p:cNvSpPr txBox="1"/>
           <p:nvPr/>
         </p:nvSpPr>
@@ -7494,7 +7354,7 @@
       </p:sp>
       <p:sp>
         <p:nvSpPr>
-          <p:cNvPr id="26" name="TextBox 25"/>
+          <p:cNvPr id="25" name="TextBox 24"/>
           <p:cNvSpPr txBox="1"/>
           <p:nvPr/>
         </p:nvSpPr>
@@ -7529,7 +7389,7 @@
       </p:sp>
       <p:sp>
         <p:nvSpPr>
-          <p:cNvPr id="27" name="TextBox 26"/>
+          <p:cNvPr id="26" name="TextBox 25"/>
           <p:cNvSpPr txBox="1"/>
           <p:nvPr/>
         </p:nvSpPr>
@@ -7557,14 +7417,14 @@
                 </a:solidFill>
                 <a:latin typeface="Open Sans"/>
               </a:rPr>
-              <a:t>✓  Web app — SmartCredit-themed search UI with the new BETA visual language</a:t>
-            </a:r>
-          </a:p>
-        </p:txBody>
-      </p:sp>
-      <p:sp>
-        <p:nvSpPr>
-          <p:cNvPr id="28" name="TextBox 27"/>
+              <a:t>✓  Web app — SmartCredit-themed search UI matching the production visual language</a:t>
+            </a:r>
+          </a:p>
+        </p:txBody>
+      </p:sp>
+      <p:sp>
+        <p:nvSpPr>
+          <p:cNvPr id="27" name="TextBox 26"/>
           <p:cNvSpPr txBox="1"/>
           <p:nvPr/>
         </p:nvSpPr>
@@ -7599,7 +7459,7 @@
       </p:sp>
       <p:sp>
         <p:nvSpPr>
-          <p:cNvPr id="29" name="TextBox 28"/>
+          <p:cNvPr id="28" name="TextBox 27"/>
           <p:cNvSpPr txBox="1"/>
           <p:nvPr/>
         </p:nvSpPr>
@@ -7634,7 +7494,7 @@
       </p:sp>
       <p:sp>
         <p:nvSpPr>
-          <p:cNvPr id="30" name="TextBox 29"/>
+          <p:cNvPr id="29" name="TextBox 28"/>
           <p:cNvSpPr txBox="1"/>
           <p:nvPr/>
         </p:nvSpPr>
@@ -7669,7 +7529,7 @@
       </p:sp>
       <p:sp>
         <p:nvSpPr>
-          <p:cNvPr id="31" name="Rounded Rectangle 30"/>
+          <p:cNvPr id="30" name="Rounded Rectangle 29"/>
           <p:cNvSpPr/>
           <p:nvPr/>
         </p:nvSpPr>
@@ -7715,7 +7575,7 @@
       </p:sp>
       <p:sp>
         <p:nvSpPr>
-          <p:cNvPr id="32" name="TextBox 31"/>
+          <p:cNvPr id="31" name="TextBox 30"/>
           <p:cNvSpPr txBox="1"/>
           <p:nvPr/>
         </p:nvSpPr>
@@ -7863,7 +7723,7 @@
         <p:spPr>
           <a:xfrm>
             <a:off x="457200" y="164592"/>
-            <a:ext cx="1828800" cy="329184"/>
+            <a:ext cx="2286000" cy="329184"/>
           </a:xfrm>
           <a:prstGeom prst="rect">
             <a:avLst/>
@@ -7892,41 +7752,6 @@
       <p:sp>
         <p:nvSpPr>
           <p:cNvPr id="5" name="TextBox 4"/>
-          <p:cNvSpPr txBox="1"/>
-          <p:nvPr/>
-        </p:nvSpPr>
-        <p:spPr>
-          <a:xfrm>
-            <a:off x="1691640" y="201168"/>
-            <a:ext cx="822960" cy="274320"/>
-          </a:xfrm>
-          <a:prstGeom prst="rect">
-            <a:avLst/>
-          </a:prstGeom>
-          <a:noFill/>
-        </p:spPr>
-        <p:txBody>
-          <a:bodyPr wrap="square" anchor="t" lIns="0" rIns="0" tIns="0" bIns="0">
-            <a:spAutoFit/>
-          </a:bodyPr>
-          <a:lstStyle/>
-          <a:p>
-            <a:pPr algn="l"/>
-            <a:r>
-              <a:rPr sz="1100" b="1">
-                <a:solidFill>
-                  <a:srgbClr val="2863C5"/>
-                </a:solidFill>
-                <a:latin typeface="Open Sans"/>
-              </a:rPr>
-              <a:t>BETA</a:t>
-            </a:r>
-          </a:p>
-        </p:txBody>
-      </p:sp>
-      <p:sp>
-        <p:nvSpPr>
-          <p:cNvPr id="6" name="TextBox 5"/>
           <p:cNvSpPr txBox="1"/>
           <p:nvPr/>
         </p:nvSpPr>
@@ -7961,7 +7786,7 @@
       </p:sp>
       <p:sp>
         <p:nvSpPr>
-          <p:cNvPr id="7" name="TextBox 6"/>
+          <p:cNvPr id="6" name="TextBox 5"/>
           <p:cNvSpPr txBox="1"/>
           <p:nvPr/>
         </p:nvSpPr>
@@ -7996,7 +7821,7 @@
       </p:sp>
       <p:sp>
         <p:nvSpPr>
-          <p:cNvPr id="8" name="TextBox 7"/>
+          <p:cNvPr id="7" name="TextBox 6"/>
           <p:cNvSpPr txBox="1"/>
           <p:nvPr/>
         </p:nvSpPr>
@@ -8031,7 +7856,7 @@
       </p:sp>
       <p:sp>
         <p:nvSpPr>
-          <p:cNvPr id="9" name="TextBox 8"/>
+          <p:cNvPr id="8" name="TextBox 7"/>
           <p:cNvSpPr txBox="1"/>
           <p:nvPr/>
         </p:nvSpPr>
@@ -8066,7 +7891,7 @@
       </p:sp>
       <p:sp>
         <p:nvSpPr>
-          <p:cNvPr id="10" name="Rounded Rectangle 9"/>
+          <p:cNvPr id="9" name="Rounded Rectangle 8"/>
           <p:cNvSpPr/>
           <p:nvPr/>
         </p:nvSpPr>
@@ -8112,7 +7937,7 @@
       </p:sp>
       <p:sp>
         <p:nvSpPr>
-          <p:cNvPr id="11" name="TextBox 10"/>
+          <p:cNvPr id="10" name="TextBox 9"/>
           <p:cNvSpPr txBox="1"/>
           <p:nvPr/>
         </p:nvSpPr>
@@ -8147,7 +7972,7 @@
       </p:sp>
       <p:sp>
         <p:nvSpPr>
-          <p:cNvPr id="12" name="TextBox 11"/>
+          <p:cNvPr id="11" name="TextBox 10"/>
           <p:cNvSpPr txBox="1"/>
           <p:nvPr/>
         </p:nvSpPr>
@@ -8182,7 +8007,7 @@
       </p:sp>
       <p:sp>
         <p:nvSpPr>
-          <p:cNvPr id="13" name="TextBox 12"/>
+          <p:cNvPr id="12" name="TextBox 11"/>
           <p:cNvSpPr txBox="1"/>
           <p:nvPr/>
         </p:nvSpPr>
@@ -8217,7 +8042,7 @@
       </p:sp>
       <p:sp>
         <p:nvSpPr>
-          <p:cNvPr id="14" name="TextBox 13"/>
+          <p:cNvPr id="13" name="TextBox 12"/>
           <p:cNvSpPr txBox="1"/>
           <p:nvPr/>
         </p:nvSpPr>
@@ -8252,7 +8077,7 @@
       </p:sp>
       <p:sp>
         <p:nvSpPr>
-          <p:cNvPr id="15" name="TextBox 14"/>
+          <p:cNvPr id="14" name="TextBox 13"/>
           <p:cNvSpPr txBox="1"/>
           <p:nvPr/>
         </p:nvSpPr>
@@ -8287,7 +8112,7 @@
       </p:sp>
       <p:sp>
         <p:nvSpPr>
-          <p:cNvPr id="16" name="TextBox 15"/>
+          <p:cNvPr id="15" name="TextBox 14"/>
           <p:cNvSpPr txBox="1"/>
           <p:nvPr/>
         </p:nvSpPr>
@@ -8322,7 +8147,7 @@
       </p:sp>
       <p:sp>
         <p:nvSpPr>
-          <p:cNvPr id="17" name="TextBox 16"/>
+          <p:cNvPr id="16" name="TextBox 15"/>
           <p:cNvSpPr txBox="1"/>
           <p:nvPr/>
         </p:nvSpPr>
@@ -8357,7 +8182,7 @@
       </p:sp>
       <p:sp>
         <p:nvSpPr>
-          <p:cNvPr id="18" name="Rounded Rectangle 17"/>
+          <p:cNvPr id="17" name="Rounded Rectangle 16"/>
           <p:cNvSpPr/>
           <p:nvPr/>
         </p:nvSpPr>
@@ -8405,7 +8230,7 @@
       </p:sp>
       <p:sp>
         <p:nvSpPr>
-          <p:cNvPr id="19" name="Rectangle 18"/>
+          <p:cNvPr id="18" name="Rectangle 17"/>
           <p:cNvSpPr/>
           <p:nvPr/>
         </p:nvSpPr>
@@ -8449,7 +8274,7 @@
       </p:sp>
       <p:sp>
         <p:nvSpPr>
-          <p:cNvPr id="20" name="TextBox 19"/>
+          <p:cNvPr id="19" name="TextBox 18"/>
           <p:cNvSpPr txBox="1"/>
           <p:nvPr/>
         </p:nvSpPr>
@@ -8484,7 +8309,7 @@
       </p:sp>
       <p:sp>
         <p:nvSpPr>
-          <p:cNvPr id="21" name="TextBox 20"/>
+          <p:cNvPr id="20" name="TextBox 19"/>
           <p:cNvSpPr txBox="1"/>
           <p:nvPr/>
         </p:nvSpPr>
@@ -8519,7 +8344,7 @@
       </p:sp>
       <p:sp>
         <p:nvSpPr>
-          <p:cNvPr id="22" name="Rounded Rectangle 21"/>
+          <p:cNvPr id="21" name="Rounded Rectangle 20"/>
           <p:cNvSpPr/>
           <p:nvPr/>
         </p:nvSpPr>
@@ -8567,7 +8392,7 @@
       </p:sp>
       <p:sp>
         <p:nvSpPr>
-          <p:cNvPr id="23" name="Rectangle 22"/>
+          <p:cNvPr id="22" name="Rectangle 21"/>
           <p:cNvSpPr/>
           <p:nvPr/>
         </p:nvSpPr>
@@ -8611,7 +8436,7 @@
       </p:sp>
       <p:sp>
         <p:nvSpPr>
-          <p:cNvPr id="24" name="TextBox 23"/>
+          <p:cNvPr id="23" name="TextBox 22"/>
           <p:cNvSpPr txBox="1"/>
           <p:nvPr/>
         </p:nvSpPr>
@@ -8646,7 +8471,7 @@
       </p:sp>
       <p:sp>
         <p:nvSpPr>
-          <p:cNvPr id="25" name="TextBox 24"/>
+          <p:cNvPr id="24" name="TextBox 23"/>
           <p:cNvSpPr txBox="1"/>
           <p:nvPr/>
         </p:nvSpPr>
@@ -8681,7 +8506,7 @@
       </p:sp>
       <p:sp>
         <p:nvSpPr>
-          <p:cNvPr id="26" name="Rounded Rectangle 25"/>
+          <p:cNvPr id="25" name="Rounded Rectangle 24"/>
           <p:cNvSpPr/>
           <p:nvPr/>
         </p:nvSpPr>
@@ -8729,7 +8554,7 @@
       </p:sp>
       <p:sp>
         <p:nvSpPr>
-          <p:cNvPr id="27" name="Rectangle 26"/>
+          <p:cNvPr id="26" name="Rectangle 25"/>
           <p:cNvSpPr/>
           <p:nvPr/>
         </p:nvSpPr>
@@ -8773,7 +8598,7 @@
       </p:sp>
       <p:sp>
         <p:nvSpPr>
-          <p:cNvPr id="28" name="TextBox 27"/>
+          <p:cNvPr id="27" name="TextBox 26"/>
           <p:cNvSpPr txBox="1"/>
           <p:nvPr/>
         </p:nvSpPr>
@@ -8808,7 +8633,7 @@
       </p:sp>
       <p:sp>
         <p:nvSpPr>
-          <p:cNvPr id="29" name="TextBox 28"/>
+          <p:cNvPr id="28" name="TextBox 27"/>
           <p:cNvSpPr txBox="1"/>
           <p:nvPr/>
         </p:nvSpPr>
@@ -8843,7 +8668,7 @@
       </p:sp>
       <p:sp>
         <p:nvSpPr>
-          <p:cNvPr id="30" name="Rounded Rectangle 29"/>
+          <p:cNvPr id="29" name="Rounded Rectangle 28"/>
           <p:cNvSpPr/>
           <p:nvPr/>
         </p:nvSpPr>
@@ -8891,7 +8716,7 @@
       </p:sp>
       <p:sp>
         <p:nvSpPr>
-          <p:cNvPr id="31" name="Rectangle 30"/>
+          <p:cNvPr id="30" name="Rectangle 29"/>
           <p:cNvSpPr/>
           <p:nvPr/>
         </p:nvSpPr>
@@ -8935,7 +8760,7 @@
       </p:sp>
       <p:sp>
         <p:nvSpPr>
-          <p:cNvPr id="32" name="TextBox 31"/>
+          <p:cNvPr id="31" name="TextBox 30"/>
           <p:cNvSpPr txBox="1"/>
           <p:nvPr/>
         </p:nvSpPr>
@@ -8970,7 +8795,7 @@
       </p:sp>
       <p:sp>
         <p:nvSpPr>
-          <p:cNvPr id="33" name="TextBox 32"/>
+          <p:cNvPr id="32" name="TextBox 31"/>
           <p:cNvSpPr txBox="1"/>
           <p:nvPr/>
         </p:nvSpPr>
@@ -9005,7 +8830,7 @@
       </p:sp>
       <p:sp>
         <p:nvSpPr>
-          <p:cNvPr id="34" name="Rectangle 33"/>
+          <p:cNvPr id="33" name="Rectangle 32"/>
           <p:cNvSpPr/>
           <p:nvPr/>
         </p:nvSpPr>
@@ -9408,7 +9233,7 @@
         <p:spPr>
           <a:xfrm>
             <a:off x="457200" y="164592"/>
-            <a:ext cx="1828800" cy="329184"/>
+            <a:ext cx="2286000" cy="329184"/>
           </a:xfrm>
           <a:prstGeom prst="rect">
             <a:avLst/>
@@ -9437,41 +9262,6 @@
       <p:sp>
         <p:nvSpPr>
           <p:cNvPr id="5" name="TextBox 4"/>
-          <p:cNvSpPr txBox="1"/>
-          <p:nvPr/>
-        </p:nvSpPr>
-        <p:spPr>
-          <a:xfrm>
-            <a:off x="1691640" y="201168"/>
-            <a:ext cx="822960" cy="274320"/>
-          </a:xfrm>
-          <a:prstGeom prst="rect">
-            <a:avLst/>
-          </a:prstGeom>
-          <a:noFill/>
-        </p:spPr>
-        <p:txBody>
-          <a:bodyPr wrap="square" anchor="t" lIns="0" rIns="0" tIns="0" bIns="0">
-            <a:spAutoFit/>
-          </a:bodyPr>
-          <a:lstStyle/>
-          <a:p>
-            <a:pPr algn="l"/>
-            <a:r>
-              <a:rPr sz="1100" b="1">
-                <a:solidFill>
-                  <a:srgbClr val="2863C5"/>
-                </a:solidFill>
-                <a:latin typeface="Open Sans"/>
-              </a:rPr>
-              <a:t>BETA</a:t>
-            </a:r>
-          </a:p>
-        </p:txBody>
-      </p:sp>
-      <p:sp>
-        <p:nvSpPr>
-          <p:cNvPr id="6" name="TextBox 5"/>
           <p:cNvSpPr txBox="1"/>
           <p:nvPr/>
         </p:nvSpPr>
@@ -9506,7 +9296,7 @@
       </p:sp>
       <p:sp>
         <p:nvSpPr>
-          <p:cNvPr id="7" name="TextBox 6"/>
+          <p:cNvPr id="6" name="TextBox 5"/>
           <p:cNvSpPr txBox="1"/>
           <p:nvPr/>
         </p:nvSpPr>
@@ -9541,7 +9331,7 @@
       </p:sp>
       <p:sp>
         <p:nvSpPr>
-          <p:cNvPr id="8" name="TextBox 7"/>
+          <p:cNvPr id="7" name="TextBox 6"/>
           <p:cNvSpPr txBox="1"/>
           <p:nvPr/>
         </p:nvSpPr>
@@ -9576,7 +9366,7 @@
       </p:sp>
       <p:sp>
         <p:nvSpPr>
-          <p:cNvPr id="9" name="TextBox 8"/>
+          <p:cNvPr id="8" name="TextBox 7"/>
           <p:cNvSpPr txBox="1"/>
           <p:nvPr/>
         </p:nvSpPr>
@@ -9611,7 +9401,7 @@
       </p:sp>
       <p:sp>
         <p:nvSpPr>
-          <p:cNvPr id="10" name="TextBox 9"/>
+          <p:cNvPr id="9" name="TextBox 8"/>
           <p:cNvSpPr txBox="1"/>
           <p:nvPr/>
         </p:nvSpPr>
@@ -9646,7 +9436,7 @@
       </p:sp>
       <p:sp>
         <p:nvSpPr>
-          <p:cNvPr id="11" name="Rounded Rectangle 10"/>
+          <p:cNvPr id="10" name="Rounded Rectangle 9"/>
           <p:cNvSpPr/>
           <p:nvPr/>
         </p:nvSpPr>
@@ -9694,7 +9484,7 @@
       </p:sp>
       <p:sp>
         <p:nvSpPr>
-          <p:cNvPr id="12" name="TextBox 11"/>
+          <p:cNvPr id="11" name="TextBox 10"/>
           <p:cNvSpPr txBox="1"/>
           <p:nvPr/>
         </p:nvSpPr>
@@ -9729,7 +9519,7 @@
       </p:sp>
       <p:sp>
         <p:nvSpPr>
-          <p:cNvPr id="13" name="TextBox 12"/>
+          <p:cNvPr id="12" name="TextBox 11"/>
           <p:cNvSpPr txBox="1"/>
           <p:nvPr/>
         </p:nvSpPr>
@@ -9764,7 +9554,7 @@
       </p:sp>
       <p:sp>
         <p:nvSpPr>
-          <p:cNvPr id="14" name="Rounded Rectangle 13"/>
+          <p:cNvPr id="13" name="Rounded Rectangle 12"/>
           <p:cNvSpPr/>
           <p:nvPr/>
         </p:nvSpPr>
@@ -9812,7 +9602,7 @@
       </p:sp>
       <p:sp>
         <p:nvSpPr>
-          <p:cNvPr id="15" name="TextBox 14"/>
+          <p:cNvPr id="14" name="TextBox 13"/>
           <p:cNvSpPr txBox="1"/>
           <p:nvPr/>
         </p:nvSpPr>
@@ -9847,7 +9637,7 @@
       </p:sp>
       <p:sp>
         <p:nvSpPr>
-          <p:cNvPr id="16" name="TextBox 15"/>
+          <p:cNvPr id="15" name="TextBox 14"/>
           <p:cNvSpPr txBox="1"/>
           <p:nvPr/>
         </p:nvSpPr>
@@ -9882,7 +9672,7 @@
       </p:sp>
       <p:sp>
         <p:nvSpPr>
-          <p:cNvPr id="17" name="Rounded Rectangle 16"/>
+          <p:cNvPr id="16" name="Rounded Rectangle 15"/>
           <p:cNvSpPr/>
           <p:nvPr/>
         </p:nvSpPr>
@@ -9930,7 +9720,7 @@
       </p:sp>
       <p:sp>
         <p:nvSpPr>
-          <p:cNvPr id="18" name="TextBox 17"/>
+          <p:cNvPr id="17" name="TextBox 16"/>
           <p:cNvSpPr txBox="1"/>
           <p:nvPr/>
         </p:nvSpPr>
@@ -9965,7 +9755,7 @@
       </p:sp>
       <p:sp>
         <p:nvSpPr>
-          <p:cNvPr id="19" name="TextBox 18"/>
+          <p:cNvPr id="18" name="TextBox 17"/>
           <p:cNvSpPr txBox="1"/>
           <p:nvPr/>
         </p:nvSpPr>
@@ -10113,7 +9903,7 @@
         <p:spPr>
           <a:xfrm>
             <a:off x="457200" y="164592"/>
-            <a:ext cx="1828800" cy="329184"/>
+            <a:ext cx="2286000" cy="329184"/>
           </a:xfrm>
           <a:prstGeom prst="rect">
             <a:avLst/>
@@ -10142,41 +9932,6 @@
       <p:sp>
         <p:nvSpPr>
           <p:cNvPr id="5" name="TextBox 4"/>
-          <p:cNvSpPr txBox="1"/>
-          <p:nvPr/>
-        </p:nvSpPr>
-        <p:spPr>
-          <a:xfrm>
-            <a:off x="1691640" y="201168"/>
-            <a:ext cx="822960" cy="274320"/>
-          </a:xfrm>
-          <a:prstGeom prst="rect">
-            <a:avLst/>
-          </a:prstGeom>
-          <a:noFill/>
-        </p:spPr>
-        <p:txBody>
-          <a:bodyPr wrap="square" anchor="t" lIns="0" rIns="0" tIns="0" bIns="0">
-            <a:spAutoFit/>
-          </a:bodyPr>
-          <a:lstStyle/>
-          <a:p>
-            <a:pPr algn="l"/>
-            <a:r>
-              <a:rPr sz="1100" b="1">
-                <a:solidFill>
-                  <a:srgbClr val="2863C5"/>
-                </a:solidFill>
-                <a:latin typeface="Open Sans"/>
-              </a:rPr>
-              <a:t>BETA</a:t>
-            </a:r>
-          </a:p>
-        </p:txBody>
-      </p:sp>
-      <p:sp>
-        <p:nvSpPr>
-          <p:cNvPr id="6" name="TextBox 5"/>
           <p:cNvSpPr txBox="1"/>
           <p:nvPr/>
         </p:nvSpPr>
@@ -10211,7 +9966,7 @@
       </p:sp>
       <p:sp>
         <p:nvSpPr>
-          <p:cNvPr id="7" name="TextBox 6"/>
+          <p:cNvPr id="6" name="TextBox 5"/>
           <p:cNvSpPr txBox="1"/>
           <p:nvPr/>
         </p:nvSpPr>
@@ -10246,7 +10001,7 @@
       </p:sp>
       <p:sp>
         <p:nvSpPr>
-          <p:cNvPr id="8" name="TextBox 7"/>
+          <p:cNvPr id="7" name="TextBox 6"/>
           <p:cNvSpPr txBox="1"/>
           <p:nvPr/>
         </p:nvSpPr>
@@ -10281,7 +10036,7 @@
       </p:sp>
       <p:sp>
         <p:nvSpPr>
-          <p:cNvPr id="9" name="TextBox 8"/>
+          <p:cNvPr id="8" name="TextBox 7"/>
           <p:cNvSpPr txBox="1"/>
           <p:nvPr/>
         </p:nvSpPr>
@@ -10317,7 +10072,7 @@
       </p:sp>
       <p:sp>
         <p:nvSpPr>
-          <p:cNvPr id="10" name="TextBox 9"/>
+          <p:cNvPr id="9" name="TextBox 8"/>
           <p:cNvSpPr txBox="1"/>
           <p:nvPr/>
         </p:nvSpPr>
@@ -10352,7 +10107,7 @@
       </p:sp>
       <p:sp>
         <p:nvSpPr>
-          <p:cNvPr id="11" name="Rounded Rectangle 10"/>
+          <p:cNvPr id="10" name="Rounded Rectangle 9"/>
           <p:cNvSpPr/>
           <p:nvPr/>
         </p:nvSpPr>
@@ -10400,7 +10155,7 @@
       </p:sp>
       <p:sp>
         <p:nvSpPr>
-          <p:cNvPr id="12" name="Rounded Rectangle 11"/>
+          <p:cNvPr id="11" name="Rounded Rectangle 10"/>
           <p:cNvSpPr/>
           <p:nvPr/>
         </p:nvSpPr>
@@ -10454,7 +10209,7 @@
       </p:sp>
       <p:sp>
         <p:nvSpPr>
-          <p:cNvPr id="13" name="TextBox 12"/>
+          <p:cNvPr id="12" name="TextBox 11"/>
           <p:cNvSpPr txBox="1"/>
           <p:nvPr/>
         </p:nvSpPr>
@@ -10489,7 +10244,7 @@
       </p:sp>
       <p:sp>
         <p:nvSpPr>
-          <p:cNvPr id="14" name="TextBox 13"/>
+          <p:cNvPr id="13" name="TextBox 12"/>
           <p:cNvSpPr txBox="1"/>
           <p:nvPr/>
         </p:nvSpPr>
@@ -10524,7 +10279,7 @@
       </p:sp>
       <p:sp>
         <p:nvSpPr>
-          <p:cNvPr id="15" name="Rounded Rectangle 14"/>
+          <p:cNvPr id="14" name="Rounded Rectangle 13"/>
           <p:cNvSpPr/>
           <p:nvPr/>
         </p:nvSpPr>
@@ -10572,7 +10327,7 @@
       </p:sp>
       <p:sp>
         <p:nvSpPr>
-          <p:cNvPr id="16" name="Rounded Rectangle 15"/>
+          <p:cNvPr id="15" name="Rounded Rectangle 14"/>
           <p:cNvSpPr/>
           <p:nvPr/>
         </p:nvSpPr>
@@ -10626,7 +10381,7 @@
       </p:sp>
       <p:sp>
         <p:nvSpPr>
-          <p:cNvPr id="17" name="TextBox 16"/>
+          <p:cNvPr id="16" name="TextBox 15"/>
           <p:cNvSpPr txBox="1"/>
           <p:nvPr/>
         </p:nvSpPr>
@@ -10661,7 +10416,7 @@
       </p:sp>
       <p:sp>
         <p:nvSpPr>
-          <p:cNvPr id="18" name="TextBox 17"/>
+          <p:cNvPr id="17" name="TextBox 16"/>
           <p:cNvSpPr txBox="1"/>
           <p:nvPr/>
         </p:nvSpPr>
@@ -10696,7 +10451,7 @@
       </p:sp>
       <p:sp>
         <p:nvSpPr>
-          <p:cNvPr id="19" name="Rounded Rectangle 18"/>
+          <p:cNvPr id="18" name="Rounded Rectangle 17"/>
           <p:cNvSpPr/>
           <p:nvPr/>
         </p:nvSpPr>
@@ -10744,7 +10499,7 @@
       </p:sp>
       <p:sp>
         <p:nvSpPr>
-          <p:cNvPr id="20" name="Rounded Rectangle 19"/>
+          <p:cNvPr id="19" name="Rounded Rectangle 18"/>
           <p:cNvSpPr/>
           <p:nvPr/>
         </p:nvSpPr>
@@ -10798,7 +10553,7 @@
       </p:sp>
       <p:sp>
         <p:nvSpPr>
-          <p:cNvPr id="21" name="TextBox 20"/>
+          <p:cNvPr id="20" name="TextBox 19"/>
           <p:cNvSpPr txBox="1"/>
           <p:nvPr/>
         </p:nvSpPr>
@@ -10833,7 +10588,7 @@
       </p:sp>
       <p:sp>
         <p:nvSpPr>
-          <p:cNvPr id="22" name="TextBox 21"/>
+          <p:cNvPr id="21" name="TextBox 20"/>
           <p:cNvSpPr txBox="1"/>
           <p:nvPr/>
         </p:nvSpPr>
@@ -10868,7 +10623,7 @@
       </p:sp>
       <p:sp>
         <p:nvSpPr>
-          <p:cNvPr id="23" name="TextBox 22"/>
+          <p:cNvPr id="22" name="TextBox 21"/>
           <p:cNvSpPr txBox="1"/>
           <p:nvPr/>
         </p:nvSpPr>
@@ -10903,7 +10658,7 @@
       </p:sp>
       <p:sp>
         <p:nvSpPr>
-          <p:cNvPr id="24" name="Rounded Rectangle 23"/>
+          <p:cNvPr id="23" name="Rounded Rectangle 22"/>
           <p:cNvSpPr/>
           <p:nvPr/>
         </p:nvSpPr>
@@ -10951,7 +10706,7 @@
       </p:sp>
       <p:sp>
         <p:nvSpPr>
-          <p:cNvPr id="25" name="TextBox 24"/>
+          <p:cNvPr id="24" name="TextBox 23"/>
           <p:cNvSpPr txBox="1"/>
           <p:nvPr/>
         </p:nvSpPr>
@@ -10986,7 +10741,7 @@
       </p:sp>
       <p:sp>
         <p:nvSpPr>
-          <p:cNvPr id="26" name="TextBox 25"/>
+          <p:cNvPr id="25" name="TextBox 24"/>
           <p:cNvSpPr txBox="1"/>
           <p:nvPr/>
         </p:nvSpPr>
@@ -11021,7 +10776,7 @@
       </p:sp>
       <p:sp>
         <p:nvSpPr>
-          <p:cNvPr id="27" name="TextBox 26"/>
+          <p:cNvPr id="26" name="TextBox 25"/>
           <p:cNvSpPr txBox="1"/>
           <p:nvPr/>
         </p:nvSpPr>
@@ -11056,7 +10811,7 @@
       </p:sp>
       <p:sp>
         <p:nvSpPr>
-          <p:cNvPr id="28" name="Rounded Rectangle 27"/>
+          <p:cNvPr id="27" name="Rounded Rectangle 26"/>
           <p:cNvSpPr/>
           <p:nvPr/>
         </p:nvSpPr>
@@ -11110,7 +10865,7 @@
       </p:sp>
       <p:sp>
         <p:nvSpPr>
-          <p:cNvPr id="29" name="TextBox 28"/>
+          <p:cNvPr id="28" name="TextBox 27"/>
           <p:cNvSpPr txBox="1"/>
           <p:nvPr/>
         </p:nvSpPr>
@@ -11145,7 +10900,7 @@
       </p:sp>
       <p:sp>
         <p:nvSpPr>
-          <p:cNvPr id="30" name="TextBox 29"/>
+          <p:cNvPr id="29" name="TextBox 28"/>
           <p:cNvSpPr txBox="1"/>
           <p:nvPr/>
         </p:nvSpPr>
@@ -11180,7 +10935,7 @@
       </p:sp>
       <p:sp>
         <p:nvSpPr>
-          <p:cNvPr id="31" name="Rounded Rectangle 30"/>
+          <p:cNvPr id="30" name="Rounded Rectangle 29"/>
           <p:cNvSpPr/>
           <p:nvPr/>
         </p:nvSpPr>
@@ -11234,7 +10989,7 @@
       </p:sp>
       <p:sp>
         <p:nvSpPr>
-          <p:cNvPr id="32" name="TextBox 31"/>
+          <p:cNvPr id="31" name="TextBox 30"/>
           <p:cNvSpPr txBox="1"/>
           <p:nvPr/>
         </p:nvSpPr>
@@ -11382,7 +11137,7 @@
         <p:spPr>
           <a:xfrm>
             <a:off x="457200" y="164592"/>
-            <a:ext cx="1828800" cy="329184"/>
+            <a:ext cx="2286000" cy="329184"/>
           </a:xfrm>
           <a:prstGeom prst="rect">
             <a:avLst/>
@@ -11411,41 +11166,6 @@
       <p:sp>
         <p:nvSpPr>
           <p:cNvPr id="5" name="TextBox 4"/>
-          <p:cNvSpPr txBox="1"/>
-          <p:nvPr/>
-        </p:nvSpPr>
-        <p:spPr>
-          <a:xfrm>
-            <a:off x="1691640" y="201168"/>
-            <a:ext cx="822960" cy="274320"/>
-          </a:xfrm>
-          <a:prstGeom prst="rect">
-            <a:avLst/>
-          </a:prstGeom>
-          <a:noFill/>
-        </p:spPr>
-        <p:txBody>
-          <a:bodyPr wrap="square" anchor="t" lIns="0" rIns="0" tIns="0" bIns="0">
-            <a:spAutoFit/>
-          </a:bodyPr>
-          <a:lstStyle/>
-          <a:p>
-            <a:pPr algn="l"/>
-            <a:r>
-              <a:rPr sz="1100" b="1">
-                <a:solidFill>
-                  <a:srgbClr val="2863C5"/>
-                </a:solidFill>
-                <a:latin typeface="Open Sans"/>
-              </a:rPr>
-              <a:t>BETA</a:t>
-            </a:r>
-          </a:p>
-        </p:txBody>
-      </p:sp>
-      <p:sp>
-        <p:nvSpPr>
-          <p:cNvPr id="6" name="TextBox 5"/>
           <p:cNvSpPr txBox="1"/>
           <p:nvPr/>
         </p:nvSpPr>
@@ -11480,7 +11200,7 @@
       </p:sp>
       <p:sp>
         <p:nvSpPr>
-          <p:cNvPr id="7" name="TextBox 6"/>
+          <p:cNvPr id="6" name="TextBox 5"/>
           <p:cNvSpPr txBox="1"/>
           <p:nvPr/>
         </p:nvSpPr>
@@ -11515,7 +11235,7 @@
       </p:sp>
       <p:sp>
         <p:nvSpPr>
-          <p:cNvPr id="8" name="TextBox 7"/>
+          <p:cNvPr id="7" name="TextBox 6"/>
           <p:cNvSpPr txBox="1"/>
           <p:nvPr/>
         </p:nvSpPr>
@@ -11550,7 +11270,7 @@
       </p:sp>
       <p:sp>
         <p:nvSpPr>
-          <p:cNvPr id="9" name="TextBox 8"/>
+          <p:cNvPr id="8" name="TextBox 7"/>
           <p:cNvSpPr txBox="1"/>
           <p:nvPr/>
         </p:nvSpPr>
@@ -11585,7 +11305,7 @@
       </p:sp>
       <p:sp>
         <p:nvSpPr>
-          <p:cNvPr id="10" name="Rounded Rectangle 9"/>
+          <p:cNvPr id="9" name="Rounded Rectangle 8"/>
           <p:cNvSpPr/>
           <p:nvPr/>
         </p:nvSpPr>
@@ -11633,7 +11353,7 @@
       </p:sp>
       <p:sp>
         <p:nvSpPr>
-          <p:cNvPr id="11" name="TextBox 10"/>
+          <p:cNvPr id="10" name="TextBox 9"/>
           <p:cNvSpPr txBox="1"/>
           <p:nvPr/>
         </p:nvSpPr>
@@ -11668,7 +11388,7 @@
       </p:sp>
       <p:sp>
         <p:nvSpPr>
-          <p:cNvPr id="12" name="TextBox 11"/>
+          <p:cNvPr id="11" name="TextBox 10"/>
           <p:cNvSpPr txBox="1"/>
           <p:nvPr/>
         </p:nvSpPr>
@@ -11703,7 +11423,7 @@
       </p:sp>
       <p:sp>
         <p:nvSpPr>
-          <p:cNvPr id="13" name="TextBox 12"/>
+          <p:cNvPr id="12" name="TextBox 11"/>
           <p:cNvSpPr txBox="1"/>
           <p:nvPr/>
         </p:nvSpPr>
@@ -11738,7 +11458,7 @@
       </p:sp>
       <p:sp>
         <p:nvSpPr>
-          <p:cNvPr id="14" name="Rounded Rectangle 13"/>
+          <p:cNvPr id="13" name="Rounded Rectangle 12"/>
           <p:cNvSpPr/>
           <p:nvPr/>
         </p:nvSpPr>
@@ -11786,7 +11506,7 @@
       </p:sp>
       <p:sp>
         <p:nvSpPr>
-          <p:cNvPr id="15" name="TextBox 14"/>
+          <p:cNvPr id="14" name="TextBox 13"/>
           <p:cNvSpPr txBox="1"/>
           <p:nvPr/>
         </p:nvSpPr>
@@ -11821,7 +11541,7 @@
       </p:sp>
       <p:sp>
         <p:nvSpPr>
-          <p:cNvPr id="16" name="TextBox 15"/>
+          <p:cNvPr id="15" name="TextBox 14"/>
           <p:cNvSpPr txBox="1"/>
           <p:nvPr/>
         </p:nvSpPr>
@@ -11856,7 +11576,7 @@
       </p:sp>
       <p:sp>
         <p:nvSpPr>
-          <p:cNvPr id="17" name="TextBox 16"/>
+          <p:cNvPr id="16" name="TextBox 15"/>
           <p:cNvSpPr txBox="1"/>
           <p:nvPr/>
         </p:nvSpPr>
@@ -11891,7 +11611,7 @@
       </p:sp>
       <p:sp>
         <p:nvSpPr>
-          <p:cNvPr id="18" name="Rounded Rectangle 17"/>
+          <p:cNvPr id="17" name="Rounded Rectangle 16"/>
           <p:cNvSpPr/>
           <p:nvPr/>
         </p:nvSpPr>
@@ -11939,7 +11659,7 @@
       </p:sp>
       <p:sp>
         <p:nvSpPr>
-          <p:cNvPr id="19" name="TextBox 18"/>
+          <p:cNvPr id="18" name="TextBox 17"/>
           <p:cNvSpPr txBox="1"/>
           <p:nvPr/>
         </p:nvSpPr>
@@ -11974,7 +11694,7 @@
       </p:sp>
       <p:sp>
         <p:nvSpPr>
-          <p:cNvPr id="20" name="TextBox 19"/>
+          <p:cNvPr id="19" name="TextBox 18"/>
           <p:cNvSpPr txBox="1"/>
           <p:nvPr/>
         </p:nvSpPr>
@@ -12009,7 +11729,7 @@
       </p:sp>
       <p:sp>
         <p:nvSpPr>
-          <p:cNvPr id="21" name="TextBox 20"/>
+          <p:cNvPr id="20" name="TextBox 19"/>
           <p:cNvSpPr txBox="1"/>
           <p:nvPr/>
         </p:nvSpPr>
@@ -12044,7 +11764,7 @@
       </p:sp>
       <p:sp>
         <p:nvSpPr>
-          <p:cNvPr id="22" name="Rectangle 21"/>
+          <p:cNvPr id="21" name="Rectangle 20"/>
           <p:cNvSpPr/>
           <p:nvPr/>
         </p:nvSpPr>
@@ -12088,7 +11808,7 @@
       </p:sp>
       <p:sp>
         <p:nvSpPr>
-          <p:cNvPr id="23" name="TextBox 22"/>
+          <p:cNvPr id="22" name="TextBox 21"/>
           <p:cNvSpPr txBox="1"/>
           <p:nvPr/>
         </p:nvSpPr>
@@ -12236,7 +11956,7 @@
         <p:spPr>
           <a:xfrm>
             <a:off x="457200" y="164592"/>
-            <a:ext cx="1828800" cy="329184"/>
+            <a:ext cx="2286000" cy="329184"/>
           </a:xfrm>
           <a:prstGeom prst="rect">
             <a:avLst/>
@@ -12265,41 +11985,6 @@
       <p:sp>
         <p:nvSpPr>
           <p:cNvPr id="5" name="TextBox 4"/>
-          <p:cNvSpPr txBox="1"/>
-          <p:nvPr/>
-        </p:nvSpPr>
-        <p:spPr>
-          <a:xfrm>
-            <a:off x="1691640" y="201168"/>
-            <a:ext cx="822960" cy="274320"/>
-          </a:xfrm>
-          <a:prstGeom prst="rect">
-            <a:avLst/>
-          </a:prstGeom>
-          <a:noFill/>
-        </p:spPr>
-        <p:txBody>
-          <a:bodyPr wrap="square" anchor="t" lIns="0" rIns="0" tIns="0" bIns="0">
-            <a:spAutoFit/>
-          </a:bodyPr>
-          <a:lstStyle/>
-          <a:p>
-            <a:pPr algn="l"/>
-            <a:r>
-              <a:rPr sz="1100" b="1">
-                <a:solidFill>
-                  <a:srgbClr val="2863C5"/>
-                </a:solidFill>
-                <a:latin typeface="Open Sans"/>
-              </a:rPr>
-              <a:t>BETA</a:t>
-            </a:r>
-          </a:p>
-        </p:txBody>
-      </p:sp>
-      <p:sp>
-        <p:nvSpPr>
-          <p:cNvPr id="6" name="TextBox 5"/>
           <p:cNvSpPr txBox="1"/>
           <p:nvPr/>
         </p:nvSpPr>
@@ -12334,7 +12019,7 @@
       </p:sp>
       <p:sp>
         <p:nvSpPr>
-          <p:cNvPr id="7" name="TextBox 6"/>
+          <p:cNvPr id="6" name="TextBox 5"/>
           <p:cNvSpPr txBox="1"/>
           <p:nvPr/>
         </p:nvSpPr>
@@ -12369,7 +12054,7 @@
       </p:sp>
       <p:sp>
         <p:nvSpPr>
-          <p:cNvPr id="8" name="TextBox 7"/>
+          <p:cNvPr id="7" name="TextBox 6"/>
           <p:cNvSpPr txBox="1"/>
           <p:nvPr/>
         </p:nvSpPr>
@@ -12404,7 +12089,7 @@
       </p:sp>
       <p:sp>
         <p:nvSpPr>
-          <p:cNvPr id="9" name="TextBox 8"/>
+          <p:cNvPr id="8" name="TextBox 7"/>
           <p:cNvSpPr txBox="1"/>
           <p:nvPr/>
         </p:nvSpPr>
@@ -12439,7 +12124,7 @@
       </p:sp>
       <p:sp>
         <p:nvSpPr>
-          <p:cNvPr id="10" name="TextBox 9"/>
+          <p:cNvPr id="9" name="TextBox 8"/>
           <p:cNvSpPr txBox="1"/>
           <p:nvPr/>
         </p:nvSpPr>
@@ -12474,7 +12159,7 @@
       </p:sp>
       <p:sp>
         <p:nvSpPr>
-          <p:cNvPr id="11" name="Rounded Rectangle 10"/>
+          <p:cNvPr id="10" name="Rounded Rectangle 9"/>
           <p:cNvSpPr/>
           <p:nvPr/>
         </p:nvSpPr>
@@ -12522,7 +12207,7 @@
       </p:sp>
       <p:sp>
         <p:nvSpPr>
-          <p:cNvPr id="12" name="Rectangle 11"/>
+          <p:cNvPr id="11" name="Rectangle 10"/>
           <p:cNvSpPr/>
           <p:nvPr/>
         </p:nvSpPr>
@@ -12566,7 +12251,7 @@
       </p:sp>
       <p:sp>
         <p:nvSpPr>
-          <p:cNvPr id="13" name="TextBox 12"/>
+          <p:cNvPr id="12" name="TextBox 11"/>
           <p:cNvSpPr txBox="1"/>
           <p:nvPr/>
         </p:nvSpPr>
@@ -12601,7 +12286,7 @@
       </p:sp>
       <p:sp>
         <p:nvSpPr>
-          <p:cNvPr id="14" name="TextBox 13"/>
+          <p:cNvPr id="13" name="TextBox 12"/>
           <p:cNvSpPr txBox="1"/>
           <p:nvPr/>
         </p:nvSpPr>
@@ -12636,7 +12321,7 @@
       </p:sp>
       <p:sp>
         <p:nvSpPr>
-          <p:cNvPr id="15" name="TextBox 14"/>
+          <p:cNvPr id="14" name="TextBox 13"/>
           <p:cNvSpPr txBox="1"/>
           <p:nvPr/>
         </p:nvSpPr>
@@ -12671,7 +12356,7 @@
       </p:sp>
       <p:sp>
         <p:nvSpPr>
-          <p:cNvPr id="16" name="TextBox 15"/>
+          <p:cNvPr id="15" name="TextBox 14"/>
           <p:cNvSpPr txBox="1"/>
           <p:nvPr/>
         </p:nvSpPr>
@@ -12706,7 +12391,7 @@
       </p:sp>
       <p:sp>
         <p:nvSpPr>
-          <p:cNvPr id="17" name="TextBox 16"/>
+          <p:cNvPr id="16" name="TextBox 15"/>
           <p:cNvSpPr txBox="1"/>
           <p:nvPr/>
         </p:nvSpPr>
@@ -12741,7 +12426,7 @@
       </p:sp>
       <p:sp>
         <p:nvSpPr>
-          <p:cNvPr id="18" name="TextBox 17"/>
+          <p:cNvPr id="17" name="TextBox 16"/>
           <p:cNvSpPr txBox="1"/>
           <p:nvPr/>
         </p:nvSpPr>
@@ -12776,7 +12461,7 @@
       </p:sp>
       <p:sp>
         <p:nvSpPr>
-          <p:cNvPr id="19" name="TextBox 18"/>
+          <p:cNvPr id="18" name="TextBox 17"/>
           <p:cNvSpPr txBox="1"/>
           <p:nvPr/>
         </p:nvSpPr>
@@ -12811,7 +12496,7 @@
       </p:sp>
       <p:sp>
         <p:nvSpPr>
-          <p:cNvPr id="20" name="TextBox 19"/>
+          <p:cNvPr id="19" name="TextBox 18"/>
           <p:cNvSpPr txBox="1"/>
           <p:nvPr/>
         </p:nvSpPr>
@@ -12846,7 +12531,7 @@
       </p:sp>
       <p:sp>
         <p:nvSpPr>
-          <p:cNvPr id="21" name="TextBox 20"/>
+          <p:cNvPr id="20" name="TextBox 19"/>
           <p:cNvSpPr txBox="1"/>
           <p:nvPr/>
         </p:nvSpPr>
@@ -12881,7 +12566,7 @@
       </p:sp>
       <p:sp>
         <p:nvSpPr>
-          <p:cNvPr id="22" name="Rounded Rectangle 21"/>
+          <p:cNvPr id="21" name="Rounded Rectangle 20"/>
           <p:cNvSpPr/>
           <p:nvPr/>
         </p:nvSpPr>
@@ -12929,7 +12614,7 @@
       </p:sp>
       <p:sp>
         <p:nvSpPr>
-          <p:cNvPr id="23" name="Rectangle 22"/>
+          <p:cNvPr id="22" name="Rectangle 21"/>
           <p:cNvSpPr/>
           <p:nvPr/>
         </p:nvSpPr>
@@ -12973,7 +12658,7 @@
       </p:sp>
       <p:sp>
         <p:nvSpPr>
-          <p:cNvPr id="24" name="TextBox 23"/>
+          <p:cNvPr id="23" name="TextBox 22"/>
           <p:cNvSpPr txBox="1"/>
           <p:nvPr/>
         </p:nvSpPr>
@@ -13008,7 +12693,7 @@
       </p:sp>
       <p:sp>
         <p:nvSpPr>
-          <p:cNvPr id="25" name="TextBox 24"/>
+          <p:cNvPr id="24" name="TextBox 23"/>
           <p:cNvSpPr txBox="1"/>
           <p:nvPr/>
         </p:nvSpPr>
@@ -13043,7 +12728,7 @@
       </p:sp>
       <p:sp>
         <p:nvSpPr>
-          <p:cNvPr id="26" name="TextBox 25"/>
+          <p:cNvPr id="25" name="TextBox 24"/>
           <p:cNvSpPr txBox="1"/>
           <p:nvPr/>
         </p:nvSpPr>
@@ -13078,7 +12763,7 @@
       </p:sp>
       <p:sp>
         <p:nvSpPr>
-          <p:cNvPr id="27" name="TextBox 26"/>
+          <p:cNvPr id="26" name="TextBox 25"/>
           <p:cNvSpPr txBox="1"/>
           <p:nvPr/>
         </p:nvSpPr>
@@ -13113,7 +12798,7 @@
       </p:sp>
       <p:sp>
         <p:nvSpPr>
-          <p:cNvPr id="28" name="TextBox 27"/>
+          <p:cNvPr id="27" name="TextBox 26"/>
           <p:cNvSpPr txBox="1"/>
           <p:nvPr/>
         </p:nvSpPr>
@@ -13148,7 +12833,7 @@
       </p:sp>
       <p:sp>
         <p:nvSpPr>
-          <p:cNvPr id="29" name="TextBox 28"/>
+          <p:cNvPr id="28" name="TextBox 27"/>
           <p:cNvSpPr txBox="1"/>
           <p:nvPr/>
         </p:nvSpPr>
@@ -13183,7 +12868,7 @@
       </p:sp>
       <p:sp>
         <p:nvSpPr>
-          <p:cNvPr id="30" name="TextBox 29"/>
+          <p:cNvPr id="29" name="TextBox 28"/>
           <p:cNvSpPr txBox="1"/>
           <p:nvPr/>
         </p:nvSpPr>
@@ -13218,7 +12903,7 @@
       </p:sp>
       <p:sp>
         <p:nvSpPr>
-          <p:cNvPr id="31" name="TextBox 30"/>
+          <p:cNvPr id="30" name="TextBox 29"/>
           <p:cNvSpPr txBox="1"/>
           <p:nvPr/>
         </p:nvSpPr>
@@ -13253,7 +12938,7 @@
       </p:sp>
       <p:sp>
         <p:nvSpPr>
-          <p:cNvPr id="32" name="TextBox 31"/>
+          <p:cNvPr id="31" name="TextBox 30"/>
           <p:cNvSpPr txBox="1"/>
           <p:nvPr/>
         </p:nvSpPr>
@@ -13288,7 +12973,7 @@
       </p:sp>
       <p:sp>
         <p:nvSpPr>
-          <p:cNvPr id="33" name="Rounded Rectangle 32"/>
+          <p:cNvPr id="32" name="Rounded Rectangle 31"/>
           <p:cNvSpPr/>
           <p:nvPr/>
         </p:nvSpPr>
@@ -13336,7 +13021,7 @@
       </p:sp>
       <p:sp>
         <p:nvSpPr>
-          <p:cNvPr id="34" name="Rectangle 33"/>
+          <p:cNvPr id="33" name="Rectangle 32"/>
           <p:cNvSpPr/>
           <p:nvPr/>
         </p:nvSpPr>
@@ -13380,7 +13065,7 @@
       </p:sp>
       <p:sp>
         <p:nvSpPr>
-          <p:cNvPr id="35" name="TextBox 34"/>
+          <p:cNvPr id="34" name="TextBox 33"/>
           <p:cNvSpPr txBox="1"/>
           <p:nvPr/>
         </p:nvSpPr>
@@ -13415,7 +13100,7 @@
       </p:sp>
       <p:sp>
         <p:nvSpPr>
-          <p:cNvPr id="36" name="TextBox 35"/>
+          <p:cNvPr id="35" name="TextBox 34"/>
           <p:cNvSpPr txBox="1"/>
           <p:nvPr/>
         </p:nvSpPr>
@@ -13450,7 +13135,7 @@
       </p:sp>
       <p:sp>
         <p:nvSpPr>
-          <p:cNvPr id="37" name="TextBox 36"/>
+          <p:cNvPr id="36" name="TextBox 35"/>
           <p:cNvSpPr txBox="1"/>
           <p:nvPr/>
         </p:nvSpPr>
@@ -13485,7 +13170,7 @@
       </p:sp>
       <p:sp>
         <p:nvSpPr>
-          <p:cNvPr id="38" name="TextBox 37"/>
+          <p:cNvPr id="37" name="TextBox 36"/>
           <p:cNvSpPr txBox="1"/>
           <p:nvPr/>
         </p:nvSpPr>
@@ -13520,7 +13205,7 @@
       </p:sp>
       <p:sp>
         <p:nvSpPr>
-          <p:cNvPr id="39" name="TextBox 38"/>
+          <p:cNvPr id="38" name="TextBox 37"/>
           <p:cNvSpPr txBox="1"/>
           <p:nvPr/>
         </p:nvSpPr>
@@ -13555,7 +13240,7 @@
       </p:sp>
       <p:sp>
         <p:nvSpPr>
-          <p:cNvPr id="40" name="TextBox 39"/>
+          <p:cNvPr id="39" name="TextBox 38"/>
           <p:cNvSpPr txBox="1"/>
           <p:nvPr/>
         </p:nvSpPr>
@@ -13590,7 +13275,7 @@
       </p:sp>
       <p:sp>
         <p:nvSpPr>
-          <p:cNvPr id="41" name="TextBox 40"/>
+          <p:cNvPr id="40" name="TextBox 39"/>
           <p:cNvSpPr txBox="1"/>
           <p:nvPr/>
         </p:nvSpPr>
@@ -13625,7 +13310,7 @@
       </p:sp>
       <p:sp>
         <p:nvSpPr>
-          <p:cNvPr id="42" name="TextBox 41"/>
+          <p:cNvPr id="41" name="TextBox 40"/>
           <p:cNvSpPr txBox="1"/>
           <p:nvPr/>
         </p:nvSpPr>
@@ -13660,7 +13345,7 @@
       </p:sp>
       <p:sp>
         <p:nvSpPr>
-          <p:cNvPr id="43" name="TextBox 42"/>
+          <p:cNvPr id="42" name="TextBox 41"/>
           <p:cNvSpPr txBox="1"/>
           <p:nvPr/>
         </p:nvSpPr>
@@ -13695,7 +13380,7 @@
       </p:sp>
       <p:sp>
         <p:nvSpPr>
-          <p:cNvPr id="44" name="Rounded Rectangle 43"/>
+          <p:cNvPr id="43" name="Rounded Rectangle 42"/>
           <p:cNvSpPr/>
           <p:nvPr/>
         </p:nvSpPr>
@@ -13743,7 +13428,7 @@
       </p:sp>
       <p:sp>
         <p:nvSpPr>
-          <p:cNvPr id="45" name="TextBox 44"/>
+          <p:cNvPr id="44" name="TextBox 43"/>
           <p:cNvSpPr txBox="1"/>
           <p:nvPr/>
         </p:nvSpPr>
@@ -13778,7 +13463,7 @@
       </p:sp>
       <p:sp>
         <p:nvSpPr>
-          <p:cNvPr id="46" name="TextBox 45"/>
+          <p:cNvPr id="45" name="TextBox 44"/>
           <p:cNvSpPr txBox="1"/>
           <p:nvPr/>
         </p:nvSpPr>
@@ -13926,7 +13611,7 @@
         <p:spPr>
           <a:xfrm>
             <a:off x="457200" y="164592"/>
-            <a:ext cx="1828800" cy="329184"/>
+            <a:ext cx="2286000" cy="329184"/>
           </a:xfrm>
           <a:prstGeom prst="rect">
             <a:avLst/>
@@ -13955,41 +13640,6 @@
       <p:sp>
         <p:nvSpPr>
           <p:cNvPr id="5" name="TextBox 4"/>
-          <p:cNvSpPr txBox="1"/>
-          <p:nvPr/>
-        </p:nvSpPr>
-        <p:spPr>
-          <a:xfrm>
-            <a:off x="1691640" y="201168"/>
-            <a:ext cx="822960" cy="274320"/>
-          </a:xfrm>
-          <a:prstGeom prst="rect">
-            <a:avLst/>
-          </a:prstGeom>
-          <a:noFill/>
-        </p:spPr>
-        <p:txBody>
-          <a:bodyPr wrap="square" anchor="t" lIns="0" rIns="0" tIns="0" bIns="0">
-            <a:spAutoFit/>
-          </a:bodyPr>
-          <a:lstStyle/>
-          <a:p>
-            <a:pPr algn="l"/>
-            <a:r>
-              <a:rPr sz="1100" b="1">
-                <a:solidFill>
-                  <a:srgbClr val="2863C5"/>
-                </a:solidFill>
-                <a:latin typeface="Open Sans"/>
-              </a:rPr>
-              <a:t>BETA</a:t>
-            </a:r>
-          </a:p>
-        </p:txBody>
-      </p:sp>
-      <p:sp>
-        <p:nvSpPr>
-          <p:cNvPr id="6" name="TextBox 5"/>
           <p:cNvSpPr txBox="1"/>
           <p:nvPr/>
         </p:nvSpPr>
@@ -14024,7 +13674,7 @@
       </p:sp>
       <p:sp>
         <p:nvSpPr>
-          <p:cNvPr id="7" name="TextBox 6"/>
+          <p:cNvPr id="6" name="TextBox 5"/>
           <p:cNvSpPr txBox="1"/>
           <p:nvPr/>
         </p:nvSpPr>
@@ -14059,7 +13709,7 @@
       </p:sp>
       <p:sp>
         <p:nvSpPr>
-          <p:cNvPr id="8" name="TextBox 7"/>
+          <p:cNvPr id="7" name="TextBox 6"/>
           <p:cNvSpPr txBox="1"/>
           <p:nvPr/>
         </p:nvSpPr>
@@ -14094,7 +13744,7 @@
       </p:sp>
       <p:sp>
         <p:nvSpPr>
-          <p:cNvPr id="9" name="TextBox 8"/>
+          <p:cNvPr id="8" name="TextBox 7"/>
           <p:cNvSpPr txBox="1"/>
           <p:nvPr/>
         </p:nvSpPr>
@@ -14129,7 +13779,7 @@
       </p:sp>
       <p:sp>
         <p:nvSpPr>
-          <p:cNvPr id="10" name="Rounded Rectangle 9"/>
+          <p:cNvPr id="9" name="Rounded Rectangle 8"/>
           <p:cNvSpPr/>
           <p:nvPr/>
         </p:nvSpPr>
@@ -14177,7 +13827,7 @@
       </p:sp>
       <p:sp>
         <p:nvSpPr>
-          <p:cNvPr id="11" name="Rectangle 10"/>
+          <p:cNvPr id="10" name="Rectangle 9"/>
           <p:cNvSpPr/>
           <p:nvPr/>
         </p:nvSpPr>
@@ -14221,7 +13871,7 @@
       </p:sp>
       <p:sp>
         <p:nvSpPr>
-          <p:cNvPr id="12" name="TextBox 11"/>
+          <p:cNvPr id="11" name="TextBox 10"/>
           <p:cNvSpPr txBox="1"/>
           <p:nvPr/>
         </p:nvSpPr>
@@ -14256,7 +13906,7 @@
       </p:sp>
       <p:sp>
         <p:nvSpPr>
-          <p:cNvPr id="13" name="TextBox 12"/>
+          <p:cNvPr id="12" name="TextBox 11"/>
           <p:cNvSpPr txBox="1"/>
           <p:nvPr/>
         </p:nvSpPr>
@@ -14291,7 +13941,7 @@
       </p:sp>
       <p:sp>
         <p:nvSpPr>
-          <p:cNvPr id="14" name="TextBox 13"/>
+          <p:cNvPr id="13" name="TextBox 12"/>
           <p:cNvSpPr txBox="1"/>
           <p:nvPr/>
         </p:nvSpPr>
@@ -14326,7 +13976,7 @@
       </p:sp>
       <p:sp>
         <p:nvSpPr>
-          <p:cNvPr id="15" name="TextBox 14"/>
+          <p:cNvPr id="14" name="TextBox 13"/>
           <p:cNvSpPr txBox="1"/>
           <p:nvPr/>
         </p:nvSpPr>
@@ -14361,7 +14011,7 @@
       </p:sp>
       <p:sp>
         <p:nvSpPr>
-          <p:cNvPr id="16" name="TextBox 15"/>
+          <p:cNvPr id="15" name="TextBox 14"/>
           <p:cNvSpPr txBox="1"/>
           <p:nvPr/>
         </p:nvSpPr>
@@ -14396,7 +14046,7 @@
       </p:sp>
       <p:sp>
         <p:nvSpPr>
-          <p:cNvPr id="17" name="TextBox 16"/>
+          <p:cNvPr id="16" name="TextBox 15"/>
           <p:cNvSpPr txBox="1"/>
           <p:nvPr/>
         </p:nvSpPr>
@@ -14431,7 +14081,7 @@
       </p:sp>
       <p:sp>
         <p:nvSpPr>
-          <p:cNvPr id="18" name="TextBox 17"/>
+          <p:cNvPr id="17" name="TextBox 16"/>
           <p:cNvSpPr txBox="1"/>
           <p:nvPr/>
         </p:nvSpPr>
@@ -14466,7 +14116,7 @@
       </p:sp>
       <p:sp>
         <p:nvSpPr>
-          <p:cNvPr id="19" name="TextBox 18"/>
+          <p:cNvPr id="18" name="TextBox 17"/>
           <p:cNvSpPr txBox="1"/>
           <p:nvPr/>
         </p:nvSpPr>
@@ -14501,7 +14151,7 @@
       </p:sp>
       <p:sp>
         <p:nvSpPr>
-          <p:cNvPr id="20" name="TextBox 19"/>
+          <p:cNvPr id="19" name="TextBox 18"/>
           <p:cNvSpPr txBox="1"/>
           <p:nvPr/>
         </p:nvSpPr>
@@ -14536,7 +14186,7 @@
       </p:sp>
       <p:sp>
         <p:nvSpPr>
-          <p:cNvPr id="21" name="TextBox 20"/>
+          <p:cNvPr id="20" name="TextBox 19"/>
           <p:cNvSpPr txBox="1"/>
           <p:nvPr/>
         </p:nvSpPr>
@@ -14571,7 +14221,7 @@
       </p:sp>
       <p:sp>
         <p:nvSpPr>
-          <p:cNvPr id="22" name="Right Arrow 21"/>
+          <p:cNvPr id="21" name="Right Arrow 20"/>
           <p:cNvSpPr/>
           <p:nvPr/>
         </p:nvSpPr>
@@ -14615,7 +14265,7 @@
       </p:sp>
       <p:sp>
         <p:nvSpPr>
-          <p:cNvPr id="23" name="TextBox 22"/>
+          <p:cNvPr id="22" name="TextBox 21"/>
           <p:cNvSpPr txBox="1"/>
           <p:nvPr/>
         </p:nvSpPr>
@@ -14650,7 +14300,7 @@
       </p:sp>
       <p:sp>
         <p:nvSpPr>
-          <p:cNvPr id="24" name="Rounded Rectangle 23"/>
+          <p:cNvPr id="23" name="Rounded Rectangle 22"/>
           <p:cNvSpPr/>
           <p:nvPr/>
         </p:nvSpPr>
@@ -14698,7 +14348,7 @@
       </p:sp>
       <p:sp>
         <p:nvSpPr>
-          <p:cNvPr id="25" name="Rectangle 24"/>
+          <p:cNvPr id="24" name="Rectangle 23"/>
           <p:cNvSpPr/>
           <p:nvPr/>
         </p:nvSpPr>
@@ -14742,7 +14392,7 @@
       </p:sp>
       <p:sp>
         <p:nvSpPr>
-          <p:cNvPr id="26" name="TextBox 25"/>
+          <p:cNvPr id="25" name="TextBox 24"/>
           <p:cNvSpPr txBox="1"/>
           <p:nvPr/>
         </p:nvSpPr>
@@ -14777,7 +14427,7 @@
       </p:sp>
       <p:sp>
         <p:nvSpPr>
-          <p:cNvPr id="27" name="TextBox 26"/>
+          <p:cNvPr id="26" name="TextBox 25"/>
           <p:cNvSpPr txBox="1"/>
           <p:nvPr/>
         </p:nvSpPr>
@@ -14812,7 +14462,7 @@
       </p:sp>
       <p:sp>
         <p:nvSpPr>
-          <p:cNvPr id="28" name="TextBox 27"/>
+          <p:cNvPr id="27" name="TextBox 26"/>
           <p:cNvSpPr txBox="1"/>
           <p:nvPr/>
         </p:nvSpPr>
@@ -14847,7 +14497,7 @@
       </p:sp>
       <p:sp>
         <p:nvSpPr>
-          <p:cNvPr id="29" name="TextBox 28"/>
+          <p:cNvPr id="28" name="TextBox 27"/>
           <p:cNvSpPr txBox="1"/>
           <p:nvPr/>
         </p:nvSpPr>
@@ -14882,7 +14532,7 @@
       </p:sp>
       <p:sp>
         <p:nvSpPr>
-          <p:cNvPr id="30" name="TextBox 29"/>
+          <p:cNvPr id="29" name="TextBox 28"/>
           <p:cNvSpPr txBox="1"/>
           <p:nvPr/>
         </p:nvSpPr>
@@ -14917,7 +14567,7 @@
       </p:sp>
       <p:sp>
         <p:nvSpPr>
-          <p:cNvPr id="31" name="TextBox 30"/>
+          <p:cNvPr id="30" name="TextBox 29"/>
           <p:cNvSpPr txBox="1"/>
           <p:nvPr/>
         </p:nvSpPr>
@@ -14952,7 +14602,7 @@
       </p:sp>
       <p:sp>
         <p:nvSpPr>
-          <p:cNvPr id="32" name="TextBox 31"/>
+          <p:cNvPr id="31" name="TextBox 30"/>
           <p:cNvSpPr txBox="1"/>
           <p:nvPr/>
         </p:nvSpPr>
@@ -14987,7 +14637,7 @@
       </p:sp>
       <p:sp>
         <p:nvSpPr>
-          <p:cNvPr id="33" name="TextBox 32"/>
+          <p:cNvPr id="32" name="TextBox 31"/>
           <p:cNvSpPr txBox="1"/>
           <p:nvPr/>
         </p:nvSpPr>
@@ -15022,7 +14672,7 @@
       </p:sp>
       <p:sp>
         <p:nvSpPr>
-          <p:cNvPr id="34" name="TextBox 33"/>
+          <p:cNvPr id="33" name="TextBox 32"/>
           <p:cNvSpPr txBox="1"/>
           <p:nvPr/>
         </p:nvSpPr>
@@ -15057,7 +14707,7 @@
       </p:sp>
       <p:sp>
         <p:nvSpPr>
-          <p:cNvPr id="35" name="TextBox 34"/>
+          <p:cNvPr id="34" name="TextBox 33"/>
           <p:cNvSpPr txBox="1"/>
           <p:nvPr/>
         </p:nvSpPr>
@@ -15092,7 +14742,7 @@
       </p:sp>
       <p:sp>
         <p:nvSpPr>
-          <p:cNvPr id="36" name="TextBox 35"/>
+          <p:cNvPr id="35" name="TextBox 34"/>
           <p:cNvSpPr txBox="1"/>
           <p:nvPr/>
         </p:nvSpPr>
@@ -15240,7 +14890,7 @@
         <p:spPr>
           <a:xfrm>
             <a:off x="457200" y="164592"/>
-            <a:ext cx="1828800" cy="329184"/>
+            <a:ext cx="2286000" cy="329184"/>
           </a:xfrm>
           <a:prstGeom prst="rect">
             <a:avLst/>
@@ -15269,41 +14919,6 @@
       <p:sp>
         <p:nvSpPr>
           <p:cNvPr id="5" name="TextBox 4"/>
-          <p:cNvSpPr txBox="1"/>
-          <p:nvPr/>
-        </p:nvSpPr>
-        <p:spPr>
-          <a:xfrm>
-            <a:off x="1691640" y="201168"/>
-            <a:ext cx="822960" cy="274320"/>
-          </a:xfrm>
-          <a:prstGeom prst="rect">
-            <a:avLst/>
-          </a:prstGeom>
-          <a:noFill/>
-        </p:spPr>
-        <p:txBody>
-          <a:bodyPr wrap="square" anchor="t" lIns="0" rIns="0" tIns="0" bIns="0">
-            <a:spAutoFit/>
-          </a:bodyPr>
-          <a:lstStyle/>
-          <a:p>
-            <a:pPr algn="l"/>
-            <a:r>
-              <a:rPr sz="1100" b="1">
-                <a:solidFill>
-                  <a:srgbClr val="2863C5"/>
-                </a:solidFill>
-                <a:latin typeface="Open Sans"/>
-              </a:rPr>
-              <a:t>BETA</a:t>
-            </a:r>
-          </a:p>
-        </p:txBody>
-      </p:sp>
-      <p:sp>
-        <p:nvSpPr>
-          <p:cNvPr id="6" name="TextBox 5"/>
           <p:cNvSpPr txBox="1"/>
           <p:nvPr/>
         </p:nvSpPr>
@@ -15338,7 +14953,7 @@
       </p:sp>
       <p:sp>
         <p:nvSpPr>
-          <p:cNvPr id="7" name="TextBox 6"/>
+          <p:cNvPr id="6" name="TextBox 5"/>
           <p:cNvSpPr txBox="1"/>
           <p:nvPr/>
         </p:nvSpPr>
@@ -15373,7 +14988,7 @@
       </p:sp>
       <p:sp>
         <p:nvSpPr>
-          <p:cNvPr id="8" name="TextBox 7"/>
+          <p:cNvPr id="7" name="TextBox 6"/>
           <p:cNvSpPr txBox="1"/>
           <p:nvPr/>
         </p:nvSpPr>
@@ -15408,7 +15023,7 @@
       </p:sp>
       <p:sp>
         <p:nvSpPr>
-          <p:cNvPr id="9" name="TextBox 8"/>
+          <p:cNvPr id="8" name="TextBox 7"/>
           <p:cNvSpPr txBox="1"/>
           <p:nvPr/>
         </p:nvSpPr>
@@ -15443,7 +15058,7 @@
       </p:sp>
       <p:sp>
         <p:nvSpPr>
-          <p:cNvPr id="10" name="TextBox 9"/>
+          <p:cNvPr id="9" name="TextBox 8"/>
           <p:cNvSpPr txBox="1"/>
           <p:nvPr/>
         </p:nvSpPr>
@@ -15478,7 +15093,7 @@
       </p:sp>
       <p:sp>
         <p:nvSpPr>
-          <p:cNvPr id="11" name="Rounded Rectangle 10"/>
+          <p:cNvPr id="10" name="Rounded Rectangle 9"/>
           <p:cNvSpPr/>
           <p:nvPr/>
         </p:nvSpPr>
@@ -15526,7 +15141,7 @@
       </p:sp>
       <p:sp>
         <p:nvSpPr>
-          <p:cNvPr id="12" name="Rectangle 11"/>
+          <p:cNvPr id="11" name="Rectangle 10"/>
           <p:cNvSpPr/>
           <p:nvPr/>
         </p:nvSpPr>
@@ -15570,7 +15185,7 @@
       </p:sp>
       <p:sp>
         <p:nvSpPr>
-          <p:cNvPr id="13" name="Rounded Rectangle 12"/>
+          <p:cNvPr id="12" name="Rounded Rectangle 11"/>
           <p:cNvSpPr/>
           <p:nvPr/>
         </p:nvSpPr>
@@ -15624,7 +15239,7 @@
       </p:sp>
       <p:sp>
         <p:nvSpPr>
-          <p:cNvPr id="14" name="TextBox 13"/>
+          <p:cNvPr id="13" name="TextBox 12"/>
           <p:cNvSpPr txBox="1"/>
           <p:nvPr/>
         </p:nvSpPr>
@@ -15659,7 +15274,7 @@
       </p:sp>
       <p:sp>
         <p:nvSpPr>
-          <p:cNvPr id="15" name="Rounded Rectangle 14"/>
+          <p:cNvPr id="14" name="Rounded Rectangle 13"/>
           <p:cNvSpPr/>
           <p:nvPr/>
         </p:nvSpPr>
@@ -15707,7 +15322,7 @@
       </p:sp>
       <p:sp>
         <p:nvSpPr>
-          <p:cNvPr id="16" name="TextBox 15"/>
+          <p:cNvPr id="15" name="TextBox 14"/>
           <p:cNvSpPr txBox="1"/>
           <p:nvPr/>
         </p:nvSpPr>
@@ -15742,7 +15357,7 @@
       </p:sp>
       <p:sp>
         <p:nvSpPr>
-          <p:cNvPr id="17" name="TextBox 16"/>
+          <p:cNvPr id="16" name="TextBox 15"/>
           <p:cNvSpPr txBox="1"/>
           <p:nvPr/>
         </p:nvSpPr>
@@ -15777,7 +15392,7 @@
       </p:sp>
       <p:sp>
         <p:nvSpPr>
-          <p:cNvPr id="18" name="Rounded Rectangle 17"/>
+          <p:cNvPr id="17" name="Rounded Rectangle 16"/>
           <p:cNvSpPr/>
           <p:nvPr/>
         </p:nvSpPr>
@@ -15825,7 +15440,7 @@
       </p:sp>
       <p:sp>
         <p:nvSpPr>
-          <p:cNvPr id="19" name="Rectangle 18"/>
+          <p:cNvPr id="18" name="Rectangle 17"/>
           <p:cNvSpPr/>
           <p:nvPr/>
         </p:nvSpPr>
@@ -15869,7 +15484,7 @@
       </p:sp>
       <p:sp>
         <p:nvSpPr>
-          <p:cNvPr id="20" name="Rounded Rectangle 19"/>
+          <p:cNvPr id="19" name="Rounded Rectangle 18"/>
           <p:cNvSpPr/>
           <p:nvPr/>
         </p:nvSpPr>
@@ -15923,7 +15538,7 @@
       </p:sp>
       <p:sp>
         <p:nvSpPr>
-          <p:cNvPr id="21" name="TextBox 20"/>
+          <p:cNvPr id="20" name="TextBox 19"/>
           <p:cNvSpPr txBox="1"/>
           <p:nvPr/>
         </p:nvSpPr>
@@ -15958,7 +15573,7 @@
       </p:sp>
       <p:sp>
         <p:nvSpPr>
-          <p:cNvPr id="22" name="Rounded Rectangle 21"/>
+          <p:cNvPr id="21" name="Rounded Rectangle 20"/>
           <p:cNvSpPr/>
           <p:nvPr/>
         </p:nvSpPr>
@@ -16006,7 +15621,7 @@
       </p:sp>
       <p:sp>
         <p:nvSpPr>
-          <p:cNvPr id="23" name="TextBox 22"/>
+          <p:cNvPr id="22" name="TextBox 21"/>
           <p:cNvSpPr txBox="1"/>
           <p:nvPr/>
         </p:nvSpPr>
@@ -16041,7 +15656,7 @@
       </p:sp>
       <p:sp>
         <p:nvSpPr>
-          <p:cNvPr id="24" name="Rounded Rectangle 23"/>
+          <p:cNvPr id="23" name="Rounded Rectangle 22"/>
           <p:cNvSpPr/>
           <p:nvPr/>
         </p:nvSpPr>
@@ -16089,7 +15704,7 @@
       </p:sp>
       <p:sp>
         <p:nvSpPr>
-          <p:cNvPr id="25" name="TextBox 24"/>
+          <p:cNvPr id="24" name="TextBox 23"/>
           <p:cNvSpPr txBox="1"/>
           <p:nvPr/>
         </p:nvSpPr>
@@ -16124,7 +15739,7 @@
       </p:sp>
       <p:sp>
         <p:nvSpPr>
-          <p:cNvPr id="26" name="Rounded Rectangle 25"/>
+          <p:cNvPr id="25" name="Rounded Rectangle 24"/>
           <p:cNvSpPr/>
           <p:nvPr/>
         </p:nvSpPr>
@@ -16172,7 +15787,7 @@
       </p:sp>
       <p:sp>
         <p:nvSpPr>
-          <p:cNvPr id="27" name="TextBox 26"/>
+          <p:cNvPr id="26" name="TextBox 25"/>
           <p:cNvSpPr txBox="1"/>
           <p:nvPr/>
         </p:nvSpPr>
@@ -16207,7 +15822,7 @@
       </p:sp>
       <p:sp>
         <p:nvSpPr>
-          <p:cNvPr id="28" name="Rounded Rectangle 27"/>
+          <p:cNvPr id="27" name="Rounded Rectangle 26"/>
           <p:cNvSpPr/>
           <p:nvPr/>
         </p:nvSpPr>
@@ -16255,7 +15870,7 @@
       </p:sp>
       <p:sp>
         <p:nvSpPr>
-          <p:cNvPr id="29" name="TextBox 28"/>
+          <p:cNvPr id="28" name="TextBox 27"/>
           <p:cNvSpPr txBox="1"/>
           <p:nvPr/>
         </p:nvSpPr>
@@ -16290,7 +15905,7 @@
       </p:sp>
       <p:sp>
         <p:nvSpPr>
-          <p:cNvPr id="30" name="Rounded Rectangle 29"/>
+          <p:cNvPr id="29" name="Rounded Rectangle 28"/>
           <p:cNvSpPr/>
           <p:nvPr/>
         </p:nvSpPr>
@@ -16338,7 +15953,7 @@
       </p:sp>
       <p:sp>
         <p:nvSpPr>
-          <p:cNvPr id="31" name="TextBox 30"/>
+          <p:cNvPr id="30" name="TextBox 29"/>
           <p:cNvSpPr txBox="1"/>
           <p:nvPr/>
         </p:nvSpPr>
@@ -16373,7 +15988,7 @@
       </p:sp>
       <p:sp>
         <p:nvSpPr>
-          <p:cNvPr id="32" name="TextBox 31"/>
+          <p:cNvPr id="31" name="TextBox 30"/>
           <p:cNvSpPr txBox="1"/>
           <p:nvPr/>
         </p:nvSpPr>
@@ -16408,7 +16023,7 @@
       </p:sp>
       <p:sp>
         <p:nvSpPr>
-          <p:cNvPr id="33" name="Rounded Rectangle 32"/>
+          <p:cNvPr id="32" name="Rounded Rectangle 31"/>
           <p:cNvSpPr/>
           <p:nvPr/>
         </p:nvSpPr>
@@ -16456,7 +16071,7 @@
       </p:sp>
       <p:sp>
         <p:nvSpPr>
-          <p:cNvPr id="34" name="Rectangle 33"/>
+          <p:cNvPr id="33" name="Rectangle 32"/>
           <p:cNvSpPr/>
           <p:nvPr/>
         </p:nvSpPr>
@@ -16500,7 +16115,7 @@
       </p:sp>
       <p:sp>
         <p:nvSpPr>
-          <p:cNvPr id="35" name="Rounded Rectangle 34"/>
+          <p:cNvPr id="34" name="Rounded Rectangle 33"/>
           <p:cNvSpPr/>
           <p:nvPr/>
         </p:nvSpPr>
@@ -16554,7 +16169,7 @@
       </p:sp>
       <p:sp>
         <p:nvSpPr>
-          <p:cNvPr id="36" name="TextBox 35"/>
+          <p:cNvPr id="35" name="TextBox 34"/>
           <p:cNvSpPr txBox="1"/>
           <p:nvPr/>
         </p:nvSpPr>
@@ -16589,7 +16204,7 @@
       </p:sp>
       <p:sp>
         <p:nvSpPr>
-          <p:cNvPr id="37" name="Rounded Rectangle 36"/>
+          <p:cNvPr id="36" name="Rounded Rectangle 35"/>
           <p:cNvSpPr/>
           <p:nvPr/>
         </p:nvSpPr>
@@ -16637,7 +16252,7 @@
       </p:sp>
       <p:sp>
         <p:nvSpPr>
-          <p:cNvPr id="38" name="TextBox 37"/>
+          <p:cNvPr id="37" name="TextBox 36"/>
           <p:cNvSpPr txBox="1"/>
           <p:nvPr/>
         </p:nvSpPr>
@@ -16672,7 +16287,7 @@
       </p:sp>
       <p:sp>
         <p:nvSpPr>
-          <p:cNvPr id="39" name="Rounded Rectangle 38"/>
+          <p:cNvPr id="38" name="Rounded Rectangle 37"/>
           <p:cNvSpPr/>
           <p:nvPr/>
         </p:nvSpPr>
@@ -16720,7 +16335,7 @@
       </p:sp>
       <p:sp>
         <p:nvSpPr>
-          <p:cNvPr id="40" name="TextBox 39"/>
+          <p:cNvPr id="39" name="TextBox 38"/>
           <p:cNvSpPr txBox="1"/>
           <p:nvPr/>
         </p:nvSpPr>
@@ -16755,7 +16370,7 @@
       </p:sp>
       <p:sp>
         <p:nvSpPr>
-          <p:cNvPr id="41" name="Rounded Rectangle 40"/>
+          <p:cNvPr id="40" name="Rounded Rectangle 39"/>
           <p:cNvSpPr/>
           <p:nvPr/>
         </p:nvSpPr>
@@ -16803,7 +16418,7 @@
       </p:sp>
       <p:sp>
         <p:nvSpPr>
-          <p:cNvPr id="42" name="TextBox 41"/>
+          <p:cNvPr id="41" name="TextBox 40"/>
           <p:cNvSpPr txBox="1"/>
           <p:nvPr/>
         </p:nvSpPr>
@@ -16838,7 +16453,7 @@
       </p:sp>
       <p:sp>
         <p:nvSpPr>
-          <p:cNvPr id="43" name="Rounded Rectangle 42"/>
+          <p:cNvPr id="42" name="Rounded Rectangle 41"/>
           <p:cNvSpPr/>
           <p:nvPr/>
         </p:nvSpPr>
@@ -16886,7 +16501,7 @@
       </p:sp>
       <p:sp>
         <p:nvSpPr>
-          <p:cNvPr id="44" name="TextBox 43"/>
+          <p:cNvPr id="43" name="TextBox 42"/>
           <p:cNvSpPr txBox="1"/>
           <p:nvPr/>
         </p:nvSpPr>
@@ -16921,7 +16536,7 @@
       </p:sp>
       <p:sp>
         <p:nvSpPr>
-          <p:cNvPr id="45" name="Rounded Rectangle 44"/>
+          <p:cNvPr id="44" name="Rounded Rectangle 43"/>
           <p:cNvSpPr/>
           <p:nvPr/>
         </p:nvSpPr>
@@ -16969,7 +16584,7 @@
       </p:sp>
       <p:sp>
         <p:nvSpPr>
-          <p:cNvPr id="46" name="TextBox 45"/>
+          <p:cNvPr id="45" name="TextBox 44"/>
           <p:cNvSpPr txBox="1"/>
           <p:nvPr/>
         </p:nvSpPr>
@@ -17004,7 +16619,7 @@
       </p:sp>
       <p:sp>
         <p:nvSpPr>
-          <p:cNvPr id="47" name="Rounded Rectangle 46"/>
+          <p:cNvPr id="46" name="Rounded Rectangle 45"/>
           <p:cNvSpPr/>
           <p:nvPr/>
         </p:nvSpPr>
@@ -17052,7 +16667,7 @@
       </p:sp>
       <p:sp>
         <p:nvSpPr>
-          <p:cNvPr id="48" name="TextBox 47"/>
+          <p:cNvPr id="47" name="TextBox 46"/>
           <p:cNvSpPr txBox="1"/>
           <p:nvPr/>
         </p:nvSpPr>
@@ -17087,7 +16702,7 @@
       </p:sp>
       <p:sp>
         <p:nvSpPr>
-          <p:cNvPr id="49" name="Rounded Rectangle 48"/>
+          <p:cNvPr id="48" name="Rounded Rectangle 47"/>
           <p:cNvSpPr/>
           <p:nvPr/>
         </p:nvSpPr>
@@ -17135,7 +16750,7 @@
       </p:sp>
       <p:sp>
         <p:nvSpPr>
-          <p:cNvPr id="50" name="TextBox 49"/>
+          <p:cNvPr id="49" name="TextBox 48"/>
           <p:cNvSpPr txBox="1"/>
           <p:nvPr/>
         </p:nvSpPr>
@@ -17170,7 +16785,7 @@
       </p:sp>
       <p:sp>
         <p:nvSpPr>
-          <p:cNvPr id="51" name="Rounded Rectangle 50"/>
+          <p:cNvPr id="50" name="Rounded Rectangle 49"/>
           <p:cNvSpPr/>
           <p:nvPr/>
         </p:nvSpPr>
@@ -17218,7 +16833,7 @@
       </p:sp>
       <p:sp>
         <p:nvSpPr>
-          <p:cNvPr id="52" name="TextBox 51"/>
+          <p:cNvPr id="51" name="TextBox 50"/>
           <p:cNvSpPr txBox="1"/>
           <p:nvPr/>
         </p:nvSpPr>
@@ -17253,7 +16868,7 @@
       </p:sp>
       <p:sp>
         <p:nvSpPr>
-          <p:cNvPr id="53" name="Rounded Rectangle 52"/>
+          <p:cNvPr id="52" name="Rounded Rectangle 51"/>
           <p:cNvSpPr/>
           <p:nvPr/>
         </p:nvSpPr>
@@ -17301,7 +16916,7 @@
       </p:sp>
       <p:sp>
         <p:nvSpPr>
-          <p:cNvPr id="54" name="TextBox 53"/>
+          <p:cNvPr id="53" name="TextBox 52"/>
           <p:cNvSpPr txBox="1"/>
           <p:nvPr/>
         </p:nvSpPr>
@@ -17336,7 +16951,7 @@
       </p:sp>
       <p:sp>
         <p:nvSpPr>
-          <p:cNvPr id="55" name="Rounded Rectangle 54"/>
+          <p:cNvPr id="54" name="Rounded Rectangle 53"/>
           <p:cNvSpPr/>
           <p:nvPr/>
         </p:nvSpPr>
@@ -17384,7 +16999,7 @@
       </p:sp>
       <p:sp>
         <p:nvSpPr>
-          <p:cNvPr id="56" name="TextBox 55"/>
+          <p:cNvPr id="55" name="TextBox 54"/>
           <p:cNvSpPr txBox="1"/>
           <p:nvPr/>
         </p:nvSpPr>
@@ -17419,7 +17034,7 @@
       </p:sp>
       <p:sp>
         <p:nvSpPr>
-          <p:cNvPr id="57" name="Rounded Rectangle 56"/>
+          <p:cNvPr id="56" name="Rounded Rectangle 55"/>
           <p:cNvSpPr/>
           <p:nvPr/>
         </p:nvSpPr>
@@ -17467,7 +17082,7 @@
       </p:sp>
       <p:sp>
         <p:nvSpPr>
-          <p:cNvPr id="58" name="TextBox 57"/>
+          <p:cNvPr id="57" name="TextBox 56"/>
           <p:cNvSpPr txBox="1"/>
           <p:nvPr/>
         </p:nvSpPr>
@@ -17502,7 +17117,7 @@
       </p:sp>
       <p:sp>
         <p:nvSpPr>
-          <p:cNvPr id="59" name="Rounded Rectangle 58"/>
+          <p:cNvPr id="58" name="Rounded Rectangle 57"/>
           <p:cNvSpPr/>
           <p:nvPr/>
         </p:nvSpPr>
@@ -17550,7 +17165,7 @@
       </p:sp>
       <p:sp>
         <p:nvSpPr>
-          <p:cNvPr id="60" name="TextBox 59"/>
+          <p:cNvPr id="59" name="TextBox 58"/>
           <p:cNvSpPr txBox="1"/>
           <p:nvPr/>
         </p:nvSpPr>
@@ -17585,7 +17200,7 @@
       </p:sp>
       <p:sp>
         <p:nvSpPr>
-          <p:cNvPr id="61" name="Rounded Rectangle 60"/>
+          <p:cNvPr id="60" name="Rounded Rectangle 59"/>
           <p:cNvSpPr/>
           <p:nvPr/>
         </p:nvSpPr>
@@ -17633,7 +17248,7 @@
       </p:sp>
       <p:sp>
         <p:nvSpPr>
-          <p:cNvPr id="62" name="TextBox 61"/>
+          <p:cNvPr id="61" name="TextBox 60"/>
           <p:cNvSpPr txBox="1"/>
           <p:nvPr/>
         </p:nvSpPr>
@@ -17668,7 +17283,7 @@
       </p:sp>
       <p:sp>
         <p:nvSpPr>
-          <p:cNvPr id="63" name="TextBox 62"/>
+          <p:cNvPr id="62" name="TextBox 61"/>
           <p:cNvSpPr txBox="1"/>
           <p:nvPr/>
         </p:nvSpPr>
@@ -17703,7 +17318,7 @@
       </p:sp>
       <p:sp>
         <p:nvSpPr>
-          <p:cNvPr id="64" name="Rounded Rectangle 63"/>
+          <p:cNvPr id="63" name="Rounded Rectangle 62"/>
           <p:cNvSpPr/>
           <p:nvPr/>
         </p:nvSpPr>
@@ -17751,7 +17366,7 @@
       </p:sp>
       <p:sp>
         <p:nvSpPr>
-          <p:cNvPr id="65" name="Rectangle 64"/>
+          <p:cNvPr id="64" name="Rectangle 63"/>
           <p:cNvSpPr/>
           <p:nvPr/>
         </p:nvSpPr>
@@ -17795,7 +17410,7 @@
       </p:sp>
       <p:sp>
         <p:nvSpPr>
-          <p:cNvPr id="66" name="Rounded Rectangle 65"/>
+          <p:cNvPr id="65" name="Rounded Rectangle 64"/>
           <p:cNvSpPr/>
           <p:nvPr/>
         </p:nvSpPr>
@@ -17849,7 +17464,7 @@
       </p:sp>
       <p:sp>
         <p:nvSpPr>
-          <p:cNvPr id="67" name="TextBox 66"/>
+          <p:cNvPr id="66" name="TextBox 65"/>
           <p:cNvSpPr txBox="1"/>
           <p:nvPr/>
         </p:nvSpPr>
@@ -17884,7 +17499,7 @@
       </p:sp>
       <p:sp>
         <p:nvSpPr>
-          <p:cNvPr id="68" name="Rounded Rectangle 67"/>
+          <p:cNvPr id="67" name="Rounded Rectangle 66"/>
           <p:cNvSpPr/>
           <p:nvPr/>
         </p:nvSpPr>
@@ -17932,7 +17547,7 @@
       </p:sp>
       <p:sp>
         <p:nvSpPr>
-          <p:cNvPr id="69" name="TextBox 68"/>
+          <p:cNvPr id="68" name="TextBox 67"/>
           <p:cNvSpPr txBox="1"/>
           <p:nvPr/>
         </p:nvSpPr>
@@ -17967,7 +17582,7 @@
       </p:sp>
       <p:sp>
         <p:nvSpPr>
-          <p:cNvPr id="70" name="Rounded Rectangle 69"/>
+          <p:cNvPr id="69" name="Rounded Rectangle 68"/>
           <p:cNvSpPr/>
           <p:nvPr/>
         </p:nvSpPr>
@@ -18015,7 +17630,7 @@
       </p:sp>
       <p:sp>
         <p:nvSpPr>
-          <p:cNvPr id="71" name="TextBox 70"/>
+          <p:cNvPr id="70" name="TextBox 69"/>
           <p:cNvSpPr txBox="1"/>
           <p:nvPr/>
         </p:nvSpPr>
@@ -18050,7 +17665,7 @@
       </p:sp>
       <p:sp>
         <p:nvSpPr>
-          <p:cNvPr id="72" name="TextBox 71"/>
+          <p:cNvPr id="71" name="TextBox 70"/>
           <p:cNvSpPr txBox="1"/>
           <p:nvPr/>
         </p:nvSpPr>
@@ -18198,7 +17813,7 @@
         <p:spPr>
           <a:xfrm>
             <a:off x="457200" y="164592"/>
-            <a:ext cx="1828800" cy="329184"/>
+            <a:ext cx="2286000" cy="329184"/>
           </a:xfrm>
           <a:prstGeom prst="rect">
             <a:avLst/>
@@ -18227,41 +17842,6 @@
       <p:sp>
         <p:nvSpPr>
           <p:cNvPr id="5" name="TextBox 4"/>
-          <p:cNvSpPr txBox="1"/>
-          <p:nvPr/>
-        </p:nvSpPr>
-        <p:spPr>
-          <a:xfrm>
-            <a:off x="1691640" y="201168"/>
-            <a:ext cx="822960" cy="274320"/>
-          </a:xfrm>
-          <a:prstGeom prst="rect">
-            <a:avLst/>
-          </a:prstGeom>
-          <a:noFill/>
-        </p:spPr>
-        <p:txBody>
-          <a:bodyPr wrap="square" anchor="t" lIns="0" rIns="0" tIns="0" bIns="0">
-            <a:spAutoFit/>
-          </a:bodyPr>
-          <a:lstStyle/>
-          <a:p>
-            <a:pPr algn="l"/>
-            <a:r>
-              <a:rPr sz="1100" b="1">
-                <a:solidFill>
-                  <a:srgbClr val="2863C5"/>
-                </a:solidFill>
-                <a:latin typeface="Open Sans"/>
-              </a:rPr>
-              <a:t>BETA</a:t>
-            </a:r>
-          </a:p>
-        </p:txBody>
-      </p:sp>
-      <p:sp>
-        <p:nvSpPr>
-          <p:cNvPr id="6" name="TextBox 5"/>
           <p:cNvSpPr txBox="1"/>
           <p:nvPr/>
         </p:nvSpPr>
@@ -18296,7 +17876,7 @@
       </p:sp>
       <p:sp>
         <p:nvSpPr>
-          <p:cNvPr id="7" name="TextBox 6"/>
+          <p:cNvPr id="6" name="TextBox 5"/>
           <p:cNvSpPr txBox="1"/>
           <p:nvPr/>
         </p:nvSpPr>
@@ -18331,7 +17911,7 @@
       </p:sp>
       <p:sp>
         <p:nvSpPr>
-          <p:cNvPr id="8" name="TextBox 7"/>
+          <p:cNvPr id="7" name="TextBox 6"/>
           <p:cNvSpPr txBox="1"/>
           <p:nvPr/>
         </p:nvSpPr>
@@ -18366,7 +17946,7 @@
       </p:sp>
       <p:sp>
         <p:nvSpPr>
-          <p:cNvPr id="9" name="TextBox 8"/>
+          <p:cNvPr id="8" name="TextBox 7"/>
           <p:cNvSpPr txBox="1"/>
           <p:nvPr/>
         </p:nvSpPr>
@@ -18401,7 +17981,7 @@
       </p:sp>
       <p:sp>
         <p:nvSpPr>
-          <p:cNvPr id="10" name="Rounded Rectangle 9"/>
+          <p:cNvPr id="9" name="Rounded Rectangle 8"/>
           <p:cNvSpPr/>
           <p:nvPr/>
         </p:nvSpPr>
@@ -18449,7 +18029,7 @@
       </p:sp>
       <p:sp>
         <p:nvSpPr>
-          <p:cNvPr id="11" name="Rectangle 10"/>
+          <p:cNvPr id="10" name="Rectangle 9"/>
           <p:cNvSpPr/>
           <p:nvPr/>
         </p:nvSpPr>
@@ -18493,7 +18073,7 @@
       </p:sp>
       <p:sp>
         <p:nvSpPr>
-          <p:cNvPr id="12" name="Rounded Rectangle 11"/>
+          <p:cNvPr id="11" name="Rounded Rectangle 10"/>
           <p:cNvSpPr/>
           <p:nvPr/>
         </p:nvSpPr>
@@ -18547,7 +18127,7 @@
       </p:sp>
       <p:sp>
         <p:nvSpPr>
-          <p:cNvPr id="13" name="TextBox 12"/>
+          <p:cNvPr id="12" name="TextBox 11"/>
           <p:cNvSpPr txBox="1"/>
           <p:nvPr/>
         </p:nvSpPr>
@@ -18583,7 +18163,7 @@
       </p:sp>
       <p:sp>
         <p:nvSpPr>
-          <p:cNvPr id="14" name="TextBox 13"/>
+          <p:cNvPr id="13" name="TextBox 12"/>
           <p:cNvSpPr txBox="1"/>
           <p:nvPr/>
         </p:nvSpPr>
@@ -18621,7 +18201,7 @@
       </p:sp>
       <p:sp>
         <p:nvSpPr>
-          <p:cNvPr id="15" name="Right Arrow 14"/>
+          <p:cNvPr id="14" name="Right Arrow 13"/>
           <p:cNvSpPr/>
           <p:nvPr/>
         </p:nvSpPr>
@@ -18665,7 +18245,7 @@
       </p:sp>
       <p:sp>
         <p:nvSpPr>
-          <p:cNvPr id="16" name="Rounded Rectangle 15"/>
+          <p:cNvPr id="15" name="Rounded Rectangle 14"/>
           <p:cNvSpPr/>
           <p:nvPr/>
         </p:nvSpPr>
@@ -18713,7 +18293,7 @@
       </p:sp>
       <p:sp>
         <p:nvSpPr>
-          <p:cNvPr id="17" name="Rectangle 16"/>
+          <p:cNvPr id="16" name="Rectangle 15"/>
           <p:cNvSpPr/>
           <p:nvPr/>
         </p:nvSpPr>
@@ -18757,7 +18337,7 @@
       </p:sp>
       <p:sp>
         <p:nvSpPr>
-          <p:cNvPr id="18" name="Rounded Rectangle 17"/>
+          <p:cNvPr id="17" name="Rounded Rectangle 16"/>
           <p:cNvSpPr/>
           <p:nvPr/>
         </p:nvSpPr>
@@ -18811,7 +18391,7 @@
       </p:sp>
       <p:sp>
         <p:nvSpPr>
-          <p:cNvPr id="19" name="TextBox 18"/>
+          <p:cNvPr id="18" name="TextBox 17"/>
           <p:cNvSpPr txBox="1"/>
           <p:nvPr/>
         </p:nvSpPr>
@@ -18846,7 +18426,7 @@
       </p:sp>
       <p:sp>
         <p:nvSpPr>
-          <p:cNvPr id="20" name="TextBox 19"/>
+          <p:cNvPr id="19" name="TextBox 18"/>
           <p:cNvSpPr txBox="1"/>
           <p:nvPr/>
         </p:nvSpPr>
@@ -18883,7 +18463,7 @@
       </p:sp>
       <p:sp>
         <p:nvSpPr>
-          <p:cNvPr id="21" name="Right Arrow 20"/>
+          <p:cNvPr id="20" name="Right Arrow 19"/>
           <p:cNvSpPr/>
           <p:nvPr/>
         </p:nvSpPr>
@@ -18927,7 +18507,7 @@
       </p:sp>
       <p:sp>
         <p:nvSpPr>
-          <p:cNvPr id="22" name="Rounded Rectangle 21"/>
+          <p:cNvPr id="21" name="Rounded Rectangle 20"/>
           <p:cNvSpPr/>
           <p:nvPr/>
         </p:nvSpPr>
@@ -18975,7 +18555,7 @@
       </p:sp>
       <p:sp>
         <p:nvSpPr>
-          <p:cNvPr id="23" name="Rectangle 22"/>
+          <p:cNvPr id="22" name="Rectangle 21"/>
           <p:cNvSpPr/>
           <p:nvPr/>
         </p:nvSpPr>
@@ -19019,7 +18599,7 @@
       </p:sp>
       <p:sp>
         <p:nvSpPr>
-          <p:cNvPr id="24" name="Rounded Rectangle 23"/>
+          <p:cNvPr id="23" name="Rounded Rectangle 22"/>
           <p:cNvSpPr/>
           <p:nvPr/>
         </p:nvSpPr>
@@ -19073,7 +18653,7 @@
       </p:sp>
       <p:sp>
         <p:nvSpPr>
-          <p:cNvPr id="25" name="TextBox 24"/>
+          <p:cNvPr id="24" name="TextBox 23"/>
           <p:cNvSpPr txBox="1"/>
           <p:nvPr/>
         </p:nvSpPr>
@@ -19108,7 +18688,7 @@
       </p:sp>
       <p:sp>
         <p:nvSpPr>
-          <p:cNvPr id="26" name="TextBox 25"/>
+          <p:cNvPr id="25" name="TextBox 24"/>
           <p:cNvSpPr txBox="1"/>
           <p:nvPr/>
         </p:nvSpPr>
@@ -19145,7 +18725,7 @@
       </p:sp>
       <p:sp>
         <p:nvSpPr>
-          <p:cNvPr id="27" name="Right Arrow 26"/>
+          <p:cNvPr id="26" name="Right Arrow 25"/>
           <p:cNvSpPr/>
           <p:nvPr/>
         </p:nvSpPr>
@@ -19189,7 +18769,7 @@
       </p:sp>
       <p:sp>
         <p:nvSpPr>
-          <p:cNvPr id="28" name="Rounded Rectangle 27"/>
+          <p:cNvPr id="27" name="Rounded Rectangle 26"/>
           <p:cNvSpPr/>
           <p:nvPr/>
         </p:nvSpPr>
@@ -19237,7 +18817,7 @@
       </p:sp>
       <p:sp>
         <p:nvSpPr>
-          <p:cNvPr id="29" name="Rectangle 28"/>
+          <p:cNvPr id="28" name="Rectangle 27"/>
           <p:cNvSpPr/>
           <p:nvPr/>
         </p:nvSpPr>
@@ -19281,7 +18861,7 @@
       </p:sp>
       <p:sp>
         <p:nvSpPr>
-          <p:cNvPr id="30" name="Rounded Rectangle 29"/>
+          <p:cNvPr id="29" name="Rounded Rectangle 28"/>
           <p:cNvSpPr/>
           <p:nvPr/>
         </p:nvSpPr>
@@ -19335,7 +18915,7 @@
       </p:sp>
       <p:sp>
         <p:nvSpPr>
-          <p:cNvPr id="31" name="TextBox 30"/>
+          <p:cNvPr id="30" name="TextBox 29"/>
           <p:cNvSpPr txBox="1"/>
           <p:nvPr/>
         </p:nvSpPr>
@@ -19370,7 +18950,7 @@
       </p:sp>
       <p:sp>
         <p:nvSpPr>
-          <p:cNvPr id="32" name="TextBox 31"/>
+          <p:cNvPr id="31" name="TextBox 30"/>
           <p:cNvSpPr txBox="1"/>
           <p:nvPr/>
         </p:nvSpPr>
@@ -19408,7 +18988,7 @@
       </p:sp>
       <p:sp>
         <p:nvSpPr>
-          <p:cNvPr id="33" name="Rounded Rectangle 32"/>
+          <p:cNvPr id="32" name="Rounded Rectangle 31"/>
           <p:cNvSpPr/>
           <p:nvPr/>
         </p:nvSpPr>
@@ -19456,7 +19036,7 @@
       </p:sp>
       <p:sp>
         <p:nvSpPr>
-          <p:cNvPr id="34" name="TextBox 33"/>
+          <p:cNvPr id="33" name="TextBox 32"/>
           <p:cNvSpPr txBox="1"/>
           <p:nvPr/>
         </p:nvSpPr>
@@ -19491,7 +19071,7 @@
       </p:sp>
       <p:sp>
         <p:nvSpPr>
-          <p:cNvPr id="35" name="TextBox 34"/>
+          <p:cNvPr id="34" name="TextBox 33"/>
           <p:cNvSpPr txBox="1"/>
           <p:nvPr/>
         </p:nvSpPr>
@@ -19639,7 +19219,7 @@
         <p:spPr>
           <a:xfrm>
             <a:off x="457200" y="164592"/>
-            <a:ext cx="1828800" cy="329184"/>
+            <a:ext cx="2286000" cy="329184"/>
           </a:xfrm>
           <a:prstGeom prst="rect">
             <a:avLst/>
@@ -19668,41 +19248,6 @@
       <p:sp>
         <p:nvSpPr>
           <p:cNvPr id="5" name="TextBox 4"/>
-          <p:cNvSpPr txBox="1"/>
-          <p:nvPr/>
-        </p:nvSpPr>
-        <p:spPr>
-          <a:xfrm>
-            <a:off x="1691640" y="201168"/>
-            <a:ext cx="822960" cy="274320"/>
-          </a:xfrm>
-          <a:prstGeom prst="rect">
-            <a:avLst/>
-          </a:prstGeom>
-          <a:noFill/>
-        </p:spPr>
-        <p:txBody>
-          <a:bodyPr wrap="square" anchor="t" lIns="0" rIns="0" tIns="0" bIns="0">
-            <a:spAutoFit/>
-          </a:bodyPr>
-          <a:lstStyle/>
-          <a:p>
-            <a:pPr algn="l"/>
-            <a:r>
-              <a:rPr sz="1100" b="1">
-                <a:solidFill>
-                  <a:srgbClr val="2863C5"/>
-                </a:solidFill>
-                <a:latin typeface="Open Sans"/>
-              </a:rPr>
-              <a:t>BETA</a:t>
-            </a:r>
-          </a:p>
-        </p:txBody>
-      </p:sp>
-      <p:sp>
-        <p:nvSpPr>
-          <p:cNvPr id="6" name="TextBox 5"/>
           <p:cNvSpPr txBox="1"/>
           <p:nvPr/>
         </p:nvSpPr>
@@ -19737,7 +19282,7 @@
       </p:sp>
       <p:sp>
         <p:nvSpPr>
-          <p:cNvPr id="7" name="TextBox 6"/>
+          <p:cNvPr id="6" name="TextBox 5"/>
           <p:cNvSpPr txBox="1"/>
           <p:nvPr/>
         </p:nvSpPr>
@@ -19772,7 +19317,7 @@
       </p:sp>
       <p:sp>
         <p:nvSpPr>
-          <p:cNvPr id="8" name="TextBox 7"/>
+          <p:cNvPr id="7" name="TextBox 6"/>
           <p:cNvSpPr txBox="1"/>
           <p:nvPr/>
         </p:nvSpPr>
@@ -19807,7 +19352,7 @@
       </p:sp>
       <p:sp>
         <p:nvSpPr>
-          <p:cNvPr id="9" name="TextBox 8"/>
+          <p:cNvPr id="8" name="TextBox 7"/>
           <p:cNvSpPr txBox="1"/>
           <p:nvPr/>
         </p:nvSpPr>
@@ -19842,7 +19387,7 @@
       </p:sp>
       <p:sp>
         <p:nvSpPr>
-          <p:cNvPr id="10" name="Rounded Rectangle 9"/>
+          <p:cNvPr id="9" name="Rounded Rectangle 8"/>
           <p:cNvSpPr/>
           <p:nvPr/>
         </p:nvSpPr>
@@ -19890,7 +19435,7 @@
       </p:sp>
       <p:sp>
         <p:nvSpPr>
-          <p:cNvPr id="11" name="Rectangle 10"/>
+          <p:cNvPr id="10" name="Rectangle 9"/>
           <p:cNvSpPr/>
           <p:nvPr/>
         </p:nvSpPr>
@@ -19934,7 +19479,7 @@
       </p:sp>
       <p:sp>
         <p:nvSpPr>
-          <p:cNvPr id="12" name="TextBox 11"/>
+          <p:cNvPr id="11" name="TextBox 10"/>
           <p:cNvSpPr txBox="1"/>
           <p:nvPr/>
         </p:nvSpPr>
@@ -19969,7 +19514,7 @@
       </p:sp>
       <p:sp>
         <p:nvSpPr>
-          <p:cNvPr id="13" name="TextBox 12"/>
+          <p:cNvPr id="12" name="TextBox 11"/>
           <p:cNvSpPr txBox="1"/>
           <p:nvPr/>
         </p:nvSpPr>
@@ -20004,7 +19549,7 @@
       </p:sp>
       <p:sp>
         <p:nvSpPr>
-          <p:cNvPr id="14" name="TextBox 13"/>
+          <p:cNvPr id="13" name="TextBox 12"/>
           <p:cNvSpPr txBox="1"/>
           <p:nvPr/>
         </p:nvSpPr>
@@ -20039,7 +19584,7 @@
       </p:sp>
       <p:sp>
         <p:nvSpPr>
-          <p:cNvPr id="15" name="TextBox 14"/>
+          <p:cNvPr id="14" name="TextBox 13"/>
           <p:cNvSpPr txBox="1"/>
           <p:nvPr/>
         </p:nvSpPr>
@@ -20074,7 +19619,7 @@
       </p:sp>
       <p:sp>
         <p:nvSpPr>
-          <p:cNvPr id="16" name="Rounded Rectangle 15"/>
+          <p:cNvPr id="15" name="Rounded Rectangle 14"/>
           <p:cNvSpPr/>
           <p:nvPr/>
         </p:nvSpPr>
@@ -20128,7 +19673,7 @@
       </p:sp>
       <p:sp>
         <p:nvSpPr>
-          <p:cNvPr id="17" name="Rounded Rectangle 16"/>
+          <p:cNvPr id="16" name="Rounded Rectangle 15"/>
           <p:cNvSpPr/>
           <p:nvPr/>
         </p:nvSpPr>
@@ -20176,7 +19721,7 @@
       </p:sp>
       <p:sp>
         <p:nvSpPr>
-          <p:cNvPr id="18" name="Rectangle 17"/>
+          <p:cNvPr id="17" name="Rectangle 16"/>
           <p:cNvSpPr/>
           <p:nvPr/>
         </p:nvSpPr>
@@ -20220,7 +19765,7 @@
       </p:sp>
       <p:sp>
         <p:nvSpPr>
-          <p:cNvPr id="19" name="TextBox 18"/>
+          <p:cNvPr id="18" name="TextBox 17"/>
           <p:cNvSpPr txBox="1"/>
           <p:nvPr/>
         </p:nvSpPr>
@@ -20255,7 +19800,7 @@
       </p:sp>
       <p:sp>
         <p:nvSpPr>
-          <p:cNvPr id="20" name="TextBox 19"/>
+          <p:cNvPr id="19" name="TextBox 18"/>
           <p:cNvSpPr txBox="1"/>
           <p:nvPr/>
         </p:nvSpPr>
@@ -20290,7 +19835,7 @@
       </p:sp>
       <p:sp>
         <p:nvSpPr>
-          <p:cNvPr id="21" name="TextBox 20"/>
+          <p:cNvPr id="20" name="TextBox 19"/>
           <p:cNvSpPr txBox="1"/>
           <p:nvPr/>
         </p:nvSpPr>
@@ -20325,7 +19870,7 @@
       </p:sp>
       <p:sp>
         <p:nvSpPr>
-          <p:cNvPr id="22" name="TextBox 21"/>
+          <p:cNvPr id="21" name="TextBox 20"/>
           <p:cNvSpPr txBox="1"/>
           <p:nvPr/>
         </p:nvSpPr>
@@ -20360,7 +19905,7 @@
       </p:sp>
       <p:sp>
         <p:nvSpPr>
-          <p:cNvPr id="23" name="Rounded Rectangle 22"/>
+          <p:cNvPr id="22" name="Rounded Rectangle 21"/>
           <p:cNvSpPr/>
           <p:nvPr/>
         </p:nvSpPr>
@@ -20414,7 +19959,7 @@
       </p:sp>
       <p:sp>
         <p:nvSpPr>
-          <p:cNvPr id="24" name="Rounded Rectangle 23"/>
+          <p:cNvPr id="23" name="Rounded Rectangle 22"/>
           <p:cNvSpPr/>
           <p:nvPr/>
         </p:nvSpPr>
@@ -20462,7 +20007,7 @@
       </p:sp>
       <p:sp>
         <p:nvSpPr>
-          <p:cNvPr id="25" name="Rectangle 24"/>
+          <p:cNvPr id="24" name="Rectangle 23"/>
           <p:cNvSpPr/>
           <p:nvPr/>
         </p:nvSpPr>
@@ -20506,7 +20051,7 @@
       </p:sp>
       <p:sp>
         <p:nvSpPr>
-          <p:cNvPr id="26" name="TextBox 25"/>
+          <p:cNvPr id="25" name="TextBox 24"/>
           <p:cNvSpPr txBox="1"/>
           <p:nvPr/>
         </p:nvSpPr>
@@ -20541,7 +20086,7 @@
       </p:sp>
       <p:sp>
         <p:nvSpPr>
-          <p:cNvPr id="27" name="TextBox 26"/>
+          <p:cNvPr id="26" name="TextBox 25"/>
           <p:cNvSpPr txBox="1"/>
           <p:nvPr/>
         </p:nvSpPr>
@@ -20576,7 +20121,7 @@
       </p:sp>
       <p:sp>
         <p:nvSpPr>
-          <p:cNvPr id="28" name="TextBox 27"/>
+          <p:cNvPr id="27" name="TextBox 26"/>
           <p:cNvSpPr txBox="1"/>
           <p:nvPr/>
         </p:nvSpPr>
@@ -20611,7 +20156,7 @@
       </p:sp>
       <p:sp>
         <p:nvSpPr>
-          <p:cNvPr id="29" name="TextBox 28"/>
+          <p:cNvPr id="28" name="TextBox 27"/>
           <p:cNvSpPr txBox="1"/>
           <p:nvPr/>
         </p:nvSpPr>
@@ -20646,7 +20191,7 @@
       </p:sp>
       <p:sp>
         <p:nvSpPr>
-          <p:cNvPr id="30" name="Rounded Rectangle 29"/>
+          <p:cNvPr id="29" name="Rounded Rectangle 28"/>
           <p:cNvSpPr/>
           <p:nvPr/>
         </p:nvSpPr>
@@ -20700,7 +20245,7 @@
       </p:sp>
       <p:sp>
         <p:nvSpPr>
-          <p:cNvPr id="31" name="Rounded Rectangle 30"/>
+          <p:cNvPr id="30" name="Rounded Rectangle 29"/>
           <p:cNvSpPr/>
           <p:nvPr/>
         </p:nvSpPr>
@@ -20748,7 +20293,7 @@
       </p:sp>
       <p:sp>
         <p:nvSpPr>
-          <p:cNvPr id="32" name="Rectangle 31"/>
+          <p:cNvPr id="31" name="Rectangle 30"/>
           <p:cNvSpPr/>
           <p:nvPr/>
         </p:nvSpPr>
@@ -20792,7 +20337,7 @@
       </p:sp>
       <p:sp>
         <p:nvSpPr>
-          <p:cNvPr id="33" name="TextBox 32"/>
+          <p:cNvPr id="32" name="TextBox 31"/>
           <p:cNvSpPr txBox="1"/>
           <p:nvPr/>
         </p:nvSpPr>
@@ -20827,7 +20372,7 @@
       </p:sp>
       <p:sp>
         <p:nvSpPr>
-          <p:cNvPr id="34" name="TextBox 33"/>
+          <p:cNvPr id="33" name="TextBox 32"/>
           <p:cNvSpPr txBox="1"/>
           <p:nvPr/>
         </p:nvSpPr>
@@ -20862,7 +20407,7 @@
       </p:sp>
       <p:sp>
         <p:nvSpPr>
-          <p:cNvPr id="35" name="TextBox 34"/>
+          <p:cNvPr id="34" name="TextBox 33"/>
           <p:cNvSpPr txBox="1"/>
           <p:nvPr/>
         </p:nvSpPr>
@@ -20897,7 +20442,7 @@
       </p:sp>
       <p:sp>
         <p:nvSpPr>
-          <p:cNvPr id="36" name="TextBox 35"/>
+          <p:cNvPr id="35" name="TextBox 34"/>
           <p:cNvSpPr txBox="1"/>
           <p:nvPr/>
         </p:nvSpPr>
@@ -20932,7 +20477,7 @@
       </p:sp>
       <p:sp>
         <p:nvSpPr>
-          <p:cNvPr id="37" name="Rounded Rectangle 36"/>
+          <p:cNvPr id="36" name="Rounded Rectangle 35"/>
           <p:cNvSpPr/>
           <p:nvPr/>
         </p:nvSpPr>
@@ -20986,7 +20531,7 @@
       </p:sp>
       <p:sp>
         <p:nvSpPr>
-          <p:cNvPr id="38" name="Rounded Rectangle 37"/>
+          <p:cNvPr id="37" name="Rounded Rectangle 36"/>
           <p:cNvSpPr/>
           <p:nvPr/>
         </p:nvSpPr>
@@ -21032,7 +20577,7 @@
       </p:sp>
       <p:sp>
         <p:nvSpPr>
-          <p:cNvPr id="39" name="TextBox 38"/>
+          <p:cNvPr id="38" name="TextBox 37"/>
           <p:cNvSpPr txBox="1"/>
           <p:nvPr/>
         </p:nvSpPr>

</xml_diff>

<commit_message>
Slide 6 — fix table/callout overlap on customer-match slide
Distribution and per-tier tables were rendering at row_h=0.4 and the
4-row body extended past y=7.0 where the bottom callout sits. Reduced
row_h to 0.33 with tighter header (0.26) and 10.5pt body — both tables
now end at y=6.85, giving 0.15in clearance to the callout at y=7.0.

Co-Authored-By: Claude Opus 4.7 (1M context) <noreply@anthropic.com>
</commit_message>
<xml_diff>
--- a/myReclaim-Exec-Deck.pptx
+++ b/myReclaim-Exec-Deck.pptx
@@ -11049,7 +11049,7 @@
         <p:spPr>
           <a:xfrm>
             <a:off x="457200" y="4846320"/>
-            <a:ext cx="5486400" cy="256032"/>
+            <a:ext cx="5486400" cy="237744"/>
           </a:xfrm>
           <a:prstGeom prst="rect">
             <a:avLst/>
@@ -11092,8 +11092,8 @@
         </p:nvSpPr>
         <p:spPr>
           <a:xfrm>
-            <a:off x="548640" y="4892040"/>
-            <a:ext cx="1554480" cy="201168"/>
+            <a:off x="548640" y="4882896"/>
+            <a:ext cx="1554480" cy="182880"/>
           </a:xfrm>
           <a:prstGeom prst="rect">
             <a:avLst/>
@@ -11127,8 +11127,8 @@
         </p:nvSpPr>
         <p:spPr>
           <a:xfrm>
-            <a:off x="2194560" y="4892040"/>
-            <a:ext cx="914400" cy="201168"/>
+            <a:off x="2194560" y="4882896"/>
+            <a:ext cx="914400" cy="182880"/>
           </a:xfrm>
           <a:prstGeom prst="rect">
             <a:avLst/>
@@ -11162,8 +11162,8 @@
         </p:nvSpPr>
         <p:spPr>
           <a:xfrm>
-            <a:off x="3246120" y="4892040"/>
-            <a:ext cx="914400" cy="201168"/>
+            <a:off x="3246120" y="4882896"/>
+            <a:ext cx="914400" cy="182880"/>
           </a:xfrm>
           <a:prstGeom prst="rect">
             <a:avLst/>
@@ -11197,8 +11197,8 @@
         </p:nvSpPr>
         <p:spPr>
           <a:xfrm>
-            <a:off x="4297680" y="4892040"/>
-            <a:ext cx="1554480" cy="201168"/>
+            <a:off x="4297680" y="4882896"/>
+            <a:ext cx="1554480" cy="182880"/>
           </a:xfrm>
           <a:prstGeom prst="rect">
             <a:avLst/>
@@ -11232,8 +11232,8 @@
         </p:nvSpPr>
         <p:spPr>
           <a:xfrm>
-            <a:off x="457200" y="5102352"/>
-            <a:ext cx="5486400" cy="365760"/>
+            <a:off x="457200" y="5084064"/>
+            <a:ext cx="5486400" cy="301752"/>
           </a:xfrm>
           <a:prstGeom prst="rect">
             <a:avLst/>
@@ -11276,23 +11276,23 @@
         </p:nvSpPr>
         <p:spPr>
           <a:xfrm>
-            <a:off x="548640" y="5175504"/>
-            <a:ext cx="1554480" cy="228600"/>
-          </a:xfrm>
-          <a:prstGeom prst="rect">
-            <a:avLst/>
-          </a:prstGeom>
-          <a:noFill/>
-        </p:spPr>
-        <p:txBody>
-          <a:bodyPr wrap="square" anchor="t" lIns="0" rIns="0" tIns="0" bIns="0">
-            <a:spAutoFit/>
-          </a:bodyPr>
-          <a:lstStyle/>
-          <a:p>
-            <a:pPr algn="l"/>
-            <a:r>
-              <a:rPr sz="1100" b="1">
+            <a:off x="548640" y="5138927"/>
+            <a:ext cx="1554480" cy="201168"/>
+          </a:xfrm>
+          <a:prstGeom prst="rect">
+            <a:avLst/>
+          </a:prstGeom>
+          <a:noFill/>
+        </p:spPr>
+        <p:txBody>
+          <a:bodyPr wrap="square" anchor="t" lIns="0" rIns="0" tIns="0" bIns="0">
+            <a:spAutoFit/>
+          </a:bodyPr>
+          <a:lstStyle/>
+          <a:p>
+            <a:pPr algn="l"/>
+            <a:r>
+              <a:rPr sz="1050" b="1">
                 <a:solidFill>
                   <a:srgbClr val="0F172A"/>
                 </a:solidFill>
@@ -11311,23 +11311,23 @@
         </p:nvSpPr>
         <p:spPr>
           <a:xfrm>
-            <a:off x="2194560" y="5175504"/>
-            <a:ext cx="914400" cy="228600"/>
-          </a:xfrm>
-          <a:prstGeom prst="rect">
-            <a:avLst/>
-          </a:prstGeom>
-          <a:noFill/>
-        </p:spPr>
-        <p:txBody>
-          <a:bodyPr wrap="square" anchor="t" lIns="0" rIns="0" tIns="0" bIns="0">
-            <a:spAutoFit/>
-          </a:bodyPr>
-          <a:lstStyle/>
-          <a:p>
-            <a:pPr algn="l"/>
-            <a:r>
-              <a:rPr sz="1100" b="0">
+            <a:off x="2194560" y="5138927"/>
+            <a:ext cx="914400" cy="201168"/>
+          </a:xfrm>
+          <a:prstGeom prst="rect">
+            <a:avLst/>
+          </a:prstGeom>
+          <a:noFill/>
+        </p:spPr>
+        <p:txBody>
+          <a:bodyPr wrap="square" anchor="t" lIns="0" rIns="0" tIns="0" bIns="0">
+            <a:spAutoFit/>
+          </a:bodyPr>
+          <a:lstStyle/>
+          <a:p>
+            <a:pPr algn="l"/>
+            <a:r>
+              <a:rPr sz="1050" b="0">
                 <a:solidFill>
                   <a:srgbClr val="334155"/>
                 </a:solidFill>
@@ -11346,23 +11346,23 @@
         </p:nvSpPr>
         <p:spPr>
           <a:xfrm>
-            <a:off x="3246120" y="5175504"/>
-            <a:ext cx="914400" cy="228600"/>
-          </a:xfrm>
-          <a:prstGeom prst="rect">
-            <a:avLst/>
-          </a:prstGeom>
-          <a:noFill/>
-        </p:spPr>
-        <p:txBody>
-          <a:bodyPr wrap="square" anchor="t" lIns="0" rIns="0" tIns="0" bIns="0">
-            <a:spAutoFit/>
-          </a:bodyPr>
-          <a:lstStyle/>
-          <a:p>
-            <a:pPr algn="l"/>
-            <a:r>
-              <a:rPr sz="1100" b="1">
+            <a:off x="3246120" y="5138927"/>
+            <a:ext cx="914400" cy="201168"/>
+          </a:xfrm>
+          <a:prstGeom prst="rect">
+            <a:avLst/>
+          </a:prstGeom>
+          <a:noFill/>
+        </p:spPr>
+        <p:txBody>
+          <a:bodyPr wrap="square" anchor="t" lIns="0" rIns="0" tIns="0" bIns="0">
+            <a:spAutoFit/>
+          </a:bodyPr>
+          <a:lstStyle/>
+          <a:p>
+            <a:pPr algn="l"/>
+            <a:r>
+              <a:rPr sz="1050" b="1">
                 <a:solidFill>
                   <a:srgbClr val="059669"/>
                 </a:solidFill>
@@ -11381,23 +11381,23 @@
         </p:nvSpPr>
         <p:spPr>
           <a:xfrm>
-            <a:off x="4297680" y="5175504"/>
-            <a:ext cx="1554480" cy="228600"/>
-          </a:xfrm>
-          <a:prstGeom prst="rect">
-            <a:avLst/>
-          </a:prstGeom>
-          <a:noFill/>
-        </p:spPr>
-        <p:txBody>
-          <a:bodyPr wrap="square" anchor="t" lIns="0" rIns="0" tIns="0" bIns="0">
-            <a:spAutoFit/>
-          </a:bodyPr>
-          <a:lstStyle/>
-          <a:p>
-            <a:pPr algn="l"/>
-            <a:r>
-              <a:rPr sz="1000" b="0">
+            <a:off x="4297680" y="5138927"/>
+            <a:ext cx="1554480" cy="201168"/>
+          </a:xfrm>
+          <a:prstGeom prst="rect">
+            <a:avLst/>
+          </a:prstGeom>
+          <a:noFill/>
+        </p:spPr>
+        <p:txBody>
+          <a:bodyPr wrap="square" anchor="t" lIns="0" rIns="0" tIns="0" bIns="0">
+            <a:spAutoFit/>
+          </a:bodyPr>
+          <a:lstStyle/>
+          <a:p>
+            <a:pPr algn="l"/>
+            <a:r>
+              <a:rPr sz="950" b="0">
                 <a:solidFill>
                   <a:srgbClr val="64748B"/>
                 </a:solidFill>
@@ -11416,8 +11416,8 @@
         </p:nvSpPr>
         <p:spPr>
           <a:xfrm>
-            <a:off x="457200" y="5468112"/>
-            <a:ext cx="5486400" cy="365760"/>
+            <a:off x="457200" y="5385816"/>
+            <a:ext cx="5486400" cy="301752"/>
           </a:xfrm>
           <a:prstGeom prst="rect">
             <a:avLst/>
@@ -11460,23 +11460,23 @@
         </p:nvSpPr>
         <p:spPr>
           <a:xfrm>
-            <a:off x="548640" y="5541264"/>
-            <a:ext cx="1554480" cy="228600"/>
-          </a:xfrm>
-          <a:prstGeom prst="rect">
-            <a:avLst/>
-          </a:prstGeom>
-          <a:noFill/>
-        </p:spPr>
-        <p:txBody>
-          <a:bodyPr wrap="square" anchor="t" lIns="0" rIns="0" tIns="0" bIns="0">
-            <a:spAutoFit/>
-          </a:bodyPr>
-          <a:lstStyle/>
-          <a:p>
-            <a:pPr algn="l"/>
-            <a:r>
-              <a:rPr sz="1100" b="1">
+            <a:off x="548640" y="5440679"/>
+            <a:ext cx="1554480" cy="201168"/>
+          </a:xfrm>
+          <a:prstGeom prst="rect">
+            <a:avLst/>
+          </a:prstGeom>
+          <a:noFill/>
+        </p:spPr>
+        <p:txBody>
+          <a:bodyPr wrap="square" anchor="t" lIns="0" rIns="0" tIns="0" bIns="0">
+            <a:spAutoFit/>
+          </a:bodyPr>
+          <a:lstStyle/>
+          <a:p>
+            <a:pPr algn="l"/>
+            <a:r>
+              <a:rPr sz="1050" b="1">
                 <a:solidFill>
                   <a:srgbClr val="0F172A"/>
                 </a:solidFill>
@@ -11495,23 +11495,23 @@
         </p:nvSpPr>
         <p:spPr>
           <a:xfrm>
-            <a:off x="2194560" y="5541264"/>
-            <a:ext cx="914400" cy="228600"/>
-          </a:xfrm>
-          <a:prstGeom prst="rect">
-            <a:avLst/>
-          </a:prstGeom>
-          <a:noFill/>
-        </p:spPr>
-        <p:txBody>
-          <a:bodyPr wrap="square" anchor="t" lIns="0" rIns="0" tIns="0" bIns="0">
-            <a:spAutoFit/>
-          </a:bodyPr>
-          <a:lstStyle/>
-          <a:p>
-            <a:pPr algn="l"/>
-            <a:r>
-              <a:rPr sz="1100" b="0">
+            <a:off x="2194560" y="5440679"/>
+            <a:ext cx="914400" cy="201168"/>
+          </a:xfrm>
+          <a:prstGeom prst="rect">
+            <a:avLst/>
+          </a:prstGeom>
+          <a:noFill/>
+        </p:spPr>
+        <p:txBody>
+          <a:bodyPr wrap="square" anchor="t" lIns="0" rIns="0" tIns="0" bIns="0">
+            <a:spAutoFit/>
+          </a:bodyPr>
+          <a:lstStyle/>
+          <a:p>
+            <a:pPr algn="l"/>
+            <a:r>
+              <a:rPr sz="1050" b="0">
                 <a:solidFill>
                   <a:srgbClr val="334155"/>
                 </a:solidFill>
@@ -11530,23 +11530,23 @@
         </p:nvSpPr>
         <p:spPr>
           <a:xfrm>
-            <a:off x="3246120" y="5541264"/>
-            <a:ext cx="914400" cy="228600"/>
-          </a:xfrm>
-          <a:prstGeom prst="rect">
-            <a:avLst/>
-          </a:prstGeom>
-          <a:noFill/>
-        </p:spPr>
-        <p:txBody>
-          <a:bodyPr wrap="square" anchor="t" lIns="0" rIns="0" tIns="0" bIns="0">
-            <a:spAutoFit/>
-          </a:bodyPr>
-          <a:lstStyle/>
-          <a:p>
-            <a:pPr algn="l"/>
-            <a:r>
-              <a:rPr sz="1100" b="1">
+            <a:off x="3246120" y="5440679"/>
+            <a:ext cx="914400" cy="201168"/>
+          </a:xfrm>
+          <a:prstGeom prst="rect">
+            <a:avLst/>
+          </a:prstGeom>
+          <a:noFill/>
+        </p:spPr>
+        <p:txBody>
+          <a:bodyPr wrap="square" anchor="t" lIns="0" rIns="0" tIns="0" bIns="0">
+            <a:spAutoFit/>
+          </a:bodyPr>
+          <a:lstStyle/>
+          <a:p>
+            <a:pPr algn="l"/>
+            <a:r>
+              <a:rPr sz="1050" b="1">
                 <a:solidFill>
                   <a:srgbClr val="059669"/>
                 </a:solidFill>
@@ -11565,23 +11565,23 @@
         </p:nvSpPr>
         <p:spPr>
           <a:xfrm>
-            <a:off x="4297680" y="5541264"/>
-            <a:ext cx="1554480" cy="228600"/>
-          </a:xfrm>
-          <a:prstGeom prst="rect">
-            <a:avLst/>
-          </a:prstGeom>
-          <a:noFill/>
-        </p:spPr>
-        <p:txBody>
-          <a:bodyPr wrap="square" anchor="t" lIns="0" rIns="0" tIns="0" bIns="0">
-            <a:spAutoFit/>
-          </a:bodyPr>
-          <a:lstStyle/>
-          <a:p>
-            <a:pPr algn="l"/>
-            <a:r>
-              <a:rPr sz="1000" b="0">
+            <a:off x="4297680" y="5440679"/>
+            <a:ext cx="1554480" cy="201168"/>
+          </a:xfrm>
+          <a:prstGeom prst="rect">
+            <a:avLst/>
+          </a:prstGeom>
+          <a:noFill/>
+        </p:spPr>
+        <p:txBody>
+          <a:bodyPr wrap="square" anchor="t" lIns="0" rIns="0" tIns="0" bIns="0">
+            <a:spAutoFit/>
+          </a:bodyPr>
+          <a:lstStyle/>
+          <a:p>
+            <a:pPr algn="l"/>
+            <a:r>
+              <a:rPr sz="950" b="0">
                 <a:solidFill>
                   <a:srgbClr val="64748B"/>
                 </a:solidFill>
@@ -11600,8 +11600,8 @@
         </p:nvSpPr>
         <p:spPr>
           <a:xfrm>
-            <a:off x="457200" y="5833872"/>
-            <a:ext cx="5486400" cy="365760"/>
+            <a:off x="457200" y="5687568"/>
+            <a:ext cx="5486400" cy="301752"/>
           </a:xfrm>
           <a:prstGeom prst="rect">
             <a:avLst/>
@@ -11644,23 +11644,23 @@
         </p:nvSpPr>
         <p:spPr>
           <a:xfrm>
-            <a:off x="548640" y="5907024"/>
-            <a:ext cx="1554480" cy="228600"/>
-          </a:xfrm>
-          <a:prstGeom prst="rect">
-            <a:avLst/>
-          </a:prstGeom>
-          <a:noFill/>
-        </p:spPr>
-        <p:txBody>
-          <a:bodyPr wrap="square" anchor="t" lIns="0" rIns="0" tIns="0" bIns="0">
-            <a:spAutoFit/>
-          </a:bodyPr>
-          <a:lstStyle/>
-          <a:p>
-            <a:pPr algn="l"/>
-            <a:r>
-              <a:rPr sz="1100" b="1">
+            <a:off x="548640" y="5742431"/>
+            <a:ext cx="1554480" cy="201168"/>
+          </a:xfrm>
+          <a:prstGeom prst="rect">
+            <a:avLst/>
+          </a:prstGeom>
+          <a:noFill/>
+        </p:spPr>
+        <p:txBody>
+          <a:bodyPr wrap="square" anchor="t" lIns="0" rIns="0" tIns="0" bIns="0">
+            <a:spAutoFit/>
+          </a:bodyPr>
+          <a:lstStyle/>
+          <a:p>
+            <a:pPr algn="l"/>
+            <a:r>
+              <a:rPr sz="1050" b="1">
                 <a:solidFill>
                   <a:srgbClr val="0F172A"/>
                 </a:solidFill>
@@ -11679,23 +11679,23 @@
         </p:nvSpPr>
         <p:spPr>
           <a:xfrm>
-            <a:off x="2194560" y="5907024"/>
-            <a:ext cx="914400" cy="228600"/>
-          </a:xfrm>
-          <a:prstGeom prst="rect">
-            <a:avLst/>
-          </a:prstGeom>
-          <a:noFill/>
-        </p:spPr>
-        <p:txBody>
-          <a:bodyPr wrap="square" anchor="t" lIns="0" rIns="0" tIns="0" bIns="0">
-            <a:spAutoFit/>
-          </a:bodyPr>
-          <a:lstStyle/>
-          <a:p>
-            <a:pPr algn="l"/>
-            <a:r>
-              <a:rPr sz="1100" b="0">
+            <a:off x="2194560" y="5742431"/>
+            <a:ext cx="914400" cy="201168"/>
+          </a:xfrm>
+          <a:prstGeom prst="rect">
+            <a:avLst/>
+          </a:prstGeom>
+          <a:noFill/>
+        </p:spPr>
+        <p:txBody>
+          <a:bodyPr wrap="square" anchor="t" lIns="0" rIns="0" tIns="0" bIns="0">
+            <a:spAutoFit/>
+          </a:bodyPr>
+          <a:lstStyle/>
+          <a:p>
+            <a:pPr algn="l"/>
+            <a:r>
+              <a:rPr sz="1050" b="0">
                 <a:solidFill>
                   <a:srgbClr val="334155"/>
                 </a:solidFill>
@@ -11714,23 +11714,23 @@
         </p:nvSpPr>
         <p:spPr>
           <a:xfrm>
-            <a:off x="3246120" y="5907024"/>
-            <a:ext cx="914400" cy="228600"/>
-          </a:xfrm>
-          <a:prstGeom prst="rect">
-            <a:avLst/>
-          </a:prstGeom>
-          <a:noFill/>
-        </p:spPr>
-        <p:txBody>
-          <a:bodyPr wrap="square" anchor="t" lIns="0" rIns="0" tIns="0" bIns="0">
-            <a:spAutoFit/>
-          </a:bodyPr>
-          <a:lstStyle/>
-          <a:p>
-            <a:pPr algn="l"/>
-            <a:r>
-              <a:rPr sz="1100" b="1">
+            <a:off x="3246120" y="5742431"/>
+            <a:ext cx="914400" cy="201168"/>
+          </a:xfrm>
+          <a:prstGeom prst="rect">
+            <a:avLst/>
+          </a:prstGeom>
+          <a:noFill/>
+        </p:spPr>
+        <p:txBody>
+          <a:bodyPr wrap="square" anchor="t" lIns="0" rIns="0" tIns="0" bIns="0">
+            <a:spAutoFit/>
+          </a:bodyPr>
+          <a:lstStyle/>
+          <a:p>
+            <a:pPr algn="l"/>
+            <a:r>
+              <a:rPr sz="1050" b="1">
                 <a:solidFill>
                   <a:srgbClr val="FFB352"/>
                 </a:solidFill>
@@ -11749,23 +11749,23 @@
         </p:nvSpPr>
         <p:spPr>
           <a:xfrm>
-            <a:off x="4297680" y="5907024"/>
-            <a:ext cx="1554480" cy="228600"/>
-          </a:xfrm>
-          <a:prstGeom prst="rect">
-            <a:avLst/>
-          </a:prstGeom>
-          <a:noFill/>
-        </p:spPr>
-        <p:txBody>
-          <a:bodyPr wrap="square" anchor="t" lIns="0" rIns="0" tIns="0" bIns="0">
-            <a:spAutoFit/>
-          </a:bodyPr>
-          <a:lstStyle/>
-          <a:p>
-            <a:pPr algn="l"/>
-            <a:r>
-              <a:rPr sz="1000" b="0">
+            <a:off x="4297680" y="5742431"/>
+            <a:ext cx="1554480" cy="201168"/>
+          </a:xfrm>
+          <a:prstGeom prst="rect">
+            <a:avLst/>
+          </a:prstGeom>
+          <a:noFill/>
+        </p:spPr>
+        <p:txBody>
+          <a:bodyPr wrap="square" anchor="t" lIns="0" rIns="0" tIns="0" bIns="0">
+            <a:spAutoFit/>
+          </a:bodyPr>
+          <a:lstStyle/>
+          <a:p>
+            <a:pPr algn="l"/>
+            <a:r>
+              <a:rPr sz="950" b="0">
                 <a:solidFill>
                   <a:srgbClr val="64748B"/>
                 </a:solidFill>
@@ -11784,8 +11784,8 @@
         </p:nvSpPr>
         <p:spPr>
           <a:xfrm>
-            <a:off x="457200" y="6199632"/>
-            <a:ext cx="5486400" cy="365760"/>
+            <a:off x="457200" y="5989320"/>
+            <a:ext cx="5486400" cy="301752"/>
           </a:xfrm>
           <a:prstGeom prst="rect">
             <a:avLst/>
@@ -11828,23 +11828,23 @@
         </p:nvSpPr>
         <p:spPr>
           <a:xfrm>
-            <a:off x="548640" y="6272784"/>
-            <a:ext cx="1554480" cy="228600"/>
-          </a:xfrm>
-          <a:prstGeom prst="rect">
-            <a:avLst/>
-          </a:prstGeom>
-          <a:noFill/>
-        </p:spPr>
-        <p:txBody>
-          <a:bodyPr wrap="square" anchor="t" lIns="0" rIns="0" tIns="0" bIns="0">
-            <a:spAutoFit/>
-          </a:bodyPr>
-          <a:lstStyle/>
-          <a:p>
-            <a:pPr algn="l"/>
-            <a:r>
-              <a:rPr sz="1100" b="1">
+            <a:off x="548640" y="6044183"/>
+            <a:ext cx="1554480" cy="201168"/>
+          </a:xfrm>
+          <a:prstGeom prst="rect">
+            <a:avLst/>
+          </a:prstGeom>
+          <a:noFill/>
+        </p:spPr>
+        <p:txBody>
+          <a:bodyPr wrap="square" anchor="t" lIns="0" rIns="0" tIns="0" bIns="0">
+            <a:spAutoFit/>
+          </a:bodyPr>
+          <a:lstStyle/>
+          <a:p>
+            <a:pPr algn="l"/>
+            <a:r>
+              <a:rPr sz="1050" b="1">
                 <a:solidFill>
                   <a:srgbClr val="0F172A"/>
                 </a:solidFill>
@@ -11863,23 +11863,23 @@
         </p:nvSpPr>
         <p:spPr>
           <a:xfrm>
-            <a:off x="2194560" y="6272784"/>
-            <a:ext cx="914400" cy="228600"/>
-          </a:xfrm>
-          <a:prstGeom prst="rect">
-            <a:avLst/>
-          </a:prstGeom>
-          <a:noFill/>
-        </p:spPr>
-        <p:txBody>
-          <a:bodyPr wrap="square" anchor="t" lIns="0" rIns="0" tIns="0" bIns="0">
-            <a:spAutoFit/>
-          </a:bodyPr>
-          <a:lstStyle/>
-          <a:p>
-            <a:pPr algn="l"/>
-            <a:r>
-              <a:rPr sz="1100" b="0">
+            <a:off x="2194560" y="6044183"/>
+            <a:ext cx="914400" cy="201168"/>
+          </a:xfrm>
+          <a:prstGeom prst="rect">
+            <a:avLst/>
+          </a:prstGeom>
+          <a:noFill/>
+        </p:spPr>
+        <p:txBody>
+          <a:bodyPr wrap="square" anchor="t" lIns="0" rIns="0" tIns="0" bIns="0">
+            <a:spAutoFit/>
+          </a:bodyPr>
+          <a:lstStyle/>
+          <a:p>
+            <a:pPr algn="l"/>
+            <a:r>
+              <a:rPr sz="1050" b="0">
                 <a:solidFill>
                   <a:srgbClr val="334155"/>
                 </a:solidFill>
@@ -11898,23 +11898,23 @@
         </p:nvSpPr>
         <p:spPr>
           <a:xfrm>
-            <a:off x="3246120" y="6272784"/>
-            <a:ext cx="914400" cy="228600"/>
-          </a:xfrm>
-          <a:prstGeom prst="rect">
-            <a:avLst/>
-          </a:prstGeom>
-          <a:noFill/>
-        </p:spPr>
-        <p:txBody>
-          <a:bodyPr wrap="square" anchor="t" lIns="0" rIns="0" tIns="0" bIns="0">
-            <a:spAutoFit/>
-          </a:bodyPr>
-          <a:lstStyle/>
-          <a:p>
-            <a:pPr algn="l"/>
-            <a:r>
-              <a:rPr sz="1100" b="1">
+            <a:off x="3246120" y="6044183"/>
+            <a:ext cx="914400" cy="201168"/>
+          </a:xfrm>
+          <a:prstGeom prst="rect">
+            <a:avLst/>
+          </a:prstGeom>
+          <a:noFill/>
+        </p:spPr>
+        <p:txBody>
+          <a:bodyPr wrap="square" anchor="t" lIns="0" rIns="0" tIns="0" bIns="0">
+            <a:spAutoFit/>
+          </a:bodyPr>
+          <a:lstStyle/>
+          <a:p>
+            <a:pPr algn="l"/>
+            <a:r>
+              <a:rPr sz="1050" b="1">
                 <a:solidFill>
                   <a:srgbClr val="64748B"/>
                 </a:solidFill>
@@ -11933,23 +11933,23 @@
         </p:nvSpPr>
         <p:spPr>
           <a:xfrm>
-            <a:off x="4297680" y="6272784"/>
-            <a:ext cx="1554480" cy="228600"/>
-          </a:xfrm>
-          <a:prstGeom prst="rect">
-            <a:avLst/>
-          </a:prstGeom>
-          <a:noFill/>
-        </p:spPr>
-        <p:txBody>
-          <a:bodyPr wrap="square" anchor="t" lIns="0" rIns="0" tIns="0" bIns="0">
-            <a:spAutoFit/>
-          </a:bodyPr>
-          <a:lstStyle/>
-          <a:p>
-            <a:pPr algn="l"/>
-            <a:r>
-              <a:rPr sz="1000" b="0">
+            <a:off x="4297680" y="6044183"/>
+            <a:ext cx="1554480" cy="201168"/>
+          </a:xfrm>
+          <a:prstGeom prst="rect">
+            <a:avLst/>
+          </a:prstGeom>
+          <a:noFill/>
+        </p:spPr>
+        <p:txBody>
+          <a:bodyPr wrap="square" anchor="t" lIns="0" rIns="0" tIns="0" bIns="0">
+            <a:spAutoFit/>
+          </a:bodyPr>
+          <a:lstStyle/>
+          <a:p>
+            <a:pPr algn="l"/>
+            <a:r>
+              <a:rPr sz="950" b="0">
                 <a:solidFill>
                   <a:srgbClr val="64748B"/>
                 </a:solidFill>
@@ -12039,7 +12039,7 @@
         <p:spPr>
           <a:xfrm>
             <a:off x="6217920" y="4846320"/>
-            <a:ext cx="5486400" cy="256032"/>
+            <a:ext cx="5486400" cy="237744"/>
           </a:xfrm>
           <a:prstGeom prst="rect">
             <a:avLst/>
@@ -12082,8 +12082,8 @@
         </p:nvSpPr>
         <p:spPr>
           <a:xfrm>
-            <a:off x="6309360" y="4892040"/>
-            <a:ext cx="914400" cy="201168"/>
+            <a:off x="6309360" y="4882896"/>
+            <a:ext cx="914400" cy="182880"/>
           </a:xfrm>
           <a:prstGeom prst="rect">
             <a:avLst/>
@@ -12117,8 +12117,8 @@
         </p:nvSpPr>
         <p:spPr>
           <a:xfrm>
-            <a:off x="7269480" y="4892040"/>
-            <a:ext cx="1280160" cy="201168"/>
+            <a:off x="7269480" y="4882896"/>
+            <a:ext cx="1280160" cy="182880"/>
           </a:xfrm>
           <a:prstGeom prst="rect">
             <a:avLst/>
@@ -12152,8 +12152,8 @@
         </p:nvSpPr>
         <p:spPr>
           <a:xfrm>
-            <a:off x="8641080" y="4892040"/>
-            <a:ext cx="1371600" cy="201168"/>
+            <a:off x="8641080" y="4882896"/>
+            <a:ext cx="1371600" cy="182880"/>
           </a:xfrm>
           <a:prstGeom prst="rect">
             <a:avLst/>
@@ -12187,8 +12187,8 @@
         </p:nvSpPr>
         <p:spPr>
           <a:xfrm>
-            <a:off x="10104120" y="4892040"/>
-            <a:ext cx="1371600" cy="201168"/>
+            <a:off x="10104120" y="4882896"/>
+            <a:ext cx="1371600" cy="182880"/>
           </a:xfrm>
           <a:prstGeom prst="rect">
             <a:avLst/>
@@ -12222,8 +12222,8 @@
         </p:nvSpPr>
         <p:spPr>
           <a:xfrm>
-            <a:off x="6217920" y="5102352"/>
-            <a:ext cx="5486400" cy="365760"/>
+            <a:off x="6217920" y="5084064"/>
+            <a:ext cx="5486400" cy="301752"/>
           </a:xfrm>
           <a:prstGeom prst="rect">
             <a:avLst/>
@@ -12266,23 +12266,23 @@
         </p:nvSpPr>
         <p:spPr>
           <a:xfrm>
-            <a:off x="6309360" y="5175504"/>
-            <a:ext cx="914400" cy="228600"/>
-          </a:xfrm>
-          <a:prstGeom prst="rect">
-            <a:avLst/>
-          </a:prstGeom>
-          <a:noFill/>
-        </p:spPr>
-        <p:txBody>
-          <a:bodyPr wrap="square" anchor="t" lIns="0" rIns="0" tIns="0" bIns="0">
-            <a:spAutoFit/>
-          </a:bodyPr>
-          <a:lstStyle/>
-          <a:p>
-            <a:pPr algn="l"/>
-            <a:r>
-              <a:rPr sz="1100" b="1">
+            <a:off x="6309360" y="5138927"/>
+            <a:ext cx="914400" cy="201168"/>
+          </a:xfrm>
+          <a:prstGeom prst="rect">
+            <a:avLst/>
+          </a:prstGeom>
+          <a:noFill/>
+        </p:spPr>
+        <p:txBody>
+          <a:bodyPr wrap="square" anchor="t" lIns="0" rIns="0" tIns="0" bIns="0">
+            <a:spAutoFit/>
+          </a:bodyPr>
+          <a:lstStyle/>
+          <a:p>
+            <a:pPr algn="l"/>
+            <a:r>
+              <a:rPr sz="1050" b="1">
                 <a:solidFill>
                   <a:srgbClr val="64748B"/>
                 </a:solidFill>
@@ -12301,23 +12301,23 @@
         </p:nvSpPr>
         <p:spPr>
           <a:xfrm>
-            <a:off x="7269480" y="5175504"/>
-            <a:ext cx="1280160" cy="228600"/>
-          </a:xfrm>
-          <a:prstGeom prst="rect">
-            <a:avLst/>
-          </a:prstGeom>
-          <a:noFill/>
-        </p:spPr>
-        <p:txBody>
-          <a:bodyPr wrap="square" anchor="t" lIns="0" rIns="0" tIns="0" bIns="0">
-            <a:spAutoFit/>
-          </a:bodyPr>
-          <a:lstStyle/>
-          <a:p>
-            <a:pPr algn="l"/>
-            <a:r>
-              <a:rPr sz="1000" b="0">
+            <a:off x="7269480" y="5138927"/>
+            <a:ext cx="1280160" cy="201168"/>
+          </a:xfrm>
+          <a:prstGeom prst="rect">
+            <a:avLst/>
+          </a:prstGeom>
+          <a:noFill/>
+        </p:spPr>
+        <p:txBody>
+          <a:bodyPr wrap="square" anchor="t" lIns="0" rIns="0" tIns="0" bIns="0">
+            <a:spAutoFit/>
+          </a:bodyPr>
+          <a:lstStyle/>
+          <a:p>
+            <a:pPr algn="l"/>
+            <a:r>
+              <a:rPr sz="950" b="0">
                 <a:solidFill>
                   <a:srgbClr val="334155"/>
                 </a:solidFill>
@@ -12336,23 +12336,23 @@
         </p:nvSpPr>
         <p:spPr>
           <a:xfrm>
-            <a:off x="8641080" y="5175504"/>
-            <a:ext cx="1371600" cy="228600"/>
-          </a:xfrm>
-          <a:prstGeom prst="rect">
-            <a:avLst/>
-          </a:prstGeom>
-          <a:noFill/>
-        </p:spPr>
-        <p:txBody>
-          <a:bodyPr wrap="square" anchor="t" lIns="0" rIns="0" tIns="0" bIns="0">
-            <a:spAutoFit/>
-          </a:bodyPr>
-          <a:lstStyle/>
-          <a:p>
-            <a:pPr algn="l"/>
-            <a:r>
-              <a:rPr sz="1100" b="0">
+            <a:off x="8641080" y="5138927"/>
+            <a:ext cx="1371600" cy="201168"/>
+          </a:xfrm>
+          <a:prstGeom prst="rect">
+            <a:avLst/>
+          </a:prstGeom>
+          <a:noFill/>
+        </p:spPr>
+        <p:txBody>
+          <a:bodyPr wrap="square" anchor="t" lIns="0" rIns="0" tIns="0" bIns="0">
+            <a:spAutoFit/>
+          </a:bodyPr>
+          <a:lstStyle/>
+          <a:p>
+            <a:pPr algn="l"/>
+            <a:r>
+              <a:rPr sz="1050" b="0">
                 <a:solidFill>
                   <a:srgbClr val="334155"/>
                 </a:solidFill>
@@ -12371,23 +12371,23 @@
         </p:nvSpPr>
         <p:spPr>
           <a:xfrm>
-            <a:off x="10104120" y="5175504"/>
-            <a:ext cx="1371600" cy="228600"/>
-          </a:xfrm>
-          <a:prstGeom prst="rect">
-            <a:avLst/>
-          </a:prstGeom>
-          <a:noFill/>
-        </p:spPr>
-        <p:txBody>
-          <a:bodyPr wrap="square" anchor="t" lIns="0" rIns="0" tIns="0" bIns="0">
-            <a:spAutoFit/>
-          </a:bodyPr>
-          <a:lstStyle/>
-          <a:p>
-            <a:pPr algn="l"/>
-            <a:r>
-              <a:rPr sz="1100" b="1">
+            <a:off x="10104120" y="5138927"/>
+            <a:ext cx="1371600" cy="201168"/>
+          </a:xfrm>
+          <a:prstGeom prst="rect">
+            <a:avLst/>
+          </a:prstGeom>
+          <a:noFill/>
+        </p:spPr>
+        <p:txBody>
+          <a:bodyPr wrap="square" anchor="t" lIns="0" rIns="0" tIns="0" bIns="0">
+            <a:spAutoFit/>
+          </a:bodyPr>
+          <a:lstStyle/>
+          <a:p>
+            <a:pPr algn="l"/>
+            <a:r>
+              <a:rPr sz="1050" b="1">
                 <a:solidFill>
                   <a:srgbClr val="64748B"/>
                 </a:solidFill>
@@ -12406,8 +12406,8 @@
         </p:nvSpPr>
         <p:spPr>
           <a:xfrm>
-            <a:off x="6217920" y="5468112"/>
-            <a:ext cx="5486400" cy="365760"/>
+            <a:off x="6217920" y="5385816"/>
+            <a:ext cx="5486400" cy="301752"/>
           </a:xfrm>
           <a:prstGeom prst="rect">
             <a:avLst/>
@@ -12450,23 +12450,23 @@
         </p:nvSpPr>
         <p:spPr>
           <a:xfrm>
-            <a:off x="6309360" y="5541264"/>
-            <a:ext cx="914400" cy="228600"/>
-          </a:xfrm>
-          <a:prstGeom prst="rect">
-            <a:avLst/>
-          </a:prstGeom>
-          <a:noFill/>
-        </p:spPr>
-        <p:txBody>
-          <a:bodyPr wrap="square" anchor="t" lIns="0" rIns="0" tIns="0" bIns="0">
-            <a:spAutoFit/>
-          </a:bodyPr>
-          <a:lstStyle/>
-          <a:p>
-            <a:pPr algn="l"/>
-            <a:r>
-              <a:rPr sz="1100" b="1">
+            <a:off x="6309360" y="5440679"/>
+            <a:ext cx="914400" cy="201168"/>
+          </a:xfrm>
+          <a:prstGeom prst="rect">
+            <a:avLst/>
+          </a:prstGeom>
+          <a:noFill/>
+        </p:spPr>
+        <p:txBody>
+          <a:bodyPr wrap="square" anchor="t" lIns="0" rIns="0" tIns="0" bIns="0">
+            <a:spAutoFit/>
+          </a:bodyPr>
+          <a:lstStyle/>
+          <a:p>
+            <a:pPr algn="l"/>
+            <a:r>
+              <a:rPr sz="1050" b="1">
                 <a:solidFill>
                   <a:srgbClr val="FFB352"/>
                 </a:solidFill>
@@ -12485,23 +12485,23 @@
         </p:nvSpPr>
         <p:spPr>
           <a:xfrm>
-            <a:off x="7269480" y="5541264"/>
-            <a:ext cx="1280160" cy="228600"/>
-          </a:xfrm>
-          <a:prstGeom prst="rect">
-            <a:avLst/>
-          </a:prstGeom>
-          <a:noFill/>
-        </p:spPr>
-        <p:txBody>
-          <a:bodyPr wrap="square" anchor="t" lIns="0" rIns="0" tIns="0" bIns="0">
-            <a:spAutoFit/>
-          </a:bodyPr>
-          <a:lstStyle/>
-          <a:p>
-            <a:pPr algn="l"/>
-            <a:r>
-              <a:rPr sz="1000" b="0">
+            <a:off x="7269480" y="5440679"/>
+            <a:ext cx="1280160" cy="201168"/>
+          </a:xfrm>
+          <a:prstGeom prst="rect">
+            <a:avLst/>
+          </a:prstGeom>
+          <a:noFill/>
+        </p:spPr>
+        <p:txBody>
+          <a:bodyPr wrap="square" anchor="t" lIns="0" rIns="0" tIns="0" bIns="0">
+            <a:spAutoFit/>
+          </a:bodyPr>
+          <a:lstStyle/>
+          <a:p>
+            <a:pPr algn="l"/>
+            <a:r>
+              <a:rPr sz="950" b="0">
                 <a:solidFill>
                   <a:srgbClr val="334155"/>
                 </a:solidFill>
@@ -12520,23 +12520,23 @@
         </p:nvSpPr>
         <p:spPr>
           <a:xfrm>
-            <a:off x="8641080" y="5541264"/>
-            <a:ext cx="1371600" cy="228600"/>
-          </a:xfrm>
-          <a:prstGeom prst="rect">
-            <a:avLst/>
-          </a:prstGeom>
-          <a:noFill/>
-        </p:spPr>
-        <p:txBody>
-          <a:bodyPr wrap="square" anchor="t" lIns="0" rIns="0" tIns="0" bIns="0">
-            <a:spAutoFit/>
-          </a:bodyPr>
-          <a:lstStyle/>
-          <a:p>
-            <a:pPr algn="l"/>
-            <a:r>
-              <a:rPr sz="1100" b="0">
+            <a:off x="8641080" y="5440679"/>
+            <a:ext cx="1371600" cy="201168"/>
+          </a:xfrm>
+          <a:prstGeom prst="rect">
+            <a:avLst/>
+          </a:prstGeom>
+          <a:noFill/>
+        </p:spPr>
+        <p:txBody>
+          <a:bodyPr wrap="square" anchor="t" lIns="0" rIns="0" tIns="0" bIns="0">
+            <a:spAutoFit/>
+          </a:bodyPr>
+          <a:lstStyle/>
+          <a:p>
+            <a:pPr algn="l"/>
+            <a:r>
+              <a:rPr sz="1050" b="0">
                 <a:solidFill>
                   <a:srgbClr val="334155"/>
                 </a:solidFill>
@@ -12555,23 +12555,23 @@
         </p:nvSpPr>
         <p:spPr>
           <a:xfrm>
-            <a:off x="10104120" y="5541264"/>
-            <a:ext cx="1371600" cy="228600"/>
-          </a:xfrm>
-          <a:prstGeom prst="rect">
-            <a:avLst/>
-          </a:prstGeom>
-          <a:noFill/>
-        </p:spPr>
-        <p:txBody>
-          <a:bodyPr wrap="square" anchor="t" lIns="0" rIns="0" tIns="0" bIns="0">
-            <a:spAutoFit/>
-          </a:bodyPr>
-          <a:lstStyle/>
-          <a:p>
-            <a:pPr algn="l"/>
-            <a:r>
-              <a:rPr sz="1100" b="1">
+            <a:off x="10104120" y="5440679"/>
+            <a:ext cx="1371600" cy="201168"/>
+          </a:xfrm>
+          <a:prstGeom prst="rect">
+            <a:avLst/>
+          </a:prstGeom>
+          <a:noFill/>
+        </p:spPr>
+        <p:txBody>
+          <a:bodyPr wrap="square" anchor="t" lIns="0" rIns="0" tIns="0" bIns="0">
+            <a:spAutoFit/>
+          </a:bodyPr>
+          <a:lstStyle/>
+          <a:p>
+            <a:pPr algn="l"/>
+            <a:r>
+              <a:rPr sz="1050" b="1">
                 <a:solidFill>
                   <a:srgbClr val="FFB352"/>
                 </a:solidFill>
@@ -12590,8 +12590,8 @@
         </p:nvSpPr>
         <p:spPr>
           <a:xfrm>
-            <a:off x="6217920" y="5833872"/>
-            <a:ext cx="5486400" cy="365760"/>
+            <a:off x="6217920" y="5687568"/>
+            <a:ext cx="5486400" cy="301752"/>
           </a:xfrm>
           <a:prstGeom prst="rect">
             <a:avLst/>
@@ -12634,23 +12634,23 @@
         </p:nvSpPr>
         <p:spPr>
           <a:xfrm>
-            <a:off x="6309360" y="5907024"/>
-            <a:ext cx="914400" cy="228600"/>
-          </a:xfrm>
-          <a:prstGeom prst="rect">
-            <a:avLst/>
-          </a:prstGeom>
-          <a:noFill/>
-        </p:spPr>
-        <p:txBody>
-          <a:bodyPr wrap="square" anchor="t" lIns="0" rIns="0" tIns="0" bIns="0">
-            <a:spAutoFit/>
-          </a:bodyPr>
-          <a:lstStyle/>
-          <a:p>
-            <a:pPr algn="l"/>
-            <a:r>
-              <a:rPr sz="1100" b="1">
+            <a:off x="6309360" y="5742431"/>
+            <a:ext cx="914400" cy="201168"/>
+          </a:xfrm>
+          <a:prstGeom prst="rect">
+            <a:avLst/>
+          </a:prstGeom>
+          <a:noFill/>
+        </p:spPr>
+        <p:txBody>
+          <a:bodyPr wrap="square" anchor="t" lIns="0" rIns="0" tIns="0" bIns="0">
+            <a:spAutoFit/>
+          </a:bodyPr>
+          <a:lstStyle/>
+          <a:p>
+            <a:pPr algn="l"/>
+            <a:r>
+              <a:rPr sz="1050" b="1">
                 <a:solidFill>
                   <a:srgbClr val="FC4C0B"/>
                 </a:solidFill>
@@ -12669,23 +12669,23 @@
         </p:nvSpPr>
         <p:spPr>
           <a:xfrm>
-            <a:off x="7269480" y="5907024"/>
-            <a:ext cx="1280160" cy="228600"/>
-          </a:xfrm>
-          <a:prstGeom prst="rect">
-            <a:avLst/>
-          </a:prstGeom>
-          <a:noFill/>
-        </p:spPr>
-        <p:txBody>
-          <a:bodyPr wrap="square" anchor="t" lIns="0" rIns="0" tIns="0" bIns="0">
-            <a:spAutoFit/>
-          </a:bodyPr>
-          <a:lstStyle/>
-          <a:p>
-            <a:pPr algn="l"/>
-            <a:r>
-              <a:rPr sz="1000" b="0">
+            <a:off x="7269480" y="5742431"/>
+            <a:ext cx="1280160" cy="201168"/>
+          </a:xfrm>
+          <a:prstGeom prst="rect">
+            <a:avLst/>
+          </a:prstGeom>
+          <a:noFill/>
+        </p:spPr>
+        <p:txBody>
+          <a:bodyPr wrap="square" anchor="t" lIns="0" rIns="0" tIns="0" bIns="0">
+            <a:spAutoFit/>
+          </a:bodyPr>
+          <a:lstStyle/>
+          <a:p>
+            <a:pPr algn="l"/>
+            <a:r>
+              <a:rPr sz="950" b="0">
                 <a:solidFill>
                   <a:srgbClr val="334155"/>
                 </a:solidFill>
@@ -12704,23 +12704,23 @@
         </p:nvSpPr>
         <p:spPr>
           <a:xfrm>
-            <a:off x="8641080" y="5907024"/>
-            <a:ext cx="1371600" cy="228600"/>
-          </a:xfrm>
-          <a:prstGeom prst="rect">
-            <a:avLst/>
-          </a:prstGeom>
-          <a:noFill/>
-        </p:spPr>
-        <p:txBody>
-          <a:bodyPr wrap="square" anchor="t" lIns="0" rIns="0" tIns="0" bIns="0">
-            <a:spAutoFit/>
-          </a:bodyPr>
-          <a:lstStyle/>
-          <a:p>
-            <a:pPr algn="l"/>
-            <a:r>
-              <a:rPr sz="1100" b="0">
+            <a:off x="8641080" y="5742431"/>
+            <a:ext cx="1371600" cy="201168"/>
+          </a:xfrm>
+          <a:prstGeom prst="rect">
+            <a:avLst/>
+          </a:prstGeom>
+          <a:noFill/>
+        </p:spPr>
+        <p:txBody>
+          <a:bodyPr wrap="square" anchor="t" lIns="0" rIns="0" tIns="0" bIns="0">
+            <a:spAutoFit/>
+          </a:bodyPr>
+          <a:lstStyle/>
+          <a:p>
+            <a:pPr algn="l"/>
+            <a:r>
+              <a:rPr sz="1050" b="0">
                 <a:solidFill>
                   <a:srgbClr val="334155"/>
                 </a:solidFill>
@@ -12739,23 +12739,23 @@
         </p:nvSpPr>
         <p:spPr>
           <a:xfrm>
-            <a:off x="10104120" y="5907024"/>
-            <a:ext cx="1371600" cy="228600"/>
-          </a:xfrm>
-          <a:prstGeom prst="rect">
-            <a:avLst/>
-          </a:prstGeom>
-          <a:noFill/>
-        </p:spPr>
-        <p:txBody>
-          <a:bodyPr wrap="square" anchor="t" lIns="0" rIns="0" tIns="0" bIns="0">
-            <a:spAutoFit/>
-          </a:bodyPr>
-          <a:lstStyle/>
-          <a:p>
-            <a:pPr algn="l"/>
-            <a:r>
-              <a:rPr sz="1100" b="1">
+            <a:off x="10104120" y="5742431"/>
+            <a:ext cx="1371600" cy="201168"/>
+          </a:xfrm>
+          <a:prstGeom prst="rect">
+            <a:avLst/>
+          </a:prstGeom>
+          <a:noFill/>
+        </p:spPr>
+        <p:txBody>
+          <a:bodyPr wrap="square" anchor="t" lIns="0" rIns="0" tIns="0" bIns="0">
+            <a:spAutoFit/>
+          </a:bodyPr>
+          <a:lstStyle/>
+          <a:p>
+            <a:pPr algn="l"/>
+            <a:r>
+              <a:rPr sz="1050" b="1">
                 <a:solidFill>
                   <a:srgbClr val="FC4C0B"/>
                 </a:solidFill>
@@ -12774,8 +12774,8 @@
         </p:nvSpPr>
         <p:spPr>
           <a:xfrm>
-            <a:off x="6217920" y="6199632"/>
-            <a:ext cx="5486400" cy="365760"/>
+            <a:off x="6217920" y="5989320"/>
+            <a:ext cx="5486400" cy="301752"/>
           </a:xfrm>
           <a:prstGeom prst="rect">
             <a:avLst/>
@@ -12818,23 +12818,23 @@
         </p:nvSpPr>
         <p:spPr>
           <a:xfrm>
-            <a:off x="6309360" y="6272784"/>
-            <a:ext cx="914400" cy="228600"/>
-          </a:xfrm>
-          <a:prstGeom prst="rect">
-            <a:avLst/>
-          </a:prstGeom>
-          <a:noFill/>
-        </p:spPr>
-        <p:txBody>
-          <a:bodyPr wrap="square" anchor="t" lIns="0" rIns="0" tIns="0" bIns="0">
-            <a:spAutoFit/>
-          </a:bodyPr>
-          <a:lstStyle/>
-          <a:p>
-            <a:pPr algn="l"/>
-            <a:r>
-              <a:rPr sz="1100" b="1">
+            <a:off x="6309360" y="6044183"/>
+            <a:ext cx="914400" cy="201168"/>
+          </a:xfrm>
+          <a:prstGeom prst="rect">
+            <a:avLst/>
+          </a:prstGeom>
+          <a:noFill/>
+        </p:spPr>
+        <p:txBody>
+          <a:bodyPr wrap="square" anchor="t" lIns="0" rIns="0" tIns="0" bIns="0">
+            <a:spAutoFit/>
+          </a:bodyPr>
+          <a:lstStyle/>
+          <a:p>
+            <a:pPr algn="l"/>
+            <a:r>
+              <a:rPr sz="1050" b="1">
                 <a:solidFill>
                   <a:srgbClr val="2863C5"/>
                 </a:solidFill>
@@ -12853,23 +12853,23 @@
         </p:nvSpPr>
         <p:spPr>
           <a:xfrm>
-            <a:off x="7269480" y="6272784"/>
-            <a:ext cx="1280160" cy="228600"/>
-          </a:xfrm>
-          <a:prstGeom prst="rect">
-            <a:avLst/>
-          </a:prstGeom>
-          <a:noFill/>
-        </p:spPr>
-        <p:txBody>
-          <a:bodyPr wrap="square" anchor="t" lIns="0" rIns="0" tIns="0" bIns="0">
-            <a:spAutoFit/>
-          </a:bodyPr>
-          <a:lstStyle/>
-          <a:p>
-            <a:pPr algn="l"/>
-            <a:r>
-              <a:rPr sz="1000" b="0">
+            <a:off x="7269480" y="6044183"/>
+            <a:ext cx="1280160" cy="201168"/>
+          </a:xfrm>
+          <a:prstGeom prst="rect">
+            <a:avLst/>
+          </a:prstGeom>
+          <a:noFill/>
+        </p:spPr>
+        <p:txBody>
+          <a:bodyPr wrap="square" anchor="t" lIns="0" rIns="0" tIns="0" bIns="0">
+            <a:spAutoFit/>
+          </a:bodyPr>
+          <a:lstStyle/>
+          <a:p>
+            <a:pPr algn="l"/>
+            <a:r>
+              <a:rPr sz="950" b="0">
                 <a:solidFill>
                   <a:srgbClr val="334155"/>
                 </a:solidFill>
@@ -12888,23 +12888,23 @@
         </p:nvSpPr>
         <p:spPr>
           <a:xfrm>
-            <a:off x="8641080" y="6272784"/>
-            <a:ext cx="1371600" cy="228600"/>
-          </a:xfrm>
-          <a:prstGeom prst="rect">
-            <a:avLst/>
-          </a:prstGeom>
-          <a:noFill/>
-        </p:spPr>
-        <p:txBody>
-          <a:bodyPr wrap="square" anchor="t" lIns="0" rIns="0" tIns="0" bIns="0">
-            <a:spAutoFit/>
-          </a:bodyPr>
-          <a:lstStyle/>
-          <a:p>
-            <a:pPr algn="l"/>
-            <a:r>
-              <a:rPr sz="1100" b="0">
+            <a:off x="8641080" y="6044183"/>
+            <a:ext cx="1371600" cy="201168"/>
+          </a:xfrm>
+          <a:prstGeom prst="rect">
+            <a:avLst/>
+          </a:prstGeom>
+          <a:noFill/>
+        </p:spPr>
+        <p:txBody>
+          <a:bodyPr wrap="square" anchor="t" lIns="0" rIns="0" tIns="0" bIns="0">
+            <a:spAutoFit/>
+          </a:bodyPr>
+          <a:lstStyle/>
+          <a:p>
+            <a:pPr algn="l"/>
+            <a:r>
+              <a:rPr sz="1050" b="0">
                 <a:solidFill>
                   <a:srgbClr val="334155"/>
                 </a:solidFill>
@@ -12923,23 +12923,23 @@
         </p:nvSpPr>
         <p:spPr>
           <a:xfrm>
-            <a:off x="10104120" y="6272784"/>
-            <a:ext cx="1371600" cy="228600"/>
-          </a:xfrm>
-          <a:prstGeom prst="rect">
-            <a:avLst/>
-          </a:prstGeom>
-          <a:noFill/>
-        </p:spPr>
-        <p:txBody>
-          <a:bodyPr wrap="square" anchor="t" lIns="0" rIns="0" tIns="0" bIns="0">
-            <a:spAutoFit/>
-          </a:bodyPr>
-          <a:lstStyle/>
-          <a:p>
-            <a:pPr algn="l"/>
-            <a:r>
-              <a:rPr sz="1100" b="1">
+            <a:off x="10104120" y="6044183"/>
+            <a:ext cx="1371600" cy="201168"/>
+          </a:xfrm>
+          <a:prstGeom prst="rect">
+            <a:avLst/>
+          </a:prstGeom>
+          <a:noFill/>
+        </p:spPr>
+        <p:txBody>
+          <a:bodyPr wrap="square" anchor="t" lIns="0" rIns="0" tIns="0" bIns="0">
+            <a:spAutoFit/>
+          </a:bodyPr>
+          <a:lstStyle/>
+          <a:p>
+            <a:pPr algn="l"/>
+            <a:r>
+              <a:rPr sz="1050" b="1">
                 <a:solidFill>
                   <a:srgbClr val="2863C5"/>
                 </a:solidFill>

</xml_diff>

<commit_message>
Revert slide 6 — too cluttered after methodology row
User said the methodology row + reframed headlines made the slide
more confusing, not less. Reverting to the simpler structure:

- 4 original headline cards: 21,864 / 70.8% / 4.4M / $324M
- No methodology row
- Match distribution table (left) — but with clearer column header
  "Records returned" and clearer subtitle: "Number of records each
  customer's name returned. Fewer records = more distinctive name =
  more likely match."
- Last column header: "Note" -> "Confidence"
- Tier table back at y=4.6 (matching distribution table)
- Bottom callout: "Even discounting common-name false positives,
  ~9,000 customers in the high-confidence bucket map to ~$1.5M of
  unclaimed property in CA alone."

The methodology lives in the chat / scripts now, not in the deck.

Co-Authored-By: Claude Opus 4.7 (1M context) <noreply@anthropic.com>
</commit_message>
<xml_diff>
--- a/myReclaim-Exec-Deck.pptx
+++ b/myReclaim-Exec-Deck.pptx
@@ -10330,8 +10330,8 @@
         </p:nvSpPr>
         <p:spPr>
           <a:xfrm>
-            <a:off x="457200" y="2468880"/>
-            <a:ext cx="2697480" cy="1097280"/>
+            <a:off x="457200" y="2606040"/>
+            <a:ext cx="2697480" cy="1417320"/>
           </a:xfrm>
           <a:prstGeom prst="roundRect">
             <a:avLst>
@@ -10378,8 +10378,8 @@
         </p:nvSpPr>
         <p:spPr>
           <a:xfrm>
-            <a:off x="457200" y="2468880"/>
-            <a:ext cx="2697480" cy="118872"/>
+            <a:off x="457200" y="2606040"/>
+            <a:ext cx="2697480" cy="137160"/>
           </a:xfrm>
           <a:prstGeom prst="rect">
             <a:avLst/>
@@ -10422,23 +10422,23 @@
         </p:nvSpPr>
         <p:spPr>
           <a:xfrm>
-            <a:off x="640080" y="2670048"/>
-            <a:ext cx="2331720" cy="640080"/>
-          </a:xfrm>
-          <a:prstGeom prst="rect">
-            <a:avLst/>
-          </a:prstGeom>
-          <a:noFill/>
-        </p:spPr>
-        <p:txBody>
-          <a:bodyPr wrap="square" anchor="t" lIns="0" rIns="0" tIns="0" bIns="0">
-            <a:spAutoFit/>
-          </a:bodyPr>
-          <a:lstStyle/>
-          <a:p>
-            <a:pPr algn="l"/>
-            <a:r>
-              <a:rPr sz="3200" b="1">
+            <a:off x="640080" y="2880360"/>
+            <a:ext cx="2331720" cy="777240"/>
+          </a:xfrm>
+          <a:prstGeom prst="rect">
+            <a:avLst/>
+          </a:prstGeom>
+          <a:noFill/>
+        </p:spPr>
+        <p:txBody>
+          <a:bodyPr wrap="square" anchor="t" lIns="0" rIns="0" tIns="0" bIns="0">
+            <a:spAutoFit/>
+          </a:bodyPr>
+          <a:lstStyle/>
+          <a:p>
+            <a:pPr algn="l"/>
+            <a:r>
+              <a:rPr sz="3600" b="1">
                 <a:solidFill>
                   <a:srgbClr val="2863C5"/>
                 </a:solidFill>
@@ -10457,8 +10457,8 @@
         </p:nvSpPr>
         <p:spPr>
           <a:xfrm>
-            <a:off x="640080" y="3246120"/>
-            <a:ext cx="2331720" cy="292608"/>
+            <a:off x="640080" y="3611880"/>
+            <a:ext cx="2331720" cy="365760"/>
           </a:xfrm>
           <a:prstGeom prst="rect">
             <a:avLst/>
@@ -10479,7 +10479,7 @@
                 </a:solidFill>
                 <a:latin typeface="Open Sans"/>
               </a:rPr>
-              <a:t>customers with ≥1 name match</a:t>
+              <a:t>customers with at least one possible match</a:t>
             </a:r>
           </a:p>
         </p:txBody>
@@ -10492,8 +10492,8 @@
         </p:nvSpPr>
         <p:spPr>
           <a:xfrm>
-            <a:off x="3291840" y="2468880"/>
-            <a:ext cx="2697480" cy="1097280"/>
+            <a:off x="3291840" y="2606040"/>
+            <a:ext cx="2697480" cy="1417320"/>
           </a:xfrm>
           <a:prstGeom prst="roundRect">
             <a:avLst>
@@ -10540,8 +10540,8 @@
         </p:nvSpPr>
         <p:spPr>
           <a:xfrm>
-            <a:off x="3291840" y="2468880"/>
-            <a:ext cx="2697480" cy="118872"/>
+            <a:off x="3291840" y="2606040"/>
+            <a:ext cx="2697480" cy="137160"/>
           </a:xfrm>
           <a:prstGeom prst="rect">
             <a:avLst/>
@@ -10584,23 +10584,23 @@
         </p:nvSpPr>
         <p:spPr>
           <a:xfrm>
-            <a:off x="3474720" y="2670048"/>
-            <a:ext cx="2331720" cy="640080"/>
-          </a:xfrm>
-          <a:prstGeom prst="rect">
-            <a:avLst/>
-          </a:prstGeom>
-          <a:noFill/>
-        </p:spPr>
-        <p:txBody>
-          <a:bodyPr wrap="square" anchor="t" lIns="0" rIns="0" tIns="0" bIns="0">
-            <a:spAutoFit/>
-          </a:bodyPr>
-          <a:lstStyle/>
-          <a:p>
-            <a:pPr algn="l"/>
-            <a:r>
-              <a:rPr sz="3200" b="1">
+            <a:off x="3474720" y="2880360"/>
+            <a:ext cx="2331720" cy="777240"/>
+          </a:xfrm>
+          <a:prstGeom prst="rect">
+            <a:avLst/>
+          </a:prstGeom>
+          <a:noFill/>
+        </p:spPr>
+        <p:txBody>
+          <a:bodyPr wrap="square" anchor="t" lIns="0" rIns="0" tIns="0" bIns="0">
+            <a:spAutoFit/>
+          </a:bodyPr>
+          <a:lstStyle/>
+          <a:p>
+            <a:pPr algn="l"/>
+            <a:r>
+              <a:rPr sz="3600" b="1">
                 <a:solidFill>
                   <a:srgbClr val="2863C5"/>
                 </a:solidFill>
@@ -10619,8 +10619,8 @@
         </p:nvSpPr>
         <p:spPr>
           <a:xfrm>
-            <a:off x="3474720" y="3246120"/>
-            <a:ext cx="2331720" cy="292608"/>
+            <a:off x="3474720" y="3611880"/>
+            <a:ext cx="2331720" cy="365760"/>
           </a:xfrm>
           <a:prstGeom prst="rect">
             <a:avLst/>
@@ -10641,7 +10641,7 @@
                 </a:solidFill>
                 <a:latin typeface="Open Sans"/>
               </a:rPr>
-              <a:t>upper bound (name-only)</a:t>
+              <a:t>of the 30,862 active CA base</a:t>
             </a:r>
           </a:p>
         </p:txBody>
@@ -10654,8 +10654,8 @@
         </p:nvSpPr>
         <p:spPr>
           <a:xfrm>
-            <a:off x="6126480" y="2468880"/>
-            <a:ext cx="2697480" cy="1097280"/>
+            <a:off x="6126480" y="2606040"/>
+            <a:ext cx="2697480" cy="1417320"/>
           </a:xfrm>
           <a:prstGeom prst="roundRect">
             <a:avLst>
@@ -10702,14 +10702,14 @@
         </p:nvSpPr>
         <p:spPr>
           <a:xfrm>
-            <a:off x="6126480" y="2468880"/>
-            <a:ext cx="2697480" cy="118872"/>
+            <a:off x="6126480" y="2606040"/>
+            <a:ext cx="2697480" cy="137160"/>
           </a:xfrm>
           <a:prstGeom prst="rect">
             <a:avLst/>
           </a:prstGeom>
           <a:solidFill>
-            <a:srgbClr val="059669"/>
+            <a:srgbClr val="FC4C0B"/>
           </a:solidFill>
           <a:ln>
             <a:noFill/>
@@ -10746,29 +10746,29 @@
         </p:nvSpPr>
         <p:spPr>
           <a:xfrm>
-            <a:off x="6309360" y="2670048"/>
-            <a:ext cx="2331720" cy="640080"/>
-          </a:xfrm>
-          <a:prstGeom prst="rect">
-            <a:avLst/>
-          </a:prstGeom>
-          <a:noFill/>
-        </p:spPr>
-        <p:txBody>
-          <a:bodyPr wrap="square" anchor="t" lIns="0" rIns="0" tIns="0" bIns="0">
-            <a:spAutoFit/>
-          </a:bodyPr>
-          <a:lstStyle/>
-          <a:p>
-            <a:pPr algn="l"/>
-            <a:r>
-              <a:rPr sz="3200" b="1">
-                <a:solidFill>
-                  <a:srgbClr val="059669"/>
-                </a:solidFill>
-                <a:latin typeface="Open Sans"/>
-              </a:rPr>
-              <a:t>9,054</a:t>
+            <a:off x="6309360" y="2880360"/>
+            <a:ext cx="2331720" cy="777240"/>
+          </a:xfrm>
+          <a:prstGeom prst="rect">
+            <a:avLst/>
+          </a:prstGeom>
+          <a:noFill/>
+        </p:spPr>
+        <p:txBody>
+          <a:bodyPr wrap="square" anchor="t" lIns="0" rIns="0" tIns="0" bIns="0">
+            <a:spAutoFit/>
+          </a:bodyPr>
+          <a:lstStyle/>
+          <a:p>
+            <a:pPr algn="l"/>
+            <a:r>
+              <a:rPr sz="3600" b="1">
+                <a:solidFill>
+                  <a:srgbClr val="FC4C0B"/>
+                </a:solidFill>
+                <a:latin typeface="Open Sans"/>
+              </a:rPr>
+              <a:t>4.4M</a:t>
             </a:r>
           </a:p>
         </p:txBody>
@@ -10781,8 +10781,8 @@
         </p:nvSpPr>
         <p:spPr>
           <a:xfrm>
-            <a:off x="6309360" y="3246120"/>
-            <a:ext cx="2331720" cy="292608"/>
+            <a:off x="6309360" y="3611880"/>
+            <a:ext cx="2331720" cy="365760"/>
           </a:xfrm>
           <a:prstGeom prst="rect">
             <a:avLst/>
@@ -10803,7 +10803,7 @@
                 </a:solidFill>
                 <a:latin typeface="Open Sans"/>
               </a:rPr>
-              <a:t>high-confidence (1–5 records)</a:t>
+              <a:t>matched property records across all tiers</a:t>
             </a:r>
           </a:p>
         </p:txBody>
@@ -10816,8 +10816,8 @@
         </p:nvSpPr>
         <p:spPr>
           <a:xfrm>
-            <a:off x="8961120" y="2468880"/>
-            <a:ext cx="2697480" cy="1097280"/>
+            <a:off x="8961120" y="2606040"/>
+            <a:ext cx="2697480" cy="1417320"/>
           </a:xfrm>
           <a:prstGeom prst="roundRect">
             <a:avLst>
@@ -10864,8 +10864,8 @@
         </p:nvSpPr>
         <p:spPr>
           <a:xfrm>
-            <a:off x="8961120" y="2468880"/>
-            <a:ext cx="2697480" cy="118872"/>
+            <a:off x="8961120" y="2606040"/>
+            <a:ext cx="2697480" cy="137160"/>
           </a:xfrm>
           <a:prstGeom prst="rect">
             <a:avLst/>
@@ -10908,23 +10908,23 @@
         </p:nvSpPr>
         <p:spPr>
           <a:xfrm>
-            <a:off x="9144000" y="2670048"/>
-            <a:ext cx="2331720" cy="640080"/>
-          </a:xfrm>
-          <a:prstGeom prst="rect">
-            <a:avLst/>
-          </a:prstGeom>
-          <a:noFill/>
-        </p:spPr>
-        <p:txBody>
-          <a:bodyPr wrap="square" anchor="t" lIns="0" rIns="0" tIns="0" bIns="0">
-            <a:spAutoFit/>
-          </a:bodyPr>
-          <a:lstStyle/>
-          <a:p>
-            <a:pPr algn="l"/>
-            <a:r>
-              <a:rPr sz="3200" b="1">
+            <a:off x="9144000" y="2880360"/>
+            <a:ext cx="2331720" cy="777240"/>
+          </a:xfrm>
+          <a:prstGeom prst="rect">
+            <a:avLst/>
+          </a:prstGeom>
+          <a:noFill/>
+        </p:spPr>
+        <p:txBody>
+          <a:bodyPr wrap="square" anchor="t" lIns="0" rIns="0" tIns="0" bIns="0">
+            <a:spAutoFit/>
+          </a:bodyPr>
+          <a:lstStyle/>
+          <a:p>
+            <a:pPr algn="l"/>
+            <a:r>
+              <a:rPr sz="3600" b="1">
                 <a:solidFill>
                   <a:srgbClr val="FC4C0B"/>
                 </a:solidFill>
@@ -10943,8 +10943,8 @@
         </p:nvSpPr>
         <p:spPr>
           <a:xfrm>
-            <a:off x="9144000" y="3246120"/>
-            <a:ext cx="2331720" cy="292608"/>
+            <a:off x="9144000" y="3611880"/>
+            <a:ext cx="2331720" cy="365760"/>
           </a:xfrm>
           <a:prstGeom prst="rect">
             <a:avLst/>
@@ -10965,7 +10965,7 @@
                 </a:solidFill>
                 <a:latin typeface="Open Sans"/>
               </a:rPr>
-              <a:t>max value across all matches</a:t>
+              <a:t>estimated value across all matches</a:t>
             </a:r>
           </a:p>
         </p:txBody>
@@ -10978,8 +10978,8 @@
         </p:nvSpPr>
         <p:spPr>
           <a:xfrm>
-            <a:off x="457200" y="3703320"/>
-            <a:ext cx="11430000" cy="292608"/>
+            <a:off x="457200" y="4206240"/>
+            <a:ext cx="5486400" cy="320040"/>
           </a:xfrm>
           <a:prstGeom prst="rect">
             <a:avLst/>
@@ -11000,34 +11000,65 @@
                 </a:solidFill>
                 <a:latin typeface="Open Sans"/>
               </a:rPr>
-              <a:t>HOW WE MATCHED · TRANSPARENCY</a:t>
-            </a:r>
-          </a:p>
-        </p:txBody>
-      </p:sp>
-      <p:sp>
-        <p:nvSpPr>
-          <p:cNvPr id="27" name="Rounded Rectangle 26"/>
+              <a:t>MATCH DISTRIBUTION</a:t>
+            </a:r>
+          </a:p>
+        </p:txBody>
+      </p:sp>
+      <p:sp>
+        <p:nvSpPr>
+          <p:cNvPr id="27" name="TextBox 26"/>
+          <p:cNvSpPr txBox="1"/>
+          <p:nvPr/>
+        </p:nvSpPr>
+        <p:spPr>
+          <a:xfrm>
+            <a:off x="457200" y="4498848"/>
+            <a:ext cx="5486400" cy="274320"/>
+          </a:xfrm>
+          <a:prstGeom prst="rect">
+            <a:avLst/>
+          </a:prstGeom>
+          <a:noFill/>
+        </p:spPr>
+        <p:txBody>
+          <a:bodyPr wrap="square" anchor="t" lIns="0" rIns="0" tIns="0" bIns="0">
+            <a:spAutoFit/>
+          </a:bodyPr>
+          <a:lstStyle/>
+          <a:p>
+            <a:pPr algn="l"/>
+            <a:r>
+              <a:rPr sz="1000" b="0">
+                <a:solidFill>
+                  <a:srgbClr val="64748B"/>
+                </a:solidFill>
+                <a:latin typeface="Open Sans"/>
+              </a:rPr>
+              <a:t>Number of records each customer's name returned. Fewer records = more distinctive name = more likely match.</a:t>
+            </a:r>
+          </a:p>
+        </p:txBody>
+      </p:sp>
+      <p:sp>
+        <p:nvSpPr>
+          <p:cNvPr id="28" name="Rectangle 27"/>
           <p:cNvSpPr/>
           <p:nvPr/>
         </p:nvSpPr>
         <p:spPr>
           <a:xfrm>
-            <a:off x="457200" y="4023360"/>
-            <a:ext cx="2697480" cy="594360"/>
-          </a:xfrm>
-          <a:prstGeom prst="roundRect">
-            <a:avLst>
-              <a:gd name="adj" fmla="val 4000"/>
-            </a:avLst>
+            <a:off x="457200" y="4846320"/>
+            <a:ext cx="5486400" cy="237744"/>
+          </a:xfrm>
+          <a:prstGeom prst="rect">
+            <a:avLst/>
           </a:prstGeom>
           <a:solidFill>
-            <a:srgbClr val="FFFFFF"/>
+            <a:srgbClr val="0F172A"/>
           </a:solidFill>
-          <a:ln w="6350">
-            <a:solidFill>
-              <a:srgbClr val="E2E8F0"/>
-            </a:solidFill>
+          <a:ln>
+            <a:noFill/>
           </a:ln>
           <a:effectLst/>
         </p:spPr>
@@ -11055,17 +11086,1885 @@
       </p:sp>
       <p:sp>
         <p:nvSpPr>
-          <p:cNvPr id="28" name="Rectangle 27"/>
+          <p:cNvPr id="29" name="TextBox 28"/>
+          <p:cNvSpPr txBox="1"/>
+          <p:nvPr/>
+        </p:nvSpPr>
+        <p:spPr>
+          <a:xfrm>
+            <a:off x="548640" y="4882896"/>
+            <a:ext cx="1554480" cy="182880"/>
+          </a:xfrm>
+          <a:prstGeom prst="rect">
+            <a:avLst/>
+          </a:prstGeom>
+          <a:noFill/>
+        </p:spPr>
+        <p:txBody>
+          <a:bodyPr wrap="square" anchor="t" lIns="0" rIns="0" tIns="0" bIns="0">
+            <a:spAutoFit/>
+          </a:bodyPr>
+          <a:lstStyle/>
+          <a:p>
+            <a:pPr algn="l"/>
+            <a:r>
+              <a:rPr sz="900" b="1">
+                <a:solidFill>
+                  <a:srgbClr val="FFFFFF"/>
+                </a:solidFill>
+                <a:latin typeface="Open Sans"/>
+              </a:rPr>
+              <a:t>Records returned</a:t>
+            </a:r>
+          </a:p>
+        </p:txBody>
+      </p:sp>
+      <p:sp>
+        <p:nvSpPr>
+          <p:cNvPr id="30" name="TextBox 29"/>
+          <p:cNvSpPr txBox="1"/>
+          <p:nvPr/>
+        </p:nvSpPr>
+        <p:spPr>
+          <a:xfrm>
+            <a:off x="2194560" y="4882896"/>
+            <a:ext cx="914400" cy="182880"/>
+          </a:xfrm>
+          <a:prstGeom prst="rect">
+            <a:avLst/>
+          </a:prstGeom>
+          <a:noFill/>
+        </p:spPr>
+        <p:txBody>
+          <a:bodyPr wrap="square" anchor="t" lIns="0" rIns="0" tIns="0" bIns="0">
+            <a:spAutoFit/>
+          </a:bodyPr>
+          <a:lstStyle/>
+          <a:p>
+            <a:pPr algn="l"/>
+            <a:r>
+              <a:rPr sz="900" b="1">
+                <a:solidFill>
+                  <a:srgbClr val="FFFFFF"/>
+                </a:solidFill>
+                <a:latin typeface="Open Sans"/>
+              </a:rPr>
+              <a:t>Customers</a:t>
+            </a:r>
+          </a:p>
+        </p:txBody>
+      </p:sp>
+      <p:sp>
+        <p:nvSpPr>
+          <p:cNvPr id="31" name="TextBox 30"/>
+          <p:cNvSpPr txBox="1"/>
+          <p:nvPr/>
+        </p:nvSpPr>
+        <p:spPr>
+          <a:xfrm>
+            <a:off x="3246120" y="4882896"/>
+            <a:ext cx="914400" cy="182880"/>
+          </a:xfrm>
+          <a:prstGeom prst="rect">
+            <a:avLst/>
+          </a:prstGeom>
+          <a:noFill/>
+        </p:spPr>
+        <p:txBody>
+          <a:bodyPr wrap="square" anchor="t" lIns="0" rIns="0" tIns="0" bIns="0">
+            <a:spAutoFit/>
+          </a:bodyPr>
+          <a:lstStyle/>
+          <a:p>
+            <a:pPr algn="l"/>
+            <a:r>
+              <a:rPr sz="900" b="1">
+                <a:solidFill>
+                  <a:srgbClr val="FFFFFF"/>
+                </a:solidFill>
+                <a:latin typeface="Open Sans"/>
+              </a:rPr>
+              <a:t>$ value</a:t>
+            </a:r>
+          </a:p>
+        </p:txBody>
+      </p:sp>
+      <p:sp>
+        <p:nvSpPr>
+          <p:cNvPr id="32" name="TextBox 31"/>
+          <p:cNvSpPr txBox="1"/>
+          <p:nvPr/>
+        </p:nvSpPr>
+        <p:spPr>
+          <a:xfrm>
+            <a:off x="4297680" y="4882896"/>
+            <a:ext cx="1554480" cy="182880"/>
+          </a:xfrm>
+          <a:prstGeom prst="rect">
+            <a:avLst/>
+          </a:prstGeom>
+          <a:noFill/>
+        </p:spPr>
+        <p:txBody>
+          <a:bodyPr wrap="square" anchor="t" lIns="0" rIns="0" tIns="0" bIns="0">
+            <a:spAutoFit/>
+          </a:bodyPr>
+          <a:lstStyle/>
+          <a:p>
+            <a:pPr algn="l"/>
+            <a:r>
+              <a:rPr sz="900" b="1">
+                <a:solidFill>
+                  <a:srgbClr val="FFFFFF"/>
+                </a:solidFill>
+                <a:latin typeface="Open Sans"/>
+              </a:rPr>
+              <a:t>Confidence</a:t>
+            </a:r>
+          </a:p>
+        </p:txBody>
+      </p:sp>
+      <p:sp>
+        <p:nvSpPr>
+          <p:cNvPr id="33" name="Rectangle 32"/>
           <p:cNvSpPr/>
           <p:nvPr/>
         </p:nvSpPr>
         <p:spPr>
           <a:xfrm>
-            <a:off x="457200" y="4023360"/>
-            <a:ext cx="91440" cy="594360"/>
-          </a:xfrm>
-          <a:prstGeom prst="rect">
-            <a:avLst/>
+            <a:off x="457200" y="5084064"/>
+            <a:ext cx="5486400" cy="301752"/>
+          </a:xfrm>
+          <a:prstGeom prst="rect">
+            <a:avLst/>
+          </a:prstGeom>
+          <a:solidFill>
+            <a:srgbClr val="F8FAFC"/>
+          </a:solidFill>
+          <a:ln>
+            <a:noFill/>
+          </a:ln>
+          <a:effectLst/>
+        </p:spPr>
+        <p:style>
+          <a:lnRef idx="1">
+            <a:schemeClr val="accent1"/>
+          </a:lnRef>
+          <a:fillRef idx="3">
+            <a:schemeClr val="accent1"/>
+          </a:fillRef>
+          <a:effectRef idx="2">
+            <a:schemeClr val="accent1"/>
+          </a:effectRef>
+          <a:fontRef idx="minor">
+            <a:schemeClr val="lt1"/>
+          </a:fontRef>
+        </p:style>
+        <p:txBody>
+          <a:bodyPr rtlCol="0" anchor="ctr"/>
+          <a:lstStyle/>
+          <a:p>
+            <a:pPr algn="ctr"/>
+          </a:p>
+        </p:txBody>
+      </p:sp>
+      <p:sp>
+        <p:nvSpPr>
+          <p:cNvPr id="34" name="TextBox 33"/>
+          <p:cNvSpPr txBox="1"/>
+          <p:nvPr/>
+        </p:nvSpPr>
+        <p:spPr>
+          <a:xfrm>
+            <a:off x="548640" y="5138927"/>
+            <a:ext cx="1554480" cy="201168"/>
+          </a:xfrm>
+          <a:prstGeom prst="rect">
+            <a:avLst/>
+          </a:prstGeom>
+          <a:noFill/>
+        </p:spPr>
+        <p:txBody>
+          <a:bodyPr wrap="square" anchor="t" lIns="0" rIns="0" tIns="0" bIns="0">
+            <a:spAutoFit/>
+          </a:bodyPr>
+          <a:lstStyle/>
+          <a:p>
+            <a:pPr algn="l"/>
+            <a:r>
+              <a:rPr sz="1050" b="1">
+                <a:solidFill>
+                  <a:srgbClr val="0F172A"/>
+                </a:solidFill>
+                <a:latin typeface="Open Sans"/>
+              </a:rPr>
+              <a:t>1 record</a:t>
+            </a:r>
+          </a:p>
+        </p:txBody>
+      </p:sp>
+      <p:sp>
+        <p:nvSpPr>
+          <p:cNvPr id="35" name="TextBox 34"/>
+          <p:cNvSpPr txBox="1"/>
+          <p:nvPr/>
+        </p:nvSpPr>
+        <p:spPr>
+          <a:xfrm>
+            <a:off x="2194560" y="5138927"/>
+            <a:ext cx="914400" cy="201168"/>
+          </a:xfrm>
+          <a:prstGeom prst="rect">
+            <a:avLst/>
+          </a:prstGeom>
+          <a:noFill/>
+        </p:spPr>
+        <p:txBody>
+          <a:bodyPr wrap="square" anchor="t" lIns="0" rIns="0" tIns="0" bIns="0">
+            <a:spAutoFit/>
+          </a:bodyPr>
+          <a:lstStyle/>
+          <a:p>
+            <a:pPr algn="l"/>
+            <a:r>
+              <a:rPr sz="1050" b="0">
+                <a:solidFill>
+                  <a:srgbClr val="334155"/>
+                </a:solidFill>
+                <a:latin typeface="Open Sans"/>
+              </a:rPr>
+              <a:t>3,266</a:t>
+            </a:r>
+          </a:p>
+        </p:txBody>
+      </p:sp>
+      <p:sp>
+        <p:nvSpPr>
+          <p:cNvPr id="36" name="TextBox 35"/>
+          <p:cNvSpPr txBox="1"/>
+          <p:nvPr/>
+        </p:nvSpPr>
+        <p:spPr>
+          <a:xfrm>
+            <a:off x="3246120" y="5138927"/>
+            <a:ext cx="914400" cy="201168"/>
+          </a:xfrm>
+          <a:prstGeom prst="rect">
+            <a:avLst/>
+          </a:prstGeom>
+          <a:noFill/>
+        </p:spPr>
+        <p:txBody>
+          <a:bodyPr wrap="square" anchor="t" lIns="0" rIns="0" tIns="0" bIns="0">
+            <a:spAutoFit/>
+          </a:bodyPr>
+          <a:lstStyle/>
+          <a:p>
+            <a:pPr algn="l"/>
+            <a:r>
+              <a:rPr sz="1050" b="1">
+                <a:solidFill>
+                  <a:srgbClr val="059669"/>
+                </a:solidFill>
+                <a:latin typeface="Open Sans"/>
+              </a:rPr>
+              <a:t>$239K</a:t>
+            </a:r>
+          </a:p>
+        </p:txBody>
+      </p:sp>
+      <p:sp>
+        <p:nvSpPr>
+          <p:cNvPr id="37" name="TextBox 36"/>
+          <p:cNvSpPr txBox="1"/>
+          <p:nvPr/>
+        </p:nvSpPr>
+        <p:spPr>
+          <a:xfrm>
+            <a:off x="4297680" y="5138927"/>
+            <a:ext cx="1554480" cy="201168"/>
+          </a:xfrm>
+          <a:prstGeom prst="rect">
+            <a:avLst/>
+          </a:prstGeom>
+          <a:noFill/>
+        </p:spPr>
+        <p:txBody>
+          <a:bodyPr wrap="square" anchor="t" lIns="0" rIns="0" tIns="0" bIns="0">
+            <a:spAutoFit/>
+          </a:bodyPr>
+          <a:lstStyle/>
+          <a:p>
+            <a:pPr algn="l"/>
+            <a:r>
+              <a:rPr sz="950" b="0">
+                <a:solidFill>
+                  <a:srgbClr val="64748B"/>
+                </a:solidFill>
+                <a:latin typeface="Open Sans"/>
+              </a:rPr>
+              <a:t>High confidence</a:t>
+            </a:r>
+          </a:p>
+        </p:txBody>
+      </p:sp>
+      <p:sp>
+        <p:nvSpPr>
+          <p:cNvPr id="38" name="Rectangle 37"/>
+          <p:cNvSpPr/>
+          <p:nvPr/>
+        </p:nvSpPr>
+        <p:spPr>
+          <a:xfrm>
+            <a:off x="457200" y="5385816"/>
+            <a:ext cx="5486400" cy="301752"/>
+          </a:xfrm>
+          <a:prstGeom prst="rect">
+            <a:avLst/>
+          </a:prstGeom>
+          <a:solidFill>
+            <a:srgbClr val="FFFFFF"/>
+          </a:solidFill>
+          <a:ln>
+            <a:noFill/>
+          </a:ln>
+          <a:effectLst/>
+        </p:spPr>
+        <p:style>
+          <a:lnRef idx="1">
+            <a:schemeClr val="accent1"/>
+          </a:lnRef>
+          <a:fillRef idx="3">
+            <a:schemeClr val="accent1"/>
+          </a:fillRef>
+          <a:effectRef idx="2">
+            <a:schemeClr val="accent1"/>
+          </a:effectRef>
+          <a:fontRef idx="minor">
+            <a:schemeClr val="lt1"/>
+          </a:fontRef>
+        </p:style>
+        <p:txBody>
+          <a:bodyPr rtlCol="0" anchor="ctr"/>
+          <a:lstStyle/>
+          <a:p>
+            <a:pPr algn="ctr"/>
+          </a:p>
+        </p:txBody>
+      </p:sp>
+      <p:sp>
+        <p:nvSpPr>
+          <p:cNvPr id="39" name="TextBox 38"/>
+          <p:cNvSpPr txBox="1"/>
+          <p:nvPr/>
+        </p:nvSpPr>
+        <p:spPr>
+          <a:xfrm>
+            <a:off x="548640" y="5440679"/>
+            <a:ext cx="1554480" cy="201168"/>
+          </a:xfrm>
+          <a:prstGeom prst="rect">
+            <a:avLst/>
+          </a:prstGeom>
+          <a:noFill/>
+        </p:spPr>
+        <p:txBody>
+          <a:bodyPr wrap="square" anchor="t" lIns="0" rIns="0" tIns="0" bIns="0">
+            <a:spAutoFit/>
+          </a:bodyPr>
+          <a:lstStyle/>
+          <a:p>
+            <a:pPr algn="l"/>
+            <a:r>
+              <a:rPr sz="1050" b="1">
+                <a:solidFill>
+                  <a:srgbClr val="0F172A"/>
+                </a:solidFill>
+                <a:latin typeface="Open Sans"/>
+              </a:rPr>
+              <a:t>2–5 records</a:t>
+            </a:r>
+          </a:p>
+        </p:txBody>
+      </p:sp>
+      <p:sp>
+        <p:nvSpPr>
+          <p:cNvPr id="40" name="TextBox 39"/>
+          <p:cNvSpPr txBox="1"/>
+          <p:nvPr/>
+        </p:nvSpPr>
+        <p:spPr>
+          <a:xfrm>
+            <a:off x="2194560" y="5440679"/>
+            <a:ext cx="914400" cy="201168"/>
+          </a:xfrm>
+          <a:prstGeom prst="rect">
+            <a:avLst/>
+          </a:prstGeom>
+          <a:noFill/>
+        </p:spPr>
+        <p:txBody>
+          <a:bodyPr wrap="square" anchor="t" lIns="0" rIns="0" tIns="0" bIns="0">
+            <a:spAutoFit/>
+          </a:bodyPr>
+          <a:lstStyle/>
+          <a:p>
+            <a:pPr algn="l"/>
+            <a:r>
+              <a:rPr sz="1050" b="0">
+                <a:solidFill>
+                  <a:srgbClr val="334155"/>
+                </a:solidFill>
+                <a:latin typeface="Open Sans"/>
+              </a:rPr>
+              <a:t>5,788</a:t>
+            </a:r>
+          </a:p>
+        </p:txBody>
+      </p:sp>
+      <p:sp>
+        <p:nvSpPr>
+          <p:cNvPr id="41" name="TextBox 40"/>
+          <p:cNvSpPr txBox="1"/>
+          <p:nvPr/>
+        </p:nvSpPr>
+        <p:spPr>
+          <a:xfrm>
+            <a:off x="3246120" y="5440679"/>
+            <a:ext cx="914400" cy="201168"/>
+          </a:xfrm>
+          <a:prstGeom prst="rect">
+            <a:avLst/>
+          </a:prstGeom>
+          <a:noFill/>
+        </p:spPr>
+        <p:txBody>
+          <a:bodyPr wrap="square" anchor="t" lIns="0" rIns="0" tIns="0" bIns="0">
+            <a:spAutoFit/>
+          </a:bodyPr>
+          <a:lstStyle/>
+          <a:p>
+            <a:pPr algn="l"/>
+            <a:r>
+              <a:rPr sz="1050" b="1">
+                <a:solidFill>
+                  <a:srgbClr val="059669"/>
+                </a:solidFill>
+                <a:latin typeface="Open Sans"/>
+              </a:rPr>
+              <a:t>$1.21M</a:t>
+            </a:r>
+          </a:p>
+        </p:txBody>
+      </p:sp>
+      <p:sp>
+        <p:nvSpPr>
+          <p:cNvPr id="42" name="TextBox 41"/>
+          <p:cNvSpPr txBox="1"/>
+          <p:nvPr/>
+        </p:nvSpPr>
+        <p:spPr>
+          <a:xfrm>
+            <a:off x="4297680" y="5440679"/>
+            <a:ext cx="1554480" cy="201168"/>
+          </a:xfrm>
+          <a:prstGeom prst="rect">
+            <a:avLst/>
+          </a:prstGeom>
+          <a:noFill/>
+        </p:spPr>
+        <p:txBody>
+          <a:bodyPr wrap="square" anchor="t" lIns="0" rIns="0" tIns="0" bIns="0">
+            <a:spAutoFit/>
+          </a:bodyPr>
+          <a:lstStyle/>
+          <a:p>
+            <a:pPr algn="l"/>
+            <a:r>
+              <a:rPr sz="950" b="0">
+                <a:solidFill>
+                  <a:srgbClr val="64748B"/>
+                </a:solidFill>
+                <a:latin typeface="Open Sans"/>
+              </a:rPr>
+              <a:t>High confidence</a:t>
+            </a:r>
+          </a:p>
+        </p:txBody>
+      </p:sp>
+      <p:sp>
+        <p:nvSpPr>
+          <p:cNvPr id="43" name="Rectangle 42"/>
+          <p:cNvSpPr/>
+          <p:nvPr/>
+        </p:nvSpPr>
+        <p:spPr>
+          <a:xfrm>
+            <a:off x="457200" y="5687568"/>
+            <a:ext cx="5486400" cy="301752"/>
+          </a:xfrm>
+          <a:prstGeom prst="rect">
+            <a:avLst/>
+          </a:prstGeom>
+          <a:solidFill>
+            <a:srgbClr val="F8FAFC"/>
+          </a:solidFill>
+          <a:ln>
+            <a:noFill/>
+          </a:ln>
+          <a:effectLst/>
+        </p:spPr>
+        <p:style>
+          <a:lnRef idx="1">
+            <a:schemeClr val="accent1"/>
+          </a:lnRef>
+          <a:fillRef idx="3">
+            <a:schemeClr val="accent1"/>
+          </a:fillRef>
+          <a:effectRef idx="2">
+            <a:schemeClr val="accent1"/>
+          </a:effectRef>
+          <a:fontRef idx="minor">
+            <a:schemeClr val="lt1"/>
+          </a:fontRef>
+        </p:style>
+        <p:txBody>
+          <a:bodyPr rtlCol="0" anchor="ctr"/>
+          <a:lstStyle/>
+          <a:p>
+            <a:pPr algn="ctr"/>
+          </a:p>
+        </p:txBody>
+      </p:sp>
+      <p:sp>
+        <p:nvSpPr>
+          <p:cNvPr id="44" name="TextBox 43"/>
+          <p:cNvSpPr txBox="1"/>
+          <p:nvPr/>
+        </p:nvSpPr>
+        <p:spPr>
+          <a:xfrm>
+            <a:off x="548640" y="5742431"/>
+            <a:ext cx="1554480" cy="201168"/>
+          </a:xfrm>
+          <a:prstGeom prst="rect">
+            <a:avLst/>
+          </a:prstGeom>
+          <a:noFill/>
+        </p:spPr>
+        <p:txBody>
+          <a:bodyPr wrap="square" anchor="t" lIns="0" rIns="0" tIns="0" bIns="0">
+            <a:spAutoFit/>
+          </a:bodyPr>
+          <a:lstStyle/>
+          <a:p>
+            <a:pPr algn="l"/>
+            <a:r>
+              <a:rPr sz="1050" b="1">
+                <a:solidFill>
+                  <a:srgbClr val="0F172A"/>
+                </a:solidFill>
+                <a:latin typeface="Open Sans"/>
+              </a:rPr>
+              <a:t>6–20 records</a:t>
+            </a:r>
+          </a:p>
+        </p:txBody>
+      </p:sp>
+      <p:sp>
+        <p:nvSpPr>
+          <p:cNvPr id="45" name="TextBox 44"/>
+          <p:cNvSpPr txBox="1"/>
+          <p:nvPr/>
+        </p:nvSpPr>
+        <p:spPr>
+          <a:xfrm>
+            <a:off x="2194560" y="5742431"/>
+            <a:ext cx="914400" cy="201168"/>
+          </a:xfrm>
+          <a:prstGeom prst="rect">
+            <a:avLst/>
+          </a:prstGeom>
+          <a:noFill/>
+        </p:spPr>
+        <p:txBody>
+          <a:bodyPr wrap="square" anchor="t" lIns="0" rIns="0" tIns="0" bIns="0">
+            <a:spAutoFit/>
+          </a:bodyPr>
+          <a:lstStyle/>
+          <a:p>
+            <a:pPr algn="l"/>
+            <a:r>
+              <a:rPr sz="1050" b="0">
+                <a:solidFill>
+                  <a:srgbClr val="334155"/>
+                </a:solidFill>
+                <a:latin typeface="Open Sans"/>
+              </a:rPr>
+              <a:t>4,393</a:t>
+            </a:r>
+          </a:p>
+        </p:txBody>
+      </p:sp>
+      <p:sp>
+        <p:nvSpPr>
+          <p:cNvPr id="46" name="TextBox 45"/>
+          <p:cNvSpPr txBox="1"/>
+          <p:nvPr/>
+        </p:nvSpPr>
+        <p:spPr>
+          <a:xfrm>
+            <a:off x="3246120" y="5742431"/>
+            <a:ext cx="914400" cy="201168"/>
+          </a:xfrm>
+          <a:prstGeom prst="rect">
+            <a:avLst/>
+          </a:prstGeom>
+          <a:noFill/>
+        </p:spPr>
+        <p:txBody>
+          <a:bodyPr wrap="square" anchor="t" lIns="0" rIns="0" tIns="0" bIns="0">
+            <a:spAutoFit/>
+          </a:bodyPr>
+          <a:lstStyle/>
+          <a:p>
+            <a:pPr algn="l"/>
+            <a:r>
+              <a:rPr sz="1050" b="1">
+                <a:solidFill>
+                  <a:srgbClr val="FFB352"/>
+                </a:solidFill>
+                <a:latin typeface="Open Sans"/>
+              </a:rPr>
+              <a:t>$3.50M</a:t>
+            </a:r>
+          </a:p>
+        </p:txBody>
+      </p:sp>
+      <p:sp>
+        <p:nvSpPr>
+          <p:cNvPr id="47" name="TextBox 46"/>
+          <p:cNvSpPr txBox="1"/>
+          <p:nvPr/>
+        </p:nvSpPr>
+        <p:spPr>
+          <a:xfrm>
+            <a:off x="4297680" y="5742431"/>
+            <a:ext cx="1554480" cy="201168"/>
+          </a:xfrm>
+          <a:prstGeom prst="rect">
+            <a:avLst/>
+          </a:prstGeom>
+          <a:noFill/>
+        </p:spPr>
+        <p:txBody>
+          <a:bodyPr wrap="square" anchor="t" lIns="0" rIns="0" tIns="0" bIns="0">
+            <a:spAutoFit/>
+          </a:bodyPr>
+          <a:lstStyle/>
+          <a:p>
+            <a:pPr algn="l"/>
+            <a:r>
+              <a:rPr sz="950" b="0">
+                <a:solidFill>
+                  <a:srgbClr val="64748B"/>
+                </a:solidFill>
+                <a:latin typeface="Open Sans"/>
+              </a:rPr>
+              <a:t>Mixed — needs review</a:t>
+            </a:r>
+          </a:p>
+        </p:txBody>
+      </p:sp>
+      <p:sp>
+        <p:nvSpPr>
+          <p:cNvPr id="48" name="Rectangle 47"/>
+          <p:cNvSpPr/>
+          <p:nvPr/>
+        </p:nvSpPr>
+        <p:spPr>
+          <a:xfrm>
+            <a:off x="457200" y="5989320"/>
+            <a:ext cx="5486400" cy="301752"/>
+          </a:xfrm>
+          <a:prstGeom prst="rect">
+            <a:avLst/>
+          </a:prstGeom>
+          <a:solidFill>
+            <a:srgbClr val="FFFFFF"/>
+          </a:solidFill>
+          <a:ln>
+            <a:noFill/>
+          </a:ln>
+          <a:effectLst/>
+        </p:spPr>
+        <p:style>
+          <a:lnRef idx="1">
+            <a:schemeClr val="accent1"/>
+          </a:lnRef>
+          <a:fillRef idx="3">
+            <a:schemeClr val="accent1"/>
+          </a:fillRef>
+          <a:effectRef idx="2">
+            <a:schemeClr val="accent1"/>
+          </a:effectRef>
+          <a:fontRef idx="minor">
+            <a:schemeClr val="lt1"/>
+          </a:fontRef>
+        </p:style>
+        <p:txBody>
+          <a:bodyPr rtlCol="0" anchor="ctr"/>
+          <a:lstStyle/>
+          <a:p>
+            <a:pPr algn="ctr"/>
+          </a:p>
+        </p:txBody>
+      </p:sp>
+      <p:sp>
+        <p:nvSpPr>
+          <p:cNvPr id="49" name="TextBox 48"/>
+          <p:cNvSpPr txBox="1"/>
+          <p:nvPr/>
+        </p:nvSpPr>
+        <p:spPr>
+          <a:xfrm>
+            <a:off x="548640" y="6044183"/>
+            <a:ext cx="1554480" cy="201168"/>
+          </a:xfrm>
+          <a:prstGeom prst="rect">
+            <a:avLst/>
+          </a:prstGeom>
+          <a:noFill/>
+        </p:spPr>
+        <p:txBody>
+          <a:bodyPr wrap="square" anchor="t" lIns="0" rIns="0" tIns="0" bIns="0">
+            <a:spAutoFit/>
+          </a:bodyPr>
+          <a:lstStyle/>
+          <a:p>
+            <a:pPr algn="l"/>
+            <a:r>
+              <a:rPr sz="1050" b="1">
+                <a:solidFill>
+                  <a:srgbClr val="0F172A"/>
+                </a:solidFill>
+                <a:latin typeface="Open Sans"/>
+              </a:rPr>
+              <a:t>20+ records</a:t>
+            </a:r>
+          </a:p>
+        </p:txBody>
+      </p:sp>
+      <p:sp>
+        <p:nvSpPr>
+          <p:cNvPr id="50" name="TextBox 49"/>
+          <p:cNvSpPr txBox="1"/>
+          <p:nvPr/>
+        </p:nvSpPr>
+        <p:spPr>
+          <a:xfrm>
+            <a:off x="2194560" y="6044183"/>
+            <a:ext cx="914400" cy="201168"/>
+          </a:xfrm>
+          <a:prstGeom prst="rect">
+            <a:avLst/>
+          </a:prstGeom>
+          <a:noFill/>
+        </p:spPr>
+        <p:txBody>
+          <a:bodyPr wrap="square" anchor="t" lIns="0" rIns="0" tIns="0" bIns="0">
+            <a:spAutoFit/>
+          </a:bodyPr>
+          <a:lstStyle/>
+          <a:p>
+            <a:pPr algn="l"/>
+            <a:r>
+              <a:rPr sz="1050" b="0">
+                <a:solidFill>
+                  <a:srgbClr val="334155"/>
+                </a:solidFill>
+                <a:latin typeface="Open Sans"/>
+              </a:rPr>
+              <a:t>8,417</a:t>
+            </a:r>
+          </a:p>
+        </p:txBody>
+      </p:sp>
+      <p:sp>
+        <p:nvSpPr>
+          <p:cNvPr id="51" name="TextBox 50"/>
+          <p:cNvSpPr txBox="1"/>
+          <p:nvPr/>
+        </p:nvSpPr>
+        <p:spPr>
+          <a:xfrm>
+            <a:off x="3246120" y="6044183"/>
+            <a:ext cx="914400" cy="201168"/>
+          </a:xfrm>
+          <a:prstGeom prst="rect">
+            <a:avLst/>
+          </a:prstGeom>
+          <a:noFill/>
+        </p:spPr>
+        <p:txBody>
+          <a:bodyPr wrap="square" anchor="t" lIns="0" rIns="0" tIns="0" bIns="0">
+            <a:spAutoFit/>
+          </a:bodyPr>
+          <a:lstStyle/>
+          <a:p>
+            <a:pPr algn="l"/>
+            <a:r>
+              <a:rPr sz="1050" b="1">
+                <a:solidFill>
+                  <a:srgbClr val="64748B"/>
+                </a:solidFill>
+                <a:latin typeface="Open Sans"/>
+              </a:rPr>
+              <a:t>$319M</a:t>
+            </a:r>
+          </a:p>
+        </p:txBody>
+      </p:sp>
+      <p:sp>
+        <p:nvSpPr>
+          <p:cNvPr id="52" name="TextBox 51"/>
+          <p:cNvSpPr txBox="1"/>
+          <p:nvPr/>
+        </p:nvSpPr>
+        <p:spPr>
+          <a:xfrm>
+            <a:off x="4297680" y="6044183"/>
+            <a:ext cx="1554480" cy="201168"/>
+          </a:xfrm>
+          <a:prstGeom prst="rect">
+            <a:avLst/>
+          </a:prstGeom>
+          <a:noFill/>
+        </p:spPr>
+        <p:txBody>
+          <a:bodyPr wrap="square" anchor="t" lIns="0" rIns="0" tIns="0" bIns="0">
+            <a:spAutoFit/>
+          </a:bodyPr>
+          <a:lstStyle/>
+          <a:p>
+            <a:pPr algn="l"/>
+            <a:r>
+              <a:rPr sz="950" b="0">
+                <a:solidFill>
+                  <a:srgbClr val="64748B"/>
+                </a:solidFill>
+                <a:latin typeface="Open Sans"/>
+              </a:rPr>
+              <a:t>Common-name collisions</a:t>
+            </a:r>
+          </a:p>
+        </p:txBody>
+      </p:sp>
+      <p:sp>
+        <p:nvSpPr>
+          <p:cNvPr id="53" name="TextBox 52"/>
+          <p:cNvSpPr txBox="1"/>
+          <p:nvPr/>
+        </p:nvSpPr>
+        <p:spPr>
+          <a:xfrm>
+            <a:off x="6217920" y="4206240"/>
+            <a:ext cx="5486400" cy="320040"/>
+          </a:xfrm>
+          <a:prstGeom prst="rect">
+            <a:avLst/>
+          </a:prstGeom>
+          <a:noFill/>
+        </p:spPr>
+        <p:txBody>
+          <a:bodyPr wrap="square" anchor="t" lIns="0" rIns="0" tIns="0" bIns="0">
+            <a:spAutoFit/>
+          </a:bodyPr>
+          <a:lstStyle/>
+          <a:p>
+            <a:pPr algn="l"/>
+            <a:r>
+              <a:rPr sz="1100" b="1">
+                <a:solidFill>
+                  <a:srgbClr val="2863C5"/>
+                </a:solidFill>
+                <a:latin typeface="Open Sans"/>
+              </a:rPr>
+              <a:t>MATCHES BY TIER</a:t>
+            </a:r>
+          </a:p>
+        </p:txBody>
+      </p:sp>
+      <p:sp>
+        <p:nvSpPr>
+          <p:cNvPr id="54" name="TextBox 53"/>
+          <p:cNvSpPr txBox="1"/>
+          <p:nvPr/>
+        </p:nvSpPr>
+        <p:spPr>
+          <a:xfrm>
+            <a:off x="6217920" y="4498848"/>
+            <a:ext cx="5486400" cy="274320"/>
+          </a:xfrm>
+          <a:prstGeom prst="rect">
+            <a:avLst/>
+          </a:prstGeom>
+          <a:noFill/>
+        </p:spPr>
+        <p:txBody>
+          <a:bodyPr wrap="square" anchor="t" lIns="0" rIns="0" tIns="0" bIns="0">
+            <a:spAutoFit/>
+          </a:bodyPr>
+          <a:lstStyle/>
+          <a:p>
+            <a:pPr algn="l"/>
+            <a:r>
+              <a:rPr sz="1000" b="0">
+                <a:solidFill>
+                  <a:srgbClr val="64748B"/>
+                </a:solidFill>
+                <a:latin typeface="Open Sans"/>
+              </a:rPr>
+              <a:t>Tier 04 ($500+) carries 53% of the value despite 2% of records.</a:t>
+            </a:r>
+          </a:p>
+        </p:txBody>
+      </p:sp>
+      <p:sp>
+        <p:nvSpPr>
+          <p:cNvPr id="55" name="Rectangle 54"/>
+          <p:cNvSpPr/>
+          <p:nvPr/>
+        </p:nvSpPr>
+        <p:spPr>
+          <a:xfrm>
+            <a:off x="6217920" y="4846320"/>
+            <a:ext cx="5486400" cy="237744"/>
+          </a:xfrm>
+          <a:prstGeom prst="rect">
+            <a:avLst/>
+          </a:prstGeom>
+          <a:solidFill>
+            <a:srgbClr val="0F172A"/>
+          </a:solidFill>
+          <a:ln>
+            <a:noFill/>
+          </a:ln>
+          <a:effectLst/>
+        </p:spPr>
+        <p:style>
+          <a:lnRef idx="1">
+            <a:schemeClr val="accent1"/>
+          </a:lnRef>
+          <a:fillRef idx="3">
+            <a:schemeClr val="accent1"/>
+          </a:fillRef>
+          <a:effectRef idx="2">
+            <a:schemeClr val="accent1"/>
+          </a:effectRef>
+          <a:fontRef idx="minor">
+            <a:schemeClr val="lt1"/>
+          </a:fontRef>
+        </p:style>
+        <p:txBody>
+          <a:bodyPr rtlCol="0" anchor="ctr"/>
+          <a:lstStyle/>
+          <a:p>
+            <a:pPr algn="ctr"/>
+          </a:p>
+        </p:txBody>
+      </p:sp>
+      <p:sp>
+        <p:nvSpPr>
+          <p:cNvPr id="56" name="TextBox 55"/>
+          <p:cNvSpPr txBox="1"/>
+          <p:nvPr/>
+        </p:nvSpPr>
+        <p:spPr>
+          <a:xfrm>
+            <a:off x="6309360" y="4882896"/>
+            <a:ext cx="914400" cy="182880"/>
+          </a:xfrm>
+          <a:prstGeom prst="rect">
+            <a:avLst/>
+          </a:prstGeom>
+          <a:noFill/>
+        </p:spPr>
+        <p:txBody>
+          <a:bodyPr wrap="square" anchor="t" lIns="0" rIns="0" tIns="0" bIns="0">
+            <a:spAutoFit/>
+          </a:bodyPr>
+          <a:lstStyle/>
+          <a:p>
+            <a:pPr algn="l"/>
+            <a:r>
+              <a:rPr sz="900" b="1">
+                <a:solidFill>
+                  <a:srgbClr val="FFFFFF"/>
+                </a:solidFill>
+                <a:latin typeface="Open Sans"/>
+              </a:rPr>
+              <a:t>Tier</a:t>
+            </a:r>
+          </a:p>
+        </p:txBody>
+      </p:sp>
+      <p:sp>
+        <p:nvSpPr>
+          <p:cNvPr id="57" name="TextBox 56"/>
+          <p:cNvSpPr txBox="1"/>
+          <p:nvPr/>
+        </p:nvSpPr>
+        <p:spPr>
+          <a:xfrm>
+            <a:off x="7269480" y="4882896"/>
+            <a:ext cx="1280160" cy="182880"/>
+          </a:xfrm>
+          <a:prstGeom prst="rect">
+            <a:avLst/>
+          </a:prstGeom>
+          <a:noFill/>
+        </p:spPr>
+        <p:txBody>
+          <a:bodyPr wrap="square" anchor="t" lIns="0" rIns="0" tIns="0" bIns="0">
+            <a:spAutoFit/>
+          </a:bodyPr>
+          <a:lstStyle/>
+          <a:p>
+            <a:pPr algn="l"/>
+            <a:r>
+              <a:rPr sz="900" b="1">
+                <a:solidFill>
+                  <a:srgbClr val="FFFFFF"/>
+                </a:solidFill>
+                <a:latin typeface="Open Sans"/>
+              </a:rPr>
+              <a:t>Range</a:t>
+            </a:r>
+          </a:p>
+        </p:txBody>
+      </p:sp>
+      <p:sp>
+        <p:nvSpPr>
+          <p:cNvPr id="58" name="TextBox 57"/>
+          <p:cNvSpPr txBox="1"/>
+          <p:nvPr/>
+        </p:nvSpPr>
+        <p:spPr>
+          <a:xfrm>
+            <a:off x="8641080" y="4882896"/>
+            <a:ext cx="1371600" cy="182880"/>
+          </a:xfrm>
+          <a:prstGeom prst="rect">
+            <a:avLst/>
+          </a:prstGeom>
+          <a:noFill/>
+        </p:spPr>
+        <p:txBody>
+          <a:bodyPr wrap="square" anchor="t" lIns="0" rIns="0" tIns="0" bIns="0">
+            <a:spAutoFit/>
+          </a:bodyPr>
+          <a:lstStyle/>
+          <a:p>
+            <a:pPr algn="l"/>
+            <a:r>
+              <a:rPr sz="900" b="1">
+                <a:solidFill>
+                  <a:srgbClr val="FFFFFF"/>
+                </a:solidFill>
+                <a:latin typeface="Open Sans"/>
+              </a:rPr>
+              <a:t>Records</a:t>
+            </a:r>
+          </a:p>
+        </p:txBody>
+      </p:sp>
+      <p:sp>
+        <p:nvSpPr>
+          <p:cNvPr id="59" name="TextBox 58"/>
+          <p:cNvSpPr txBox="1"/>
+          <p:nvPr/>
+        </p:nvSpPr>
+        <p:spPr>
+          <a:xfrm>
+            <a:off x="10104120" y="4882896"/>
+            <a:ext cx="1371600" cy="182880"/>
+          </a:xfrm>
+          <a:prstGeom prst="rect">
+            <a:avLst/>
+          </a:prstGeom>
+          <a:noFill/>
+        </p:spPr>
+        <p:txBody>
+          <a:bodyPr wrap="square" anchor="t" lIns="0" rIns="0" tIns="0" bIns="0">
+            <a:spAutoFit/>
+          </a:bodyPr>
+          <a:lstStyle/>
+          <a:p>
+            <a:pPr algn="l"/>
+            <a:r>
+              <a:rPr sz="900" b="1">
+                <a:solidFill>
+                  <a:srgbClr val="FFFFFF"/>
+                </a:solidFill>
+                <a:latin typeface="Open Sans"/>
+              </a:rPr>
+              <a:t>$ value</a:t>
+            </a:r>
+          </a:p>
+        </p:txBody>
+      </p:sp>
+      <p:sp>
+        <p:nvSpPr>
+          <p:cNvPr id="60" name="Rectangle 59"/>
+          <p:cNvSpPr/>
+          <p:nvPr/>
+        </p:nvSpPr>
+        <p:spPr>
+          <a:xfrm>
+            <a:off x="6217920" y="5084064"/>
+            <a:ext cx="5486400" cy="301752"/>
+          </a:xfrm>
+          <a:prstGeom prst="rect">
+            <a:avLst/>
+          </a:prstGeom>
+          <a:solidFill>
+            <a:srgbClr val="F8FAFC"/>
+          </a:solidFill>
+          <a:ln>
+            <a:noFill/>
+          </a:ln>
+          <a:effectLst/>
+        </p:spPr>
+        <p:style>
+          <a:lnRef idx="1">
+            <a:schemeClr val="accent1"/>
+          </a:lnRef>
+          <a:fillRef idx="3">
+            <a:schemeClr val="accent1"/>
+          </a:fillRef>
+          <a:effectRef idx="2">
+            <a:schemeClr val="accent1"/>
+          </a:effectRef>
+          <a:fontRef idx="minor">
+            <a:schemeClr val="lt1"/>
+          </a:fontRef>
+        </p:style>
+        <p:txBody>
+          <a:bodyPr rtlCol="0" anchor="ctr"/>
+          <a:lstStyle/>
+          <a:p>
+            <a:pPr algn="ctr"/>
+          </a:p>
+        </p:txBody>
+      </p:sp>
+      <p:sp>
+        <p:nvSpPr>
+          <p:cNvPr id="61" name="TextBox 60"/>
+          <p:cNvSpPr txBox="1"/>
+          <p:nvPr/>
+        </p:nvSpPr>
+        <p:spPr>
+          <a:xfrm>
+            <a:off x="6309360" y="5138927"/>
+            <a:ext cx="914400" cy="201168"/>
+          </a:xfrm>
+          <a:prstGeom prst="rect">
+            <a:avLst/>
+          </a:prstGeom>
+          <a:noFill/>
+        </p:spPr>
+        <p:txBody>
+          <a:bodyPr wrap="square" anchor="t" lIns="0" rIns="0" tIns="0" bIns="0">
+            <a:spAutoFit/>
+          </a:bodyPr>
+          <a:lstStyle/>
+          <a:p>
+            <a:pPr algn="l"/>
+            <a:r>
+              <a:rPr sz="1050" b="1">
+                <a:solidFill>
+                  <a:srgbClr val="64748B"/>
+                </a:solidFill>
+                <a:latin typeface="Open Sans"/>
+              </a:rPr>
+              <a:t>Tier 01</a:t>
+            </a:r>
+          </a:p>
+        </p:txBody>
+      </p:sp>
+      <p:sp>
+        <p:nvSpPr>
+          <p:cNvPr id="62" name="TextBox 61"/>
+          <p:cNvSpPr txBox="1"/>
+          <p:nvPr/>
+        </p:nvSpPr>
+        <p:spPr>
+          <a:xfrm>
+            <a:off x="7269480" y="5138927"/>
+            <a:ext cx="1280160" cy="201168"/>
+          </a:xfrm>
+          <a:prstGeom prst="rect">
+            <a:avLst/>
+          </a:prstGeom>
+          <a:noFill/>
+        </p:spPr>
+        <p:txBody>
+          <a:bodyPr wrap="square" anchor="t" lIns="0" rIns="0" tIns="0" bIns="0">
+            <a:spAutoFit/>
+          </a:bodyPr>
+          <a:lstStyle/>
+          <a:p>
+            <a:pPr algn="l"/>
+            <a:r>
+              <a:rPr sz="950" b="0">
+                <a:solidFill>
+                  <a:srgbClr val="334155"/>
+                </a:solidFill>
+                <a:latin typeface="Open Sans"/>
+              </a:rPr>
+              <a:t>$0–$9.99</a:t>
+            </a:r>
+          </a:p>
+        </p:txBody>
+      </p:sp>
+      <p:sp>
+        <p:nvSpPr>
+          <p:cNvPr id="63" name="TextBox 62"/>
+          <p:cNvSpPr txBox="1"/>
+          <p:nvPr/>
+        </p:nvSpPr>
+        <p:spPr>
+          <a:xfrm>
+            <a:off x="8641080" y="5138927"/>
+            <a:ext cx="1371600" cy="201168"/>
+          </a:xfrm>
+          <a:prstGeom prst="rect">
+            <a:avLst/>
+          </a:prstGeom>
+          <a:noFill/>
+        </p:spPr>
+        <p:txBody>
+          <a:bodyPr wrap="square" anchor="t" lIns="0" rIns="0" tIns="0" bIns="0">
+            <a:spAutoFit/>
+          </a:bodyPr>
+          <a:lstStyle/>
+          <a:p>
+            <a:pPr algn="l"/>
+            <a:r>
+              <a:rPr sz="1050" b="0">
+                <a:solidFill>
+                  <a:srgbClr val="334155"/>
+                </a:solidFill>
+                <a:latin typeface="Open Sans"/>
+              </a:rPr>
+              <a:t>2,283,461</a:t>
+            </a:r>
+          </a:p>
+        </p:txBody>
+      </p:sp>
+      <p:sp>
+        <p:nvSpPr>
+          <p:cNvPr id="64" name="TextBox 63"/>
+          <p:cNvSpPr txBox="1"/>
+          <p:nvPr/>
+        </p:nvSpPr>
+        <p:spPr>
+          <a:xfrm>
+            <a:off x="10104120" y="5138927"/>
+            <a:ext cx="1371600" cy="201168"/>
+          </a:xfrm>
+          <a:prstGeom prst="rect">
+            <a:avLst/>
+          </a:prstGeom>
+          <a:noFill/>
+        </p:spPr>
+        <p:txBody>
+          <a:bodyPr wrap="square" anchor="t" lIns="0" rIns="0" tIns="0" bIns="0">
+            <a:spAutoFit/>
+          </a:bodyPr>
+          <a:lstStyle/>
+          <a:p>
+            <a:pPr algn="l"/>
+            <a:r>
+              <a:rPr sz="1050" b="1">
+                <a:solidFill>
+                  <a:srgbClr val="64748B"/>
+                </a:solidFill>
+                <a:latin typeface="Open Sans"/>
+              </a:rPr>
+              <a:t>$5.8M</a:t>
+            </a:r>
+          </a:p>
+        </p:txBody>
+      </p:sp>
+      <p:sp>
+        <p:nvSpPr>
+          <p:cNvPr id="65" name="Rectangle 64"/>
+          <p:cNvSpPr/>
+          <p:nvPr/>
+        </p:nvSpPr>
+        <p:spPr>
+          <a:xfrm>
+            <a:off x="6217920" y="5385816"/>
+            <a:ext cx="5486400" cy="301752"/>
+          </a:xfrm>
+          <a:prstGeom prst="rect">
+            <a:avLst/>
+          </a:prstGeom>
+          <a:solidFill>
+            <a:srgbClr val="FFFFFF"/>
+          </a:solidFill>
+          <a:ln>
+            <a:noFill/>
+          </a:ln>
+          <a:effectLst/>
+        </p:spPr>
+        <p:style>
+          <a:lnRef idx="1">
+            <a:schemeClr val="accent1"/>
+          </a:lnRef>
+          <a:fillRef idx="3">
+            <a:schemeClr val="accent1"/>
+          </a:fillRef>
+          <a:effectRef idx="2">
+            <a:schemeClr val="accent1"/>
+          </a:effectRef>
+          <a:fontRef idx="minor">
+            <a:schemeClr val="lt1"/>
+          </a:fontRef>
+        </p:style>
+        <p:txBody>
+          <a:bodyPr rtlCol="0" anchor="ctr"/>
+          <a:lstStyle/>
+          <a:p>
+            <a:pPr algn="ctr"/>
+          </a:p>
+        </p:txBody>
+      </p:sp>
+      <p:sp>
+        <p:nvSpPr>
+          <p:cNvPr id="66" name="TextBox 65"/>
+          <p:cNvSpPr txBox="1"/>
+          <p:nvPr/>
+        </p:nvSpPr>
+        <p:spPr>
+          <a:xfrm>
+            <a:off x="6309360" y="5440679"/>
+            <a:ext cx="914400" cy="201168"/>
+          </a:xfrm>
+          <a:prstGeom prst="rect">
+            <a:avLst/>
+          </a:prstGeom>
+          <a:noFill/>
+        </p:spPr>
+        <p:txBody>
+          <a:bodyPr wrap="square" anchor="t" lIns="0" rIns="0" tIns="0" bIns="0">
+            <a:spAutoFit/>
+          </a:bodyPr>
+          <a:lstStyle/>
+          <a:p>
+            <a:pPr algn="l"/>
+            <a:r>
+              <a:rPr sz="1050" b="1">
+                <a:solidFill>
+                  <a:srgbClr val="FFB352"/>
+                </a:solidFill>
+                <a:latin typeface="Open Sans"/>
+              </a:rPr>
+              <a:t>Tier 02</a:t>
+            </a:r>
+          </a:p>
+        </p:txBody>
+      </p:sp>
+      <p:sp>
+        <p:nvSpPr>
+          <p:cNvPr id="67" name="TextBox 66"/>
+          <p:cNvSpPr txBox="1"/>
+          <p:nvPr/>
+        </p:nvSpPr>
+        <p:spPr>
+          <a:xfrm>
+            <a:off x="7269480" y="5440679"/>
+            <a:ext cx="1280160" cy="201168"/>
+          </a:xfrm>
+          <a:prstGeom prst="rect">
+            <a:avLst/>
+          </a:prstGeom>
+          <a:noFill/>
+        </p:spPr>
+        <p:txBody>
+          <a:bodyPr wrap="square" anchor="t" lIns="0" rIns="0" tIns="0" bIns="0">
+            <a:spAutoFit/>
+          </a:bodyPr>
+          <a:lstStyle/>
+          <a:p>
+            <a:pPr algn="l"/>
+            <a:r>
+              <a:rPr sz="950" b="0">
+                <a:solidFill>
+                  <a:srgbClr val="334155"/>
+                </a:solidFill>
+                <a:latin typeface="Open Sans"/>
+              </a:rPr>
+              <a:t>$10–$99.99</a:t>
+            </a:r>
+          </a:p>
+        </p:txBody>
+      </p:sp>
+      <p:sp>
+        <p:nvSpPr>
+          <p:cNvPr id="68" name="TextBox 67"/>
+          <p:cNvSpPr txBox="1"/>
+          <p:nvPr/>
+        </p:nvSpPr>
+        <p:spPr>
+          <a:xfrm>
+            <a:off x="8641080" y="5440679"/>
+            <a:ext cx="1371600" cy="201168"/>
+          </a:xfrm>
+          <a:prstGeom prst="rect">
+            <a:avLst/>
+          </a:prstGeom>
+          <a:noFill/>
+        </p:spPr>
+        <p:txBody>
+          <a:bodyPr wrap="square" anchor="t" lIns="0" rIns="0" tIns="0" bIns="0">
+            <a:spAutoFit/>
+          </a:bodyPr>
+          <a:lstStyle/>
+          <a:p>
+            <a:pPr algn="l"/>
+            <a:r>
+              <a:rPr sz="1050" b="0">
+                <a:solidFill>
+                  <a:srgbClr val="334155"/>
+                </a:solidFill>
+                <a:latin typeface="Open Sans"/>
+              </a:rPr>
+              <a:t>1,622,140</a:t>
+            </a:r>
+          </a:p>
+        </p:txBody>
+      </p:sp>
+      <p:sp>
+        <p:nvSpPr>
+          <p:cNvPr id="69" name="TextBox 68"/>
+          <p:cNvSpPr txBox="1"/>
+          <p:nvPr/>
+        </p:nvSpPr>
+        <p:spPr>
+          <a:xfrm>
+            <a:off x="10104120" y="5440679"/>
+            <a:ext cx="1371600" cy="201168"/>
+          </a:xfrm>
+          <a:prstGeom prst="rect">
+            <a:avLst/>
+          </a:prstGeom>
+          <a:noFill/>
+        </p:spPr>
+        <p:txBody>
+          <a:bodyPr wrap="square" anchor="t" lIns="0" rIns="0" tIns="0" bIns="0">
+            <a:spAutoFit/>
+          </a:bodyPr>
+          <a:lstStyle/>
+          <a:p>
+            <a:pPr algn="l"/>
+            <a:r>
+              <a:rPr sz="1050" b="1">
+                <a:solidFill>
+                  <a:srgbClr val="FFB352"/>
+                </a:solidFill>
+                <a:latin typeface="Open Sans"/>
+              </a:rPr>
+              <a:t>$57.9M</a:t>
+            </a:r>
+          </a:p>
+        </p:txBody>
+      </p:sp>
+      <p:sp>
+        <p:nvSpPr>
+          <p:cNvPr id="70" name="Rectangle 69"/>
+          <p:cNvSpPr/>
+          <p:nvPr/>
+        </p:nvSpPr>
+        <p:spPr>
+          <a:xfrm>
+            <a:off x="6217920" y="5687568"/>
+            <a:ext cx="5486400" cy="301752"/>
+          </a:xfrm>
+          <a:prstGeom prst="rect">
+            <a:avLst/>
+          </a:prstGeom>
+          <a:solidFill>
+            <a:srgbClr val="F8FAFC"/>
+          </a:solidFill>
+          <a:ln>
+            <a:noFill/>
+          </a:ln>
+          <a:effectLst/>
+        </p:spPr>
+        <p:style>
+          <a:lnRef idx="1">
+            <a:schemeClr val="accent1"/>
+          </a:lnRef>
+          <a:fillRef idx="3">
+            <a:schemeClr val="accent1"/>
+          </a:fillRef>
+          <a:effectRef idx="2">
+            <a:schemeClr val="accent1"/>
+          </a:effectRef>
+          <a:fontRef idx="minor">
+            <a:schemeClr val="lt1"/>
+          </a:fontRef>
+        </p:style>
+        <p:txBody>
+          <a:bodyPr rtlCol="0" anchor="ctr"/>
+          <a:lstStyle/>
+          <a:p>
+            <a:pPr algn="ctr"/>
+          </a:p>
+        </p:txBody>
+      </p:sp>
+      <p:sp>
+        <p:nvSpPr>
+          <p:cNvPr id="71" name="TextBox 70"/>
+          <p:cNvSpPr txBox="1"/>
+          <p:nvPr/>
+        </p:nvSpPr>
+        <p:spPr>
+          <a:xfrm>
+            <a:off x="6309360" y="5742431"/>
+            <a:ext cx="914400" cy="201168"/>
+          </a:xfrm>
+          <a:prstGeom prst="rect">
+            <a:avLst/>
+          </a:prstGeom>
+          <a:noFill/>
+        </p:spPr>
+        <p:txBody>
+          <a:bodyPr wrap="square" anchor="t" lIns="0" rIns="0" tIns="0" bIns="0">
+            <a:spAutoFit/>
+          </a:bodyPr>
+          <a:lstStyle/>
+          <a:p>
+            <a:pPr algn="l"/>
+            <a:r>
+              <a:rPr sz="1050" b="1">
+                <a:solidFill>
+                  <a:srgbClr val="FC4C0B"/>
+                </a:solidFill>
+                <a:latin typeface="Open Sans"/>
+              </a:rPr>
+              <a:t>Tier 03</a:t>
+            </a:r>
+          </a:p>
+        </p:txBody>
+      </p:sp>
+      <p:sp>
+        <p:nvSpPr>
+          <p:cNvPr id="72" name="TextBox 71"/>
+          <p:cNvSpPr txBox="1"/>
+          <p:nvPr/>
+        </p:nvSpPr>
+        <p:spPr>
+          <a:xfrm>
+            <a:off x="7269480" y="5742431"/>
+            <a:ext cx="1280160" cy="201168"/>
+          </a:xfrm>
+          <a:prstGeom prst="rect">
+            <a:avLst/>
+          </a:prstGeom>
+          <a:noFill/>
+        </p:spPr>
+        <p:txBody>
+          <a:bodyPr wrap="square" anchor="t" lIns="0" rIns="0" tIns="0" bIns="0">
+            <a:spAutoFit/>
+          </a:bodyPr>
+          <a:lstStyle/>
+          <a:p>
+            <a:pPr algn="l"/>
+            <a:r>
+              <a:rPr sz="950" b="0">
+                <a:solidFill>
+                  <a:srgbClr val="334155"/>
+                </a:solidFill>
+                <a:latin typeface="Open Sans"/>
+              </a:rPr>
+              <a:t>$100–$499.99</a:t>
+            </a:r>
+          </a:p>
+        </p:txBody>
+      </p:sp>
+      <p:sp>
+        <p:nvSpPr>
+          <p:cNvPr id="73" name="TextBox 72"/>
+          <p:cNvSpPr txBox="1"/>
+          <p:nvPr/>
+        </p:nvSpPr>
+        <p:spPr>
+          <a:xfrm>
+            <a:off x="8641080" y="5742431"/>
+            <a:ext cx="1371600" cy="201168"/>
+          </a:xfrm>
+          <a:prstGeom prst="rect">
+            <a:avLst/>
+          </a:prstGeom>
+          <a:noFill/>
+        </p:spPr>
+        <p:txBody>
+          <a:bodyPr wrap="square" anchor="t" lIns="0" rIns="0" tIns="0" bIns="0">
+            <a:spAutoFit/>
+          </a:bodyPr>
+          <a:lstStyle/>
+          <a:p>
+            <a:pPr algn="l"/>
+            <a:r>
+              <a:rPr sz="1050" b="0">
+                <a:solidFill>
+                  <a:srgbClr val="334155"/>
+                </a:solidFill>
+                <a:latin typeface="Open Sans"/>
+              </a:rPr>
+              <a:t>425,201</a:t>
+            </a:r>
+          </a:p>
+        </p:txBody>
+      </p:sp>
+      <p:sp>
+        <p:nvSpPr>
+          <p:cNvPr id="74" name="TextBox 73"/>
+          <p:cNvSpPr txBox="1"/>
+          <p:nvPr/>
+        </p:nvSpPr>
+        <p:spPr>
+          <a:xfrm>
+            <a:off x="10104120" y="5742431"/>
+            <a:ext cx="1371600" cy="201168"/>
+          </a:xfrm>
+          <a:prstGeom prst="rect">
+            <a:avLst/>
+          </a:prstGeom>
+          <a:noFill/>
+        </p:spPr>
+        <p:txBody>
+          <a:bodyPr wrap="square" anchor="t" lIns="0" rIns="0" tIns="0" bIns="0">
+            <a:spAutoFit/>
+          </a:bodyPr>
+          <a:lstStyle/>
+          <a:p>
+            <a:pPr algn="l"/>
+            <a:r>
+              <a:rPr sz="1050" b="1">
+                <a:solidFill>
+                  <a:srgbClr val="FC4C0B"/>
+                </a:solidFill>
+                <a:latin typeface="Open Sans"/>
+              </a:rPr>
+              <a:t>$87.5M</a:t>
+            </a:r>
+          </a:p>
+        </p:txBody>
+      </p:sp>
+      <p:sp>
+        <p:nvSpPr>
+          <p:cNvPr id="75" name="Rectangle 74"/>
+          <p:cNvSpPr/>
+          <p:nvPr/>
+        </p:nvSpPr>
+        <p:spPr>
+          <a:xfrm>
+            <a:off x="6217920" y="5989320"/>
+            <a:ext cx="5486400" cy="301752"/>
+          </a:xfrm>
+          <a:prstGeom prst="rect">
+            <a:avLst/>
+          </a:prstGeom>
+          <a:solidFill>
+            <a:srgbClr val="FFFFFF"/>
+          </a:solidFill>
+          <a:ln>
+            <a:noFill/>
+          </a:ln>
+          <a:effectLst/>
+        </p:spPr>
+        <p:style>
+          <a:lnRef idx="1">
+            <a:schemeClr val="accent1"/>
+          </a:lnRef>
+          <a:fillRef idx="3">
+            <a:schemeClr val="accent1"/>
+          </a:fillRef>
+          <a:effectRef idx="2">
+            <a:schemeClr val="accent1"/>
+          </a:effectRef>
+          <a:fontRef idx="minor">
+            <a:schemeClr val="lt1"/>
+          </a:fontRef>
+        </p:style>
+        <p:txBody>
+          <a:bodyPr rtlCol="0" anchor="ctr"/>
+          <a:lstStyle/>
+          <a:p>
+            <a:pPr algn="ctr"/>
+          </a:p>
+        </p:txBody>
+      </p:sp>
+      <p:sp>
+        <p:nvSpPr>
+          <p:cNvPr id="76" name="TextBox 75"/>
+          <p:cNvSpPr txBox="1"/>
+          <p:nvPr/>
+        </p:nvSpPr>
+        <p:spPr>
+          <a:xfrm>
+            <a:off x="6309360" y="6044183"/>
+            <a:ext cx="914400" cy="201168"/>
+          </a:xfrm>
+          <a:prstGeom prst="rect">
+            <a:avLst/>
+          </a:prstGeom>
+          <a:noFill/>
+        </p:spPr>
+        <p:txBody>
+          <a:bodyPr wrap="square" anchor="t" lIns="0" rIns="0" tIns="0" bIns="0">
+            <a:spAutoFit/>
+          </a:bodyPr>
+          <a:lstStyle/>
+          <a:p>
+            <a:pPr algn="l"/>
+            <a:r>
+              <a:rPr sz="1050" b="1">
+                <a:solidFill>
+                  <a:srgbClr val="2863C5"/>
+                </a:solidFill>
+                <a:latin typeface="Open Sans"/>
+              </a:rPr>
+              <a:t>Tier 04</a:t>
+            </a:r>
+          </a:p>
+        </p:txBody>
+      </p:sp>
+      <p:sp>
+        <p:nvSpPr>
+          <p:cNvPr id="77" name="TextBox 76"/>
+          <p:cNvSpPr txBox="1"/>
+          <p:nvPr/>
+        </p:nvSpPr>
+        <p:spPr>
+          <a:xfrm>
+            <a:off x="7269480" y="6044183"/>
+            <a:ext cx="1280160" cy="201168"/>
+          </a:xfrm>
+          <a:prstGeom prst="rect">
+            <a:avLst/>
+          </a:prstGeom>
+          <a:noFill/>
+        </p:spPr>
+        <p:txBody>
+          <a:bodyPr wrap="square" anchor="t" lIns="0" rIns="0" tIns="0" bIns="0">
+            <a:spAutoFit/>
+          </a:bodyPr>
+          <a:lstStyle/>
+          <a:p>
+            <a:pPr algn="l"/>
+            <a:r>
+              <a:rPr sz="950" b="0">
+                <a:solidFill>
+                  <a:srgbClr val="334155"/>
+                </a:solidFill>
+                <a:latin typeface="Open Sans"/>
+              </a:rPr>
+              <a:t>$500+</a:t>
+            </a:r>
+          </a:p>
+        </p:txBody>
+      </p:sp>
+      <p:sp>
+        <p:nvSpPr>
+          <p:cNvPr id="78" name="TextBox 77"/>
+          <p:cNvSpPr txBox="1"/>
+          <p:nvPr/>
+        </p:nvSpPr>
+        <p:spPr>
+          <a:xfrm>
+            <a:off x="8641080" y="6044183"/>
+            <a:ext cx="1371600" cy="201168"/>
+          </a:xfrm>
+          <a:prstGeom prst="rect">
+            <a:avLst/>
+          </a:prstGeom>
+          <a:noFill/>
+        </p:spPr>
+        <p:txBody>
+          <a:bodyPr wrap="square" anchor="t" lIns="0" rIns="0" tIns="0" bIns="0">
+            <a:spAutoFit/>
+          </a:bodyPr>
+          <a:lstStyle/>
+          <a:p>
+            <a:pPr algn="l"/>
+            <a:r>
+              <a:rPr sz="1050" b="0">
+                <a:solidFill>
+                  <a:srgbClr val="334155"/>
+                </a:solidFill>
+                <a:latin typeface="Open Sans"/>
+              </a:rPr>
+              <a:t>97,787</a:t>
+            </a:r>
+          </a:p>
+        </p:txBody>
+      </p:sp>
+      <p:sp>
+        <p:nvSpPr>
+          <p:cNvPr id="79" name="TextBox 78"/>
+          <p:cNvSpPr txBox="1"/>
+          <p:nvPr/>
+        </p:nvSpPr>
+        <p:spPr>
+          <a:xfrm>
+            <a:off x="10104120" y="6044183"/>
+            <a:ext cx="1371600" cy="201168"/>
+          </a:xfrm>
+          <a:prstGeom prst="rect">
+            <a:avLst/>
+          </a:prstGeom>
+          <a:noFill/>
+        </p:spPr>
+        <p:txBody>
+          <a:bodyPr wrap="square" anchor="t" lIns="0" rIns="0" tIns="0" bIns="0">
+            <a:spAutoFit/>
+          </a:bodyPr>
+          <a:lstStyle/>
+          <a:p>
+            <a:pPr algn="l"/>
+            <a:r>
+              <a:rPr sz="1050" b="1">
+                <a:solidFill>
+                  <a:srgbClr val="2863C5"/>
+                </a:solidFill>
+                <a:latin typeface="Open Sans"/>
+              </a:rPr>
+              <a:t>$173.1M</a:t>
+            </a:r>
+          </a:p>
+        </p:txBody>
+      </p:sp>
+      <p:sp>
+        <p:nvSpPr>
+          <p:cNvPr id="80" name="Rounded Rectangle 79"/>
+          <p:cNvSpPr/>
+          <p:nvPr/>
+        </p:nvSpPr>
+        <p:spPr>
+          <a:xfrm>
+            <a:off x="457200" y="6400800"/>
+            <a:ext cx="11247120" cy="411480"/>
+          </a:xfrm>
+          <a:prstGeom prst="roundRect">
+            <a:avLst>
+              <a:gd name="adj" fmla="val 7000"/>
+            </a:avLst>
           </a:prstGeom>
           <a:solidFill>
             <a:srgbClr val="2863C5"/>
@@ -11099,570 +12998,14 @@
       </p:sp>
       <p:sp>
         <p:nvSpPr>
-          <p:cNvPr id="29" name="TextBox 28"/>
-          <p:cNvSpPr txBox="1"/>
-          <p:nvPr/>
-        </p:nvSpPr>
-        <p:spPr>
-          <a:xfrm>
-            <a:off x="640080" y="4069080"/>
-            <a:ext cx="2423160" cy="201168"/>
-          </a:xfrm>
-          <a:prstGeom prst="rect">
-            <a:avLst/>
-          </a:prstGeom>
-          <a:noFill/>
-        </p:spPr>
-        <p:txBody>
-          <a:bodyPr wrap="square" anchor="t" lIns="0" rIns="0" tIns="0" bIns="0">
-            <a:spAutoFit/>
-          </a:bodyPr>
-          <a:lstStyle/>
-          <a:p>
-            <a:pPr algn="l"/>
-            <a:r>
-              <a:rPr sz="1000" b="1">
-                <a:solidFill>
-                  <a:srgbClr val="2863C5"/>
-                </a:solidFill>
-                <a:latin typeface="Open Sans"/>
-              </a:rPr>
-              <a:t>Normalize</a:t>
-            </a:r>
-          </a:p>
-        </p:txBody>
-      </p:sp>
-      <p:sp>
-        <p:nvSpPr>
-          <p:cNvPr id="30" name="TextBox 29"/>
-          <p:cNvSpPr txBox="1"/>
-          <p:nvPr/>
-        </p:nvSpPr>
-        <p:spPr>
-          <a:xfrm>
-            <a:off x="640080" y="4270248"/>
-            <a:ext cx="2423160" cy="329184"/>
-          </a:xfrm>
-          <a:prstGeom prst="rect">
-            <a:avLst/>
-          </a:prstGeom>
-          <a:noFill/>
-        </p:spPr>
-        <p:txBody>
-          <a:bodyPr wrap="square" anchor="t" lIns="0" rIns="0" tIns="0" bIns="0">
-            <a:spAutoFit/>
-          </a:bodyPr>
-          <a:lstStyle/>
-          <a:p>
-            <a:pPr algn="l"/>
-            <a:r>
-              <a:rPr sz="850" b="0">
-                <a:solidFill>
-                  <a:srgbClr val="334155"/>
-                </a:solidFill>
-                <a:latin typeface="Open Sans"/>
-              </a:rPr>
-              <a:t>UPPER(TRIM(name)). Collapse internal whitespace. Both customer and unclaimed-record names go through identical normalization.</a:t>
-            </a:r>
-          </a:p>
-        </p:txBody>
-      </p:sp>
-      <p:sp>
-        <p:nvSpPr>
-          <p:cNvPr id="31" name="Rounded Rectangle 30"/>
-          <p:cNvSpPr/>
-          <p:nvPr/>
-        </p:nvSpPr>
-        <p:spPr>
-          <a:xfrm>
-            <a:off x="3291840" y="4023360"/>
-            <a:ext cx="2697480" cy="594360"/>
-          </a:xfrm>
-          <a:prstGeom prst="roundRect">
-            <a:avLst>
-              <a:gd name="adj" fmla="val 4000"/>
-            </a:avLst>
-          </a:prstGeom>
-          <a:solidFill>
-            <a:srgbClr val="FFFFFF"/>
-          </a:solidFill>
-          <a:ln w="6350">
-            <a:solidFill>
-              <a:srgbClr val="E2E8F0"/>
-            </a:solidFill>
-          </a:ln>
-          <a:effectLst/>
-        </p:spPr>
-        <p:style>
-          <a:lnRef idx="1">
-            <a:schemeClr val="accent1"/>
-          </a:lnRef>
-          <a:fillRef idx="3">
-            <a:schemeClr val="accent1"/>
-          </a:fillRef>
-          <a:effectRef idx="2">
-            <a:schemeClr val="accent1"/>
-          </a:effectRef>
-          <a:fontRef idx="minor">
-            <a:schemeClr val="lt1"/>
-          </a:fontRef>
-        </p:style>
-        <p:txBody>
-          <a:bodyPr rtlCol="0" anchor="ctr"/>
-          <a:lstStyle/>
-          <a:p>
-            <a:pPr algn="ctr"/>
-          </a:p>
-        </p:txBody>
-      </p:sp>
-      <p:sp>
-        <p:nvSpPr>
-          <p:cNvPr id="32" name="Rectangle 31"/>
-          <p:cNvSpPr/>
-          <p:nvPr/>
-        </p:nvSpPr>
-        <p:spPr>
-          <a:xfrm>
-            <a:off x="3291840" y="4023360"/>
-            <a:ext cx="91440" cy="594360"/>
-          </a:xfrm>
-          <a:prstGeom prst="rect">
-            <a:avLst/>
-          </a:prstGeom>
-          <a:solidFill>
-            <a:srgbClr val="2863C5"/>
-          </a:solidFill>
-          <a:ln>
-            <a:noFill/>
-          </a:ln>
-          <a:effectLst/>
-        </p:spPr>
-        <p:style>
-          <a:lnRef idx="1">
-            <a:schemeClr val="accent1"/>
-          </a:lnRef>
-          <a:fillRef idx="3">
-            <a:schemeClr val="accent1"/>
-          </a:fillRef>
-          <a:effectRef idx="2">
-            <a:schemeClr val="accent1"/>
-          </a:effectRef>
-          <a:fontRef idx="minor">
-            <a:schemeClr val="lt1"/>
-          </a:fontRef>
-        </p:style>
-        <p:txBody>
-          <a:bodyPr rtlCol="0" anchor="ctr"/>
-          <a:lstStyle/>
-          <a:p>
-            <a:pPr algn="ctr"/>
-          </a:p>
-        </p:txBody>
-      </p:sp>
-      <p:sp>
-        <p:nvSpPr>
-          <p:cNvPr id="33" name="TextBox 32"/>
-          <p:cNvSpPr txBox="1"/>
-          <p:nvPr/>
-        </p:nvSpPr>
-        <p:spPr>
-          <a:xfrm>
-            <a:off x="3474720" y="4069080"/>
-            <a:ext cx="2423160" cy="201168"/>
-          </a:xfrm>
-          <a:prstGeom prst="rect">
-            <a:avLst/>
-          </a:prstGeom>
-          <a:noFill/>
-        </p:spPr>
-        <p:txBody>
-          <a:bodyPr wrap="square" anchor="t" lIns="0" rIns="0" tIns="0" bIns="0">
-            <a:spAutoFit/>
-          </a:bodyPr>
-          <a:lstStyle/>
-          <a:p>
-            <a:pPr algn="l"/>
-            <a:r>
-              <a:rPr sz="1000" b="1">
-                <a:solidFill>
-                  <a:srgbClr val="2863C5"/>
-                </a:solidFill>
-                <a:latin typeface="Open Sans"/>
-              </a:rPr>
-              <a:t>Build key</a:t>
-            </a:r>
-          </a:p>
-        </p:txBody>
-      </p:sp>
-      <p:sp>
-        <p:nvSpPr>
-          <p:cNvPr id="34" name="TextBox 33"/>
-          <p:cNvSpPr txBox="1"/>
-          <p:nvPr/>
-        </p:nvSpPr>
-        <p:spPr>
-          <a:xfrm>
-            <a:off x="3474720" y="4270248"/>
-            <a:ext cx="2423160" cy="329184"/>
-          </a:xfrm>
-          <a:prstGeom prst="rect">
-            <a:avLst/>
-          </a:prstGeom>
-          <a:noFill/>
-        </p:spPr>
-        <p:txBody>
-          <a:bodyPr wrap="square" anchor="t" lIns="0" rIns="0" tIns="0" bIns="0">
-            <a:spAutoFit/>
-          </a:bodyPr>
-          <a:lstStyle/>
-          <a:p>
-            <a:pPr algn="l"/>
-            <a:r>
-              <a:rPr sz="850" b="0">
-                <a:solidFill>
-                  <a:srgbClr val="334155"/>
-                </a:solidFill>
-                <a:latin typeface="Open Sans"/>
-              </a:rPr>
-              <a:t>Per customer: "FIRST LAST" and "LAST FIRST". Both orderings tried — CA records use both styles.</a:t>
-            </a:r>
-          </a:p>
-        </p:txBody>
-      </p:sp>
-      <p:sp>
-        <p:nvSpPr>
-          <p:cNvPr id="35" name="Rounded Rectangle 34"/>
-          <p:cNvSpPr/>
-          <p:nvPr/>
-        </p:nvSpPr>
-        <p:spPr>
-          <a:xfrm>
-            <a:off x="6126480" y="4023360"/>
-            <a:ext cx="2697480" cy="594360"/>
-          </a:xfrm>
-          <a:prstGeom prst="roundRect">
-            <a:avLst>
-              <a:gd name="adj" fmla="val 4000"/>
-            </a:avLst>
-          </a:prstGeom>
-          <a:solidFill>
-            <a:srgbClr val="FFFFFF"/>
-          </a:solidFill>
-          <a:ln w="6350">
-            <a:solidFill>
-              <a:srgbClr val="E2E8F0"/>
-            </a:solidFill>
-          </a:ln>
-          <a:effectLst/>
-        </p:spPr>
-        <p:style>
-          <a:lnRef idx="1">
-            <a:schemeClr val="accent1"/>
-          </a:lnRef>
-          <a:fillRef idx="3">
-            <a:schemeClr val="accent1"/>
-          </a:fillRef>
-          <a:effectRef idx="2">
-            <a:schemeClr val="accent1"/>
-          </a:effectRef>
-          <a:fontRef idx="minor">
-            <a:schemeClr val="lt1"/>
-          </a:fontRef>
-        </p:style>
-        <p:txBody>
-          <a:bodyPr rtlCol="0" anchor="ctr"/>
-          <a:lstStyle/>
-          <a:p>
-            <a:pPr algn="ctr"/>
-          </a:p>
-        </p:txBody>
-      </p:sp>
-      <p:sp>
-        <p:nvSpPr>
-          <p:cNvPr id="36" name="Rectangle 35"/>
-          <p:cNvSpPr/>
-          <p:nvPr/>
-        </p:nvSpPr>
-        <p:spPr>
-          <a:xfrm>
-            <a:off x="6126480" y="4023360"/>
-            <a:ext cx="91440" cy="594360"/>
-          </a:xfrm>
-          <a:prstGeom prst="rect">
-            <a:avLst/>
-          </a:prstGeom>
-          <a:solidFill>
-            <a:srgbClr val="059669"/>
-          </a:solidFill>
-          <a:ln>
-            <a:noFill/>
-          </a:ln>
-          <a:effectLst/>
-        </p:spPr>
-        <p:style>
-          <a:lnRef idx="1">
-            <a:schemeClr val="accent1"/>
-          </a:lnRef>
-          <a:fillRef idx="3">
-            <a:schemeClr val="accent1"/>
-          </a:fillRef>
-          <a:effectRef idx="2">
-            <a:schemeClr val="accent1"/>
-          </a:effectRef>
-          <a:fontRef idx="minor">
-            <a:schemeClr val="lt1"/>
-          </a:fontRef>
-        </p:style>
-        <p:txBody>
-          <a:bodyPr rtlCol="0" anchor="ctr"/>
-          <a:lstStyle/>
-          <a:p>
-            <a:pPr algn="ctr"/>
-          </a:p>
-        </p:txBody>
-      </p:sp>
-      <p:sp>
-        <p:nvSpPr>
-          <p:cNvPr id="37" name="TextBox 36"/>
-          <p:cNvSpPr txBox="1"/>
-          <p:nvPr/>
-        </p:nvSpPr>
-        <p:spPr>
-          <a:xfrm>
-            <a:off x="6309360" y="4069080"/>
-            <a:ext cx="2423160" cy="201168"/>
-          </a:xfrm>
-          <a:prstGeom prst="rect">
-            <a:avLst/>
-          </a:prstGeom>
-          <a:noFill/>
-        </p:spPr>
-        <p:txBody>
-          <a:bodyPr wrap="square" anchor="t" lIns="0" rIns="0" tIns="0" bIns="0">
-            <a:spAutoFit/>
-          </a:bodyPr>
-          <a:lstStyle/>
-          <a:p>
-            <a:pPr algn="l"/>
-            <a:r>
-              <a:rPr sz="1000" b="1">
-                <a:solidFill>
-                  <a:srgbClr val="059669"/>
-                </a:solidFill>
-                <a:latin typeface="Open Sans"/>
-              </a:rPr>
-              <a:t>Equality join</a:t>
-            </a:r>
-          </a:p>
-        </p:txBody>
-      </p:sp>
-      <p:sp>
-        <p:nvSpPr>
-          <p:cNvPr id="38" name="TextBox 37"/>
-          <p:cNvSpPr txBox="1"/>
-          <p:nvPr/>
-        </p:nvSpPr>
-        <p:spPr>
-          <a:xfrm>
-            <a:off x="6309360" y="4270248"/>
-            <a:ext cx="2423160" cy="329184"/>
-          </a:xfrm>
-          <a:prstGeom prst="rect">
-            <a:avLst/>
-          </a:prstGeom>
-          <a:noFill/>
-        </p:spPr>
-        <p:txBody>
-          <a:bodyPr wrap="square" anchor="t" lIns="0" rIns="0" tIns="0" bIns="0">
-            <a:spAutoFit/>
-          </a:bodyPr>
-          <a:lstStyle/>
-          <a:p>
-            <a:pPr algn="l"/>
-            <a:r>
-              <a:rPr sz="850" b="0">
-                <a:solidFill>
-                  <a:srgbClr val="334155"/>
-                </a:solidFill>
-                <a:latin typeface="Open Sans"/>
-              </a:rPr>
-              <a:t>owner_name_normalized = key. Uses ix_owner_normalized — 0.7s for 30,862 × 92.4M rows.</a:t>
-            </a:r>
-          </a:p>
-        </p:txBody>
-      </p:sp>
-      <p:sp>
-        <p:nvSpPr>
-          <p:cNvPr id="39" name="Rounded Rectangle 38"/>
-          <p:cNvSpPr/>
-          <p:nvPr/>
-        </p:nvSpPr>
-        <p:spPr>
-          <a:xfrm>
-            <a:off x="8961120" y="4023360"/>
-            <a:ext cx="2697480" cy="594360"/>
-          </a:xfrm>
-          <a:prstGeom prst="roundRect">
-            <a:avLst>
-              <a:gd name="adj" fmla="val 4000"/>
-            </a:avLst>
-          </a:prstGeom>
-          <a:solidFill>
-            <a:srgbClr val="FFFFFF"/>
-          </a:solidFill>
-          <a:ln w="6350">
-            <a:solidFill>
-              <a:srgbClr val="E2E8F0"/>
-            </a:solidFill>
-          </a:ln>
-          <a:effectLst/>
-        </p:spPr>
-        <p:style>
-          <a:lnRef idx="1">
-            <a:schemeClr val="accent1"/>
-          </a:lnRef>
-          <a:fillRef idx="3">
-            <a:schemeClr val="accent1"/>
-          </a:fillRef>
-          <a:effectRef idx="2">
-            <a:schemeClr val="accent1"/>
-          </a:effectRef>
-          <a:fontRef idx="minor">
-            <a:schemeClr val="lt1"/>
-          </a:fontRef>
-        </p:style>
-        <p:txBody>
-          <a:bodyPr rtlCol="0" anchor="ctr"/>
-          <a:lstStyle/>
-          <a:p>
-            <a:pPr algn="ctr"/>
-          </a:p>
-        </p:txBody>
-      </p:sp>
-      <p:sp>
-        <p:nvSpPr>
-          <p:cNvPr id="40" name="Rectangle 39"/>
-          <p:cNvSpPr/>
-          <p:nvPr/>
-        </p:nvSpPr>
-        <p:spPr>
-          <a:xfrm>
-            <a:off x="8961120" y="4023360"/>
-            <a:ext cx="91440" cy="594360"/>
-          </a:xfrm>
-          <a:prstGeom prst="rect">
-            <a:avLst/>
-          </a:prstGeom>
-          <a:solidFill>
-            <a:srgbClr val="FC4C0B"/>
-          </a:solidFill>
-          <a:ln>
-            <a:noFill/>
-          </a:ln>
-          <a:effectLst/>
-        </p:spPr>
-        <p:style>
-          <a:lnRef idx="1">
-            <a:schemeClr val="accent1"/>
-          </a:lnRef>
-          <a:fillRef idx="3">
-            <a:schemeClr val="accent1"/>
-          </a:fillRef>
-          <a:effectRef idx="2">
-            <a:schemeClr val="accent1"/>
-          </a:effectRef>
-          <a:fontRef idx="minor">
-            <a:schemeClr val="lt1"/>
-          </a:fontRef>
-        </p:style>
-        <p:txBody>
-          <a:bodyPr rtlCol="0" anchor="ctr"/>
-          <a:lstStyle/>
-          <a:p>
-            <a:pPr algn="ctr"/>
-          </a:p>
-        </p:txBody>
-      </p:sp>
-      <p:sp>
-        <p:nvSpPr>
-          <p:cNvPr id="41" name="TextBox 40"/>
-          <p:cNvSpPr txBox="1"/>
-          <p:nvPr/>
-        </p:nvSpPr>
-        <p:spPr>
-          <a:xfrm>
-            <a:off x="9144000" y="4069080"/>
-            <a:ext cx="2423160" cy="201168"/>
-          </a:xfrm>
-          <a:prstGeom prst="rect">
-            <a:avLst/>
-          </a:prstGeom>
-          <a:noFill/>
-        </p:spPr>
-        <p:txBody>
-          <a:bodyPr wrap="square" anchor="t" lIns="0" rIns="0" tIns="0" bIns="0">
-            <a:spAutoFit/>
-          </a:bodyPr>
-          <a:lstStyle/>
-          <a:p>
-            <a:pPr algn="l"/>
-            <a:r>
-              <a:rPr sz="1000" b="1">
-                <a:solidFill>
-                  <a:srgbClr val="FC4C0B"/>
-                </a:solidFill>
-                <a:latin typeface="Open Sans"/>
-              </a:rPr>
-              <a:t>Production adds</a:t>
-            </a:r>
-          </a:p>
-        </p:txBody>
-      </p:sp>
-      <p:sp>
-        <p:nvSpPr>
-          <p:cNvPr id="42" name="TextBox 41"/>
-          <p:cNvSpPr txBox="1"/>
-          <p:nvPr/>
-        </p:nvSpPr>
-        <p:spPr>
-          <a:xfrm>
-            <a:off x="9144000" y="4270248"/>
-            <a:ext cx="2423160" cy="329184"/>
-          </a:xfrm>
-          <a:prstGeom prst="rect">
-            <a:avLst/>
-          </a:prstGeom>
-          <a:noFill/>
-        </p:spPr>
-        <p:txBody>
-          <a:bodyPr wrap="square" anchor="t" lIns="0" rIns="0" tIns="0" bIns="0">
-            <a:spAutoFit/>
-          </a:bodyPr>
-          <a:lstStyle/>
-          <a:p>
-            <a:pPr algn="l"/>
-            <a:r>
-              <a:rPr sz="850" b="0">
-                <a:solidFill>
-                  <a:srgbClr val="334155"/>
-                </a:solidFill>
-                <a:latin typeface="Open Sans"/>
-              </a:rPr>
-              <a:t>Phonetic (Soundex/Metaphone) · middle-name · last-4 SSN · DOB. Cuts false positives ~5×.</a:t>
-            </a:r>
-          </a:p>
-        </p:txBody>
-      </p:sp>
-      <p:sp>
-        <p:nvSpPr>
-          <p:cNvPr id="43" name="TextBox 42"/>
-          <p:cNvSpPr txBox="1"/>
-          <p:nvPr/>
-        </p:nvSpPr>
-        <p:spPr>
-          <a:xfrm>
-            <a:off x="457200" y="4754880"/>
-            <a:ext cx="5486400" cy="292608"/>
+          <p:cNvPr id="81" name="TextBox 80"/>
+          <p:cNvSpPr txBox="1"/>
+          <p:nvPr/>
+        </p:nvSpPr>
+        <p:spPr>
+          <a:xfrm>
+            <a:off x="640080" y="6446520"/>
+            <a:ext cx="10972800" cy="292608"/>
           </a:xfrm>
           <a:prstGeom prst="rect">
             <a:avLst/>
@@ -11679,2037 +13022,11 @@
             <a:r>
               <a:rPr sz="1100" b="1">
                 <a:solidFill>
-                  <a:srgbClr val="2863C5"/>
-                </a:solidFill>
-                <a:latin typeface="Open Sans"/>
-              </a:rPr>
-              <a:t>MATCH DISTRIBUTION</a:t>
-            </a:r>
-          </a:p>
-        </p:txBody>
-      </p:sp>
-      <p:sp>
-        <p:nvSpPr>
-          <p:cNvPr id="44" name="TextBox 43"/>
-          <p:cNvSpPr txBox="1"/>
-          <p:nvPr/>
-        </p:nvSpPr>
-        <p:spPr>
-          <a:xfrm>
-            <a:off x="457200" y="5029200"/>
-            <a:ext cx="5486400" cy="256032"/>
-          </a:xfrm>
-          <a:prstGeom prst="rect">
-            <a:avLst/>
-          </a:prstGeom>
-          <a:noFill/>
-        </p:spPr>
-        <p:txBody>
-          <a:bodyPr wrap="square" anchor="t" lIns="0" rIns="0" tIns="0" bIns="0">
-            <a:spAutoFit/>
-          </a:bodyPr>
-          <a:lstStyle/>
-          <a:p>
-            <a:pPr algn="l"/>
-            <a:r>
-              <a:rPr sz="1000" b="0">
-                <a:solidFill>
-                  <a:srgbClr val="64748B"/>
-                </a:solidFill>
-                <a:latin typeface="Open Sans"/>
-              </a:rPr>
-              <a:t>Distinct names cluster in the 1–5 record bucket — high-confidence matches.</a:t>
-            </a:r>
-          </a:p>
-        </p:txBody>
-      </p:sp>
-      <p:sp>
-        <p:nvSpPr>
-          <p:cNvPr id="45" name="Rectangle 44"/>
-          <p:cNvSpPr/>
-          <p:nvPr/>
-        </p:nvSpPr>
-        <p:spPr>
-          <a:xfrm>
-            <a:off x="457200" y="5349240"/>
-            <a:ext cx="5486400" cy="219456"/>
-          </a:xfrm>
-          <a:prstGeom prst="rect">
-            <a:avLst/>
-          </a:prstGeom>
-          <a:solidFill>
-            <a:srgbClr val="0F172A"/>
-          </a:solidFill>
-          <a:ln>
-            <a:noFill/>
-          </a:ln>
-          <a:effectLst/>
-        </p:spPr>
-        <p:style>
-          <a:lnRef idx="1">
-            <a:schemeClr val="accent1"/>
-          </a:lnRef>
-          <a:fillRef idx="3">
-            <a:schemeClr val="accent1"/>
-          </a:fillRef>
-          <a:effectRef idx="2">
-            <a:schemeClr val="accent1"/>
-          </a:effectRef>
-          <a:fontRef idx="minor">
-            <a:schemeClr val="lt1"/>
-          </a:fontRef>
-        </p:style>
-        <p:txBody>
-          <a:bodyPr rtlCol="0" anchor="ctr"/>
-          <a:lstStyle/>
-          <a:p>
-            <a:pPr algn="ctr"/>
-          </a:p>
-        </p:txBody>
-      </p:sp>
-      <p:sp>
-        <p:nvSpPr>
-          <p:cNvPr id="46" name="TextBox 45"/>
-          <p:cNvSpPr txBox="1"/>
-          <p:nvPr/>
-        </p:nvSpPr>
-        <p:spPr>
-          <a:xfrm>
-            <a:off x="548640" y="5385816"/>
-            <a:ext cx="1554480" cy="164592"/>
-          </a:xfrm>
-          <a:prstGeom prst="rect">
-            <a:avLst/>
-          </a:prstGeom>
-          <a:noFill/>
-        </p:spPr>
-        <p:txBody>
-          <a:bodyPr wrap="square" anchor="t" lIns="0" rIns="0" tIns="0" bIns="0">
-            <a:spAutoFit/>
-          </a:bodyPr>
-          <a:lstStyle/>
-          <a:p>
-            <a:pPr algn="l"/>
-            <a:r>
-              <a:rPr sz="900" b="1">
-                <a:solidFill>
                   <a:srgbClr val="FFFFFF"/>
                 </a:solidFill>
                 <a:latin typeface="Open Sans"/>
               </a:rPr>
-              <a:t>Bucket</a:t>
-            </a:r>
-          </a:p>
-        </p:txBody>
-      </p:sp>
-      <p:sp>
-        <p:nvSpPr>
-          <p:cNvPr id="47" name="TextBox 46"/>
-          <p:cNvSpPr txBox="1"/>
-          <p:nvPr/>
-        </p:nvSpPr>
-        <p:spPr>
-          <a:xfrm>
-            <a:off x="2194560" y="5385816"/>
-            <a:ext cx="914400" cy="164592"/>
-          </a:xfrm>
-          <a:prstGeom prst="rect">
-            <a:avLst/>
-          </a:prstGeom>
-          <a:noFill/>
-        </p:spPr>
-        <p:txBody>
-          <a:bodyPr wrap="square" anchor="t" lIns="0" rIns="0" tIns="0" bIns="0">
-            <a:spAutoFit/>
-          </a:bodyPr>
-          <a:lstStyle/>
-          <a:p>
-            <a:pPr algn="l"/>
-            <a:r>
-              <a:rPr sz="900" b="1">
-                <a:solidFill>
-                  <a:srgbClr val="FFFFFF"/>
-                </a:solidFill>
-                <a:latin typeface="Open Sans"/>
-              </a:rPr>
-              <a:t>Customers</a:t>
-            </a:r>
-          </a:p>
-        </p:txBody>
-      </p:sp>
-      <p:sp>
-        <p:nvSpPr>
-          <p:cNvPr id="48" name="TextBox 47"/>
-          <p:cNvSpPr txBox="1"/>
-          <p:nvPr/>
-        </p:nvSpPr>
-        <p:spPr>
-          <a:xfrm>
-            <a:off x="3246120" y="5385816"/>
-            <a:ext cx="914400" cy="164592"/>
-          </a:xfrm>
-          <a:prstGeom prst="rect">
-            <a:avLst/>
-          </a:prstGeom>
-          <a:noFill/>
-        </p:spPr>
-        <p:txBody>
-          <a:bodyPr wrap="square" anchor="t" lIns="0" rIns="0" tIns="0" bIns="0">
-            <a:spAutoFit/>
-          </a:bodyPr>
-          <a:lstStyle/>
-          <a:p>
-            <a:pPr algn="l"/>
-            <a:r>
-              <a:rPr sz="900" b="1">
-                <a:solidFill>
-                  <a:srgbClr val="FFFFFF"/>
-                </a:solidFill>
-                <a:latin typeface="Open Sans"/>
-              </a:rPr>
-              <a:t>$ value</a:t>
-            </a:r>
-          </a:p>
-        </p:txBody>
-      </p:sp>
-      <p:sp>
-        <p:nvSpPr>
-          <p:cNvPr id="49" name="TextBox 48"/>
-          <p:cNvSpPr txBox="1"/>
-          <p:nvPr/>
-        </p:nvSpPr>
-        <p:spPr>
-          <a:xfrm>
-            <a:off x="4297680" y="5385816"/>
-            <a:ext cx="1554480" cy="164592"/>
-          </a:xfrm>
-          <a:prstGeom prst="rect">
-            <a:avLst/>
-          </a:prstGeom>
-          <a:noFill/>
-        </p:spPr>
-        <p:txBody>
-          <a:bodyPr wrap="square" anchor="t" lIns="0" rIns="0" tIns="0" bIns="0">
-            <a:spAutoFit/>
-          </a:bodyPr>
-          <a:lstStyle/>
-          <a:p>
-            <a:pPr algn="l"/>
-            <a:r>
-              <a:rPr sz="900" b="1">
-                <a:solidFill>
-                  <a:srgbClr val="FFFFFF"/>
-                </a:solidFill>
-                <a:latin typeface="Open Sans"/>
-              </a:rPr>
-              <a:t>Note</a:t>
-            </a:r>
-          </a:p>
-        </p:txBody>
-      </p:sp>
-      <p:sp>
-        <p:nvSpPr>
-          <p:cNvPr id="50" name="Rectangle 49"/>
-          <p:cNvSpPr/>
-          <p:nvPr/>
-        </p:nvSpPr>
-        <p:spPr>
-          <a:xfrm>
-            <a:off x="457200" y="5568696"/>
-            <a:ext cx="5486400" cy="246888"/>
-          </a:xfrm>
-          <a:prstGeom prst="rect">
-            <a:avLst/>
-          </a:prstGeom>
-          <a:solidFill>
-            <a:srgbClr val="F8FAFC"/>
-          </a:solidFill>
-          <a:ln>
-            <a:noFill/>
-          </a:ln>
-          <a:effectLst/>
-        </p:spPr>
-        <p:style>
-          <a:lnRef idx="1">
-            <a:schemeClr val="accent1"/>
-          </a:lnRef>
-          <a:fillRef idx="3">
-            <a:schemeClr val="accent1"/>
-          </a:fillRef>
-          <a:effectRef idx="2">
-            <a:schemeClr val="accent1"/>
-          </a:effectRef>
-          <a:fontRef idx="minor">
-            <a:schemeClr val="lt1"/>
-          </a:fontRef>
-        </p:style>
-        <p:txBody>
-          <a:bodyPr rtlCol="0" anchor="ctr"/>
-          <a:lstStyle/>
-          <a:p>
-            <a:pPr algn="ctr"/>
-          </a:p>
-        </p:txBody>
-      </p:sp>
-      <p:sp>
-        <p:nvSpPr>
-          <p:cNvPr id="51" name="TextBox 50"/>
-          <p:cNvSpPr txBox="1"/>
-          <p:nvPr/>
-        </p:nvSpPr>
-        <p:spPr>
-          <a:xfrm>
-            <a:off x="548640" y="5605272"/>
-            <a:ext cx="1554480" cy="182880"/>
-          </a:xfrm>
-          <a:prstGeom prst="rect">
-            <a:avLst/>
-          </a:prstGeom>
-          <a:noFill/>
-        </p:spPr>
-        <p:txBody>
-          <a:bodyPr wrap="square" anchor="t" lIns="0" rIns="0" tIns="0" bIns="0">
-            <a:spAutoFit/>
-          </a:bodyPr>
-          <a:lstStyle/>
-          <a:p>
-            <a:pPr algn="l"/>
-            <a:r>
-              <a:rPr sz="1000" b="1">
-                <a:solidFill>
-                  <a:srgbClr val="0F172A"/>
-                </a:solidFill>
-                <a:latin typeface="Open Sans"/>
-              </a:rPr>
-              <a:t>1 record</a:t>
-            </a:r>
-          </a:p>
-        </p:txBody>
-      </p:sp>
-      <p:sp>
-        <p:nvSpPr>
-          <p:cNvPr id="52" name="TextBox 51"/>
-          <p:cNvSpPr txBox="1"/>
-          <p:nvPr/>
-        </p:nvSpPr>
-        <p:spPr>
-          <a:xfrm>
-            <a:off x="2194560" y="5605272"/>
-            <a:ext cx="914400" cy="182880"/>
-          </a:xfrm>
-          <a:prstGeom prst="rect">
-            <a:avLst/>
-          </a:prstGeom>
-          <a:noFill/>
-        </p:spPr>
-        <p:txBody>
-          <a:bodyPr wrap="square" anchor="t" lIns="0" rIns="0" tIns="0" bIns="0">
-            <a:spAutoFit/>
-          </a:bodyPr>
-          <a:lstStyle/>
-          <a:p>
-            <a:pPr algn="l"/>
-            <a:r>
-              <a:rPr sz="1000" b="0">
-                <a:solidFill>
-                  <a:srgbClr val="334155"/>
-                </a:solidFill>
-                <a:latin typeface="Open Sans"/>
-              </a:rPr>
-              <a:t>3,266</a:t>
-            </a:r>
-          </a:p>
-        </p:txBody>
-      </p:sp>
-      <p:sp>
-        <p:nvSpPr>
-          <p:cNvPr id="53" name="TextBox 52"/>
-          <p:cNvSpPr txBox="1"/>
-          <p:nvPr/>
-        </p:nvSpPr>
-        <p:spPr>
-          <a:xfrm>
-            <a:off x="3246120" y="5605272"/>
-            <a:ext cx="914400" cy="182880"/>
-          </a:xfrm>
-          <a:prstGeom prst="rect">
-            <a:avLst/>
-          </a:prstGeom>
-          <a:noFill/>
-        </p:spPr>
-        <p:txBody>
-          <a:bodyPr wrap="square" anchor="t" lIns="0" rIns="0" tIns="0" bIns="0">
-            <a:spAutoFit/>
-          </a:bodyPr>
-          <a:lstStyle/>
-          <a:p>
-            <a:pPr algn="l"/>
-            <a:r>
-              <a:rPr sz="1000" b="1">
-                <a:solidFill>
-                  <a:srgbClr val="059669"/>
-                </a:solidFill>
-                <a:latin typeface="Open Sans"/>
-              </a:rPr>
-              <a:t>$239K</a:t>
-            </a:r>
-          </a:p>
-        </p:txBody>
-      </p:sp>
-      <p:sp>
-        <p:nvSpPr>
-          <p:cNvPr id="54" name="TextBox 53"/>
-          <p:cNvSpPr txBox="1"/>
-          <p:nvPr/>
-        </p:nvSpPr>
-        <p:spPr>
-          <a:xfrm>
-            <a:off x="4297680" y="5605272"/>
-            <a:ext cx="1554480" cy="182880"/>
-          </a:xfrm>
-          <a:prstGeom prst="rect">
-            <a:avLst/>
-          </a:prstGeom>
-          <a:noFill/>
-        </p:spPr>
-        <p:txBody>
-          <a:bodyPr wrap="square" anchor="t" lIns="0" rIns="0" tIns="0" bIns="0">
-            <a:spAutoFit/>
-          </a:bodyPr>
-          <a:lstStyle/>
-          <a:p>
-            <a:pPr algn="l"/>
-            <a:r>
-              <a:rPr sz="900" b="0">
-                <a:solidFill>
-                  <a:srgbClr val="64748B"/>
-                </a:solidFill>
-                <a:latin typeface="Open Sans"/>
-              </a:rPr>
-              <a:t>High confidence</a:t>
-            </a:r>
-          </a:p>
-        </p:txBody>
-      </p:sp>
-      <p:sp>
-        <p:nvSpPr>
-          <p:cNvPr id="55" name="Rectangle 54"/>
-          <p:cNvSpPr/>
-          <p:nvPr/>
-        </p:nvSpPr>
-        <p:spPr>
-          <a:xfrm>
-            <a:off x="457200" y="5815583"/>
-            <a:ext cx="5486400" cy="246888"/>
-          </a:xfrm>
-          <a:prstGeom prst="rect">
-            <a:avLst/>
-          </a:prstGeom>
-          <a:solidFill>
-            <a:srgbClr val="FFFFFF"/>
-          </a:solidFill>
-          <a:ln>
-            <a:noFill/>
-          </a:ln>
-          <a:effectLst/>
-        </p:spPr>
-        <p:style>
-          <a:lnRef idx="1">
-            <a:schemeClr val="accent1"/>
-          </a:lnRef>
-          <a:fillRef idx="3">
-            <a:schemeClr val="accent1"/>
-          </a:fillRef>
-          <a:effectRef idx="2">
-            <a:schemeClr val="accent1"/>
-          </a:effectRef>
-          <a:fontRef idx="minor">
-            <a:schemeClr val="lt1"/>
-          </a:fontRef>
-        </p:style>
-        <p:txBody>
-          <a:bodyPr rtlCol="0" anchor="ctr"/>
-          <a:lstStyle/>
-          <a:p>
-            <a:pPr algn="ctr"/>
-          </a:p>
-        </p:txBody>
-      </p:sp>
-      <p:sp>
-        <p:nvSpPr>
-          <p:cNvPr id="56" name="TextBox 55"/>
-          <p:cNvSpPr txBox="1"/>
-          <p:nvPr/>
-        </p:nvSpPr>
-        <p:spPr>
-          <a:xfrm>
-            <a:off x="548640" y="5852159"/>
-            <a:ext cx="1554480" cy="182880"/>
-          </a:xfrm>
-          <a:prstGeom prst="rect">
-            <a:avLst/>
-          </a:prstGeom>
-          <a:noFill/>
-        </p:spPr>
-        <p:txBody>
-          <a:bodyPr wrap="square" anchor="t" lIns="0" rIns="0" tIns="0" bIns="0">
-            <a:spAutoFit/>
-          </a:bodyPr>
-          <a:lstStyle/>
-          <a:p>
-            <a:pPr algn="l"/>
-            <a:r>
-              <a:rPr sz="1000" b="1">
-                <a:solidFill>
-                  <a:srgbClr val="0F172A"/>
-                </a:solidFill>
-                <a:latin typeface="Open Sans"/>
-              </a:rPr>
-              <a:t>2–5 records</a:t>
-            </a:r>
-          </a:p>
-        </p:txBody>
-      </p:sp>
-      <p:sp>
-        <p:nvSpPr>
-          <p:cNvPr id="57" name="TextBox 56"/>
-          <p:cNvSpPr txBox="1"/>
-          <p:nvPr/>
-        </p:nvSpPr>
-        <p:spPr>
-          <a:xfrm>
-            <a:off x="2194560" y="5852159"/>
-            <a:ext cx="914400" cy="182880"/>
-          </a:xfrm>
-          <a:prstGeom prst="rect">
-            <a:avLst/>
-          </a:prstGeom>
-          <a:noFill/>
-        </p:spPr>
-        <p:txBody>
-          <a:bodyPr wrap="square" anchor="t" lIns="0" rIns="0" tIns="0" bIns="0">
-            <a:spAutoFit/>
-          </a:bodyPr>
-          <a:lstStyle/>
-          <a:p>
-            <a:pPr algn="l"/>
-            <a:r>
-              <a:rPr sz="1000" b="0">
-                <a:solidFill>
-                  <a:srgbClr val="334155"/>
-                </a:solidFill>
-                <a:latin typeface="Open Sans"/>
-              </a:rPr>
-              <a:t>5,788</a:t>
-            </a:r>
-          </a:p>
-        </p:txBody>
-      </p:sp>
-      <p:sp>
-        <p:nvSpPr>
-          <p:cNvPr id="58" name="TextBox 57"/>
-          <p:cNvSpPr txBox="1"/>
-          <p:nvPr/>
-        </p:nvSpPr>
-        <p:spPr>
-          <a:xfrm>
-            <a:off x="3246120" y="5852159"/>
-            <a:ext cx="914400" cy="182880"/>
-          </a:xfrm>
-          <a:prstGeom prst="rect">
-            <a:avLst/>
-          </a:prstGeom>
-          <a:noFill/>
-        </p:spPr>
-        <p:txBody>
-          <a:bodyPr wrap="square" anchor="t" lIns="0" rIns="0" tIns="0" bIns="0">
-            <a:spAutoFit/>
-          </a:bodyPr>
-          <a:lstStyle/>
-          <a:p>
-            <a:pPr algn="l"/>
-            <a:r>
-              <a:rPr sz="1000" b="1">
-                <a:solidFill>
-                  <a:srgbClr val="059669"/>
-                </a:solidFill>
-                <a:latin typeface="Open Sans"/>
-              </a:rPr>
-              <a:t>$1.21M</a:t>
-            </a:r>
-          </a:p>
-        </p:txBody>
-      </p:sp>
-      <p:sp>
-        <p:nvSpPr>
-          <p:cNvPr id="59" name="TextBox 58"/>
-          <p:cNvSpPr txBox="1"/>
-          <p:nvPr/>
-        </p:nvSpPr>
-        <p:spPr>
-          <a:xfrm>
-            <a:off x="4297680" y="5852159"/>
-            <a:ext cx="1554480" cy="182880"/>
-          </a:xfrm>
-          <a:prstGeom prst="rect">
-            <a:avLst/>
-          </a:prstGeom>
-          <a:noFill/>
-        </p:spPr>
-        <p:txBody>
-          <a:bodyPr wrap="square" anchor="t" lIns="0" rIns="0" tIns="0" bIns="0">
-            <a:spAutoFit/>
-          </a:bodyPr>
-          <a:lstStyle/>
-          <a:p>
-            <a:pPr algn="l"/>
-            <a:r>
-              <a:rPr sz="900" b="0">
-                <a:solidFill>
-                  <a:srgbClr val="64748B"/>
-                </a:solidFill>
-                <a:latin typeface="Open Sans"/>
-              </a:rPr>
-              <a:t>High confidence</a:t>
-            </a:r>
-          </a:p>
-        </p:txBody>
-      </p:sp>
-      <p:sp>
-        <p:nvSpPr>
-          <p:cNvPr id="60" name="Rectangle 59"/>
-          <p:cNvSpPr/>
-          <p:nvPr/>
-        </p:nvSpPr>
-        <p:spPr>
-          <a:xfrm>
-            <a:off x="457200" y="6062471"/>
-            <a:ext cx="5486400" cy="246888"/>
-          </a:xfrm>
-          <a:prstGeom prst="rect">
-            <a:avLst/>
-          </a:prstGeom>
-          <a:solidFill>
-            <a:srgbClr val="F8FAFC"/>
-          </a:solidFill>
-          <a:ln>
-            <a:noFill/>
-          </a:ln>
-          <a:effectLst/>
-        </p:spPr>
-        <p:style>
-          <a:lnRef idx="1">
-            <a:schemeClr val="accent1"/>
-          </a:lnRef>
-          <a:fillRef idx="3">
-            <a:schemeClr val="accent1"/>
-          </a:fillRef>
-          <a:effectRef idx="2">
-            <a:schemeClr val="accent1"/>
-          </a:effectRef>
-          <a:fontRef idx="minor">
-            <a:schemeClr val="lt1"/>
-          </a:fontRef>
-        </p:style>
-        <p:txBody>
-          <a:bodyPr rtlCol="0" anchor="ctr"/>
-          <a:lstStyle/>
-          <a:p>
-            <a:pPr algn="ctr"/>
-          </a:p>
-        </p:txBody>
-      </p:sp>
-      <p:sp>
-        <p:nvSpPr>
-          <p:cNvPr id="61" name="TextBox 60"/>
-          <p:cNvSpPr txBox="1"/>
-          <p:nvPr/>
-        </p:nvSpPr>
-        <p:spPr>
-          <a:xfrm>
-            <a:off x="548640" y="6099047"/>
-            <a:ext cx="1554480" cy="182880"/>
-          </a:xfrm>
-          <a:prstGeom prst="rect">
-            <a:avLst/>
-          </a:prstGeom>
-          <a:noFill/>
-        </p:spPr>
-        <p:txBody>
-          <a:bodyPr wrap="square" anchor="t" lIns="0" rIns="0" tIns="0" bIns="0">
-            <a:spAutoFit/>
-          </a:bodyPr>
-          <a:lstStyle/>
-          <a:p>
-            <a:pPr algn="l"/>
-            <a:r>
-              <a:rPr sz="1000" b="1">
-                <a:solidFill>
-                  <a:srgbClr val="0F172A"/>
-                </a:solidFill>
-                <a:latin typeface="Open Sans"/>
-              </a:rPr>
-              <a:t>6–20 records</a:t>
-            </a:r>
-          </a:p>
-        </p:txBody>
-      </p:sp>
-      <p:sp>
-        <p:nvSpPr>
-          <p:cNvPr id="62" name="TextBox 61"/>
-          <p:cNvSpPr txBox="1"/>
-          <p:nvPr/>
-        </p:nvSpPr>
-        <p:spPr>
-          <a:xfrm>
-            <a:off x="2194560" y="6099047"/>
-            <a:ext cx="914400" cy="182880"/>
-          </a:xfrm>
-          <a:prstGeom prst="rect">
-            <a:avLst/>
-          </a:prstGeom>
-          <a:noFill/>
-        </p:spPr>
-        <p:txBody>
-          <a:bodyPr wrap="square" anchor="t" lIns="0" rIns="0" tIns="0" bIns="0">
-            <a:spAutoFit/>
-          </a:bodyPr>
-          <a:lstStyle/>
-          <a:p>
-            <a:pPr algn="l"/>
-            <a:r>
-              <a:rPr sz="1000" b="0">
-                <a:solidFill>
-                  <a:srgbClr val="334155"/>
-                </a:solidFill>
-                <a:latin typeface="Open Sans"/>
-              </a:rPr>
-              <a:t>4,393</a:t>
-            </a:r>
-          </a:p>
-        </p:txBody>
-      </p:sp>
-      <p:sp>
-        <p:nvSpPr>
-          <p:cNvPr id="63" name="TextBox 62"/>
-          <p:cNvSpPr txBox="1"/>
-          <p:nvPr/>
-        </p:nvSpPr>
-        <p:spPr>
-          <a:xfrm>
-            <a:off x="3246120" y="6099047"/>
-            <a:ext cx="914400" cy="182880"/>
-          </a:xfrm>
-          <a:prstGeom prst="rect">
-            <a:avLst/>
-          </a:prstGeom>
-          <a:noFill/>
-        </p:spPr>
-        <p:txBody>
-          <a:bodyPr wrap="square" anchor="t" lIns="0" rIns="0" tIns="0" bIns="0">
-            <a:spAutoFit/>
-          </a:bodyPr>
-          <a:lstStyle/>
-          <a:p>
-            <a:pPr algn="l"/>
-            <a:r>
-              <a:rPr sz="1000" b="1">
-                <a:solidFill>
-                  <a:srgbClr val="FFB352"/>
-                </a:solidFill>
-                <a:latin typeface="Open Sans"/>
-              </a:rPr>
-              <a:t>$3.50M</a:t>
-            </a:r>
-          </a:p>
-        </p:txBody>
-      </p:sp>
-      <p:sp>
-        <p:nvSpPr>
-          <p:cNvPr id="64" name="TextBox 63"/>
-          <p:cNvSpPr txBox="1"/>
-          <p:nvPr/>
-        </p:nvSpPr>
-        <p:spPr>
-          <a:xfrm>
-            <a:off x="4297680" y="6099047"/>
-            <a:ext cx="1554480" cy="182880"/>
-          </a:xfrm>
-          <a:prstGeom prst="rect">
-            <a:avLst/>
-          </a:prstGeom>
-          <a:noFill/>
-        </p:spPr>
-        <p:txBody>
-          <a:bodyPr wrap="square" anchor="t" lIns="0" rIns="0" tIns="0" bIns="0">
-            <a:spAutoFit/>
-          </a:bodyPr>
-          <a:lstStyle/>
-          <a:p>
-            <a:pPr algn="l"/>
-            <a:r>
-              <a:rPr sz="900" b="0">
-                <a:solidFill>
-                  <a:srgbClr val="64748B"/>
-                </a:solidFill>
-                <a:latin typeface="Open Sans"/>
-              </a:rPr>
-              <a:t>Mixed — needs review</a:t>
-            </a:r>
-          </a:p>
-        </p:txBody>
-      </p:sp>
-      <p:sp>
-        <p:nvSpPr>
-          <p:cNvPr id="65" name="Rectangle 64"/>
-          <p:cNvSpPr/>
-          <p:nvPr/>
-        </p:nvSpPr>
-        <p:spPr>
-          <a:xfrm>
-            <a:off x="457200" y="6309359"/>
-            <a:ext cx="5486400" cy="246888"/>
-          </a:xfrm>
-          <a:prstGeom prst="rect">
-            <a:avLst/>
-          </a:prstGeom>
-          <a:solidFill>
-            <a:srgbClr val="FFFFFF"/>
-          </a:solidFill>
-          <a:ln>
-            <a:noFill/>
-          </a:ln>
-          <a:effectLst/>
-        </p:spPr>
-        <p:style>
-          <a:lnRef idx="1">
-            <a:schemeClr val="accent1"/>
-          </a:lnRef>
-          <a:fillRef idx="3">
-            <a:schemeClr val="accent1"/>
-          </a:fillRef>
-          <a:effectRef idx="2">
-            <a:schemeClr val="accent1"/>
-          </a:effectRef>
-          <a:fontRef idx="minor">
-            <a:schemeClr val="lt1"/>
-          </a:fontRef>
-        </p:style>
-        <p:txBody>
-          <a:bodyPr rtlCol="0" anchor="ctr"/>
-          <a:lstStyle/>
-          <a:p>
-            <a:pPr algn="ctr"/>
-          </a:p>
-        </p:txBody>
-      </p:sp>
-      <p:sp>
-        <p:nvSpPr>
-          <p:cNvPr id="66" name="TextBox 65"/>
-          <p:cNvSpPr txBox="1"/>
-          <p:nvPr/>
-        </p:nvSpPr>
-        <p:spPr>
-          <a:xfrm>
-            <a:off x="548640" y="6345935"/>
-            <a:ext cx="1554480" cy="182880"/>
-          </a:xfrm>
-          <a:prstGeom prst="rect">
-            <a:avLst/>
-          </a:prstGeom>
-          <a:noFill/>
-        </p:spPr>
-        <p:txBody>
-          <a:bodyPr wrap="square" anchor="t" lIns="0" rIns="0" tIns="0" bIns="0">
-            <a:spAutoFit/>
-          </a:bodyPr>
-          <a:lstStyle/>
-          <a:p>
-            <a:pPr algn="l"/>
-            <a:r>
-              <a:rPr sz="1000" b="1">
-                <a:solidFill>
-                  <a:srgbClr val="0F172A"/>
-                </a:solidFill>
-                <a:latin typeface="Open Sans"/>
-              </a:rPr>
-              <a:t>20+ records</a:t>
-            </a:r>
-          </a:p>
-        </p:txBody>
-      </p:sp>
-      <p:sp>
-        <p:nvSpPr>
-          <p:cNvPr id="67" name="TextBox 66"/>
-          <p:cNvSpPr txBox="1"/>
-          <p:nvPr/>
-        </p:nvSpPr>
-        <p:spPr>
-          <a:xfrm>
-            <a:off x="2194560" y="6345935"/>
-            <a:ext cx="914400" cy="182880"/>
-          </a:xfrm>
-          <a:prstGeom prst="rect">
-            <a:avLst/>
-          </a:prstGeom>
-          <a:noFill/>
-        </p:spPr>
-        <p:txBody>
-          <a:bodyPr wrap="square" anchor="t" lIns="0" rIns="0" tIns="0" bIns="0">
-            <a:spAutoFit/>
-          </a:bodyPr>
-          <a:lstStyle/>
-          <a:p>
-            <a:pPr algn="l"/>
-            <a:r>
-              <a:rPr sz="1000" b="0">
-                <a:solidFill>
-                  <a:srgbClr val="334155"/>
-                </a:solidFill>
-                <a:latin typeface="Open Sans"/>
-              </a:rPr>
-              <a:t>8,417</a:t>
-            </a:r>
-          </a:p>
-        </p:txBody>
-      </p:sp>
-      <p:sp>
-        <p:nvSpPr>
-          <p:cNvPr id="68" name="TextBox 67"/>
-          <p:cNvSpPr txBox="1"/>
-          <p:nvPr/>
-        </p:nvSpPr>
-        <p:spPr>
-          <a:xfrm>
-            <a:off x="3246120" y="6345935"/>
-            <a:ext cx="914400" cy="182880"/>
-          </a:xfrm>
-          <a:prstGeom prst="rect">
-            <a:avLst/>
-          </a:prstGeom>
-          <a:noFill/>
-        </p:spPr>
-        <p:txBody>
-          <a:bodyPr wrap="square" anchor="t" lIns="0" rIns="0" tIns="0" bIns="0">
-            <a:spAutoFit/>
-          </a:bodyPr>
-          <a:lstStyle/>
-          <a:p>
-            <a:pPr algn="l"/>
-            <a:r>
-              <a:rPr sz="1000" b="1">
-                <a:solidFill>
-                  <a:srgbClr val="64748B"/>
-                </a:solidFill>
-                <a:latin typeface="Open Sans"/>
-              </a:rPr>
-              <a:t>$319M</a:t>
-            </a:r>
-          </a:p>
-        </p:txBody>
-      </p:sp>
-      <p:sp>
-        <p:nvSpPr>
-          <p:cNvPr id="69" name="TextBox 68"/>
-          <p:cNvSpPr txBox="1"/>
-          <p:nvPr/>
-        </p:nvSpPr>
-        <p:spPr>
-          <a:xfrm>
-            <a:off x="4297680" y="6345935"/>
-            <a:ext cx="1554480" cy="182880"/>
-          </a:xfrm>
-          <a:prstGeom prst="rect">
-            <a:avLst/>
-          </a:prstGeom>
-          <a:noFill/>
-        </p:spPr>
-        <p:txBody>
-          <a:bodyPr wrap="square" anchor="t" lIns="0" rIns="0" tIns="0" bIns="0">
-            <a:spAutoFit/>
-          </a:bodyPr>
-          <a:lstStyle/>
-          <a:p>
-            <a:pPr algn="l"/>
-            <a:r>
-              <a:rPr sz="900" b="0">
-                <a:solidFill>
-                  <a:srgbClr val="64748B"/>
-                </a:solidFill>
-                <a:latin typeface="Open Sans"/>
-              </a:rPr>
-              <a:t>Common-name collisions</a:t>
-            </a:r>
-          </a:p>
-        </p:txBody>
-      </p:sp>
-      <p:sp>
-        <p:nvSpPr>
-          <p:cNvPr id="70" name="TextBox 69"/>
-          <p:cNvSpPr txBox="1"/>
-          <p:nvPr/>
-        </p:nvSpPr>
-        <p:spPr>
-          <a:xfrm>
-            <a:off x="6217920" y="4754880"/>
-            <a:ext cx="5486400" cy="292608"/>
-          </a:xfrm>
-          <a:prstGeom prst="rect">
-            <a:avLst/>
-          </a:prstGeom>
-          <a:noFill/>
-        </p:spPr>
-        <p:txBody>
-          <a:bodyPr wrap="square" anchor="t" lIns="0" rIns="0" tIns="0" bIns="0">
-            <a:spAutoFit/>
-          </a:bodyPr>
-          <a:lstStyle/>
-          <a:p>
-            <a:pPr algn="l"/>
-            <a:r>
-              <a:rPr sz="1100" b="1">
-                <a:solidFill>
-                  <a:srgbClr val="2863C5"/>
-                </a:solidFill>
-                <a:latin typeface="Open Sans"/>
-              </a:rPr>
-              <a:t>MATCHES BY TIER</a:t>
-            </a:r>
-          </a:p>
-        </p:txBody>
-      </p:sp>
-      <p:sp>
-        <p:nvSpPr>
-          <p:cNvPr id="71" name="TextBox 70"/>
-          <p:cNvSpPr txBox="1"/>
-          <p:nvPr/>
-        </p:nvSpPr>
-        <p:spPr>
-          <a:xfrm>
-            <a:off x="6217920" y="5029200"/>
-            <a:ext cx="5486400" cy="256032"/>
-          </a:xfrm>
-          <a:prstGeom prst="rect">
-            <a:avLst/>
-          </a:prstGeom>
-          <a:noFill/>
-        </p:spPr>
-        <p:txBody>
-          <a:bodyPr wrap="square" anchor="t" lIns="0" rIns="0" tIns="0" bIns="0">
-            <a:spAutoFit/>
-          </a:bodyPr>
-          <a:lstStyle/>
-          <a:p>
-            <a:pPr algn="l"/>
-            <a:r>
-              <a:rPr sz="1000" b="0">
-                <a:solidFill>
-                  <a:srgbClr val="64748B"/>
-                </a:solidFill>
-                <a:latin typeface="Open Sans"/>
-              </a:rPr>
-              <a:t>Tier 04 ($500+) carries 53% of the value despite 2% of records.</a:t>
-            </a:r>
-          </a:p>
-        </p:txBody>
-      </p:sp>
-      <p:sp>
-        <p:nvSpPr>
-          <p:cNvPr id="72" name="Rectangle 71"/>
-          <p:cNvSpPr/>
-          <p:nvPr/>
-        </p:nvSpPr>
-        <p:spPr>
-          <a:xfrm>
-            <a:off x="6217920" y="5349240"/>
-            <a:ext cx="5486400" cy="219456"/>
-          </a:xfrm>
-          <a:prstGeom prst="rect">
-            <a:avLst/>
-          </a:prstGeom>
-          <a:solidFill>
-            <a:srgbClr val="0F172A"/>
-          </a:solidFill>
-          <a:ln>
-            <a:noFill/>
-          </a:ln>
-          <a:effectLst/>
-        </p:spPr>
-        <p:style>
-          <a:lnRef idx="1">
-            <a:schemeClr val="accent1"/>
-          </a:lnRef>
-          <a:fillRef idx="3">
-            <a:schemeClr val="accent1"/>
-          </a:fillRef>
-          <a:effectRef idx="2">
-            <a:schemeClr val="accent1"/>
-          </a:effectRef>
-          <a:fontRef idx="minor">
-            <a:schemeClr val="lt1"/>
-          </a:fontRef>
-        </p:style>
-        <p:txBody>
-          <a:bodyPr rtlCol="0" anchor="ctr"/>
-          <a:lstStyle/>
-          <a:p>
-            <a:pPr algn="ctr"/>
-          </a:p>
-        </p:txBody>
-      </p:sp>
-      <p:sp>
-        <p:nvSpPr>
-          <p:cNvPr id="73" name="TextBox 72"/>
-          <p:cNvSpPr txBox="1"/>
-          <p:nvPr/>
-        </p:nvSpPr>
-        <p:spPr>
-          <a:xfrm>
-            <a:off x="6309360" y="5385816"/>
-            <a:ext cx="914400" cy="164592"/>
-          </a:xfrm>
-          <a:prstGeom prst="rect">
-            <a:avLst/>
-          </a:prstGeom>
-          <a:noFill/>
-        </p:spPr>
-        <p:txBody>
-          <a:bodyPr wrap="square" anchor="t" lIns="0" rIns="0" tIns="0" bIns="0">
-            <a:spAutoFit/>
-          </a:bodyPr>
-          <a:lstStyle/>
-          <a:p>
-            <a:pPr algn="l"/>
-            <a:r>
-              <a:rPr sz="900" b="1">
-                <a:solidFill>
-                  <a:srgbClr val="FFFFFF"/>
-                </a:solidFill>
-                <a:latin typeface="Open Sans"/>
-              </a:rPr>
-              <a:t>Tier</a:t>
-            </a:r>
-          </a:p>
-        </p:txBody>
-      </p:sp>
-      <p:sp>
-        <p:nvSpPr>
-          <p:cNvPr id="74" name="TextBox 73"/>
-          <p:cNvSpPr txBox="1"/>
-          <p:nvPr/>
-        </p:nvSpPr>
-        <p:spPr>
-          <a:xfrm>
-            <a:off x="7269480" y="5385816"/>
-            <a:ext cx="1280160" cy="164592"/>
-          </a:xfrm>
-          <a:prstGeom prst="rect">
-            <a:avLst/>
-          </a:prstGeom>
-          <a:noFill/>
-        </p:spPr>
-        <p:txBody>
-          <a:bodyPr wrap="square" anchor="t" lIns="0" rIns="0" tIns="0" bIns="0">
-            <a:spAutoFit/>
-          </a:bodyPr>
-          <a:lstStyle/>
-          <a:p>
-            <a:pPr algn="l"/>
-            <a:r>
-              <a:rPr sz="900" b="1">
-                <a:solidFill>
-                  <a:srgbClr val="FFFFFF"/>
-                </a:solidFill>
-                <a:latin typeface="Open Sans"/>
-              </a:rPr>
-              <a:t>Range</a:t>
-            </a:r>
-          </a:p>
-        </p:txBody>
-      </p:sp>
-      <p:sp>
-        <p:nvSpPr>
-          <p:cNvPr id="75" name="TextBox 74"/>
-          <p:cNvSpPr txBox="1"/>
-          <p:nvPr/>
-        </p:nvSpPr>
-        <p:spPr>
-          <a:xfrm>
-            <a:off x="8641080" y="5385816"/>
-            <a:ext cx="1371600" cy="164592"/>
-          </a:xfrm>
-          <a:prstGeom prst="rect">
-            <a:avLst/>
-          </a:prstGeom>
-          <a:noFill/>
-        </p:spPr>
-        <p:txBody>
-          <a:bodyPr wrap="square" anchor="t" lIns="0" rIns="0" tIns="0" bIns="0">
-            <a:spAutoFit/>
-          </a:bodyPr>
-          <a:lstStyle/>
-          <a:p>
-            <a:pPr algn="l"/>
-            <a:r>
-              <a:rPr sz="900" b="1">
-                <a:solidFill>
-                  <a:srgbClr val="FFFFFF"/>
-                </a:solidFill>
-                <a:latin typeface="Open Sans"/>
-              </a:rPr>
-              <a:t>Records</a:t>
-            </a:r>
-          </a:p>
-        </p:txBody>
-      </p:sp>
-      <p:sp>
-        <p:nvSpPr>
-          <p:cNvPr id="76" name="TextBox 75"/>
-          <p:cNvSpPr txBox="1"/>
-          <p:nvPr/>
-        </p:nvSpPr>
-        <p:spPr>
-          <a:xfrm>
-            <a:off x="10104120" y="5385816"/>
-            <a:ext cx="1371600" cy="164592"/>
-          </a:xfrm>
-          <a:prstGeom prst="rect">
-            <a:avLst/>
-          </a:prstGeom>
-          <a:noFill/>
-        </p:spPr>
-        <p:txBody>
-          <a:bodyPr wrap="square" anchor="t" lIns="0" rIns="0" tIns="0" bIns="0">
-            <a:spAutoFit/>
-          </a:bodyPr>
-          <a:lstStyle/>
-          <a:p>
-            <a:pPr algn="l"/>
-            <a:r>
-              <a:rPr sz="900" b="1">
-                <a:solidFill>
-                  <a:srgbClr val="FFFFFF"/>
-                </a:solidFill>
-                <a:latin typeface="Open Sans"/>
-              </a:rPr>
-              <a:t>$ value</a:t>
-            </a:r>
-          </a:p>
-        </p:txBody>
-      </p:sp>
-      <p:sp>
-        <p:nvSpPr>
-          <p:cNvPr id="77" name="Rectangle 76"/>
-          <p:cNvSpPr/>
-          <p:nvPr/>
-        </p:nvSpPr>
-        <p:spPr>
-          <a:xfrm>
-            <a:off x="6217920" y="5568696"/>
-            <a:ext cx="5486400" cy="246888"/>
-          </a:xfrm>
-          <a:prstGeom prst="rect">
-            <a:avLst/>
-          </a:prstGeom>
-          <a:solidFill>
-            <a:srgbClr val="F8FAFC"/>
-          </a:solidFill>
-          <a:ln>
-            <a:noFill/>
-          </a:ln>
-          <a:effectLst/>
-        </p:spPr>
-        <p:style>
-          <a:lnRef idx="1">
-            <a:schemeClr val="accent1"/>
-          </a:lnRef>
-          <a:fillRef idx="3">
-            <a:schemeClr val="accent1"/>
-          </a:fillRef>
-          <a:effectRef idx="2">
-            <a:schemeClr val="accent1"/>
-          </a:effectRef>
-          <a:fontRef idx="minor">
-            <a:schemeClr val="lt1"/>
-          </a:fontRef>
-        </p:style>
-        <p:txBody>
-          <a:bodyPr rtlCol="0" anchor="ctr"/>
-          <a:lstStyle/>
-          <a:p>
-            <a:pPr algn="ctr"/>
-          </a:p>
-        </p:txBody>
-      </p:sp>
-      <p:sp>
-        <p:nvSpPr>
-          <p:cNvPr id="78" name="TextBox 77"/>
-          <p:cNvSpPr txBox="1"/>
-          <p:nvPr/>
-        </p:nvSpPr>
-        <p:spPr>
-          <a:xfrm>
-            <a:off x="6309360" y="5605272"/>
-            <a:ext cx="914400" cy="182880"/>
-          </a:xfrm>
-          <a:prstGeom prst="rect">
-            <a:avLst/>
-          </a:prstGeom>
-          <a:noFill/>
-        </p:spPr>
-        <p:txBody>
-          <a:bodyPr wrap="square" anchor="t" lIns="0" rIns="0" tIns="0" bIns="0">
-            <a:spAutoFit/>
-          </a:bodyPr>
-          <a:lstStyle/>
-          <a:p>
-            <a:pPr algn="l"/>
-            <a:r>
-              <a:rPr sz="1000" b="1">
-                <a:solidFill>
-                  <a:srgbClr val="64748B"/>
-                </a:solidFill>
-                <a:latin typeface="Open Sans"/>
-              </a:rPr>
-              <a:t>Tier 01</a:t>
-            </a:r>
-          </a:p>
-        </p:txBody>
-      </p:sp>
-      <p:sp>
-        <p:nvSpPr>
-          <p:cNvPr id="79" name="TextBox 78"/>
-          <p:cNvSpPr txBox="1"/>
-          <p:nvPr/>
-        </p:nvSpPr>
-        <p:spPr>
-          <a:xfrm>
-            <a:off x="7269480" y="5605272"/>
-            <a:ext cx="1280160" cy="182880"/>
-          </a:xfrm>
-          <a:prstGeom prst="rect">
-            <a:avLst/>
-          </a:prstGeom>
-          <a:noFill/>
-        </p:spPr>
-        <p:txBody>
-          <a:bodyPr wrap="square" anchor="t" lIns="0" rIns="0" tIns="0" bIns="0">
-            <a:spAutoFit/>
-          </a:bodyPr>
-          <a:lstStyle/>
-          <a:p>
-            <a:pPr algn="l"/>
-            <a:r>
-              <a:rPr sz="900" b="0">
-                <a:solidFill>
-                  <a:srgbClr val="334155"/>
-                </a:solidFill>
-                <a:latin typeface="Open Sans"/>
-              </a:rPr>
-              <a:t>$0–$9.99</a:t>
-            </a:r>
-          </a:p>
-        </p:txBody>
-      </p:sp>
-      <p:sp>
-        <p:nvSpPr>
-          <p:cNvPr id="80" name="TextBox 79"/>
-          <p:cNvSpPr txBox="1"/>
-          <p:nvPr/>
-        </p:nvSpPr>
-        <p:spPr>
-          <a:xfrm>
-            <a:off x="8641080" y="5605272"/>
-            <a:ext cx="1371600" cy="182880"/>
-          </a:xfrm>
-          <a:prstGeom prst="rect">
-            <a:avLst/>
-          </a:prstGeom>
-          <a:noFill/>
-        </p:spPr>
-        <p:txBody>
-          <a:bodyPr wrap="square" anchor="t" lIns="0" rIns="0" tIns="0" bIns="0">
-            <a:spAutoFit/>
-          </a:bodyPr>
-          <a:lstStyle/>
-          <a:p>
-            <a:pPr algn="l"/>
-            <a:r>
-              <a:rPr sz="1000" b="0">
-                <a:solidFill>
-                  <a:srgbClr val="334155"/>
-                </a:solidFill>
-                <a:latin typeface="Open Sans"/>
-              </a:rPr>
-              <a:t>2,283,461</a:t>
-            </a:r>
-          </a:p>
-        </p:txBody>
-      </p:sp>
-      <p:sp>
-        <p:nvSpPr>
-          <p:cNvPr id="81" name="TextBox 80"/>
-          <p:cNvSpPr txBox="1"/>
-          <p:nvPr/>
-        </p:nvSpPr>
-        <p:spPr>
-          <a:xfrm>
-            <a:off x="10104120" y="5605272"/>
-            <a:ext cx="1371600" cy="182880"/>
-          </a:xfrm>
-          <a:prstGeom prst="rect">
-            <a:avLst/>
-          </a:prstGeom>
-          <a:noFill/>
-        </p:spPr>
-        <p:txBody>
-          <a:bodyPr wrap="square" anchor="t" lIns="0" rIns="0" tIns="0" bIns="0">
-            <a:spAutoFit/>
-          </a:bodyPr>
-          <a:lstStyle/>
-          <a:p>
-            <a:pPr algn="l"/>
-            <a:r>
-              <a:rPr sz="1000" b="1">
-                <a:solidFill>
-                  <a:srgbClr val="64748B"/>
-                </a:solidFill>
-                <a:latin typeface="Open Sans"/>
-              </a:rPr>
-              <a:t>$5.8M</a:t>
-            </a:r>
-          </a:p>
-        </p:txBody>
-      </p:sp>
-      <p:sp>
-        <p:nvSpPr>
-          <p:cNvPr id="82" name="Rectangle 81"/>
-          <p:cNvSpPr/>
-          <p:nvPr/>
-        </p:nvSpPr>
-        <p:spPr>
-          <a:xfrm>
-            <a:off x="6217920" y="5815583"/>
-            <a:ext cx="5486400" cy="246888"/>
-          </a:xfrm>
-          <a:prstGeom prst="rect">
-            <a:avLst/>
-          </a:prstGeom>
-          <a:solidFill>
-            <a:srgbClr val="FFFFFF"/>
-          </a:solidFill>
-          <a:ln>
-            <a:noFill/>
-          </a:ln>
-          <a:effectLst/>
-        </p:spPr>
-        <p:style>
-          <a:lnRef idx="1">
-            <a:schemeClr val="accent1"/>
-          </a:lnRef>
-          <a:fillRef idx="3">
-            <a:schemeClr val="accent1"/>
-          </a:fillRef>
-          <a:effectRef idx="2">
-            <a:schemeClr val="accent1"/>
-          </a:effectRef>
-          <a:fontRef idx="minor">
-            <a:schemeClr val="lt1"/>
-          </a:fontRef>
-        </p:style>
-        <p:txBody>
-          <a:bodyPr rtlCol="0" anchor="ctr"/>
-          <a:lstStyle/>
-          <a:p>
-            <a:pPr algn="ctr"/>
-          </a:p>
-        </p:txBody>
-      </p:sp>
-      <p:sp>
-        <p:nvSpPr>
-          <p:cNvPr id="83" name="TextBox 82"/>
-          <p:cNvSpPr txBox="1"/>
-          <p:nvPr/>
-        </p:nvSpPr>
-        <p:spPr>
-          <a:xfrm>
-            <a:off x="6309360" y="5852159"/>
-            <a:ext cx="914400" cy="182880"/>
-          </a:xfrm>
-          <a:prstGeom prst="rect">
-            <a:avLst/>
-          </a:prstGeom>
-          <a:noFill/>
-        </p:spPr>
-        <p:txBody>
-          <a:bodyPr wrap="square" anchor="t" lIns="0" rIns="0" tIns="0" bIns="0">
-            <a:spAutoFit/>
-          </a:bodyPr>
-          <a:lstStyle/>
-          <a:p>
-            <a:pPr algn="l"/>
-            <a:r>
-              <a:rPr sz="1000" b="1">
-                <a:solidFill>
-                  <a:srgbClr val="FFB352"/>
-                </a:solidFill>
-                <a:latin typeface="Open Sans"/>
-              </a:rPr>
-              <a:t>Tier 02</a:t>
-            </a:r>
-          </a:p>
-        </p:txBody>
-      </p:sp>
-      <p:sp>
-        <p:nvSpPr>
-          <p:cNvPr id="84" name="TextBox 83"/>
-          <p:cNvSpPr txBox="1"/>
-          <p:nvPr/>
-        </p:nvSpPr>
-        <p:spPr>
-          <a:xfrm>
-            <a:off x="7269480" y="5852159"/>
-            <a:ext cx="1280160" cy="182880"/>
-          </a:xfrm>
-          <a:prstGeom prst="rect">
-            <a:avLst/>
-          </a:prstGeom>
-          <a:noFill/>
-        </p:spPr>
-        <p:txBody>
-          <a:bodyPr wrap="square" anchor="t" lIns="0" rIns="0" tIns="0" bIns="0">
-            <a:spAutoFit/>
-          </a:bodyPr>
-          <a:lstStyle/>
-          <a:p>
-            <a:pPr algn="l"/>
-            <a:r>
-              <a:rPr sz="900" b="0">
-                <a:solidFill>
-                  <a:srgbClr val="334155"/>
-                </a:solidFill>
-                <a:latin typeface="Open Sans"/>
-              </a:rPr>
-              <a:t>$10–$99.99</a:t>
-            </a:r>
-          </a:p>
-        </p:txBody>
-      </p:sp>
-      <p:sp>
-        <p:nvSpPr>
-          <p:cNvPr id="85" name="TextBox 84"/>
-          <p:cNvSpPr txBox="1"/>
-          <p:nvPr/>
-        </p:nvSpPr>
-        <p:spPr>
-          <a:xfrm>
-            <a:off x="8641080" y="5852159"/>
-            <a:ext cx="1371600" cy="182880"/>
-          </a:xfrm>
-          <a:prstGeom prst="rect">
-            <a:avLst/>
-          </a:prstGeom>
-          <a:noFill/>
-        </p:spPr>
-        <p:txBody>
-          <a:bodyPr wrap="square" anchor="t" lIns="0" rIns="0" tIns="0" bIns="0">
-            <a:spAutoFit/>
-          </a:bodyPr>
-          <a:lstStyle/>
-          <a:p>
-            <a:pPr algn="l"/>
-            <a:r>
-              <a:rPr sz="1000" b="0">
-                <a:solidFill>
-                  <a:srgbClr val="334155"/>
-                </a:solidFill>
-                <a:latin typeface="Open Sans"/>
-              </a:rPr>
-              <a:t>1,622,140</a:t>
-            </a:r>
-          </a:p>
-        </p:txBody>
-      </p:sp>
-      <p:sp>
-        <p:nvSpPr>
-          <p:cNvPr id="86" name="TextBox 85"/>
-          <p:cNvSpPr txBox="1"/>
-          <p:nvPr/>
-        </p:nvSpPr>
-        <p:spPr>
-          <a:xfrm>
-            <a:off x="10104120" y="5852159"/>
-            <a:ext cx="1371600" cy="182880"/>
-          </a:xfrm>
-          <a:prstGeom prst="rect">
-            <a:avLst/>
-          </a:prstGeom>
-          <a:noFill/>
-        </p:spPr>
-        <p:txBody>
-          <a:bodyPr wrap="square" anchor="t" lIns="0" rIns="0" tIns="0" bIns="0">
-            <a:spAutoFit/>
-          </a:bodyPr>
-          <a:lstStyle/>
-          <a:p>
-            <a:pPr algn="l"/>
-            <a:r>
-              <a:rPr sz="1000" b="1">
-                <a:solidFill>
-                  <a:srgbClr val="FFB352"/>
-                </a:solidFill>
-                <a:latin typeface="Open Sans"/>
-              </a:rPr>
-              <a:t>$57.9M</a:t>
-            </a:r>
-          </a:p>
-        </p:txBody>
-      </p:sp>
-      <p:sp>
-        <p:nvSpPr>
-          <p:cNvPr id="87" name="Rectangle 86"/>
-          <p:cNvSpPr/>
-          <p:nvPr/>
-        </p:nvSpPr>
-        <p:spPr>
-          <a:xfrm>
-            <a:off x="6217920" y="6062471"/>
-            <a:ext cx="5486400" cy="246888"/>
-          </a:xfrm>
-          <a:prstGeom prst="rect">
-            <a:avLst/>
-          </a:prstGeom>
-          <a:solidFill>
-            <a:srgbClr val="F8FAFC"/>
-          </a:solidFill>
-          <a:ln>
-            <a:noFill/>
-          </a:ln>
-          <a:effectLst/>
-        </p:spPr>
-        <p:style>
-          <a:lnRef idx="1">
-            <a:schemeClr val="accent1"/>
-          </a:lnRef>
-          <a:fillRef idx="3">
-            <a:schemeClr val="accent1"/>
-          </a:fillRef>
-          <a:effectRef idx="2">
-            <a:schemeClr val="accent1"/>
-          </a:effectRef>
-          <a:fontRef idx="minor">
-            <a:schemeClr val="lt1"/>
-          </a:fontRef>
-        </p:style>
-        <p:txBody>
-          <a:bodyPr rtlCol="0" anchor="ctr"/>
-          <a:lstStyle/>
-          <a:p>
-            <a:pPr algn="ctr"/>
-          </a:p>
-        </p:txBody>
-      </p:sp>
-      <p:sp>
-        <p:nvSpPr>
-          <p:cNvPr id="88" name="TextBox 87"/>
-          <p:cNvSpPr txBox="1"/>
-          <p:nvPr/>
-        </p:nvSpPr>
-        <p:spPr>
-          <a:xfrm>
-            <a:off x="6309360" y="6099047"/>
-            <a:ext cx="914400" cy="182880"/>
-          </a:xfrm>
-          <a:prstGeom prst="rect">
-            <a:avLst/>
-          </a:prstGeom>
-          <a:noFill/>
-        </p:spPr>
-        <p:txBody>
-          <a:bodyPr wrap="square" anchor="t" lIns="0" rIns="0" tIns="0" bIns="0">
-            <a:spAutoFit/>
-          </a:bodyPr>
-          <a:lstStyle/>
-          <a:p>
-            <a:pPr algn="l"/>
-            <a:r>
-              <a:rPr sz="1000" b="1">
-                <a:solidFill>
-                  <a:srgbClr val="FC4C0B"/>
-                </a:solidFill>
-                <a:latin typeface="Open Sans"/>
-              </a:rPr>
-              <a:t>Tier 03</a:t>
-            </a:r>
-          </a:p>
-        </p:txBody>
-      </p:sp>
-      <p:sp>
-        <p:nvSpPr>
-          <p:cNvPr id="89" name="TextBox 88"/>
-          <p:cNvSpPr txBox="1"/>
-          <p:nvPr/>
-        </p:nvSpPr>
-        <p:spPr>
-          <a:xfrm>
-            <a:off x="7269480" y="6099047"/>
-            <a:ext cx="1280160" cy="182880"/>
-          </a:xfrm>
-          <a:prstGeom prst="rect">
-            <a:avLst/>
-          </a:prstGeom>
-          <a:noFill/>
-        </p:spPr>
-        <p:txBody>
-          <a:bodyPr wrap="square" anchor="t" lIns="0" rIns="0" tIns="0" bIns="0">
-            <a:spAutoFit/>
-          </a:bodyPr>
-          <a:lstStyle/>
-          <a:p>
-            <a:pPr algn="l"/>
-            <a:r>
-              <a:rPr sz="900" b="0">
-                <a:solidFill>
-                  <a:srgbClr val="334155"/>
-                </a:solidFill>
-                <a:latin typeface="Open Sans"/>
-              </a:rPr>
-              <a:t>$100–$499.99</a:t>
-            </a:r>
-          </a:p>
-        </p:txBody>
-      </p:sp>
-      <p:sp>
-        <p:nvSpPr>
-          <p:cNvPr id="90" name="TextBox 89"/>
-          <p:cNvSpPr txBox="1"/>
-          <p:nvPr/>
-        </p:nvSpPr>
-        <p:spPr>
-          <a:xfrm>
-            <a:off x="8641080" y="6099047"/>
-            <a:ext cx="1371600" cy="182880"/>
-          </a:xfrm>
-          <a:prstGeom prst="rect">
-            <a:avLst/>
-          </a:prstGeom>
-          <a:noFill/>
-        </p:spPr>
-        <p:txBody>
-          <a:bodyPr wrap="square" anchor="t" lIns="0" rIns="0" tIns="0" bIns="0">
-            <a:spAutoFit/>
-          </a:bodyPr>
-          <a:lstStyle/>
-          <a:p>
-            <a:pPr algn="l"/>
-            <a:r>
-              <a:rPr sz="1000" b="0">
-                <a:solidFill>
-                  <a:srgbClr val="334155"/>
-                </a:solidFill>
-                <a:latin typeface="Open Sans"/>
-              </a:rPr>
-              <a:t>425,201</a:t>
-            </a:r>
-          </a:p>
-        </p:txBody>
-      </p:sp>
-      <p:sp>
-        <p:nvSpPr>
-          <p:cNvPr id="91" name="TextBox 90"/>
-          <p:cNvSpPr txBox="1"/>
-          <p:nvPr/>
-        </p:nvSpPr>
-        <p:spPr>
-          <a:xfrm>
-            <a:off x="10104120" y="6099047"/>
-            <a:ext cx="1371600" cy="182880"/>
-          </a:xfrm>
-          <a:prstGeom prst="rect">
-            <a:avLst/>
-          </a:prstGeom>
-          <a:noFill/>
-        </p:spPr>
-        <p:txBody>
-          <a:bodyPr wrap="square" anchor="t" lIns="0" rIns="0" tIns="0" bIns="0">
-            <a:spAutoFit/>
-          </a:bodyPr>
-          <a:lstStyle/>
-          <a:p>
-            <a:pPr algn="l"/>
-            <a:r>
-              <a:rPr sz="1000" b="1">
-                <a:solidFill>
-                  <a:srgbClr val="FC4C0B"/>
-                </a:solidFill>
-                <a:latin typeface="Open Sans"/>
-              </a:rPr>
-              <a:t>$87.5M</a:t>
-            </a:r>
-          </a:p>
-        </p:txBody>
-      </p:sp>
-      <p:sp>
-        <p:nvSpPr>
-          <p:cNvPr id="92" name="Rectangle 91"/>
-          <p:cNvSpPr/>
-          <p:nvPr/>
-        </p:nvSpPr>
-        <p:spPr>
-          <a:xfrm>
-            <a:off x="6217920" y="6309359"/>
-            <a:ext cx="5486400" cy="246888"/>
-          </a:xfrm>
-          <a:prstGeom prst="rect">
-            <a:avLst/>
-          </a:prstGeom>
-          <a:solidFill>
-            <a:srgbClr val="FFFFFF"/>
-          </a:solidFill>
-          <a:ln>
-            <a:noFill/>
-          </a:ln>
-          <a:effectLst/>
-        </p:spPr>
-        <p:style>
-          <a:lnRef idx="1">
-            <a:schemeClr val="accent1"/>
-          </a:lnRef>
-          <a:fillRef idx="3">
-            <a:schemeClr val="accent1"/>
-          </a:fillRef>
-          <a:effectRef idx="2">
-            <a:schemeClr val="accent1"/>
-          </a:effectRef>
-          <a:fontRef idx="minor">
-            <a:schemeClr val="lt1"/>
-          </a:fontRef>
-        </p:style>
-        <p:txBody>
-          <a:bodyPr rtlCol="0" anchor="ctr"/>
-          <a:lstStyle/>
-          <a:p>
-            <a:pPr algn="ctr"/>
-          </a:p>
-        </p:txBody>
-      </p:sp>
-      <p:sp>
-        <p:nvSpPr>
-          <p:cNvPr id="93" name="TextBox 92"/>
-          <p:cNvSpPr txBox="1"/>
-          <p:nvPr/>
-        </p:nvSpPr>
-        <p:spPr>
-          <a:xfrm>
-            <a:off x="6309360" y="6345935"/>
-            <a:ext cx="914400" cy="182880"/>
-          </a:xfrm>
-          <a:prstGeom prst="rect">
-            <a:avLst/>
-          </a:prstGeom>
-          <a:noFill/>
-        </p:spPr>
-        <p:txBody>
-          <a:bodyPr wrap="square" anchor="t" lIns="0" rIns="0" tIns="0" bIns="0">
-            <a:spAutoFit/>
-          </a:bodyPr>
-          <a:lstStyle/>
-          <a:p>
-            <a:pPr algn="l"/>
-            <a:r>
-              <a:rPr sz="1000" b="1">
-                <a:solidFill>
-                  <a:srgbClr val="2863C5"/>
-                </a:solidFill>
-                <a:latin typeface="Open Sans"/>
-              </a:rPr>
-              <a:t>Tier 04</a:t>
-            </a:r>
-          </a:p>
-        </p:txBody>
-      </p:sp>
-      <p:sp>
-        <p:nvSpPr>
-          <p:cNvPr id="94" name="TextBox 93"/>
-          <p:cNvSpPr txBox="1"/>
-          <p:nvPr/>
-        </p:nvSpPr>
-        <p:spPr>
-          <a:xfrm>
-            <a:off x="7269480" y="6345935"/>
-            <a:ext cx="1280160" cy="182880"/>
-          </a:xfrm>
-          <a:prstGeom prst="rect">
-            <a:avLst/>
-          </a:prstGeom>
-          <a:noFill/>
-        </p:spPr>
-        <p:txBody>
-          <a:bodyPr wrap="square" anchor="t" lIns="0" rIns="0" tIns="0" bIns="0">
-            <a:spAutoFit/>
-          </a:bodyPr>
-          <a:lstStyle/>
-          <a:p>
-            <a:pPr algn="l"/>
-            <a:r>
-              <a:rPr sz="900" b="0">
-                <a:solidFill>
-                  <a:srgbClr val="334155"/>
-                </a:solidFill>
-                <a:latin typeface="Open Sans"/>
-              </a:rPr>
-              <a:t>$500+</a:t>
-            </a:r>
-          </a:p>
-        </p:txBody>
-      </p:sp>
-      <p:sp>
-        <p:nvSpPr>
-          <p:cNvPr id="95" name="TextBox 94"/>
-          <p:cNvSpPr txBox="1"/>
-          <p:nvPr/>
-        </p:nvSpPr>
-        <p:spPr>
-          <a:xfrm>
-            <a:off x="8641080" y="6345935"/>
-            <a:ext cx="1371600" cy="182880"/>
-          </a:xfrm>
-          <a:prstGeom prst="rect">
-            <a:avLst/>
-          </a:prstGeom>
-          <a:noFill/>
-        </p:spPr>
-        <p:txBody>
-          <a:bodyPr wrap="square" anchor="t" lIns="0" rIns="0" tIns="0" bIns="0">
-            <a:spAutoFit/>
-          </a:bodyPr>
-          <a:lstStyle/>
-          <a:p>
-            <a:pPr algn="l"/>
-            <a:r>
-              <a:rPr sz="1000" b="0">
-                <a:solidFill>
-                  <a:srgbClr val="334155"/>
-                </a:solidFill>
-                <a:latin typeface="Open Sans"/>
-              </a:rPr>
-              <a:t>97,787</a:t>
-            </a:r>
-          </a:p>
-        </p:txBody>
-      </p:sp>
-      <p:sp>
-        <p:nvSpPr>
-          <p:cNvPr id="96" name="TextBox 95"/>
-          <p:cNvSpPr txBox="1"/>
-          <p:nvPr/>
-        </p:nvSpPr>
-        <p:spPr>
-          <a:xfrm>
-            <a:off x="10104120" y="6345935"/>
-            <a:ext cx="1371600" cy="182880"/>
-          </a:xfrm>
-          <a:prstGeom prst="rect">
-            <a:avLst/>
-          </a:prstGeom>
-          <a:noFill/>
-        </p:spPr>
-        <p:txBody>
-          <a:bodyPr wrap="square" anchor="t" lIns="0" rIns="0" tIns="0" bIns="0">
-            <a:spAutoFit/>
-          </a:bodyPr>
-          <a:lstStyle/>
-          <a:p>
-            <a:pPr algn="l"/>
-            <a:r>
-              <a:rPr sz="1000" b="1">
-                <a:solidFill>
-                  <a:srgbClr val="2863C5"/>
-                </a:solidFill>
-                <a:latin typeface="Open Sans"/>
-              </a:rPr>
-              <a:t>$173.1M</a:t>
-            </a:r>
-          </a:p>
-        </p:txBody>
-      </p:sp>
-      <p:sp>
-        <p:nvSpPr>
-          <p:cNvPr id="97" name="Rounded Rectangle 96"/>
-          <p:cNvSpPr/>
-          <p:nvPr/>
-        </p:nvSpPr>
-        <p:spPr>
-          <a:xfrm>
-            <a:off x="457200" y="6492240"/>
-            <a:ext cx="11247120" cy="329184"/>
-          </a:xfrm>
-          <a:prstGeom prst="roundRect">
-            <a:avLst>
-              <a:gd name="adj" fmla="val 10000"/>
-            </a:avLst>
-          </a:prstGeom>
-          <a:solidFill>
-            <a:srgbClr val="2863C5"/>
-          </a:solidFill>
-          <a:ln>
-            <a:noFill/>
-          </a:ln>
-          <a:effectLst/>
-        </p:spPr>
-        <p:style>
-          <a:lnRef idx="1">
-            <a:schemeClr val="accent1"/>
-          </a:lnRef>
-          <a:fillRef idx="3">
-            <a:schemeClr val="accent1"/>
-          </a:fillRef>
-          <a:effectRef idx="2">
-            <a:schemeClr val="accent1"/>
-          </a:effectRef>
-          <a:fontRef idx="minor">
-            <a:schemeClr val="lt1"/>
-          </a:fontRef>
-        </p:style>
-        <p:txBody>
-          <a:bodyPr rtlCol="0" anchor="ctr"/>
-          <a:lstStyle/>
-          <a:p>
-            <a:pPr algn="ctr"/>
-          </a:p>
-        </p:txBody>
-      </p:sp>
-      <p:sp>
-        <p:nvSpPr>
-          <p:cNvPr id="98" name="TextBox 97"/>
-          <p:cNvSpPr txBox="1"/>
-          <p:nvPr/>
-        </p:nvSpPr>
-        <p:spPr>
-          <a:xfrm>
-            <a:off x="640080" y="6537960"/>
-            <a:ext cx="10972800" cy="256032"/>
-          </a:xfrm>
-          <a:prstGeom prst="rect">
-            <a:avLst/>
-          </a:prstGeom>
-          <a:noFill/>
-        </p:spPr>
-        <p:txBody>
-          <a:bodyPr wrap="square" anchor="t" lIns="0" rIns="0" tIns="0" bIns="0">
-            <a:spAutoFit/>
-          </a:bodyPr>
-          <a:lstStyle/>
-          <a:p>
-            <a:pPr algn="l"/>
-            <a:r>
-              <a:rPr sz="1100" b="1">
-                <a:solidFill>
-                  <a:srgbClr val="FFFFFF"/>
-                </a:solidFill>
-                <a:latin typeface="Open Sans"/>
-              </a:rPr>
-              <a:t>70.8% is the upper bound. NAUPA baseline is ~14% of Americans. With the production PII matcher, expect 20–30% of our CA base.</a:t>
+              <a:t>Even discounting common-name false positives, ~9,000 customers in the high-confidence bucket map to ~$1.5M of unclaimed property in CA alone.</a:t>
             </a:r>
           </a:p>
         </p:txBody>

</xml_diff>

<commit_message>
Slide 6 — by-tier table now shows $/customer instead of misleading Records
User flagged that the "Records" column was the SQL join's COUNT(*) (i.e.
match hits including common-name false positives), not the count of
real property records. Replaced with the actually-meaningful "$ per
customer" derived from $total / unique customers in each tier.

  Tier 01 $0-9.99      19,476  $5.8M    $298 / customer
  Tier 02 $10-99.99    17,927  $57.9M   $3,230 / customer
  Tier 03 $100-499.99  12,384  $87.5M   $7,067 / customer
  Tier 04 $500+        7,569   $173.1M  $22,872 / customer

Subtitle updated to disclose the math: "$ shown is sum across all
matched records / unique customers in that tier."

Co-Authored-By: Claude Opus 4.7 (1M context) <noreply@anthropic.com>
</commit_message>
<xml_diff>
--- a/myReclaim-Exec-Deck.pptx
+++ b/myReclaim-Exec-Deck.pptx
@@ -12200,7 +12200,7 @@
                 </a:solidFill>
                 <a:latin typeface="Open Sans"/>
               </a:rPr>
-              <a:t>Tier 04 ($500+) carries 53% of the value despite 2% of records.</a:t>
+              <a:t>$ shown is sum across all matched records ÷ unique customers in that tier.</a:t>
             </a:r>
           </a:p>
         </p:txBody>
@@ -12384,7 +12384,7 @@
                 </a:solidFill>
                 <a:latin typeface="Open Sans"/>
               </a:rPr>
-              <a:t>Records</a:t>
+              <a:t>$ total</a:t>
             </a:r>
           </a:p>
         </p:txBody>
@@ -12419,7 +12419,7 @@
                 </a:solidFill>
                 <a:latin typeface="Open Sans"/>
               </a:rPr>
-              <a:t>$ value</a:t>
+              <a:t>$/customer</a:t>
             </a:r>
           </a:p>
         </p:txBody>
@@ -12597,13 +12597,13 @@
           <a:p>
             <a:pPr algn="l"/>
             <a:r>
-              <a:rPr sz="1000" b="0">
-                <a:solidFill>
-                  <a:srgbClr val="334155"/>
-                </a:solidFill>
-                <a:latin typeface="Open Sans"/>
-              </a:rPr>
-              <a:t>2.28M</a:t>
+              <a:rPr sz="1000" b="1">
+                <a:solidFill>
+                  <a:srgbClr val="64748B"/>
+                </a:solidFill>
+                <a:latin typeface="Open Sans"/>
+              </a:rPr>
+              <a:t>$5.8M</a:t>
             </a:r>
           </a:p>
         </p:txBody>
@@ -12632,13 +12632,13 @@
           <a:p>
             <a:pPr algn="l"/>
             <a:r>
-              <a:rPr sz="1000" b="1">
+              <a:rPr sz="1000" b="0">
                 <a:solidFill>
                   <a:srgbClr val="64748B"/>
                 </a:solidFill>
                 <a:latin typeface="Open Sans"/>
               </a:rPr>
-              <a:t>$5.8M</a:t>
+              <a:t>$298</a:t>
             </a:r>
           </a:p>
         </p:txBody>
@@ -12816,13 +12816,13 @@
           <a:p>
             <a:pPr algn="l"/>
             <a:r>
-              <a:rPr sz="1000" b="0">
-                <a:solidFill>
-                  <a:srgbClr val="334155"/>
-                </a:solidFill>
-                <a:latin typeface="Open Sans"/>
-              </a:rPr>
-              <a:t>1.62M</a:t>
+              <a:rPr sz="1000" b="1">
+                <a:solidFill>
+                  <a:srgbClr val="FFB352"/>
+                </a:solidFill>
+                <a:latin typeface="Open Sans"/>
+              </a:rPr>
+              <a:t>$57.9M</a:t>
             </a:r>
           </a:p>
         </p:txBody>
@@ -12851,13 +12851,13 @@
           <a:p>
             <a:pPr algn="l"/>
             <a:r>
-              <a:rPr sz="1000" b="1">
+              <a:rPr sz="1000" b="0">
                 <a:solidFill>
                   <a:srgbClr val="FFB352"/>
                 </a:solidFill>
                 <a:latin typeface="Open Sans"/>
               </a:rPr>
-              <a:t>$57.9M</a:t>
+              <a:t>$3,230</a:t>
             </a:r>
           </a:p>
         </p:txBody>
@@ -13035,13 +13035,13 @@
           <a:p>
             <a:pPr algn="l"/>
             <a:r>
-              <a:rPr sz="1000" b="0">
-                <a:solidFill>
-                  <a:srgbClr val="334155"/>
-                </a:solidFill>
-                <a:latin typeface="Open Sans"/>
-              </a:rPr>
-              <a:t>425,201</a:t>
+              <a:rPr sz="1000" b="1">
+                <a:solidFill>
+                  <a:srgbClr val="FC4C0B"/>
+                </a:solidFill>
+                <a:latin typeface="Open Sans"/>
+              </a:rPr>
+              <a:t>$87.5M</a:t>
             </a:r>
           </a:p>
         </p:txBody>
@@ -13070,13 +13070,13 @@
           <a:p>
             <a:pPr algn="l"/>
             <a:r>
-              <a:rPr sz="1000" b="1">
+              <a:rPr sz="1000" b="0">
                 <a:solidFill>
                   <a:srgbClr val="FC4C0B"/>
                 </a:solidFill>
                 <a:latin typeface="Open Sans"/>
               </a:rPr>
-              <a:t>$87.5M</a:t>
+              <a:t>$7,067</a:t>
             </a:r>
           </a:p>
         </p:txBody>
@@ -13254,13 +13254,13 @@
           <a:p>
             <a:pPr algn="l"/>
             <a:r>
-              <a:rPr sz="1000" b="0">
-                <a:solidFill>
-                  <a:srgbClr val="334155"/>
-                </a:solidFill>
-                <a:latin typeface="Open Sans"/>
-              </a:rPr>
-              <a:t>97,787</a:t>
+              <a:rPr sz="1000" b="1">
+                <a:solidFill>
+                  <a:srgbClr val="2863C5"/>
+                </a:solidFill>
+                <a:latin typeface="Open Sans"/>
+              </a:rPr>
+              <a:t>$173.1M</a:t>
             </a:r>
           </a:p>
         </p:txBody>
@@ -13289,13 +13289,13 @@
           <a:p>
             <a:pPr algn="l"/>
             <a:r>
-              <a:rPr sz="1000" b="1">
+              <a:rPr sz="1000" b="0">
                 <a:solidFill>
                   <a:srgbClr val="2863C5"/>
                 </a:solidFill>
                 <a:latin typeface="Open Sans"/>
               </a:rPr>
-              <a:t>$173.1M</a:t>
+              <a:t>$22,872</a:t>
             </a:r>
           </a:p>
         </p:txBody>

</xml_diff>

<commit_message>
Slide 6 — add cohort definition (active product 4, non-test) to method line
Per Codex flag: 30,862 (Active_SC_Customers_CA.csv) and 44,222
(Customers_by_State.csv) describe different cohorts. Slide 5 cites the
44,222 total CA base; slide 6 was using 30,862 without explaining
which subset that is.

Method line now reads:
  "Cohort: active SmartCredit customers with customerproductid=4,
   excluding test accounts (30,862 of the 44,222 total CA base).
   Method: exact name match (FIRST LAST or LAST FIRST) on
   de-duplicated customer names — same logic the prototype uses,
   indexed equality path. State determines actual eligibility per
   record."

This makes slide 5's 44,222 and slide 6's 30,862 internally consistent.

Co-Authored-By: Claude Opus 4.7 (1M context) <noreply@anthropic.com>
</commit_message>
<xml_diff>
--- a/myReclaim-Exec-Deck.pptx
+++ b/myReclaim-Exec-Deck.pptx
@@ -10311,13 +10311,13 @@
           <a:p>
             <a:pPr algn="l"/>
             <a:r>
-              <a:rPr sz="1100" b="0">
+              <a:rPr sz="1000" b="0">
                 <a:solidFill>
                   <a:srgbClr val="64748B"/>
                 </a:solidFill>
                 <a:latin typeface="Open Sans"/>
               </a:rPr>
-              <a:t>Method: exact name match (FIRST LAST or LAST FIRST) on de-duplicated customer names. Same logic the prototype uses, run via the indexed equality path. The state determines actual eligibility per record.</a:t>
+              <a:t>Cohort: active SmartCredit customers with customerproductid=4, excluding test accounts (30,862 of the 44,222 total CA base). Method: exact name match (FIRST LAST or LAST FIRST) on de-duplicated customer names — same logic the prototype uses, indexed equality path. State determines actual eligibility per record.</a:t>
             </a:r>
           </a:p>
         </p:txBody>

</xml_diff>

<commit_message>
Slide 5 — Codex audit fixes + FL framing nuance
- CA row: 81M → 92.4M rows across 4 tiers (matches loaded DB)
- Top-10 coverage: ~70% → ~65% (288,065 of 443,206 — actual math)
- FL row: MANUAL → LEGAL — permissioned claimant-rep path; bulk
  ingest/caching needs written DFS approval (Ch. 717 registration
  alone does not equal scrape/cache permission)
- app/ingest.py: add tier 01 to TIERS so default ingest matches
  the 4-tier DB the slide claims

Co-Authored-By: Claude Opus 4.7 (1M context) <noreply@anthropic.com>
</commit_message>
<xml_diff>
--- a/myReclaim-Exec-Deck.pptx
+++ b/myReclaim-Exec-Deck.pptx
@@ -7242,7 +7242,7 @@
                 </a:solidFill>
                 <a:latin typeface="Open Sans"/>
               </a:rPr>
-              <a:t>Top 10 customer states cover ~70% of the SmartCredit base. Four of the top five (FL, TX, GA, NY) need a state agreement before we can ingest at scale. CA is the only top-10 state with a clean public bulk feed — that's where the prototype starts.</a:t>
+              <a:t>Top 10 customer states cover ~65% of the SmartCredit base (288,065 of 443,206). Four of the top five (FL, TX, GA, NY) need a state agreement before we can ingest at scale. CA is the only top-10 state with a clean public bulk feed — that's where the prototype starts.</a:t>
             </a:r>
           </a:p>
         </p:txBody>
@@ -7664,7 +7664,7 @@
                 </a:solidFill>
                 <a:latin typeface="Open Sans"/>
               </a:rPr>
-              <a:t>MANUAL</a:t>
+              <a:t>LEGAL</a:t>
             </a:r>
           </a:p>
         </p:txBody>
@@ -7699,7 +7699,7 @@
                 </a:solidFill>
                 <a:latin typeface="Open Sans"/>
               </a:rPr>
-              <a:t>Registered FL rep path (atty/CPA/PI, Ch. 717). No cacheable bulk dataset confirmed.</a:t>
+              <a:t>Permissioned claimant-rep path (FL atty/CPA/PI, Ch. 717). Bulk ingest/caching only after written DFS approval; portal manual by default.</a:t>
             </a:r>
           </a:p>
         </p:txBody>
@@ -8219,7 +8219,7 @@
                 </a:solidFill>
                 <a:latin typeface="Open Sans"/>
               </a:rPr>
-              <a:t>Public CSV, updated Thursdays — prototype loaded 81M rows ✓</a:t>
+              <a:t>Public CSV, updated Thursdays — prototype loaded 92.4M rows across 4 tiers ✓</a:t>
             </a:r>
           </a:p>
         </p:txBody>
@@ -9966,7 +9966,7 @@
                 </a:solidFill>
                 <a:latin typeface="Open Sans"/>
               </a:rPr>
-              <a:t>Top-10 states = 288,065 customers (~70% of base, pending base-size confirmation).</a:t>
+              <a:t>Top 10 customer states cover ~65% of the SmartCredit base (288,065 of 443,206).</a:t>
             </a:r>
           </a:p>
         </p:txBody>

</xml_diff>

<commit_message>
Slide 5 — drop CA green sidebar, fit FL note + callout in one line
- Remove CA green left sidebar (visual noise, BUILD pill already
  conveys the unique status)
- Shorten FL note to one line: "Atty/CPA/PI rep path (Ch. 717).
  Bulk caching needs written DFS approval; portal manual by default."
- Tighten bottom-callout body to a single line so it doesn't bleed
  into the slide footer / page number

Co-Authored-By: Claude Opus 4.7 (1M context) <noreply@anthropic.com>
</commit_message>
<xml_diff>
--- a/myReclaim-Exec-Deck.pptx
+++ b/myReclaim-Exec-Deck.pptx
@@ -7699,7 +7699,7 @@
                 </a:solidFill>
                 <a:latin typeface="Open Sans"/>
               </a:rPr>
-              <a:t>Permissioned claimant-rep path (FL atty/CPA/PI, Ch. 717). Bulk ingest/caching only after written DFS approval; portal manual by default.</a:t>
+              <a:t>Atty/CPA/PI rep path (Ch. 717). Bulk caching needs written DFS approval; portal manual by default.</a:t>
             </a:r>
           </a:p>
         </p:txBody>
@@ -7988,17 +7988,124 @@
       </p:sp>
       <p:sp>
         <p:nvSpPr>
-          <p:cNvPr id="29" name="Rectangle 28"/>
+          <p:cNvPr id="29" name="TextBox 28"/>
+          <p:cNvSpPr txBox="1"/>
+          <p:nvPr/>
+        </p:nvSpPr>
+        <p:spPr>
+          <a:xfrm>
+            <a:off x="548640" y="3493008"/>
+            <a:ext cx="457200" cy="201168"/>
+          </a:xfrm>
+          <a:prstGeom prst="rect">
+            <a:avLst/>
+          </a:prstGeom>
+          <a:noFill/>
+        </p:spPr>
+        <p:txBody>
+          <a:bodyPr wrap="square" anchor="t" lIns="0" rIns="0" tIns="0" bIns="0">
+            <a:spAutoFit/>
+          </a:bodyPr>
+          <a:lstStyle/>
+          <a:p>
+            <a:pPr algn="l"/>
+            <a:r>
+              <a:rPr sz="1100" b="1">
+                <a:solidFill>
+                  <a:srgbClr val="64748B"/>
+                </a:solidFill>
+                <a:latin typeface="Open Sans"/>
+              </a:rPr>
+              <a:t>3</a:t>
+            </a:r>
+          </a:p>
+        </p:txBody>
+      </p:sp>
+      <p:sp>
+        <p:nvSpPr>
+          <p:cNvPr id="30" name="TextBox 29"/>
+          <p:cNvSpPr txBox="1"/>
+          <p:nvPr/>
+        </p:nvSpPr>
+        <p:spPr>
+          <a:xfrm>
+            <a:off x="1051560" y="3474720"/>
+            <a:ext cx="822960" cy="219456"/>
+          </a:xfrm>
+          <a:prstGeom prst="rect">
+            <a:avLst/>
+          </a:prstGeom>
+          <a:noFill/>
+        </p:spPr>
+        <p:txBody>
+          <a:bodyPr wrap="square" anchor="t" lIns="0" rIns="0" tIns="0" bIns="0">
+            <a:spAutoFit/>
+          </a:bodyPr>
+          <a:lstStyle/>
+          <a:p>
+            <a:pPr algn="l"/>
+            <a:r>
+              <a:rPr sz="1400" b="1">
+                <a:solidFill>
+                  <a:srgbClr val="0F172A"/>
+                </a:solidFill>
+                <a:latin typeface="Open Sans"/>
+              </a:rPr>
+              <a:t>CA</a:t>
+            </a:r>
+          </a:p>
+        </p:txBody>
+      </p:sp>
+      <p:sp>
+        <p:nvSpPr>
+          <p:cNvPr id="31" name="TextBox 30"/>
+          <p:cNvSpPr txBox="1"/>
+          <p:nvPr/>
+        </p:nvSpPr>
+        <p:spPr>
+          <a:xfrm>
+            <a:off x="1920240" y="3483863"/>
+            <a:ext cx="1463040" cy="201168"/>
+          </a:xfrm>
+          <a:prstGeom prst="rect">
+            <a:avLst/>
+          </a:prstGeom>
+          <a:noFill/>
+        </p:spPr>
+        <p:txBody>
+          <a:bodyPr wrap="square" anchor="t" lIns="0" rIns="0" tIns="0" bIns="0">
+            <a:spAutoFit/>
+          </a:bodyPr>
+          <a:lstStyle/>
+          <a:p>
+            <a:pPr algn="l"/>
+            <a:r>
+              <a:rPr sz="1200" b="1">
+                <a:solidFill>
+                  <a:srgbClr val="0F172A"/>
+                </a:solidFill>
+                <a:latin typeface="Open Sans"/>
+              </a:rPr>
+              <a:t>44,222</a:t>
+            </a:r>
+          </a:p>
+        </p:txBody>
+      </p:sp>
+      <p:sp>
+        <p:nvSpPr>
+          <p:cNvPr id="32" name="Rounded Rectangle 31"/>
           <p:cNvSpPr/>
           <p:nvPr/>
         </p:nvSpPr>
         <p:spPr>
           <a:xfrm>
-            <a:off x="457200" y="3419856"/>
-            <a:ext cx="109728" cy="329184"/>
-          </a:xfrm>
-          <a:prstGeom prst="rect">
-            <a:avLst/>
+            <a:off x="3520440" y="3474720"/>
+            <a:ext cx="960120" cy="219456"/>
+          </a:xfrm>
+          <a:prstGeom prst="roundRect">
+            <a:avLst>
+              <a:gd name="adj" fmla="val 50000"/>
+            </a:avLst>
           </a:prstGeom>
           <a:solidFill>
             <a:srgbClr val="059669"/>
@@ -8006,7 +8113,6 @@
           <a:ln>
             <a:noFill/>
           </a:ln>
-          <a:effectLst/>
         </p:spPr>
         <p:style>
           <a:lnRef idx="1">
@@ -8023,160 +8129,10 @@
           </a:fontRef>
         </p:style>
         <p:txBody>
-          <a:bodyPr rtlCol="0" anchor="ctr"/>
+          <a:bodyPr rtlCol="0" anchor="ctr" lIns="45720" rIns="45720" tIns="18288" bIns="18288"/>
           <a:lstStyle/>
           <a:p>
             <a:pPr algn="ctr"/>
-          </a:p>
-        </p:txBody>
-      </p:sp>
-      <p:sp>
-        <p:nvSpPr>
-          <p:cNvPr id="30" name="TextBox 29"/>
-          <p:cNvSpPr txBox="1"/>
-          <p:nvPr/>
-        </p:nvSpPr>
-        <p:spPr>
-          <a:xfrm>
-            <a:off x="548640" y="3493008"/>
-            <a:ext cx="457200" cy="201168"/>
-          </a:xfrm>
-          <a:prstGeom prst="rect">
-            <a:avLst/>
-          </a:prstGeom>
-          <a:noFill/>
-        </p:spPr>
-        <p:txBody>
-          <a:bodyPr wrap="square" anchor="t" lIns="0" rIns="0" tIns="0" bIns="0">
-            <a:spAutoFit/>
-          </a:bodyPr>
-          <a:lstStyle/>
-          <a:p>
-            <a:pPr algn="l"/>
-            <a:r>
-              <a:rPr sz="1100" b="1">
-                <a:solidFill>
-                  <a:srgbClr val="64748B"/>
-                </a:solidFill>
-                <a:latin typeface="Open Sans"/>
-              </a:rPr>
-              <a:t>3</a:t>
-            </a:r>
-          </a:p>
-        </p:txBody>
-      </p:sp>
-      <p:sp>
-        <p:nvSpPr>
-          <p:cNvPr id="31" name="TextBox 30"/>
-          <p:cNvSpPr txBox="1"/>
-          <p:nvPr/>
-        </p:nvSpPr>
-        <p:spPr>
-          <a:xfrm>
-            <a:off x="1051560" y="3474720"/>
-            <a:ext cx="822960" cy="219456"/>
-          </a:xfrm>
-          <a:prstGeom prst="rect">
-            <a:avLst/>
-          </a:prstGeom>
-          <a:noFill/>
-        </p:spPr>
-        <p:txBody>
-          <a:bodyPr wrap="square" anchor="t" lIns="0" rIns="0" tIns="0" bIns="0">
-            <a:spAutoFit/>
-          </a:bodyPr>
-          <a:lstStyle/>
-          <a:p>
-            <a:pPr algn="l"/>
-            <a:r>
-              <a:rPr sz="1400" b="1">
-                <a:solidFill>
-                  <a:srgbClr val="0F172A"/>
-                </a:solidFill>
-                <a:latin typeface="Open Sans"/>
-              </a:rPr>
-              <a:t>CA</a:t>
-            </a:r>
-          </a:p>
-        </p:txBody>
-      </p:sp>
-      <p:sp>
-        <p:nvSpPr>
-          <p:cNvPr id="32" name="TextBox 31"/>
-          <p:cNvSpPr txBox="1"/>
-          <p:nvPr/>
-        </p:nvSpPr>
-        <p:spPr>
-          <a:xfrm>
-            <a:off x="1920240" y="3483863"/>
-            <a:ext cx="1463040" cy="201168"/>
-          </a:xfrm>
-          <a:prstGeom prst="rect">
-            <a:avLst/>
-          </a:prstGeom>
-          <a:noFill/>
-        </p:spPr>
-        <p:txBody>
-          <a:bodyPr wrap="square" anchor="t" lIns="0" rIns="0" tIns="0" bIns="0">
-            <a:spAutoFit/>
-          </a:bodyPr>
-          <a:lstStyle/>
-          <a:p>
-            <a:pPr algn="l"/>
-            <a:r>
-              <a:rPr sz="1200" b="1">
-                <a:solidFill>
-                  <a:srgbClr val="0F172A"/>
-                </a:solidFill>
-                <a:latin typeface="Open Sans"/>
-              </a:rPr>
-              <a:t>44,222</a:t>
-            </a:r>
-          </a:p>
-        </p:txBody>
-      </p:sp>
-      <p:sp>
-        <p:nvSpPr>
-          <p:cNvPr id="33" name="Rounded Rectangle 32"/>
-          <p:cNvSpPr/>
-          <p:nvPr/>
-        </p:nvSpPr>
-        <p:spPr>
-          <a:xfrm>
-            <a:off x="3520440" y="3474720"/>
-            <a:ext cx="960120" cy="219456"/>
-          </a:xfrm>
-          <a:prstGeom prst="roundRect">
-            <a:avLst>
-              <a:gd name="adj" fmla="val 50000"/>
-            </a:avLst>
-          </a:prstGeom>
-          <a:solidFill>
-            <a:srgbClr val="059669"/>
-          </a:solidFill>
-          <a:ln>
-            <a:noFill/>
-          </a:ln>
-        </p:spPr>
-        <p:style>
-          <a:lnRef idx="1">
-            <a:schemeClr val="accent1"/>
-          </a:lnRef>
-          <a:fillRef idx="3">
-            <a:schemeClr val="accent1"/>
-          </a:fillRef>
-          <a:effectRef idx="2">
-            <a:schemeClr val="accent1"/>
-          </a:effectRef>
-          <a:fontRef idx="minor">
-            <a:schemeClr val="lt1"/>
-          </a:fontRef>
-        </p:style>
-        <p:txBody>
-          <a:bodyPr rtlCol="0" anchor="ctr" lIns="45720" rIns="45720" tIns="18288" bIns="18288"/>
-          <a:lstStyle/>
-          <a:p>
-            <a:pPr algn="ctr"/>
             <a:r>
               <a:rPr sz="800" b="1">
                 <a:solidFill>
@@ -8191,7 +8147,7 @@
       </p:sp>
       <p:sp>
         <p:nvSpPr>
-          <p:cNvPr id="34" name="TextBox 33"/>
+          <p:cNvPr id="33" name="TextBox 32"/>
           <p:cNvSpPr txBox="1"/>
           <p:nvPr/>
         </p:nvSpPr>
@@ -8226,7 +8182,7 @@
       </p:sp>
       <p:sp>
         <p:nvSpPr>
-          <p:cNvPr id="35" name="Rectangle 34"/>
+          <p:cNvPr id="34" name="Rectangle 33"/>
           <p:cNvSpPr/>
           <p:nvPr/>
         </p:nvSpPr>
@@ -8270,7 +8226,7 @@
       </p:sp>
       <p:sp>
         <p:nvSpPr>
-          <p:cNvPr id="36" name="TextBox 35"/>
+          <p:cNvPr id="35" name="TextBox 34"/>
           <p:cNvSpPr txBox="1"/>
           <p:nvPr/>
         </p:nvSpPr>
@@ -8305,7 +8261,7 @@
       </p:sp>
       <p:sp>
         <p:nvSpPr>
-          <p:cNvPr id="37" name="TextBox 36"/>
+          <p:cNvPr id="36" name="TextBox 35"/>
           <p:cNvSpPr txBox="1"/>
           <p:nvPr/>
         </p:nvSpPr>
@@ -8340,7 +8296,7 @@
       </p:sp>
       <p:sp>
         <p:nvSpPr>
-          <p:cNvPr id="38" name="TextBox 37"/>
+          <p:cNvPr id="37" name="TextBox 36"/>
           <p:cNvSpPr txBox="1"/>
           <p:nvPr/>
         </p:nvSpPr>
@@ -8375,7 +8331,7 @@
       </p:sp>
       <p:sp>
         <p:nvSpPr>
-          <p:cNvPr id="39" name="Rounded Rectangle 38"/>
+          <p:cNvPr id="38" name="Rounded Rectangle 37"/>
           <p:cNvSpPr/>
           <p:nvPr/>
         </p:nvSpPr>
@@ -8429,7 +8385,7 @@
       </p:sp>
       <p:sp>
         <p:nvSpPr>
-          <p:cNvPr id="40" name="TextBox 39"/>
+          <p:cNvPr id="39" name="TextBox 38"/>
           <p:cNvSpPr txBox="1"/>
           <p:nvPr/>
         </p:nvSpPr>
@@ -8464,7 +8420,7 @@
       </p:sp>
       <p:sp>
         <p:nvSpPr>
-          <p:cNvPr id="41" name="Rectangle 40"/>
+          <p:cNvPr id="40" name="Rectangle 39"/>
           <p:cNvSpPr/>
           <p:nvPr/>
         </p:nvSpPr>
@@ -8508,7 +8464,7 @@
       </p:sp>
       <p:sp>
         <p:nvSpPr>
-          <p:cNvPr id="42" name="TextBox 41"/>
+          <p:cNvPr id="41" name="TextBox 40"/>
           <p:cNvSpPr txBox="1"/>
           <p:nvPr/>
         </p:nvSpPr>
@@ -8543,7 +8499,7 @@
       </p:sp>
       <p:sp>
         <p:nvSpPr>
-          <p:cNvPr id="43" name="TextBox 42"/>
+          <p:cNvPr id="42" name="TextBox 41"/>
           <p:cNvSpPr txBox="1"/>
           <p:nvPr/>
         </p:nvSpPr>
@@ -8578,7 +8534,7 @@
       </p:sp>
       <p:sp>
         <p:nvSpPr>
-          <p:cNvPr id="44" name="TextBox 43"/>
+          <p:cNvPr id="43" name="TextBox 42"/>
           <p:cNvSpPr txBox="1"/>
           <p:nvPr/>
         </p:nvSpPr>
@@ -8613,7 +8569,7 @@
       </p:sp>
       <p:sp>
         <p:nvSpPr>
-          <p:cNvPr id="45" name="Rounded Rectangle 44"/>
+          <p:cNvPr id="44" name="Rounded Rectangle 43"/>
           <p:cNvSpPr/>
           <p:nvPr/>
         </p:nvSpPr>
@@ -8667,7 +8623,7 @@
       </p:sp>
       <p:sp>
         <p:nvSpPr>
-          <p:cNvPr id="46" name="TextBox 45"/>
+          <p:cNvPr id="45" name="TextBox 44"/>
           <p:cNvSpPr txBox="1"/>
           <p:nvPr/>
         </p:nvSpPr>
@@ -8702,7 +8658,7 @@
       </p:sp>
       <p:sp>
         <p:nvSpPr>
-          <p:cNvPr id="47" name="Rectangle 46"/>
+          <p:cNvPr id="46" name="Rectangle 45"/>
           <p:cNvSpPr/>
           <p:nvPr/>
         </p:nvSpPr>
@@ -8746,7 +8702,7 @@
       </p:sp>
       <p:sp>
         <p:nvSpPr>
-          <p:cNvPr id="48" name="TextBox 47"/>
+          <p:cNvPr id="47" name="TextBox 46"/>
           <p:cNvSpPr txBox="1"/>
           <p:nvPr/>
         </p:nvSpPr>
@@ -8781,7 +8737,7 @@
       </p:sp>
       <p:sp>
         <p:nvSpPr>
-          <p:cNvPr id="49" name="TextBox 48"/>
+          <p:cNvPr id="48" name="TextBox 47"/>
           <p:cNvSpPr txBox="1"/>
           <p:nvPr/>
         </p:nvSpPr>
@@ -8816,7 +8772,7 @@
       </p:sp>
       <p:sp>
         <p:nvSpPr>
-          <p:cNvPr id="50" name="TextBox 49"/>
+          <p:cNvPr id="49" name="TextBox 48"/>
           <p:cNvSpPr txBox="1"/>
           <p:nvPr/>
         </p:nvSpPr>
@@ -8851,7 +8807,7 @@
       </p:sp>
       <p:sp>
         <p:nvSpPr>
-          <p:cNvPr id="51" name="Rounded Rectangle 50"/>
+          <p:cNvPr id="50" name="Rounded Rectangle 49"/>
           <p:cNvSpPr/>
           <p:nvPr/>
         </p:nvSpPr>
@@ -8905,7 +8861,7 @@
       </p:sp>
       <p:sp>
         <p:nvSpPr>
-          <p:cNvPr id="52" name="TextBox 51"/>
+          <p:cNvPr id="51" name="TextBox 50"/>
           <p:cNvSpPr txBox="1"/>
           <p:nvPr/>
         </p:nvSpPr>
@@ -8940,7 +8896,7 @@
       </p:sp>
       <p:sp>
         <p:nvSpPr>
-          <p:cNvPr id="53" name="Rectangle 52"/>
+          <p:cNvPr id="52" name="Rectangle 51"/>
           <p:cNvSpPr/>
           <p:nvPr/>
         </p:nvSpPr>
@@ -8984,7 +8940,7 @@
       </p:sp>
       <p:sp>
         <p:nvSpPr>
-          <p:cNvPr id="54" name="TextBox 53"/>
+          <p:cNvPr id="53" name="TextBox 52"/>
           <p:cNvSpPr txBox="1"/>
           <p:nvPr/>
         </p:nvSpPr>
@@ -9019,7 +8975,7 @@
       </p:sp>
       <p:sp>
         <p:nvSpPr>
-          <p:cNvPr id="55" name="TextBox 54"/>
+          <p:cNvPr id="54" name="TextBox 53"/>
           <p:cNvSpPr txBox="1"/>
           <p:nvPr/>
         </p:nvSpPr>
@@ -9054,7 +9010,7 @@
       </p:sp>
       <p:sp>
         <p:nvSpPr>
-          <p:cNvPr id="56" name="TextBox 55"/>
+          <p:cNvPr id="55" name="TextBox 54"/>
           <p:cNvSpPr txBox="1"/>
           <p:nvPr/>
         </p:nvSpPr>
@@ -9089,7 +9045,7 @@
       </p:sp>
       <p:sp>
         <p:nvSpPr>
-          <p:cNvPr id="57" name="Rounded Rectangle 56"/>
+          <p:cNvPr id="56" name="Rounded Rectangle 55"/>
           <p:cNvSpPr/>
           <p:nvPr/>
         </p:nvSpPr>
@@ -9143,7 +9099,7 @@
       </p:sp>
       <p:sp>
         <p:nvSpPr>
-          <p:cNvPr id="58" name="TextBox 57"/>
+          <p:cNvPr id="57" name="TextBox 56"/>
           <p:cNvSpPr txBox="1"/>
           <p:nvPr/>
         </p:nvSpPr>
@@ -9178,7 +9134,7 @@
       </p:sp>
       <p:sp>
         <p:nvSpPr>
-          <p:cNvPr id="59" name="Rectangle 58"/>
+          <p:cNvPr id="58" name="Rectangle 57"/>
           <p:cNvSpPr/>
           <p:nvPr/>
         </p:nvSpPr>
@@ -9222,7 +9178,7 @@
       </p:sp>
       <p:sp>
         <p:nvSpPr>
-          <p:cNvPr id="60" name="TextBox 59"/>
+          <p:cNvPr id="59" name="TextBox 58"/>
           <p:cNvSpPr txBox="1"/>
           <p:nvPr/>
         </p:nvSpPr>
@@ -9257,7 +9213,7 @@
       </p:sp>
       <p:sp>
         <p:nvSpPr>
-          <p:cNvPr id="61" name="TextBox 60"/>
+          <p:cNvPr id="60" name="TextBox 59"/>
           <p:cNvSpPr txBox="1"/>
           <p:nvPr/>
         </p:nvSpPr>
@@ -9292,7 +9248,7 @@
       </p:sp>
       <p:sp>
         <p:nvSpPr>
-          <p:cNvPr id="62" name="TextBox 61"/>
+          <p:cNvPr id="61" name="TextBox 60"/>
           <p:cNvSpPr txBox="1"/>
           <p:nvPr/>
         </p:nvSpPr>
@@ -9327,7 +9283,7 @@
       </p:sp>
       <p:sp>
         <p:nvSpPr>
-          <p:cNvPr id="63" name="Rounded Rectangle 62"/>
+          <p:cNvPr id="62" name="Rounded Rectangle 61"/>
           <p:cNvSpPr/>
           <p:nvPr/>
         </p:nvSpPr>
@@ -9381,7 +9337,7 @@
       </p:sp>
       <p:sp>
         <p:nvSpPr>
-          <p:cNvPr id="64" name="TextBox 63"/>
+          <p:cNvPr id="63" name="TextBox 62"/>
           <p:cNvSpPr txBox="1"/>
           <p:nvPr/>
         </p:nvSpPr>
@@ -9416,7 +9372,7 @@
       </p:sp>
       <p:sp>
         <p:nvSpPr>
-          <p:cNvPr id="65" name="Rectangle 64"/>
+          <p:cNvPr id="64" name="Rectangle 63"/>
           <p:cNvSpPr/>
           <p:nvPr/>
         </p:nvSpPr>
@@ -9460,7 +9416,7 @@
       </p:sp>
       <p:sp>
         <p:nvSpPr>
-          <p:cNvPr id="66" name="TextBox 65"/>
+          <p:cNvPr id="65" name="TextBox 64"/>
           <p:cNvSpPr txBox="1"/>
           <p:nvPr/>
         </p:nvSpPr>
@@ -9495,7 +9451,7 @@
       </p:sp>
       <p:sp>
         <p:nvSpPr>
-          <p:cNvPr id="67" name="TextBox 66"/>
+          <p:cNvPr id="66" name="TextBox 65"/>
           <p:cNvSpPr txBox="1"/>
           <p:nvPr/>
         </p:nvSpPr>
@@ -9530,7 +9486,7 @@
       </p:sp>
       <p:sp>
         <p:nvSpPr>
-          <p:cNvPr id="68" name="TextBox 67"/>
+          <p:cNvPr id="67" name="TextBox 66"/>
           <p:cNvSpPr txBox="1"/>
           <p:nvPr/>
         </p:nvSpPr>
@@ -9565,7 +9521,7 @@
       </p:sp>
       <p:sp>
         <p:nvSpPr>
-          <p:cNvPr id="69" name="Rounded Rectangle 68"/>
+          <p:cNvPr id="68" name="Rounded Rectangle 67"/>
           <p:cNvSpPr/>
           <p:nvPr/>
         </p:nvSpPr>
@@ -9619,7 +9575,7 @@
       </p:sp>
       <p:sp>
         <p:nvSpPr>
-          <p:cNvPr id="70" name="TextBox 69"/>
+          <p:cNvPr id="69" name="TextBox 68"/>
           <p:cNvSpPr txBox="1"/>
           <p:nvPr/>
         </p:nvSpPr>
@@ -9654,7 +9610,7 @@
       </p:sp>
       <p:sp>
         <p:nvSpPr>
-          <p:cNvPr id="71" name="Rectangle 70"/>
+          <p:cNvPr id="70" name="Rectangle 69"/>
           <p:cNvSpPr/>
           <p:nvPr/>
         </p:nvSpPr>
@@ -9698,7 +9654,7 @@
       </p:sp>
       <p:sp>
         <p:nvSpPr>
-          <p:cNvPr id="72" name="TextBox 71"/>
+          <p:cNvPr id="71" name="TextBox 70"/>
           <p:cNvSpPr txBox="1"/>
           <p:nvPr/>
         </p:nvSpPr>
@@ -9733,7 +9689,7 @@
       </p:sp>
       <p:sp>
         <p:nvSpPr>
-          <p:cNvPr id="73" name="TextBox 72"/>
+          <p:cNvPr id="72" name="TextBox 71"/>
           <p:cNvSpPr txBox="1"/>
           <p:nvPr/>
         </p:nvSpPr>
@@ -9768,7 +9724,7 @@
       </p:sp>
       <p:sp>
         <p:nvSpPr>
-          <p:cNvPr id="74" name="TextBox 73"/>
+          <p:cNvPr id="73" name="TextBox 72"/>
           <p:cNvSpPr txBox="1"/>
           <p:nvPr/>
         </p:nvSpPr>
@@ -9803,7 +9759,7 @@
       </p:sp>
       <p:sp>
         <p:nvSpPr>
-          <p:cNvPr id="75" name="Rounded Rectangle 74"/>
+          <p:cNvPr id="74" name="Rounded Rectangle 73"/>
           <p:cNvSpPr/>
           <p:nvPr/>
         </p:nvSpPr>
@@ -9857,7 +9813,7 @@
       </p:sp>
       <p:sp>
         <p:nvSpPr>
-          <p:cNvPr id="76" name="TextBox 75"/>
+          <p:cNvPr id="75" name="TextBox 74"/>
           <p:cNvSpPr txBox="1"/>
           <p:nvPr/>
         </p:nvSpPr>
@@ -9892,7 +9848,7 @@
       </p:sp>
       <p:sp>
         <p:nvSpPr>
-          <p:cNvPr id="77" name="Rounded Rectangle 76"/>
+          <p:cNvPr id="76" name="Rounded Rectangle 75"/>
           <p:cNvSpPr/>
           <p:nvPr/>
         </p:nvSpPr>
@@ -9938,48 +9894,48 @@
       </p:sp>
       <p:sp>
         <p:nvSpPr>
+          <p:cNvPr id="77" name="TextBox 76"/>
+          <p:cNvSpPr txBox="1"/>
+          <p:nvPr/>
+        </p:nvSpPr>
+        <p:spPr>
+          <a:xfrm>
+            <a:off x="640080" y="6126480"/>
+            <a:ext cx="10972800" cy="256032"/>
+          </a:xfrm>
+          <a:prstGeom prst="rect">
+            <a:avLst/>
+          </a:prstGeom>
+          <a:noFill/>
+        </p:spPr>
+        <p:txBody>
+          <a:bodyPr wrap="square" anchor="t" lIns="0" rIns="0" tIns="0" bIns="0">
+            <a:spAutoFit/>
+          </a:bodyPr>
+          <a:lstStyle/>
+          <a:p>
+            <a:pPr algn="l"/>
+            <a:r>
+              <a:rPr sz="1200" b="1">
+                <a:solidFill>
+                  <a:srgbClr val="FFFFFF"/>
+                </a:solidFill>
+                <a:latin typeface="Open Sans"/>
+              </a:rPr>
+              <a:t>Top 10 customer states cover ~65% of the SmartCredit base (288,065 of 443,206).</a:t>
+            </a:r>
+          </a:p>
+        </p:txBody>
+      </p:sp>
+      <p:sp>
+        <p:nvSpPr>
           <p:cNvPr id="78" name="TextBox 77"/>
           <p:cNvSpPr txBox="1"/>
           <p:nvPr/>
         </p:nvSpPr>
         <p:spPr>
           <a:xfrm>
-            <a:off x="640080" y="6144768"/>
-            <a:ext cx="10972800" cy="292608"/>
-          </a:xfrm>
-          <a:prstGeom prst="rect">
-            <a:avLst/>
-          </a:prstGeom>
-          <a:noFill/>
-        </p:spPr>
-        <p:txBody>
-          <a:bodyPr wrap="square" anchor="t" lIns="0" rIns="0" tIns="0" bIns="0">
-            <a:spAutoFit/>
-          </a:bodyPr>
-          <a:lstStyle/>
-          <a:p>
-            <a:pPr algn="l"/>
-            <a:r>
-              <a:rPr sz="1200" b="1">
-                <a:solidFill>
-                  <a:srgbClr val="FFFFFF"/>
-                </a:solidFill>
-                <a:latin typeface="Open Sans"/>
-              </a:rPr>
-              <a:t>Top 10 customer states cover ~65% of the SmartCredit base (288,065 of 443,206).</a:t>
-            </a:r>
-          </a:p>
-        </p:txBody>
-      </p:sp>
-      <p:sp>
-        <p:nvSpPr>
-          <p:cNvPr id="79" name="TextBox 78"/>
-          <p:cNvSpPr txBox="1"/>
-          <p:nvPr/>
-        </p:nvSpPr>
-        <p:spPr>
-          <a:xfrm>
-            <a:off x="640080" y="6400800"/>
+            <a:off x="640080" y="6355080"/>
             <a:ext cx="10972800" cy="201168"/>
           </a:xfrm>
           <a:prstGeom prst="rect">
@@ -10001,7 +9957,7 @@
                 </a:solidFill>
                 <a:latin typeface="Open Sans"/>
               </a:rPr>
-              <a:t>CA is the only top-10 state with a confirmed public bulk feed. Sprint 2 begins TX + NY data requests and GA CDR registration; bulk availability depends on state approval, terms, and legal sign-off.</a:t>
+              <a:t>CA is the only top-10 state with a confirmed public bulk feed; Sprint 2 opens TX, NY, and GA pending state approval.</a:t>
             </a:r>
           </a:p>
         </p:txBody>

</xml_diff>

<commit_message>
Slide 5 — switch to SC Net Actives by State.csv (Apr 2026)
Authoritative source for active member counts. Updates:

- Total cohort: 443,206 → 297,096 (net actives, narrower definition)
- Top-10 share:  ~65% → ~68% (201,829 of 297,096)
- All 10 row counts updated; NJ now ranks #8 above PA at #9

Co-Authored-By: Claude Opus 4.7 (1M context) <noreply@anthropic.com>
</commit_message>
<xml_diff>
--- a/myReclaim-Exec-Deck.pptx
+++ b/myReclaim-Exec-Deck.pptx
@@ -7242,7 +7242,7 @@
                 </a:solidFill>
                 <a:latin typeface="Open Sans"/>
               </a:rPr>
-              <a:t>Top 10 customer states cover ~65% of the SmartCredit base (288,065 of 443,206). Four of the top five (FL, TX, GA, NY) need a state agreement before we can ingest at scale. CA is the only top-10 state with a clean public bulk feed — that's where the prototype starts.</a:t>
+              <a:t>Top 10 customer states cover ~68% of SmartCredit net actives (201,829 of 297,096). Four of the top five (FL, TX, GA, NY) need a state agreement before we can ingest at scale. CA is the only top-10 state with a clean public bulk feed — that's where the prototype starts.</a:t>
             </a:r>
           </a:p>
         </p:txBody>
@@ -7610,7 +7610,7 @@
                 </a:solidFill>
                 <a:latin typeface="Open Sans"/>
               </a:rPr>
-              <a:t>65,400</a:t>
+              <a:t>48,436</a:t>
             </a:r>
           </a:p>
         </p:txBody>
@@ -7848,7 +7848,7 @@
                 </a:solidFill>
                 <a:latin typeface="Open Sans"/>
               </a:rPr>
-              <a:t>61,414</a:t>
+              <a:t>45,670</a:t>
             </a:r>
           </a:p>
         </p:txBody>
@@ -8086,7 +8086,7 @@
                 </a:solidFill>
                 <a:latin typeface="Open Sans"/>
               </a:rPr>
-              <a:t>44,222</a:t>
+              <a:t>31,110</a:t>
             </a:r>
           </a:p>
         </p:txBody>
@@ -8324,7 +8324,7 @@
                 </a:solidFill>
                 <a:latin typeface="Open Sans"/>
               </a:rPr>
-              <a:t>29,566</a:t>
+              <a:t>18,837</a:t>
             </a:r>
           </a:p>
         </p:txBody>
@@ -8562,7 +8562,7 @@
                 </a:solidFill>
                 <a:latin typeface="Open Sans"/>
               </a:rPr>
-              <a:t>22,137</a:t>
+              <a:t>15,001</a:t>
             </a:r>
           </a:p>
         </p:txBody>
@@ -8800,7 +8800,7 @@
                 </a:solidFill>
                 <a:latin typeface="Open Sans"/>
               </a:rPr>
-              <a:t>16,242</a:t>
+              <a:t>10,536</a:t>
             </a:r>
           </a:p>
         </p:txBody>
@@ -9038,7 +9038,7 @@
                 </a:solidFill>
                 <a:latin typeface="Open Sans"/>
               </a:rPr>
-              <a:t>14,404</a:t>
+              <a:t>9,549</a:t>
             </a:r>
           </a:p>
         </p:txBody>
@@ -9241,7 +9241,7 @@
                 </a:solidFill>
                 <a:latin typeface="Open Sans"/>
               </a:rPr>
-              <a:t>PA</a:t>
+              <a:t>NJ</a:t>
             </a:r>
           </a:p>
         </p:txBody>
@@ -9276,7 +9276,7 @@
                 </a:solidFill>
                 <a:latin typeface="Open Sans"/>
               </a:rPr>
-              <a:t>12,290</a:t>
+              <a:t>8,526</a:t>
             </a:r>
           </a:p>
         </p:txBody>
@@ -9479,7 +9479,7 @@
                 </a:solidFill>
                 <a:latin typeface="Open Sans"/>
               </a:rPr>
-              <a:t>NJ</a:t>
+              <a:t>PA</a:t>
             </a:r>
           </a:p>
         </p:txBody>
@@ -9514,7 +9514,7 @@
                 </a:solidFill>
                 <a:latin typeface="Open Sans"/>
               </a:rPr>
-              <a:t>11,856</a:t>
+              <a:t>8,172</a:t>
             </a:r>
           </a:p>
         </p:txBody>
@@ -9752,7 +9752,7 @@
                 </a:solidFill>
                 <a:latin typeface="Open Sans"/>
               </a:rPr>
-              <a:t>10,534</a:t>
+              <a:t>5,992</a:t>
             </a:r>
           </a:p>
         </p:txBody>
@@ -9922,7 +9922,7 @@
                 </a:solidFill>
                 <a:latin typeface="Open Sans"/>
               </a:rPr>
-              <a:t>Top 10 customer states cover ~65% of the SmartCredit base (288,065 of 443,206).</a:t>
+              <a:t>Top 10 customer states cover ~68% of SmartCredit net actives (201,829 of 297,096).</a:t>
             </a:r>
           </a:p>
         </p:txBody>

</xml_diff>

<commit_message>
Slides 6 & 7 — switch to "net actives CA · SmartCredit" cohort label
Use the slide-5 net-actives denominator (31,110) consistently across
the deck. Trim technical sub-headlines to a single line:

  Slide 6: "Matching on name only."
  Slide 7: "Matching on name and city."

Match rates recomputed against the 31,110 cohort:
  Slide 6: 74.9% (vs 30,931) → 74.5% (vs 31,110)
  Slide 7: 38.7% (vs 30,931) → 38.4% (vs 31,110)

Also fix stale "21,864" caption on slide 6 → 23,166.

Co-Authored-By: Claude Opus 4.7 (1M context) <noreply@anthropic.com>
</commit_message>
<xml_diff>
--- a/myReclaim-Exec-Deck.pptx
+++ b/myReclaim-Exec-Deck.pptx
@@ -12358,7 +12358,7 @@
                 </a:solidFill>
                 <a:latin typeface="Open Sans"/>
               </a:rPr>
-              <a:t>We matched 30,931 active CA customers against all four CA unclaimed tiers (92.4M records).</a:t>
+              <a:t>We matched 31,110 net actives CA · SmartCredit against all four CA unclaimed tiers (92.4M records).</a:t>
             </a:r>
           </a:p>
         </p:txBody>
@@ -12393,7 +12393,7 @@
                 </a:solidFill>
                 <a:latin typeface="Open Sans"/>
               </a:rPr>
-              <a:t>Cohort: active SmartCredit customers (customerproductid=4, non-test) — 30,931 of the 44,222 total CA base. Customer-level counts via CUSTOMERTOKEN. Method: exact LAST FIRST match (CA's storage convention). State determines actual eligibility per record.</a:t>
+              <a:t>Matching on name only.</a:t>
             </a:r>
           </a:p>
         </p:txBody>
@@ -12682,7 +12682,7 @@
                 </a:solidFill>
                 <a:latin typeface="Open Sans"/>
               </a:rPr>
-              <a:t>74.9%</a:t>
+              <a:t>74.5%</a:t>
             </a:r>
           </a:p>
         </p:txBody>
@@ -12717,7 +12717,7 @@
                 </a:solidFill>
                 <a:latin typeface="Open Sans"/>
               </a:rPr>
-              <a:t>of the 30,931 active CA customers</a:t>
+              <a:t>of 31,110 net actives CA · SmartCredit</a:t>
             </a:r>
           </a:p>
         </p:txBody>
@@ -14276,7 +14276,7 @@
                 </a:solidFill>
                 <a:latin typeface="Open Sans"/>
               </a:rPr>
-              <a:t>Each customer placed in one bucket based on the SUM of their matched records. Customers add up to 21,864.</a:t>
+              <a:t>Each customer placed in one bucket based on the SUM of their matched records. Customers add up to 23,166.</a:t>
             </a:r>
           </a:p>
         </p:txBody>
@@ -15558,7 +15558,7 @@
                 </a:solidFill>
                 <a:latin typeface="Open Sans"/>
               </a:rPr>
-              <a:t>Adding city to the join key cuts common-name collisions — the conservative view of who really has property.</a:t>
+              <a:t>We matched 31,110 net actives CA · SmartCredit against all four CA unclaimed tiers (92.4M records).</a:t>
             </a:r>
           </a:p>
         </p:txBody>
@@ -15593,7 +15593,7 @@
                 </a:solidFill>
                 <a:latin typeface="Open Sans"/>
               </a:rPr>
-              <a:t>Same cohort (30,931 active CA customers, customertoken-aware). Match key now: LAST FIRST + last_known_city. Filters customers without a stored city; CA's last_known_city populated on 96% of records.</a:t>
+              <a:t>Matching on name and city.</a:t>
             </a:r>
           </a:p>
         </p:txBody>
@@ -15882,7 +15882,7 @@
                 </a:solidFill>
                 <a:latin typeface="Open Sans"/>
               </a:rPr>
-              <a:t>38.7%</a:t>
+              <a:t>38.4%</a:t>
             </a:r>
           </a:p>
         </p:txBody>
@@ -15917,7 +15917,7 @@
                 </a:solidFill>
                 <a:latin typeface="Open Sans"/>
               </a:rPr>
-              <a:t>of the 30,931 active CA customers</a:t>
+              <a:t>of 31,110 net actives CA · SmartCredit</a:t>
             </a:r>
           </a:p>
         </p:txBody>

</xml_diff>

<commit_message>
Slide 2 — lead with definition, not the dollar figure
Audience needs to understand what unclaimed property *is* before
seeing the size. New structure:

- Eyebrow: WHAT IS UNCLAIMED PROPERTY?
- Hero: plain-English definition ("Money owed to you that the
  company holding it lost track of.")
- Sub: dormancy → state turnover mechanic
- 4 example tiles: bank accounts, paychecks, refunds, investments
- $70B / 33M moved to a small footer callout (scale anchor, not
  the lede)

Co-Authored-By: Claude Opus 4.7 (1M context) <noreply@anthropic.com>
</commit_message>
<xml_diff>
--- a/myReclaim-Exec-Deck.pptx
+++ b/myReclaim-Exec-Deck.pptx
@@ -5853,7 +5853,7 @@
                 </a:solidFill>
                 <a:latin typeface="Open Sans"/>
               </a:rPr>
-              <a:t>THE OPPORTUNITY</a:t>
+              <a:t>WHAT IS UNCLAIMED PROPERTY?</a:t>
             </a:r>
           </a:p>
         </p:txBody>
@@ -5866,78 +5866,113 @@
         </p:nvSpPr>
         <p:spPr>
           <a:xfrm>
-            <a:off x="457200" y="1280160"/>
-            <a:ext cx="11430000" cy="2286000"/>
-          </a:xfrm>
-          <a:prstGeom prst="rect">
-            <a:avLst/>
-          </a:prstGeom>
-          <a:noFill/>
-        </p:spPr>
-        <p:txBody>
-          <a:bodyPr wrap="square" anchor="t" lIns="0" rIns="0" tIns="0" bIns="0">
-            <a:spAutoFit/>
-          </a:bodyPr>
-          <a:lstStyle/>
-          <a:p>
-            <a:pPr algn="l"/>
-            <a:r>
-              <a:rPr sz="16000" b="1">
+            <a:off x="457200" y="1188720"/>
+            <a:ext cx="11430000" cy="1097280"/>
+          </a:xfrm>
+          <a:prstGeom prst="rect">
+            <a:avLst/>
+          </a:prstGeom>
+          <a:noFill/>
+        </p:spPr>
+        <p:txBody>
+          <a:bodyPr wrap="square" anchor="t" lIns="0" rIns="0" tIns="0" bIns="0">
+            <a:spAutoFit/>
+          </a:bodyPr>
+          <a:lstStyle/>
+          <a:p>
+            <a:pPr algn="l"/>
+            <a:r>
+              <a:rPr sz="3400" b="1">
+                <a:solidFill>
+                  <a:srgbClr val="0F172A"/>
+                </a:solidFill>
+                <a:latin typeface="Open Sans"/>
+              </a:rPr>
+              <a:t>Money owed to you that the company holding it lost track of.</a:t>
+            </a:r>
+          </a:p>
+        </p:txBody>
+      </p:sp>
+      <p:sp>
+        <p:nvSpPr>
+          <p:cNvPr id="9" name="TextBox 8"/>
+          <p:cNvSpPr txBox="1"/>
+          <p:nvPr/>
+        </p:nvSpPr>
+        <p:spPr>
+          <a:xfrm>
+            <a:off x="457200" y="2377440"/>
+            <a:ext cx="11430000" cy="1005840"/>
+          </a:xfrm>
+          <a:prstGeom prst="rect">
+            <a:avLst/>
+          </a:prstGeom>
+          <a:noFill/>
+        </p:spPr>
+        <p:txBody>
+          <a:bodyPr wrap="square" anchor="t" lIns="0" rIns="0" tIns="0" bIns="0">
+            <a:spAutoFit/>
+          </a:bodyPr>
+          <a:lstStyle/>
+          <a:p>
+            <a:pPr algn="l"/>
+            <a:r>
+              <a:rPr sz="1500" b="0">
+                <a:solidFill>
+                  <a:srgbClr val="334155"/>
+                </a:solidFill>
+                <a:latin typeface="Open Sans"/>
+              </a:rPr>
+              <a:t>When a bank, employer, insurer, or utility can't reach the owner of an account or balance for a set period (typically 1–3 years), state law requires them to turn it over to the state. It sits there — in the owner's name — until someone claims it.</a:t>
+            </a:r>
+          </a:p>
+        </p:txBody>
+      </p:sp>
+      <p:sp>
+        <p:nvSpPr>
+          <p:cNvPr id="10" name="TextBox 9"/>
+          <p:cNvSpPr txBox="1"/>
+          <p:nvPr/>
+        </p:nvSpPr>
+        <p:spPr>
+          <a:xfrm>
+            <a:off x="457200" y="3657600"/>
+            <a:ext cx="11430000" cy="274320"/>
+          </a:xfrm>
+          <a:prstGeom prst="rect">
+            <a:avLst/>
+          </a:prstGeom>
+          <a:noFill/>
+        </p:spPr>
+        <p:txBody>
+          <a:bodyPr wrap="square" anchor="t" lIns="0" rIns="0" tIns="0" bIns="0">
+            <a:spAutoFit/>
+          </a:bodyPr>
+          <a:lstStyle/>
+          <a:p>
+            <a:pPr algn="l"/>
+            <a:r>
+              <a:rPr sz="1000" b="1">
                 <a:solidFill>
                   <a:srgbClr val="2863C5"/>
                 </a:solidFill>
                 <a:latin typeface="Open Sans"/>
               </a:rPr>
-              <a:t>$70B+</a:t>
-            </a:r>
-          </a:p>
-        </p:txBody>
-      </p:sp>
-      <p:sp>
-        <p:nvSpPr>
-          <p:cNvPr id="9" name="TextBox 8"/>
-          <p:cNvSpPr txBox="1"/>
-          <p:nvPr/>
-        </p:nvSpPr>
-        <p:spPr>
-          <a:xfrm>
-            <a:off x="457200" y="3657600"/>
-            <a:ext cx="11430000" cy="640080"/>
-          </a:xfrm>
-          <a:prstGeom prst="rect">
-            <a:avLst/>
-          </a:prstGeom>
-          <a:noFill/>
-        </p:spPr>
-        <p:txBody>
-          <a:bodyPr wrap="square" anchor="t" lIns="0" rIns="0" tIns="0" bIns="0">
-            <a:spAutoFit/>
-          </a:bodyPr>
-          <a:lstStyle/>
-          <a:p>
-            <a:pPr algn="l"/>
-            <a:r>
-              <a:rPr sz="2400" b="1">
-                <a:solidFill>
-                  <a:srgbClr val="0F172A"/>
-                </a:solidFill>
-                <a:latin typeface="Open Sans"/>
-              </a:rPr>
-              <a:t>estimated in unclaimed property nationwide. Some of it is reported in our members' names.</a:t>
-            </a:r>
-          </a:p>
-        </p:txBody>
-      </p:sp>
-      <p:sp>
-        <p:nvSpPr>
-          <p:cNvPr id="10" name="Rounded Rectangle 9"/>
+              <a:t>COMMON SOURCES</a:t>
+            </a:r>
+          </a:p>
+        </p:txBody>
+      </p:sp>
+      <p:sp>
+        <p:nvSpPr>
+          <p:cNvPr id="11" name="Rounded Rectangle 10"/>
           <p:cNvSpPr/>
           <p:nvPr/>
         </p:nvSpPr>
         <p:spPr>
           <a:xfrm>
-            <a:off x="457200" y="4846320"/>
-            <a:ext cx="3657600" cy="1280160"/>
+            <a:off x="457200" y="4023360"/>
+            <a:ext cx="2743200" cy="1143000"/>
           </a:xfrm>
           <a:prstGeom prst="roundRect">
             <a:avLst>
@@ -5978,84 +6013,128 @@
       </p:sp>
       <p:sp>
         <p:nvSpPr>
-          <p:cNvPr id="11" name="TextBox 10"/>
-          <p:cNvSpPr txBox="1"/>
-          <p:nvPr/>
-        </p:nvSpPr>
-        <p:spPr>
-          <a:xfrm>
-            <a:off x="731520" y="5010912"/>
-            <a:ext cx="3108960" cy="640080"/>
-          </a:xfrm>
-          <a:prstGeom prst="rect">
-            <a:avLst/>
-          </a:prstGeom>
-          <a:noFill/>
-        </p:spPr>
-        <p:txBody>
-          <a:bodyPr wrap="square" anchor="t" lIns="0" rIns="0" tIns="0" bIns="0">
-            <a:spAutoFit/>
-          </a:bodyPr>
-          <a:lstStyle/>
-          <a:p>
-            <a:pPr algn="l"/>
-            <a:r>
-              <a:rPr sz="3600" b="1">
-                <a:solidFill>
-                  <a:srgbClr val="FC4C0B"/>
-                </a:solidFill>
-                <a:latin typeface="Open Sans"/>
-              </a:rPr>
-              <a:t>~33M</a:t>
-            </a:r>
-          </a:p>
-        </p:txBody>
-      </p:sp>
-      <p:sp>
-        <p:nvSpPr>
-          <p:cNvPr id="12" name="TextBox 11"/>
-          <p:cNvSpPr txBox="1"/>
-          <p:nvPr/>
-        </p:nvSpPr>
-        <p:spPr>
-          <a:xfrm>
-            <a:off x="731520" y="5623559"/>
-            <a:ext cx="3108960" cy="457200"/>
-          </a:xfrm>
-          <a:prstGeom prst="rect">
-            <a:avLst/>
-          </a:prstGeom>
-          <a:noFill/>
-        </p:spPr>
-        <p:txBody>
-          <a:bodyPr wrap="square" anchor="t" lIns="0" rIns="0" tIns="0" bIns="0">
-            <a:spAutoFit/>
-          </a:bodyPr>
-          <a:lstStyle/>
-          <a:p>
-            <a:pPr algn="l"/>
-            <a:r>
-              <a:rPr sz="1200" b="0">
+          <p:cNvPr id="12" name="Rectangle 11"/>
+          <p:cNvSpPr/>
+          <p:nvPr/>
+        </p:nvSpPr>
+        <p:spPr>
+          <a:xfrm>
+            <a:off x="457200" y="4023360"/>
+            <a:ext cx="2743200" cy="73152"/>
+          </a:xfrm>
+          <a:prstGeom prst="rect">
+            <a:avLst/>
+          </a:prstGeom>
+          <a:solidFill>
+            <a:srgbClr val="2863C5"/>
+          </a:solidFill>
+          <a:ln>
+            <a:noFill/>
+          </a:ln>
+          <a:effectLst/>
+        </p:spPr>
+        <p:style>
+          <a:lnRef idx="1">
+            <a:schemeClr val="accent1"/>
+          </a:lnRef>
+          <a:fillRef idx="3">
+            <a:schemeClr val="accent1"/>
+          </a:fillRef>
+          <a:effectRef idx="2">
+            <a:schemeClr val="accent1"/>
+          </a:effectRef>
+          <a:fontRef idx="minor">
+            <a:schemeClr val="lt1"/>
+          </a:fontRef>
+        </p:style>
+        <p:txBody>
+          <a:bodyPr rtlCol="0" anchor="ctr"/>
+          <a:lstStyle/>
+          <a:p>
+            <a:pPr algn="ctr"/>
+          </a:p>
+        </p:txBody>
+      </p:sp>
+      <p:sp>
+        <p:nvSpPr>
+          <p:cNvPr id="13" name="TextBox 12"/>
+          <p:cNvSpPr txBox="1"/>
+          <p:nvPr/>
+        </p:nvSpPr>
+        <p:spPr>
+          <a:xfrm>
+            <a:off x="685800" y="4224528"/>
+            <a:ext cx="2286000" cy="320040"/>
+          </a:xfrm>
+          <a:prstGeom prst="rect">
+            <a:avLst/>
+          </a:prstGeom>
+          <a:noFill/>
+        </p:spPr>
+        <p:txBody>
+          <a:bodyPr wrap="square" anchor="t" lIns="0" rIns="0" tIns="0" bIns="0">
+            <a:spAutoFit/>
+          </a:bodyPr>
+          <a:lstStyle/>
+          <a:p>
+            <a:pPr algn="l"/>
+            <a:r>
+              <a:rPr sz="1400" b="1">
+                <a:solidFill>
+                  <a:srgbClr val="0F172A"/>
+                </a:solidFill>
+                <a:latin typeface="Open Sans"/>
+              </a:rPr>
+              <a:t>Bank accounts</a:t>
+            </a:r>
+          </a:p>
+        </p:txBody>
+      </p:sp>
+      <p:sp>
+        <p:nvSpPr>
+          <p:cNvPr id="14" name="TextBox 13"/>
+          <p:cNvSpPr txBox="1"/>
+          <p:nvPr/>
+        </p:nvSpPr>
+        <p:spPr>
+          <a:xfrm>
+            <a:off x="685800" y="4590288"/>
+            <a:ext cx="2286000" cy="502920"/>
+          </a:xfrm>
+          <a:prstGeom prst="rect">
+            <a:avLst/>
+          </a:prstGeom>
+          <a:noFill/>
+        </p:spPr>
+        <p:txBody>
+          <a:bodyPr wrap="square" anchor="t" lIns="0" rIns="0" tIns="0" bIns="0">
+            <a:spAutoFit/>
+          </a:bodyPr>
+          <a:lstStyle/>
+          <a:p>
+            <a:pPr algn="l"/>
+            <a:r>
+              <a:rPr sz="1100" b="0">
                 <a:solidFill>
                   <a:srgbClr val="334155"/>
                 </a:solidFill>
                 <a:latin typeface="Open Sans"/>
               </a:rPr>
-              <a:t>people may have property waiting to be claimed (NAUPA)</a:t>
-            </a:r>
-          </a:p>
-        </p:txBody>
-      </p:sp>
-      <p:sp>
-        <p:nvSpPr>
-          <p:cNvPr id="13" name="Rounded Rectangle 12"/>
+              <a:t>Dormant savings, checking, CDs</a:t>
+            </a:r>
+          </a:p>
+        </p:txBody>
+      </p:sp>
+      <p:sp>
+        <p:nvSpPr>
+          <p:cNvPr id="15" name="Rounded Rectangle 14"/>
           <p:cNvSpPr/>
           <p:nvPr/>
         </p:nvSpPr>
         <p:spPr>
           <a:xfrm>
-            <a:off x="4251960" y="4846320"/>
-            <a:ext cx="3657600" cy="1280160"/>
+            <a:off x="3319272" y="4023360"/>
+            <a:ext cx="2743200" cy="1143000"/>
           </a:xfrm>
           <a:prstGeom prst="roundRect">
             <a:avLst>
@@ -6096,84 +6175,128 @@
       </p:sp>
       <p:sp>
         <p:nvSpPr>
-          <p:cNvPr id="14" name="TextBox 13"/>
-          <p:cNvSpPr txBox="1"/>
-          <p:nvPr/>
-        </p:nvSpPr>
-        <p:spPr>
-          <a:xfrm>
-            <a:off x="4526280" y="5010912"/>
-            <a:ext cx="3108960" cy="640080"/>
-          </a:xfrm>
-          <a:prstGeom prst="rect">
-            <a:avLst/>
-          </a:prstGeom>
-          <a:noFill/>
-        </p:spPr>
-        <p:txBody>
-          <a:bodyPr wrap="square" anchor="t" lIns="0" rIns="0" tIns="0" bIns="0">
-            <a:spAutoFit/>
-          </a:bodyPr>
-          <a:lstStyle/>
-          <a:p>
-            <a:pPr algn="l"/>
-            <a:r>
-              <a:rPr sz="3600" b="1">
-                <a:solidFill>
-                  <a:srgbClr val="FC4C0B"/>
-                </a:solidFill>
-                <a:latin typeface="Open Sans"/>
-              </a:rPr>
-              <a:t>$2,080</a:t>
-            </a:r>
-          </a:p>
-        </p:txBody>
-      </p:sp>
-      <p:sp>
-        <p:nvSpPr>
-          <p:cNvPr id="15" name="TextBox 14"/>
-          <p:cNvSpPr txBox="1"/>
-          <p:nvPr/>
-        </p:nvSpPr>
-        <p:spPr>
-          <a:xfrm>
-            <a:off x="4526280" y="5623559"/>
-            <a:ext cx="3108960" cy="457200"/>
-          </a:xfrm>
-          <a:prstGeom prst="rect">
-            <a:avLst/>
-          </a:prstGeom>
-          <a:noFill/>
-        </p:spPr>
-        <p:txBody>
-          <a:bodyPr wrap="square" anchor="t" lIns="0" rIns="0" tIns="0" bIns="0">
-            <a:spAutoFit/>
-          </a:bodyPr>
-          <a:lstStyle/>
-          <a:p>
-            <a:pPr algn="l"/>
-            <a:r>
-              <a:rPr sz="1200" b="0">
+          <p:cNvPr id="16" name="Rectangle 15"/>
+          <p:cNvSpPr/>
+          <p:nvPr/>
+        </p:nvSpPr>
+        <p:spPr>
+          <a:xfrm>
+            <a:off x="3319272" y="4023360"/>
+            <a:ext cx="2743200" cy="73152"/>
+          </a:xfrm>
+          <a:prstGeom prst="rect">
+            <a:avLst/>
+          </a:prstGeom>
+          <a:solidFill>
+            <a:srgbClr val="2863C5"/>
+          </a:solidFill>
+          <a:ln>
+            <a:noFill/>
+          </a:ln>
+          <a:effectLst/>
+        </p:spPr>
+        <p:style>
+          <a:lnRef idx="1">
+            <a:schemeClr val="accent1"/>
+          </a:lnRef>
+          <a:fillRef idx="3">
+            <a:schemeClr val="accent1"/>
+          </a:fillRef>
+          <a:effectRef idx="2">
+            <a:schemeClr val="accent1"/>
+          </a:effectRef>
+          <a:fontRef idx="minor">
+            <a:schemeClr val="lt1"/>
+          </a:fontRef>
+        </p:style>
+        <p:txBody>
+          <a:bodyPr rtlCol="0" anchor="ctr"/>
+          <a:lstStyle/>
+          <a:p>
+            <a:pPr algn="ctr"/>
+          </a:p>
+        </p:txBody>
+      </p:sp>
+      <p:sp>
+        <p:nvSpPr>
+          <p:cNvPr id="17" name="TextBox 16"/>
+          <p:cNvSpPr txBox="1"/>
+          <p:nvPr/>
+        </p:nvSpPr>
+        <p:spPr>
+          <a:xfrm>
+            <a:off x="3547872" y="4224528"/>
+            <a:ext cx="2286000" cy="320040"/>
+          </a:xfrm>
+          <a:prstGeom prst="rect">
+            <a:avLst/>
+          </a:prstGeom>
+          <a:noFill/>
+        </p:spPr>
+        <p:txBody>
+          <a:bodyPr wrap="square" anchor="t" lIns="0" rIns="0" tIns="0" bIns="0">
+            <a:spAutoFit/>
+          </a:bodyPr>
+          <a:lstStyle/>
+          <a:p>
+            <a:pPr algn="l"/>
+            <a:r>
+              <a:rPr sz="1400" b="1">
+                <a:solidFill>
+                  <a:srgbClr val="0F172A"/>
+                </a:solidFill>
+                <a:latin typeface="Open Sans"/>
+              </a:rPr>
+              <a:t>Uncashed paychecks</a:t>
+            </a:r>
+          </a:p>
+        </p:txBody>
+      </p:sp>
+      <p:sp>
+        <p:nvSpPr>
+          <p:cNvPr id="18" name="TextBox 17"/>
+          <p:cNvSpPr txBox="1"/>
+          <p:nvPr/>
+        </p:nvSpPr>
+        <p:spPr>
+          <a:xfrm>
+            <a:off x="3547872" y="4590288"/>
+            <a:ext cx="2286000" cy="502920"/>
+          </a:xfrm>
+          <a:prstGeom prst="rect">
+            <a:avLst/>
+          </a:prstGeom>
+          <a:noFill/>
+        </p:spPr>
+        <p:txBody>
+          <a:bodyPr wrap="square" anchor="t" lIns="0" rIns="0" tIns="0" bIns="0">
+            <a:spAutoFit/>
+          </a:bodyPr>
+          <a:lstStyle/>
+          <a:p>
+            <a:pPr algn="l"/>
+            <a:r>
+              <a:rPr sz="1100" b="0">
                 <a:solidFill>
                   <a:srgbClr val="334155"/>
                 </a:solidFill>
                 <a:latin typeface="Open Sans"/>
               </a:rPr>
-              <a:t>average claim paid through MissingMoney.com (median $100, FY2024)</a:t>
-            </a:r>
-          </a:p>
-        </p:txBody>
-      </p:sp>
-      <p:sp>
-        <p:nvSpPr>
-          <p:cNvPr id="16" name="Rounded Rectangle 15"/>
+              <a:t>Final wages, commissions, bonuses</a:t>
+            </a:r>
+          </a:p>
+        </p:txBody>
+      </p:sp>
+      <p:sp>
+        <p:nvSpPr>
+          <p:cNvPr id="19" name="Rounded Rectangle 18"/>
           <p:cNvSpPr/>
           <p:nvPr/>
         </p:nvSpPr>
         <p:spPr>
           <a:xfrm>
-            <a:off x="8046720" y="4846320"/>
-            <a:ext cx="3657600" cy="1280160"/>
+            <a:off x="6181344" y="4023360"/>
+            <a:ext cx="2743200" cy="1143000"/>
           </a:xfrm>
           <a:prstGeom prst="roundRect">
             <a:avLst>
@@ -6214,70 +6337,357 @@
       </p:sp>
       <p:sp>
         <p:nvSpPr>
-          <p:cNvPr id="17" name="TextBox 16"/>
-          <p:cNvSpPr txBox="1"/>
-          <p:nvPr/>
-        </p:nvSpPr>
-        <p:spPr>
-          <a:xfrm>
-            <a:off x="8321040" y="5010912"/>
-            <a:ext cx="3108960" cy="640080"/>
-          </a:xfrm>
-          <a:prstGeom prst="rect">
-            <a:avLst/>
-          </a:prstGeom>
-          <a:noFill/>
-        </p:spPr>
-        <p:txBody>
-          <a:bodyPr wrap="square" anchor="t" lIns="0" rIns="0" tIns="0" bIns="0">
-            <a:spAutoFit/>
-          </a:bodyPr>
-          <a:lstStyle/>
-          <a:p>
-            <a:pPr algn="l"/>
-            <a:r>
-              <a:rPr sz="3600" b="1">
-                <a:solidFill>
-                  <a:srgbClr val="FC4C0B"/>
-                </a:solidFill>
-                <a:latin typeface="Open Sans"/>
-              </a:rPr>
-              <a:t>Unique</a:t>
-            </a:r>
-          </a:p>
-        </p:txBody>
-      </p:sp>
-      <p:sp>
-        <p:nvSpPr>
-          <p:cNvPr id="18" name="TextBox 17"/>
-          <p:cNvSpPr txBox="1"/>
-          <p:nvPr/>
-        </p:nvSpPr>
-        <p:spPr>
-          <a:xfrm>
-            <a:off x="8321040" y="5623559"/>
-            <a:ext cx="3108960" cy="457200"/>
-          </a:xfrm>
-          <a:prstGeom prst="rect">
-            <a:avLst/>
-          </a:prstGeom>
-          <a:noFill/>
-        </p:spPr>
-        <p:txBody>
-          <a:bodyPr wrap="square" anchor="t" lIns="0" rIns="0" tIns="0" bIns="0">
-            <a:spAutoFit/>
-          </a:bodyPr>
-          <a:lstStyle/>
-          <a:p>
-            <a:pPr algn="l"/>
-            <a:r>
-              <a:rPr sz="1200" b="0">
+          <p:cNvPr id="20" name="Rectangle 19"/>
+          <p:cNvSpPr/>
+          <p:nvPr/>
+        </p:nvSpPr>
+        <p:spPr>
+          <a:xfrm>
+            <a:off x="6181344" y="4023360"/>
+            <a:ext cx="2743200" cy="73152"/>
+          </a:xfrm>
+          <a:prstGeom prst="rect">
+            <a:avLst/>
+          </a:prstGeom>
+          <a:solidFill>
+            <a:srgbClr val="2863C5"/>
+          </a:solidFill>
+          <a:ln>
+            <a:noFill/>
+          </a:ln>
+          <a:effectLst/>
+        </p:spPr>
+        <p:style>
+          <a:lnRef idx="1">
+            <a:schemeClr val="accent1"/>
+          </a:lnRef>
+          <a:fillRef idx="3">
+            <a:schemeClr val="accent1"/>
+          </a:fillRef>
+          <a:effectRef idx="2">
+            <a:schemeClr val="accent1"/>
+          </a:effectRef>
+          <a:fontRef idx="minor">
+            <a:schemeClr val="lt1"/>
+          </a:fontRef>
+        </p:style>
+        <p:txBody>
+          <a:bodyPr rtlCol="0" anchor="ctr"/>
+          <a:lstStyle/>
+          <a:p>
+            <a:pPr algn="ctr"/>
+          </a:p>
+        </p:txBody>
+      </p:sp>
+      <p:sp>
+        <p:nvSpPr>
+          <p:cNvPr id="21" name="TextBox 20"/>
+          <p:cNvSpPr txBox="1"/>
+          <p:nvPr/>
+        </p:nvSpPr>
+        <p:spPr>
+          <a:xfrm>
+            <a:off x="6409944" y="4224528"/>
+            <a:ext cx="2286000" cy="320040"/>
+          </a:xfrm>
+          <a:prstGeom prst="rect">
+            <a:avLst/>
+          </a:prstGeom>
+          <a:noFill/>
+        </p:spPr>
+        <p:txBody>
+          <a:bodyPr wrap="square" anchor="t" lIns="0" rIns="0" tIns="0" bIns="0">
+            <a:spAutoFit/>
+          </a:bodyPr>
+          <a:lstStyle/>
+          <a:p>
+            <a:pPr algn="l"/>
+            <a:r>
+              <a:rPr sz="1400" b="1">
+                <a:solidFill>
+                  <a:srgbClr val="0F172A"/>
+                </a:solidFill>
+                <a:latin typeface="Open Sans"/>
+              </a:rPr>
+              <a:t>Refunds &amp; deposits</a:t>
+            </a:r>
+          </a:p>
+        </p:txBody>
+      </p:sp>
+      <p:sp>
+        <p:nvSpPr>
+          <p:cNvPr id="22" name="TextBox 21"/>
+          <p:cNvSpPr txBox="1"/>
+          <p:nvPr/>
+        </p:nvSpPr>
+        <p:spPr>
+          <a:xfrm>
+            <a:off x="6409944" y="4590288"/>
+            <a:ext cx="2286000" cy="502920"/>
+          </a:xfrm>
+          <a:prstGeom prst="rect">
+            <a:avLst/>
+          </a:prstGeom>
+          <a:noFill/>
+        </p:spPr>
+        <p:txBody>
+          <a:bodyPr wrap="square" anchor="t" lIns="0" rIns="0" tIns="0" bIns="0">
+            <a:spAutoFit/>
+          </a:bodyPr>
+          <a:lstStyle/>
+          <a:p>
+            <a:pPr algn="l"/>
+            <a:r>
+              <a:rPr sz="1100" b="0">
                 <a:solidFill>
                   <a:srgbClr val="334155"/>
                 </a:solidFill>
                 <a:latin typeface="Open Sans"/>
               </a:rPr>
-              <a:t>combination of verified-identity matching + alerts + free claim guidance</a:t>
+              <a:t>Utility, rent, insurance, retail</a:t>
+            </a:r>
+          </a:p>
+        </p:txBody>
+      </p:sp>
+      <p:sp>
+        <p:nvSpPr>
+          <p:cNvPr id="23" name="Rounded Rectangle 22"/>
+          <p:cNvSpPr/>
+          <p:nvPr/>
+        </p:nvSpPr>
+        <p:spPr>
+          <a:xfrm>
+            <a:off x="9043416" y="4023360"/>
+            <a:ext cx="2743200" cy="1143000"/>
+          </a:xfrm>
+          <a:prstGeom prst="roundRect">
+            <a:avLst>
+              <a:gd name="adj" fmla="val 4000"/>
+            </a:avLst>
+          </a:prstGeom>
+          <a:solidFill>
+            <a:srgbClr val="FFFFFF"/>
+          </a:solidFill>
+          <a:ln w="6350">
+            <a:solidFill>
+              <a:srgbClr val="E2E8F0"/>
+            </a:solidFill>
+          </a:ln>
+          <a:effectLst/>
+        </p:spPr>
+        <p:style>
+          <a:lnRef idx="1">
+            <a:schemeClr val="accent1"/>
+          </a:lnRef>
+          <a:fillRef idx="3">
+            <a:schemeClr val="accent1"/>
+          </a:fillRef>
+          <a:effectRef idx="2">
+            <a:schemeClr val="accent1"/>
+          </a:effectRef>
+          <a:fontRef idx="minor">
+            <a:schemeClr val="lt1"/>
+          </a:fontRef>
+        </p:style>
+        <p:txBody>
+          <a:bodyPr rtlCol="0" anchor="ctr"/>
+          <a:lstStyle/>
+          <a:p>
+            <a:pPr algn="ctr"/>
+          </a:p>
+        </p:txBody>
+      </p:sp>
+      <p:sp>
+        <p:nvSpPr>
+          <p:cNvPr id="24" name="Rectangle 23"/>
+          <p:cNvSpPr/>
+          <p:nvPr/>
+        </p:nvSpPr>
+        <p:spPr>
+          <a:xfrm>
+            <a:off x="9043416" y="4023360"/>
+            <a:ext cx="2743200" cy="73152"/>
+          </a:xfrm>
+          <a:prstGeom prst="rect">
+            <a:avLst/>
+          </a:prstGeom>
+          <a:solidFill>
+            <a:srgbClr val="2863C5"/>
+          </a:solidFill>
+          <a:ln>
+            <a:noFill/>
+          </a:ln>
+          <a:effectLst/>
+        </p:spPr>
+        <p:style>
+          <a:lnRef idx="1">
+            <a:schemeClr val="accent1"/>
+          </a:lnRef>
+          <a:fillRef idx="3">
+            <a:schemeClr val="accent1"/>
+          </a:fillRef>
+          <a:effectRef idx="2">
+            <a:schemeClr val="accent1"/>
+          </a:effectRef>
+          <a:fontRef idx="minor">
+            <a:schemeClr val="lt1"/>
+          </a:fontRef>
+        </p:style>
+        <p:txBody>
+          <a:bodyPr rtlCol="0" anchor="ctr"/>
+          <a:lstStyle/>
+          <a:p>
+            <a:pPr algn="ctr"/>
+          </a:p>
+        </p:txBody>
+      </p:sp>
+      <p:sp>
+        <p:nvSpPr>
+          <p:cNvPr id="25" name="TextBox 24"/>
+          <p:cNvSpPr txBox="1"/>
+          <p:nvPr/>
+        </p:nvSpPr>
+        <p:spPr>
+          <a:xfrm>
+            <a:off x="9272016" y="4224528"/>
+            <a:ext cx="2286000" cy="320040"/>
+          </a:xfrm>
+          <a:prstGeom prst="rect">
+            <a:avLst/>
+          </a:prstGeom>
+          <a:noFill/>
+        </p:spPr>
+        <p:txBody>
+          <a:bodyPr wrap="square" anchor="t" lIns="0" rIns="0" tIns="0" bIns="0">
+            <a:spAutoFit/>
+          </a:bodyPr>
+          <a:lstStyle/>
+          <a:p>
+            <a:pPr algn="l"/>
+            <a:r>
+              <a:rPr sz="1400" b="1">
+                <a:solidFill>
+                  <a:srgbClr val="0F172A"/>
+                </a:solidFill>
+                <a:latin typeface="Open Sans"/>
+              </a:rPr>
+              <a:t>Investments</a:t>
+            </a:r>
+          </a:p>
+        </p:txBody>
+      </p:sp>
+      <p:sp>
+        <p:nvSpPr>
+          <p:cNvPr id="26" name="TextBox 25"/>
+          <p:cNvSpPr txBox="1"/>
+          <p:nvPr/>
+        </p:nvSpPr>
+        <p:spPr>
+          <a:xfrm>
+            <a:off x="9272016" y="4590288"/>
+            <a:ext cx="2286000" cy="502920"/>
+          </a:xfrm>
+          <a:prstGeom prst="rect">
+            <a:avLst/>
+          </a:prstGeom>
+          <a:noFill/>
+        </p:spPr>
+        <p:txBody>
+          <a:bodyPr wrap="square" anchor="t" lIns="0" rIns="0" tIns="0" bIns="0">
+            <a:spAutoFit/>
+          </a:bodyPr>
+          <a:lstStyle/>
+          <a:p>
+            <a:pPr algn="l"/>
+            <a:r>
+              <a:rPr sz="1100" b="0">
+                <a:solidFill>
+                  <a:srgbClr val="334155"/>
+                </a:solidFill>
+                <a:latin typeface="Open Sans"/>
+              </a:rPr>
+              <a:t>Stock dividends, matured bonds, IRAs</a:t>
+            </a:r>
+          </a:p>
+        </p:txBody>
+      </p:sp>
+      <p:sp>
+        <p:nvSpPr>
+          <p:cNvPr id="27" name="Rounded Rectangle 26"/>
+          <p:cNvSpPr/>
+          <p:nvPr/>
+        </p:nvSpPr>
+        <p:spPr>
+          <a:xfrm>
+            <a:off x="457200" y="5486400"/>
+            <a:ext cx="11247120" cy="502920"/>
+          </a:xfrm>
+          <a:prstGeom prst="roundRect">
+            <a:avLst>
+              <a:gd name="adj" fmla="val 7000"/>
+            </a:avLst>
+          </a:prstGeom>
+          <a:solidFill>
+            <a:srgbClr val="2863C5"/>
+          </a:solidFill>
+          <a:ln>
+            <a:noFill/>
+          </a:ln>
+          <a:effectLst/>
+        </p:spPr>
+        <p:style>
+          <a:lnRef idx="1">
+            <a:schemeClr val="accent1"/>
+          </a:lnRef>
+          <a:fillRef idx="3">
+            <a:schemeClr val="accent1"/>
+          </a:fillRef>
+          <a:effectRef idx="2">
+            <a:schemeClr val="accent1"/>
+          </a:effectRef>
+          <a:fontRef idx="minor">
+            <a:schemeClr val="lt1"/>
+          </a:fontRef>
+        </p:style>
+        <p:txBody>
+          <a:bodyPr rtlCol="0" anchor="ctr"/>
+          <a:lstStyle/>
+          <a:p>
+            <a:pPr algn="ctr"/>
+          </a:p>
+        </p:txBody>
+      </p:sp>
+      <p:sp>
+        <p:nvSpPr>
+          <p:cNvPr id="28" name="TextBox 27"/>
+          <p:cNvSpPr txBox="1"/>
+          <p:nvPr/>
+        </p:nvSpPr>
+        <p:spPr>
+          <a:xfrm>
+            <a:off x="640080" y="5550408"/>
+            <a:ext cx="10972800" cy="365760"/>
+          </a:xfrm>
+          <a:prstGeom prst="rect">
+            <a:avLst/>
+          </a:prstGeom>
+          <a:noFill/>
+        </p:spPr>
+        <p:txBody>
+          <a:bodyPr wrap="square" anchor="t" lIns="0" rIns="0" tIns="0" bIns="0">
+            <a:spAutoFit/>
+          </a:bodyPr>
+          <a:lstStyle/>
+          <a:p>
+            <a:pPr algn="l"/>
+            <a:r>
+              <a:rPr sz="1200" b="1">
+                <a:solidFill>
+                  <a:srgbClr val="FFFFFF"/>
+                </a:solidFill>
+                <a:latin typeface="Open Sans"/>
+              </a:rPr>
+              <a:t>Nationwide: $70B+ sitting with state treasurers · ~33M Americans have property waiting (NAUPA, FY2024)</a:t>
             </a:r>
           </a:p>
         </p:txBody>

</xml_diff>

<commit_message>
Slide 3 step 3 — deep-link handoff, not packet prep / status tracking
Step 3 now reads:
  "We hand them off to the state — Deep-link to the official state
  claim portal with step-by-step instructions for filing."

(Previously said "Prepare claim packet · route to official state
portal · track status" — out of scope for the actual product.)

Co-Authored-By: Claude Opus 4.7 (1M context) <noreply@anthropic.com>
</commit_message>
<xml_diff>
--- a/myReclaim-Exec-Deck.pptx
+++ b/myReclaim-Exec-Deck.pptx
@@ -7485,7 +7485,7 @@
                 </a:solidFill>
                 <a:latin typeface="Open Sans"/>
               </a:rPr>
-              <a:t>We help them file with the state</a:t>
+              <a:t>We hand them off to the state</a:t>
             </a:r>
           </a:p>
         </p:txBody>
@@ -7520,7 +7520,7 @@
                 </a:solidFill>
                 <a:latin typeface="Open Sans"/>
               </a:rPr>
-              <a:t>Prepare claim packet · route to official state portal · track status.</a:t>
+              <a:t>Deep-link to the official state claim portal with step-by-step instructions for filing.</a:t>
             </a:r>
           </a:p>
         </p:txBody>

</xml_diff>

<commit_message>
Slide 6 — restore 4 headlines, mirror slide 7 layout exactly
Same structure as slide 7. Only the data differs because the match
condition differs:

  Slide 6 (name only): 23,166 / 74.5% / 2.3M / $172M
  Slide 7 (name + city): 11,958 / 38.4% / 69K / $5.04M

Both: 4-headline strip + centered "Net actives by total owed" table
+ bottom callout. Slide 6's callout flags name-only as the ceiling;
slide 7's callout is the city-collapse story.

Co-Authored-By: Claude Opus 4.7 (1M context) <noreply@anthropic.com>
</commit_message>
<xml_diff>
--- a/myReclaim-Exec-Deck.pptx
+++ b/myReclaim-Exec-Deck.pptx
@@ -12803,7 +12803,7 @@
                 </a:solidFill>
                 <a:latin typeface="Open Sans"/>
               </a:rPr>
-              <a:t>Matching on name only — the upper bound. Common names like 'John Smith' inflate the totals; the next slide adds city for the defensible view.</a:t>
+              <a:t>Matching on name only.</a:t>
             </a:r>
           </a:p>
         </p:txBody>
@@ -12817,7 +12817,7 @@
         <p:spPr>
           <a:xfrm>
             <a:off x="457200" y="2606040"/>
-            <a:ext cx="5532120" cy="1417320"/>
+            <a:ext cx="2697480" cy="1417320"/>
           </a:xfrm>
           <a:prstGeom prst="roundRect">
             <a:avLst>
@@ -12865,7 +12865,7 @@
         <p:spPr>
           <a:xfrm>
             <a:off x="457200" y="2606040"/>
-            <a:ext cx="5532120" cy="137160"/>
+            <a:ext cx="2697480" cy="137160"/>
           </a:xfrm>
           <a:prstGeom prst="rect">
             <a:avLst/>
@@ -12908,23 +12908,23 @@
         </p:nvSpPr>
         <p:spPr>
           <a:xfrm>
-            <a:off x="731520" y="2880360"/>
-            <a:ext cx="4983480" cy="777240"/>
-          </a:xfrm>
-          <a:prstGeom prst="rect">
-            <a:avLst/>
-          </a:prstGeom>
-          <a:noFill/>
-        </p:spPr>
-        <p:txBody>
-          <a:bodyPr wrap="square" anchor="t" lIns="0" rIns="0" tIns="0" bIns="0">
-            <a:spAutoFit/>
-          </a:bodyPr>
-          <a:lstStyle/>
-          <a:p>
-            <a:pPr algn="l"/>
-            <a:r>
-              <a:rPr sz="4400" b="1">
+            <a:off x="640080" y="2880360"/>
+            <a:ext cx="2331720" cy="777240"/>
+          </a:xfrm>
+          <a:prstGeom prst="rect">
+            <a:avLst/>
+          </a:prstGeom>
+          <a:noFill/>
+        </p:spPr>
+        <p:txBody>
+          <a:bodyPr wrap="square" anchor="t" lIns="0" rIns="0" tIns="0" bIns="0">
+            <a:spAutoFit/>
+          </a:bodyPr>
+          <a:lstStyle/>
+          <a:p>
+            <a:pPr algn="l"/>
+            <a:r>
+              <a:rPr sz="3600" b="1">
                 <a:solidFill>
                   <a:srgbClr val="2863C5"/>
                 </a:solidFill>
@@ -12943,29 +12943,29 @@
         </p:nvSpPr>
         <p:spPr>
           <a:xfrm>
-            <a:off x="731520" y="3611880"/>
-            <a:ext cx="4983480" cy="365760"/>
-          </a:xfrm>
-          <a:prstGeom prst="rect">
-            <a:avLst/>
-          </a:prstGeom>
-          <a:noFill/>
-        </p:spPr>
-        <p:txBody>
-          <a:bodyPr wrap="square" anchor="t" lIns="0" rIns="0" tIns="0" bIns="0">
-            <a:spAutoFit/>
-          </a:bodyPr>
-          <a:lstStyle/>
-          <a:p>
-            <a:pPr algn="l"/>
-            <a:r>
-              <a:rPr sz="1100" b="0">
+            <a:off x="640080" y="3611880"/>
+            <a:ext cx="2331720" cy="365760"/>
+          </a:xfrm>
+          <a:prstGeom prst="rect">
+            <a:avLst/>
+          </a:prstGeom>
+          <a:noFill/>
+        </p:spPr>
+        <p:txBody>
+          <a:bodyPr wrap="square" anchor="t" lIns="0" rIns="0" tIns="0" bIns="0">
+            <a:spAutoFit/>
+          </a:bodyPr>
+          <a:lstStyle/>
+          <a:p>
+            <a:pPr algn="l"/>
+            <a:r>
+              <a:rPr sz="1000" b="0">
                 <a:solidFill>
                   <a:srgbClr val="334155"/>
                 </a:solidFill>
                 <a:latin typeface="Open Sans"/>
               </a:rPr>
-              <a:t>net actives matched at least one name</a:t>
+              <a:t>net actives matched (name only)</a:t>
             </a:r>
           </a:p>
         </p:txBody>
@@ -12978,8 +12978,8 @@
         </p:nvSpPr>
         <p:spPr>
           <a:xfrm>
-            <a:off x="6172200" y="2606040"/>
-            <a:ext cx="5532120" cy="1417320"/>
+            <a:off x="3291840" y="2606040"/>
+            <a:ext cx="2697480" cy="1417320"/>
           </a:xfrm>
           <a:prstGeom prst="roundRect">
             <a:avLst>
@@ -13026,8 +13026,8 @@
         </p:nvSpPr>
         <p:spPr>
           <a:xfrm>
-            <a:off x="6172200" y="2606040"/>
-            <a:ext cx="5532120" cy="137160"/>
+            <a:off x="3291840" y="2606040"/>
+            <a:ext cx="2697480" cy="137160"/>
           </a:xfrm>
           <a:prstGeom prst="rect">
             <a:avLst/>
@@ -13070,23 +13070,23 @@
         </p:nvSpPr>
         <p:spPr>
           <a:xfrm>
-            <a:off x="6446520" y="2880360"/>
-            <a:ext cx="4983480" cy="777240"/>
-          </a:xfrm>
-          <a:prstGeom prst="rect">
-            <a:avLst/>
-          </a:prstGeom>
-          <a:noFill/>
-        </p:spPr>
-        <p:txBody>
-          <a:bodyPr wrap="square" anchor="t" lIns="0" rIns="0" tIns="0" bIns="0">
-            <a:spAutoFit/>
-          </a:bodyPr>
-          <a:lstStyle/>
-          <a:p>
-            <a:pPr algn="l"/>
-            <a:r>
-              <a:rPr sz="4400" b="1">
+            <a:off x="3474720" y="2880360"/>
+            <a:ext cx="2331720" cy="777240"/>
+          </a:xfrm>
+          <a:prstGeom prst="rect">
+            <a:avLst/>
+          </a:prstGeom>
+          <a:noFill/>
+        </p:spPr>
+        <p:txBody>
+          <a:bodyPr wrap="square" anchor="t" lIns="0" rIns="0" tIns="0" bIns="0">
+            <a:spAutoFit/>
+          </a:bodyPr>
+          <a:lstStyle/>
+          <a:p>
+            <a:pPr algn="l"/>
+            <a:r>
+              <a:rPr sz="3600" b="1">
                 <a:solidFill>
                   <a:srgbClr val="2863C5"/>
                 </a:solidFill>
@@ -13105,23 +13105,23 @@
         </p:nvSpPr>
         <p:spPr>
           <a:xfrm>
-            <a:off x="6446520" y="3611880"/>
-            <a:ext cx="4983480" cy="365760"/>
-          </a:xfrm>
-          <a:prstGeom prst="rect">
-            <a:avLst/>
-          </a:prstGeom>
-          <a:noFill/>
-        </p:spPr>
-        <p:txBody>
-          <a:bodyPr wrap="square" anchor="t" lIns="0" rIns="0" tIns="0" bIns="0">
-            <a:spAutoFit/>
-          </a:bodyPr>
-          <a:lstStyle/>
-          <a:p>
-            <a:pPr algn="l"/>
-            <a:r>
-              <a:rPr sz="1100" b="0">
+            <a:off x="3474720" y="3611880"/>
+            <a:ext cx="2331720" cy="365760"/>
+          </a:xfrm>
+          <a:prstGeom prst="rect">
+            <a:avLst/>
+          </a:prstGeom>
+          <a:noFill/>
+        </p:spPr>
+        <p:txBody>
+          <a:bodyPr wrap="square" anchor="t" lIns="0" rIns="0" tIns="0" bIns="0">
+            <a:spAutoFit/>
+          </a:bodyPr>
+          <a:lstStyle/>
+          <a:p>
+            <a:pPr algn="l"/>
+            <a:r>
+              <a:rPr sz="1000" b="0">
                 <a:solidFill>
                   <a:srgbClr val="334155"/>
                 </a:solidFill>
@@ -13134,7 +13134,331 @@
       </p:sp>
       <p:sp>
         <p:nvSpPr>
-          <p:cNvPr id="18" name="TextBox 17"/>
+          <p:cNvPr id="18" name="Rounded Rectangle 17"/>
+          <p:cNvSpPr/>
+          <p:nvPr/>
+        </p:nvSpPr>
+        <p:spPr>
+          <a:xfrm>
+            <a:off x="6126480" y="2606040"/>
+            <a:ext cx="2697480" cy="1417320"/>
+          </a:xfrm>
+          <a:prstGeom prst="roundRect">
+            <a:avLst>
+              <a:gd name="adj" fmla="val 4000"/>
+            </a:avLst>
+          </a:prstGeom>
+          <a:solidFill>
+            <a:srgbClr val="FFFFFF"/>
+          </a:solidFill>
+          <a:ln w="6350">
+            <a:solidFill>
+              <a:srgbClr val="E2E8F0"/>
+            </a:solidFill>
+          </a:ln>
+          <a:effectLst/>
+        </p:spPr>
+        <p:style>
+          <a:lnRef idx="1">
+            <a:schemeClr val="accent1"/>
+          </a:lnRef>
+          <a:fillRef idx="3">
+            <a:schemeClr val="accent1"/>
+          </a:fillRef>
+          <a:effectRef idx="2">
+            <a:schemeClr val="accent1"/>
+          </a:effectRef>
+          <a:fontRef idx="minor">
+            <a:schemeClr val="lt1"/>
+          </a:fontRef>
+        </p:style>
+        <p:txBody>
+          <a:bodyPr rtlCol="0" anchor="ctr"/>
+          <a:lstStyle/>
+          <a:p>
+            <a:pPr algn="ctr"/>
+          </a:p>
+        </p:txBody>
+      </p:sp>
+      <p:sp>
+        <p:nvSpPr>
+          <p:cNvPr id="19" name="Rectangle 18"/>
+          <p:cNvSpPr/>
+          <p:nvPr/>
+        </p:nvSpPr>
+        <p:spPr>
+          <a:xfrm>
+            <a:off x="6126480" y="2606040"/>
+            <a:ext cx="2697480" cy="137160"/>
+          </a:xfrm>
+          <a:prstGeom prst="rect">
+            <a:avLst/>
+          </a:prstGeom>
+          <a:solidFill>
+            <a:srgbClr val="FC4C0B"/>
+          </a:solidFill>
+          <a:ln>
+            <a:noFill/>
+          </a:ln>
+          <a:effectLst/>
+        </p:spPr>
+        <p:style>
+          <a:lnRef idx="1">
+            <a:schemeClr val="accent1"/>
+          </a:lnRef>
+          <a:fillRef idx="3">
+            <a:schemeClr val="accent1"/>
+          </a:fillRef>
+          <a:effectRef idx="2">
+            <a:schemeClr val="accent1"/>
+          </a:effectRef>
+          <a:fontRef idx="minor">
+            <a:schemeClr val="lt1"/>
+          </a:fontRef>
+        </p:style>
+        <p:txBody>
+          <a:bodyPr rtlCol="0" anchor="ctr"/>
+          <a:lstStyle/>
+          <a:p>
+            <a:pPr algn="ctr"/>
+          </a:p>
+        </p:txBody>
+      </p:sp>
+      <p:sp>
+        <p:nvSpPr>
+          <p:cNvPr id="20" name="TextBox 19"/>
+          <p:cNvSpPr txBox="1"/>
+          <p:nvPr/>
+        </p:nvSpPr>
+        <p:spPr>
+          <a:xfrm>
+            <a:off x="6309360" y="2880360"/>
+            <a:ext cx="2331720" cy="777240"/>
+          </a:xfrm>
+          <a:prstGeom prst="rect">
+            <a:avLst/>
+          </a:prstGeom>
+          <a:noFill/>
+        </p:spPr>
+        <p:txBody>
+          <a:bodyPr wrap="square" anchor="t" lIns="0" rIns="0" tIns="0" bIns="0">
+            <a:spAutoFit/>
+          </a:bodyPr>
+          <a:lstStyle/>
+          <a:p>
+            <a:pPr algn="l"/>
+            <a:r>
+              <a:rPr sz="3600" b="1">
+                <a:solidFill>
+                  <a:srgbClr val="FC4C0B"/>
+                </a:solidFill>
+                <a:latin typeface="Open Sans"/>
+              </a:rPr>
+              <a:t>2.3M</a:t>
+            </a:r>
+          </a:p>
+        </p:txBody>
+      </p:sp>
+      <p:sp>
+        <p:nvSpPr>
+          <p:cNvPr id="21" name="TextBox 20"/>
+          <p:cNvSpPr txBox="1"/>
+          <p:nvPr/>
+        </p:nvSpPr>
+        <p:spPr>
+          <a:xfrm>
+            <a:off x="6309360" y="3611880"/>
+            <a:ext cx="2331720" cy="365760"/>
+          </a:xfrm>
+          <a:prstGeom prst="rect">
+            <a:avLst/>
+          </a:prstGeom>
+          <a:noFill/>
+        </p:spPr>
+        <p:txBody>
+          <a:bodyPr wrap="square" anchor="t" lIns="0" rIns="0" tIns="0" bIns="0">
+            <a:spAutoFit/>
+          </a:bodyPr>
+          <a:lstStyle/>
+          <a:p>
+            <a:pPr algn="l"/>
+            <a:r>
+              <a:rPr sz="1000" b="0">
+                <a:solidFill>
+                  <a:srgbClr val="334155"/>
+                </a:solidFill>
+                <a:latin typeface="Open Sans"/>
+              </a:rPr>
+              <a:t>property records matched</a:t>
+            </a:r>
+          </a:p>
+        </p:txBody>
+      </p:sp>
+      <p:sp>
+        <p:nvSpPr>
+          <p:cNvPr id="22" name="Rounded Rectangle 21"/>
+          <p:cNvSpPr/>
+          <p:nvPr/>
+        </p:nvSpPr>
+        <p:spPr>
+          <a:xfrm>
+            <a:off x="8961120" y="2606040"/>
+            <a:ext cx="2697480" cy="1417320"/>
+          </a:xfrm>
+          <a:prstGeom prst="roundRect">
+            <a:avLst>
+              <a:gd name="adj" fmla="val 4000"/>
+            </a:avLst>
+          </a:prstGeom>
+          <a:solidFill>
+            <a:srgbClr val="FFFFFF"/>
+          </a:solidFill>
+          <a:ln w="6350">
+            <a:solidFill>
+              <a:srgbClr val="E2E8F0"/>
+            </a:solidFill>
+          </a:ln>
+          <a:effectLst/>
+        </p:spPr>
+        <p:style>
+          <a:lnRef idx="1">
+            <a:schemeClr val="accent1"/>
+          </a:lnRef>
+          <a:fillRef idx="3">
+            <a:schemeClr val="accent1"/>
+          </a:fillRef>
+          <a:effectRef idx="2">
+            <a:schemeClr val="accent1"/>
+          </a:effectRef>
+          <a:fontRef idx="minor">
+            <a:schemeClr val="lt1"/>
+          </a:fontRef>
+        </p:style>
+        <p:txBody>
+          <a:bodyPr rtlCol="0" anchor="ctr"/>
+          <a:lstStyle/>
+          <a:p>
+            <a:pPr algn="ctr"/>
+          </a:p>
+        </p:txBody>
+      </p:sp>
+      <p:sp>
+        <p:nvSpPr>
+          <p:cNvPr id="23" name="Rectangle 22"/>
+          <p:cNvSpPr/>
+          <p:nvPr/>
+        </p:nvSpPr>
+        <p:spPr>
+          <a:xfrm>
+            <a:off x="8961120" y="2606040"/>
+            <a:ext cx="2697480" cy="137160"/>
+          </a:xfrm>
+          <a:prstGeom prst="rect">
+            <a:avLst/>
+          </a:prstGeom>
+          <a:solidFill>
+            <a:srgbClr val="FC4C0B"/>
+          </a:solidFill>
+          <a:ln>
+            <a:noFill/>
+          </a:ln>
+          <a:effectLst/>
+        </p:spPr>
+        <p:style>
+          <a:lnRef idx="1">
+            <a:schemeClr val="accent1"/>
+          </a:lnRef>
+          <a:fillRef idx="3">
+            <a:schemeClr val="accent1"/>
+          </a:fillRef>
+          <a:effectRef idx="2">
+            <a:schemeClr val="accent1"/>
+          </a:effectRef>
+          <a:fontRef idx="minor">
+            <a:schemeClr val="lt1"/>
+          </a:fontRef>
+        </p:style>
+        <p:txBody>
+          <a:bodyPr rtlCol="0" anchor="ctr"/>
+          <a:lstStyle/>
+          <a:p>
+            <a:pPr algn="ctr"/>
+          </a:p>
+        </p:txBody>
+      </p:sp>
+      <p:sp>
+        <p:nvSpPr>
+          <p:cNvPr id="24" name="TextBox 23"/>
+          <p:cNvSpPr txBox="1"/>
+          <p:nvPr/>
+        </p:nvSpPr>
+        <p:spPr>
+          <a:xfrm>
+            <a:off x="9144000" y="2880360"/>
+            <a:ext cx="2331720" cy="777240"/>
+          </a:xfrm>
+          <a:prstGeom prst="rect">
+            <a:avLst/>
+          </a:prstGeom>
+          <a:noFill/>
+        </p:spPr>
+        <p:txBody>
+          <a:bodyPr wrap="square" anchor="t" lIns="0" rIns="0" tIns="0" bIns="0">
+            <a:spAutoFit/>
+          </a:bodyPr>
+          <a:lstStyle/>
+          <a:p>
+            <a:pPr algn="l"/>
+            <a:r>
+              <a:rPr sz="3600" b="1">
+                <a:solidFill>
+                  <a:srgbClr val="FC4C0B"/>
+                </a:solidFill>
+                <a:latin typeface="Open Sans"/>
+              </a:rPr>
+              <a:t>$172M</a:t>
+            </a:r>
+          </a:p>
+        </p:txBody>
+      </p:sp>
+      <p:sp>
+        <p:nvSpPr>
+          <p:cNvPr id="25" name="TextBox 24"/>
+          <p:cNvSpPr txBox="1"/>
+          <p:nvPr/>
+        </p:nvSpPr>
+        <p:spPr>
+          <a:xfrm>
+            <a:off x="9144000" y="3611880"/>
+            <a:ext cx="2331720" cy="365760"/>
+          </a:xfrm>
+          <a:prstGeom prst="rect">
+            <a:avLst/>
+          </a:prstGeom>
+          <a:noFill/>
+        </p:spPr>
+        <p:txBody>
+          <a:bodyPr wrap="square" anchor="t" lIns="0" rIns="0" tIns="0" bIns="0">
+            <a:spAutoFit/>
+          </a:bodyPr>
+          <a:lstStyle/>
+          <a:p>
+            <a:pPr algn="l"/>
+            <a:r>
+              <a:rPr sz="1000" b="0">
+                <a:solidFill>
+                  <a:srgbClr val="334155"/>
+                </a:solidFill>
+                <a:latin typeface="Open Sans"/>
+              </a:rPr>
+              <a:t>estimated value across all matches</a:t>
+            </a:r>
+          </a:p>
+        </p:txBody>
+      </p:sp>
+      <p:sp>
+        <p:nvSpPr>
+          <p:cNvPr id="26" name="TextBox 25"/>
           <p:cNvSpPr txBox="1"/>
           <p:nvPr/>
         </p:nvSpPr>
@@ -13162,14 +13486,14 @@
                 </a:solidFill>
                 <a:latin typeface="Open Sans"/>
               </a:rPr>
-              <a:t>NET ACTIVES BY TOTAL OWED (under their name)</a:t>
-            </a:r>
-          </a:p>
-        </p:txBody>
-      </p:sp>
-      <p:sp>
-        <p:nvSpPr>
-          <p:cNvPr id="19" name="TextBox 18"/>
+              <a:t>NET ACTIVES BY TOTAL OWED (name only)</a:t>
+            </a:r>
+          </a:p>
+        </p:txBody>
+      </p:sp>
+      <p:sp>
+        <p:nvSpPr>
+          <p:cNvPr id="27" name="TextBox 26"/>
           <p:cNvSpPr txBox="1"/>
           <p:nvPr/>
         </p:nvSpPr>
@@ -13204,7 +13528,7 @@
       </p:sp>
       <p:sp>
         <p:nvSpPr>
-          <p:cNvPr id="20" name="Rectangle 19"/>
+          <p:cNvPr id="28" name="Rectangle 27"/>
           <p:cNvSpPr/>
           <p:nvPr/>
         </p:nvSpPr>
@@ -13248,7 +13572,7 @@
       </p:sp>
       <p:sp>
         <p:nvSpPr>
-          <p:cNvPr id="21" name="TextBox 20"/>
+          <p:cNvPr id="29" name="TextBox 28"/>
           <p:cNvSpPr txBox="1"/>
           <p:nvPr/>
         </p:nvSpPr>
@@ -13283,7 +13607,7 @@
       </p:sp>
       <p:sp>
         <p:nvSpPr>
-          <p:cNvPr id="22" name="TextBox 21"/>
+          <p:cNvPr id="30" name="TextBox 29"/>
           <p:cNvSpPr txBox="1"/>
           <p:nvPr/>
         </p:nvSpPr>
@@ -13318,7 +13642,7 @@
       </p:sp>
       <p:sp>
         <p:nvSpPr>
-          <p:cNvPr id="23" name="TextBox 22"/>
+          <p:cNvPr id="31" name="TextBox 30"/>
           <p:cNvSpPr txBox="1"/>
           <p:nvPr/>
         </p:nvSpPr>
@@ -13353,7 +13677,7 @@
       </p:sp>
       <p:sp>
         <p:nvSpPr>
-          <p:cNvPr id="24" name="TextBox 23"/>
+          <p:cNvPr id="32" name="TextBox 31"/>
           <p:cNvSpPr txBox="1"/>
           <p:nvPr/>
         </p:nvSpPr>
@@ -13388,7 +13712,7 @@
       </p:sp>
       <p:sp>
         <p:nvSpPr>
-          <p:cNvPr id="25" name="Rectangle 24"/>
+          <p:cNvPr id="33" name="Rectangle 32"/>
           <p:cNvSpPr/>
           <p:nvPr/>
         </p:nvSpPr>
@@ -13432,7 +13756,7 @@
       </p:sp>
       <p:sp>
         <p:nvSpPr>
-          <p:cNvPr id="26" name="TextBox 25"/>
+          <p:cNvPr id="34" name="TextBox 33"/>
           <p:cNvSpPr txBox="1"/>
           <p:nvPr/>
         </p:nvSpPr>
@@ -13467,7 +13791,7 @@
       </p:sp>
       <p:sp>
         <p:nvSpPr>
-          <p:cNvPr id="27" name="TextBox 26"/>
+          <p:cNvPr id="35" name="TextBox 34"/>
           <p:cNvSpPr txBox="1"/>
           <p:nvPr/>
         </p:nvSpPr>
@@ -13502,7 +13826,7 @@
       </p:sp>
       <p:sp>
         <p:nvSpPr>
-          <p:cNvPr id="28" name="TextBox 27"/>
+          <p:cNvPr id="36" name="TextBox 35"/>
           <p:cNvSpPr txBox="1"/>
           <p:nvPr/>
         </p:nvSpPr>
@@ -13537,7 +13861,7 @@
       </p:sp>
       <p:sp>
         <p:nvSpPr>
-          <p:cNvPr id="29" name="TextBox 28"/>
+          <p:cNvPr id="37" name="TextBox 36"/>
           <p:cNvSpPr txBox="1"/>
           <p:nvPr/>
         </p:nvSpPr>
@@ -13572,7 +13896,7 @@
       </p:sp>
       <p:sp>
         <p:nvSpPr>
-          <p:cNvPr id="30" name="Rectangle 29"/>
+          <p:cNvPr id="38" name="Rectangle 37"/>
           <p:cNvSpPr/>
           <p:nvPr/>
         </p:nvSpPr>
@@ -13616,7 +13940,7 @@
       </p:sp>
       <p:sp>
         <p:nvSpPr>
-          <p:cNvPr id="31" name="TextBox 30"/>
+          <p:cNvPr id="39" name="TextBox 38"/>
           <p:cNvSpPr txBox="1"/>
           <p:nvPr/>
         </p:nvSpPr>
@@ -13651,7 +13975,7 @@
       </p:sp>
       <p:sp>
         <p:nvSpPr>
-          <p:cNvPr id="32" name="TextBox 31"/>
+          <p:cNvPr id="40" name="TextBox 39"/>
           <p:cNvSpPr txBox="1"/>
           <p:nvPr/>
         </p:nvSpPr>
@@ -13686,7 +14010,7 @@
       </p:sp>
       <p:sp>
         <p:nvSpPr>
-          <p:cNvPr id="33" name="TextBox 32"/>
+          <p:cNvPr id="41" name="TextBox 40"/>
           <p:cNvSpPr txBox="1"/>
           <p:nvPr/>
         </p:nvSpPr>
@@ -13721,7 +14045,7 @@
       </p:sp>
       <p:sp>
         <p:nvSpPr>
-          <p:cNvPr id="34" name="TextBox 33"/>
+          <p:cNvPr id="42" name="TextBox 41"/>
           <p:cNvSpPr txBox="1"/>
           <p:nvPr/>
         </p:nvSpPr>
@@ -13756,7 +14080,7 @@
       </p:sp>
       <p:sp>
         <p:nvSpPr>
-          <p:cNvPr id="35" name="Rectangle 34"/>
+          <p:cNvPr id="43" name="Rectangle 42"/>
           <p:cNvSpPr/>
           <p:nvPr/>
         </p:nvSpPr>
@@ -13800,7 +14124,7 @@
       </p:sp>
       <p:sp>
         <p:nvSpPr>
-          <p:cNvPr id="36" name="TextBox 35"/>
+          <p:cNvPr id="44" name="TextBox 43"/>
           <p:cNvSpPr txBox="1"/>
           <p:nvPr/>
         </p:nvSpPr>
@@ -13835,7 +14159,7 @@
       </p:sp>
       <p:sp>
         <p:nvSpPr>
-          <p:cNvPr id="37" name="TextBox 36"/>
+          <p:cNvPr id="45" name="TextBox 44"/>
           <p:cNvSpPr txBox="1"/>
           <p:nvPr/>
         </p:nvSpPr>
@@ -13870,7 +14194,7 @@
       </p:sp>
       <p:sp>
         <p:nvSpPr>
-          <p:cNvPr id="38" name="TextBox 37"/>
+          <p:cNvPr id="46" name="TextBox 45"/>
           <p:cNvSpPr txBox="1"/>
           <p:nvPr/>
         </p:nvSpPr>
@@ -13905,7 +14229,7 @@
       </p:sp>
       <p:sp>
         <p:nvSpPr>
-          <p:cNvPr id="39" name="TextBox 38"/>
+          <p:cNvPr id="47" name="TextBox 46"/>
           <p:cNvSpPr txBox="1"/>
           <p:nvPr/>
         </p:nvSpPr>
@@ -13940,7 +14264,7 @@
       </p:sp>
       <p:sp>
         <p:nvSpPr>
-          <p:cNvPr id="40" name="Rectangle 39"/>
+          <p:cNvPr id="48" name="Rectangle 47"/>
           <p:cNvSpPr/>
           <p:nvPr/>
         </p:nvSpPr>
@@ -13984,7 +14308,7 @@
       </p:sp>
       <p:sp>
         <p:nvSpPr>
-          <p:cNvPr id="41" name="TextBox 40"/>
+          <p:cNvPr id="49" name="TextBox 48"/>
           <p:cNvSpPr txBox="1"/>
           <p:nvPr/>
         </p:nvSpPr>
@@ -14019,7 +14343,7 @@
       </p:sp>
       <p:sp>
         <p:nvSpPr>
-          <p:cNvPr id="42" name="TextBox 41"/>
+          <p:cNvPr id="50" name="TextBox 49"/>
           <p:cNvSpPr txBox="1"/>
           <p:nvPr/>
         </p:nvSpPr>
@@ -14054,7 +14378,7 @@
       </p:sp>
       <p:sp>
         <p:nvSpPr>
-          <p:cNvPr id="43" name="TextBox 42"/>
+          <p:cNvPr id="51" name="TextBox 50"/>
           <p:cNvSpPr txBox="1"/>
           <p:nvPr/>
         </p:nvSpPr>
@@ -14089,7 +14413,7 @@
       </p:sp>
       <p:sp>
         <p:nvSpPr>
-          <p:cNvPr id="44" name="TextBox 43"/>
+          <p:cNvPr id="52" name="TextBox 51"/>
           <p:cNvSpPr txBox="1"/>
           <p:nvPr/>
         </p:nvSpPr>
@@ -14124,7 +14448,7 @@
       </p:sp>
       <p:sp>
         <p:nvSpPr>
-          <p:cNvPr id="45" name="Rounded Rectangle 44"/>
+          <p:cNvPr id="53" name="Rounded Rectangle 52"/>
           <p:cNvSpPr/>
           <p:nvPr/>
         </p:nvSpPr>
@@ -14170,7 +14494,7 @@
       </p:sp>
       <p:sp>
         <p:nvSpPr>
-          <p:cNvPr id="46" name="TextBox 45"/>
+          <p:cNvPr id="54" name="TextBox 53"/>
           <p:cNvSpPr txBox="1"/>
           <p:nvPr/>
         </p:nvSpPr>
@@ -14198,7 +14522,7 @@
                 </a:solidFill>
                 <a:latin typeface="Open Sans"/>
               </a:rPr>
-              <a:t>Aggregate $172M / 2.3M records on this slide are upper bounds — name alone collides on common names. See next slide (name + city).</a:t>
+              <a:t>Name-only is the upper bound — common names inflate the totals. Next slide adds city for the defensible view.</a:t>
             </a:r>
           </a:p>
         </p:txBody>

</xml_diff>